<commit_message>
Defense slides R2: problem statement from Ch.1 and full literature review from Ch.2 (12 slides), neutral wording on Lord-Shulman
Co-Authored-By: Claude Sonnet 5.5 <noreply@anthropic.com>
</commit_message>
<xml_diff>
--- a/claude/defense/DEFENSE_SLIDES_FA_R2.pptx
+++ b/claude/defense/DEFENSE_SLIDES_FA_R2.pptx
@@ -5,7 +5,7 @@
     <p:sldMasterId id="2147483648" r:id="rId1"/>
   </p:sldMasterIdLst>
   <p:notesMasterIdLst>
-    <p:notesMasterId r:id="rId34"/>
+    <p:notesMasterId r:id="rId43"/>
   </p:notesMasterIdLst>
   <p:sldIdLst>
     <p:sldId id="256" r:id="rId2"/>
@@ -40,6 +40,15 @@
     <p:sldId id="285" r:id="rId31"/>
     <p:sldId id="286" r:id="rId32"/>
     <p:sldId id="287" r:id="rId33"/>
+    <p:sldId id="288" r:id="rId34"/>
+    <p:sldId id="289" r:id="rId35"/>
+    <p:sldId id="290" r:id="rId36"/>
+    <p:sldId id="291" r:id="rId37"/>
+    <p:sldId id="292" r:id="rId38"/>
+    <p:sldId id="293" r:id="rId39"/>
+    <p:sldId id="294" r:id="rId40"/>
+    <p:sldId id="295" r:id="rId41"/>
+    <p:sldId id="296" r:id="rId42"/>
   </p:sldIdLst>
   <p:sldSz cx="9144000" cy="5143500" type="screen16x9"/>
   <p:notesSz cx="6858000" cy="9144000"/>
@@ -555,7 +564,7 @@
             </a:pPr>
             <a:r>
               <a:rPr/>
-              <a:t>با یک جملهٔ ملموس شروع کنید: «اگر جدارهٔ یک مخزن در چند ثانیه ۳۰۰ درجه گرم شود، مدل کلاسیک عملاً می‌گوید اثرِ آن بلافاصله به سطح بیرونی می‌رسد — که فیزیکی نیست.»</a:t>
+              <a:t>منبع: فصل ۱، بندهای ۱-۱ و ۱-۶. با کاربردهای ملموس شروع کنید؛ هنوز وارد نظریه نشوید.</a:t>
             </a:r>
           </a:p>
         </p:txBody>
@@ -637,7 +646,7 @@
             </a:pPr>
             <a:r>
               <a:rPr/>
-              <a:t>اگر پرسیدند «چرا مرجع تحلیلی و نه مقالهٔ چاپ‌شده؟» بگویید: حل دقیق برای همین هندسه استخراج شده، پس مقایسه بدون خطای رقمی‌سازیِ شکلِ مرجع و بدون اختلاف در فرضیات انجام می‌شود. پیشانی موج با دقت کمتر از یک فاصلهٔ شبکه ردیابی می‌شود.</a:t>
+              <a:t>منبع: فصل ۲، بند ۲-۶. مرجع‌های نزدیک را نام ببرید: [۳]، [۶۸]، [۷۰]. اگر داور پرسید «تفاوت شما با کار حیدرپور چیست؟» پاسخ در اسلاید بعد است.</a:t>
             </a:r>
           </a:p>
         </p:txBody>
@@ -659,7 +668,7 @@
           <a:p>
             <a:fld id="{18BDFEC3-8487-43E8-A154-7C12CBC1FFF2}" type="slidenum">
               <a:rPr lang="en-US"/>
-              <a:t>17</a:t>
+              <a:t>12</a:t>
             </a:fld>
             <a:endParaRPr lang="en-US"/>
           </a:p>
@@ -719,7 +728,7 @@
             </a:pPr>
             <a:r>
               <a:rPr/>
-              <a:t>راستای محوری راستای مقیدکننده است.</a:t>
+              <a:t>منبع: فصل ۲، بند ۲-۷. «تا آنجا که در این مرور بررسی شد» را بگویید؛ ادعای مطلق نکنید.</a:t>
             </a:r>
           </a:p>
         </p:txBody>
@@ -741,7 +750,7 @@
           <a:p>
             <a:fld id="{18BDFEC3-8487-43E8-A154-7C12CBC1FFF2}" type="slidenum">
               <a:rPr lang="en-US"/>
-              <a:t>18</a:t>
+              <a:t>13</a:t>
             </a:fld>
             <a:endParaRPr lang="en-US"/>
           </a:p>
@@ -801,7 +810,7 @@
             </a:pPr>
             <a:r>
               <a:rPr/>
-              <a:t>این مهم‌ترین یافتهٔ پایان‌نامه است. اینجا سرعت را کم کنید، جمله‌بندی را دقیق بگویید و توصیهٔ طراحی را صریح اعلام کنید.</a:t>
+              <a:t>منبع: فصل ۲، بند ۲-۷ (بند پایانی). هر مورد این فهرست یکی از شکاف‌های اسلاید قبل را پاسخ می‌دهد.</a:t>
             </a:r>
           </a:p>
         </p:txBody>
@@ -823,7 +832,7 @@
           <a:p>
             <a:fld id="{18BDFEC3-8487-43E8-A154-7C12CBC1FFF2}" type="slidenum">
               <a:rPr lang="en-US"/>
-              <a:t>22</a:t>
+              <a:t>14</a:t>
             </a:fld>
             <a:endParaRPr lang="en-US"/>
           </a:p>
@@ -883,7 +892,433 @@
             </a:pPr>
             <a:r>
               <a:rPr/>
-              <a:t>این قوی‌ترین استدلال شما به سود تئوری تعمیم‌یافته است.</a:t>
+              <a:t>تأکید: </a:t>
+            </a:r>
+            <a:r>
+              <a:rPr/>
+              <a:t>\tau^*=0.15</a:t>
+            </a:r>
+            <a:r>
+              <a:rPr/>
+              <a:t> پارامتر بی‌بعدِ اصلی است؛ </a:t>
+            </a:r>
+            <a:r>
+              <a:rPr/>
+              <a:t>\tau_0=418</a:t>
+            </a:r>
+            <a:r>
+              <a:rPr/>
+              <a:t> s مقیاس‌گذاریِ جدارهٔ ۰٫۵ متری است، نه خاصیتِ اندازه‌گیری‌شدهٔ یک ماده. اگر پرسیدند، بگویید این یک مطالعهٔ پارامتریِ بی‌بعد است.</a:t>
+            </a:r>
+          </a:p>
+        </p:txBody>
+      </p:sp>
+      <p:sp>
+        <p:nvSpPr>
+          <p:cNvPr id="4" name="Slide Number Placeholder 3"/>
+          <p:cNvSpPr>
+            <a:spLocks noGrp="1"/>
+          </p:cNvSpPr>
+          <p:nvPr>
+            <p:ph type="sldNum" sz="quarter" idx="10"/>
+          </p:nvPr>
+        </p:nvSpPr>
+        <p:spPr/>
+        <p:txBody>
+          <a:bodyPr/>
+          <a:lstStyle/>
+          <a:p>
+            <a:fld id="{18BDFEC3-8487-43E8-A154-7C12CBC1FFF2}" type="slidenum">
+              <a:rPr lang="en-US"/>
+              <a:t>16</a:t>
+            </a:fld>
+            <a:endParaRPr lang="en-US"/>
+          </a:p>
+        </p:txBody>
+      </p:sp>
+    </p:spTree>
+  </p:cSld>
+</p:notes>
+</file>
+
+<file path=ppt/notesSlides/notesSlide14.xml><?xml version="1.0" encoding="utf-8"?>
+<p:notes xmlns:a="http://schemas.openxmlformats.org/drawingml/2006/main" xmlns:r="http://schemas.openxmlformats.org/officeDocument/2006/relationships" xmlns:p="http://schemas.openxmlformats.org/presentationml/2006/main">
+  <p:cSld>
+    <p:spTree>
+      <p:nvGrpSpPr>
+        <p:cNvPr id="1" name=""/>
+        <p:cNvGrpSpPr/>
+        <p:nvPr/>
+      </p:nvGrpSpPr>
+      <p:grpSpPr>
+        <a:xfrm>
+          <a:off x="0" y="0"/>
+          <a:ext cx="0" cy="0"/>
+          <a:chOff x="0" y="0"/>
+          <a:chExt cx="0" cy="0"/>
+        </a:xfrm>
+      </p:grpSpPr>
+      <p:sp>
+        <p:nvSpPr>
+          <p:cNvPr id="2" name="Slide Image Placeholder 1"/>
+          <p:cNvSpPr>
+            <a:spLocks noGrp="1" noRot="1" noChangeAspect="1"/>
+          </p:cNvSpPr>
+          <p:nvPr>
+            <p:ph type="sldImg"/>
+          </p:nvPr>
+        </p:nvSpPr>
+        <p:spPr/>
+      </p:sp>
+      <p:sp>
+        <p:nvSpPr>
+          <p:cNvPr id="3" name="Notes Placeholder 2"/>
+          <p:cNvSpPr>
+            <a:spLocks noGrp="1"/>
+          </p:cNvSpPr>
+          <p:nvPr>
+            <p:ph type="body" idx="1"/>
+          </p:nvPr>
+        </p:nvSpPr>
+        <p:spPr/>
+        <p:txBody>
+          <a:bodyPr/>
+          <a:lstStyle/>
+          <a:p>
+            <a:pPr lvl="0" indent="0" marL="0">
+              <a:buNone/>
+            </a:pPr>
+            <a:r>
+              <a:rPr/>
+              <a:t>تأکید کنید V و A آینهٔ یکدیگرند — این نکته بعداً در یافتهٔ هم‌افزایی کلیدی می‌شود.</a:t>
+            </a:r>
+          </a:p>
+        </p:txBody>
+      </p:sp>
+      <p:sp>
+        <p:nvSpPr>
+          <p:cNvPr id="4" name="Slide Number Placeholder 3"/>
+          <p:cNvSpPr>
+            <a:spLocks noGrp="1"/>
+          </p:cNvSpPr>
+          <p:nvPr>
+            <p:ph type="sldNum" sz="quarter" idx="10"/>
+          </p:nvPr>
+        </p:nvSpPr>
+        <p:spPr/>
+        <p:txBody>
+          <a:bodyPr/>
+          <a:lstStyle/>
+          <a:p>
+            <a:fld id="{18BDFEC3-8487-43E8-A154-7C12CBC1FFF2}" type="slidenum">
+              <a:rPr lang="en-US"/>
+              <a:t>18</a:t>
+            </a:fld>
+            <a:endParaRPr lang="en-US"/>
+          </a:p>
+        </p:txBody>
+      </p:sp>
+    </p:spTree>
+  </p:cSld>
+</p:notes>
+</file>
+
+<file path=ppt/notesSlides/notesSlide15.xml><?xml version="1.0" encoding="utf-8"?>
+<p:notes xmlns:a="http://schemas.openxmlformats.org/drawingml/2006/main" xmlns:r="http://schemas.openxmlformats.org/officeDocument/2006/relationships" xmlns:p="http://schemas.openxmlformats.org/presentationml/2006/main">
+  <p:cSld>
+    <p:spTree>
+      <p:nvGrpSpPr>
+        <p:cNvPr id="1" name=""/>
+        <p:cNvGrpSpPr/>
+        <p:nvPr/>
+      </p:nvGrpSpPr>
+      <p:grpSpPr>
+        <a:xfrm>
+          <a:off x="0" y="0"/>
+          <a:ext cx="0" cy="0"/>
+          <a:chOff x="0" y="0"/>
+          <a:chExt cx="0" cy="0"/>
+        </a:xfrm>
+      </p:grpSpPr>
+      <p:sp>
+        <p:nvSpPr>
+          <p:cNvPr id="2" name="Slide Image Placeholder 1"/>
+          <p:cNvSpPr>
+            <a:spLocks noGrp="1" noRot="1" noChangeAspect="1"/>
+          </p:cNvSpPr>
+          <p:nvPr>
+            <p:ph type="sldImg"/>
+          </p:nvPr>
+        </p:nvSpPr>
+        <p:spPr/>
+      </p:sp>
+      <p:sp>
+        <p:nvSpPr>
+          <p:cNvPr id="3" name="Notes Placeholder 2"/>
+          <p:cNvSpPr>
+            <a:spLocks noGrp="1"/>
+          </p:cNvSpPr>
+          <p:nvPr>
+            <p:ph type="body" idx="1"/>
+          </p:nvPr>
+        </p:nvSpPr>
+        <p:spPr/>
+        <p:txBody>
+          <a:bodyPr/>
+          <a:lstStyle/>
+          <a:p>
+            <a:pPr lvl="0" indent="0" marL="0">
+              <a:buNone/>
+            </a:pPr>
+            <a:r>
+              <a:rPr/>
+              <a:t>فقط همین یک معادله را نشان دهید. اگر جزئیات استخراج را خواستند، اسلاید پشتیبان (فصل ۳) را باز کنید.</a:t>
+            </a:r>
+          </a:p>
+        </p:txBody>
+      </p:sp>
+      <p:sp>
+        <p:nvSpPr>
+          <p:cNvPr id="4" name="Slide Number Placeholder 3"/>
+          <p:cNvSpPr>
+            <a:spLocks noGrp="1"/>
+          </p:cNvSpPr>
+          <p:nvPr>
+            <p:ph type="sldNum" sz="quarter" idx="10"/>
+          </p:nvPr>
+        </p:nvSpPr>
+        <p:spPr/>
+        <p:txBody>
+          <a:bodyPr/>
+          <a:lstStyle/>
+          <a:p>
+            <a:fld id="{18BDFEC3-8487-43E8-A154-7C12CBC1FFF2}" type="slidenum">
+              <a:rPr lang="en-US"/>
+              <a:t>19</a:t>
+            </a:fld>
+            <a:endParaRPr lang="en-US"/>
+          </a:p>
+        </p:txBody>
+      </p:sp>
+    </p:spTree>
+  </p:cSld>
+</p:notes>
+</file>
+
+<file path=ppt/notesSlides/notesSlide16.xml><?xml version="1.0" encoding="utf-8"?>
+<p:notes xmlns:a="http://schemas.openxmlformats.org/drawingml/2006/main" xmlns:r="http://schemas.openxmlformats.org/officeDocument/2006/relationships" xmlns:p="http://schemas.openxmlformats.org/presentationml/2006/main">
+  <p:cSld>
+    <p:spTree>
+      <p:nvGrpSpPr>
+        <p:cNvPr id="1" name=""/>
+        <p:cNvGrpSpPr/>
+        <p:nvPr/>
+      </p:nvGrpSpPr>
+      <p:grpSpPr>
+        <a:xfrm>
+          <a:off x="0" y="0"/>
+          <a:ext cx="0" cy="0"/>
+          <a:chOff x="0" y="0"/>
+          <a:chExt cx="0" cy="0"/>
+        </a:xfrm>
+      </p:grpSpPr>
+      <p:sp>
+        <p:nvSpPr>
+          <p:cNvPr id="2" name="Slide Image Placeholder 1"/>
+          <p:cNvSpPr>
+            <a:spLocks noGrp="1" noRot="1" noChangeAspect="1"/>
+          </p:cNvSpPr>
+          <p:nvPr>
+            <p:ph type="sldImg"/>
+          </p:nvPr>
+        </p:nvSpPr>
+        <p:spPr/>
+      </p:sp>
+      <p:sp>
+        <p:nvSpPr>
+          <p:cNvPr id="3" name="Notes Placeholder 2"/>
+          <p:cNvSpPr>
+            <a:spLocks noGrp="1"/>
+          </p:cNvSpPr>
+          <p:nvPr>
+            <p:ph type="body" idx="1"/>
+          </p:nvPr>
+        </p:nvSpPr>
+        <p:spPr/>
+        <p:txBody>
+          <a:bodyPr/>
+          <a:lstStyle/>
+          <a:p>
+            <a:pPr lvl="0" indent="0" marL="0">
+              <a:buNone/>
+            </a:pPr>
+            <a:r>
+              <a:rPr/>
+              <a:t>اگر زمان کم است، این اسلاید و اسلاید قبل را حذف یا به پشتیبان ببرید.</a:t>
+            </a:r>
+          </a:p>
+        </p:txBody>
+      </p:sp>
+      <p:sp>
+        <p:nvSpPr>
+          <p:cNvPr id="4" name="Slide Number Placeholder 3"/>
+          <p:cNvSpPr>
+            <a:spLocks noGrp="1"/>
+          </p:cNvSpPr>
+          <p:nvPr>
+            <p:ph type="sldNum" sz="quarter" idx="10"/>
+          </p:nvPr>
+        </p:nvSpPr>
+        <p:spPr/>
+        <p:txBody>
+          <a:bodyPr/>
+          <a:lstStyle/>
+          <a:p>
+            <a:fld id="{18BDFEC3-8487-43E8-A154-7C12CBC1FFF2}" type="slidenum">
+              <a:rPr lang="en-US"/>
+              <a:t>22</a:t>
+            </a:fld>
+            <a:endParaRPr lang="en-US"/>
+          </a:p>
+        </p:txBody>
+      </p:sp>
+    </p:spTree>
+  </p:cSld>
+</p:notes>
+</file>
+
+<file path=ppt/notesSlides/notesSlide17.xml><?xml version="1.0" encoding="utf-8"?>
+<p:notes xmlns:a="http://schemas.openxmlformats.org/drawingml/2006/main" xmlns:r="http://schemas.openxmlformats.org/officeDocument/2006/relationships" xmlns:p="http://schemas.openxmlformats.org/presentationml/2006/main">
+  <p:cSld>
+    <p:spTree>
+      <p:nvGrpSpPr>
+        <p:cNvPr id="1" name=""/>
+        <p:cNvGrpSpPr/>
+        <p:nvPr/>
+      </p:nvGrpSpPr>
+      <p:grpSpPr>
+        <a:xfrm>
+          <a:off x="0" y="0"/>
+          <a:ext cx="0" cy="0"/>
+          <a:chOff x="0" y="0"/>
+          <a:chExt cx="0" cy="0"/>
+        </a:xfrm>
+      </p:grpSpPr>
+      <p:sp>
+        <p:nvSpPr>
+          <p:cNvPr id="2" name="Slide Image Placeholder 1"/>
+          <p:cNvSpPr>
+            <a:spLocks noGrp="1" noRot="1" noChangeAspect="1"/>
+          </p:cNvSpPr>
+          <p:nvPr>
+            <p:ph type="sldImg"/>
+          </p:nvPr>
+        </p:nvSpPr>
+        <p:spPr/>
+      </p:sp>
+      <p:sp>
+        <p:nvSpPr>
+          <p:cNvPr id="3" name="Notes Placeholder 2"/>
+          <p:cNvSpPr>
+            <a:spLocks noGrp="1"/>
+          </p:cNvSpPr>
+          <p:nvPr>
+            <p:ph type="body" idx="1"/>
+          </p:nvPr>
+        </p:nvSpPr>
+        <p:spPr/>
+        <p:txBody>
+          <a:bodyPr/>
+          <a:lstStyle/>
+          <a:p>
+            <a:pPr lvl="0" indent="0" marL="0">
+              <a:buNone/>
+            </a:pPr>
+            <a:r>
+              <a:rPr/>
+              <a:t>این مهم‌ترین سپرِ دفاعی شماست. آرام و با اعتمادبه‌نفس بخوانید.</a:t>
+            </a:r>
+          </a:p>
+        </p:txBody>
+      </p:sp>
+      <p:sp>
+        <p:nvSpPr>
+          <p:cNvPr id="4" name="Slide Number Placeholder 3"/>
+          <p:cNvSpPr>
+            <a:spLocks noGrp="1"/>
+          </p:cNvSpPr>
+          <p:nvPr>
+            <p:ph type="sldNum" sz="quarter" idx="10"/>
+          </p:nvPr>
+        </p:nvSpPr>
+        <p:spPr/>
+        <p:txBody>
+          <a:bodyPr/>
+          <a:lstStyle/>
+          <a:p>
+            <a:fld id="{18BDFEC3-8487-43E8-A154-7C12CBC1FFF2}" type="slidenum">
+              <a:rPr lang="en-US"/>
+              <a:t>23</a:t>
+            </a:fld>
+            <a:endParaRPr lang="en-US"/>
+          </a:p>
+        </p:txBody>
+      </p:sp>
+    </p:spTree>
+  </p:cSld>
+</p:notes>
+</file>
+
+<file path=ppt/notesSlides/notesSlide18.xml><?xml version="1.0" encoding="utf-8"?>
+<p:notes xmlns:a="http://schemas.openxmlformats.org/drawingml/2006/main" xmlns:r="http://schemas.openxmlformats.org/officeDocument/2006/relationships" xmlns:p="http://schemas.openxmlformats.org/presentationml/2006/main">
+  <p:cSld>
+    <p:spTree>
+      <p:nvGrpSpPr>
+        <p:cNvPr id="1" name=""/>
+        <p:cNvGrpSpPr/>
+        <p:nvPr/>
+      </p:nvGrpSpPr>
+      <p:grpSpPr>
+        <a:xfrm>
+          <a:off x="0" y="0"/>
+          <a:ext cx="0" cy="0"/>
+          <a:chOff x="0" y="0"/>
+          <a:chExt cx="0" cy="0"/>
+        </a:xfrm>
+      </p:grpSpPr>
+      <p:sp>
+        <p:nvSpPr>
+          <p:cNvPr id="2" name="Slide Image Placeholder 1"/>
+          <p:cNvSpPr>
+            <a:spLocks noGrp="1" noRot="1" noChangeAspect="1"/>
+          </p:cNvSpPr>
+          <p:nvPr>
+            <p:ph type="sldImg"/>
+          </p:nvPr>
+        </p:nvSpPr>
+        <p:spPr/>
+      </p:sp>
+      <p:sp>
+        <p:nvSpPr>
+          <p:cNvPr id="3" name="Notes Placeholder 2"/>
+          <p:cNvSpPr>
+            <a:spLocks noGrp="1"/>
+          </p:cNvSpPr>
+          <p:nvPr>
+            <p:ph type="body" idx="1"/>
+          </p:nvPr>
+        </p:nvSpPr>
+        <p:spPr/>
+        <p:txBody>
+          <a:bodyPr/>
+          <a:lstStyle/>
+          <a:p>
+            <a:pPr lvl="0" indent="0" marL="0">
+              <a:buNone/>
+            </a:pPr>
+            <a:r>
+              <a:rPr/>
+              <a:t>جابجایی شعاعی بی‌بعد سطح داخلی در برابر زمان؛ حل حاضر، مرجع و ANSYS. اختلاف ۰٫۱ تا ۰٫۲٪.</a:t>
             </a:r>
           </a:p>
         </p:txBody>
@@ -906,6 +1341,104 @@
             <a:fld id="{18BDFEC3-8487-43E8-A154-7C12CBC1FFF2}" type="slidenum">
               <a:rPr lang="en-US"/>
               <a:t>24</a:t>
+            </a:fld>
+            <a:endParaRPr lang="en-US"/>
+          </a:p>
+        </p:txBody>
+      </p:sp>
+    </p:spTree>
+  </p:cSld>
+</p:notes>
+</file>
+
+<file path=ppt/notesSlides/notesSlide19.xml><?xml version="1.0" encoding="utf-8"?>
+<p:notes xmlns:a="http://schemas.openxmlformats.org/drawingml/2006/main" xmlns:r="http://schemas.openxmlformats.org/officeDocument/2006/relationships" xmlns:p="http://schemas.openxmlformats.org/presentationml/2006/main">
+  <p:cSld>
+    <p:spTree>
+      <p:nvGrpSpPr>
+        <p:cNvPr id="1" name=""/>
+        <p:cNvGrpSpPr/>
+        <p:nvPr/>
+      </p:nvGrpSpPr>
+      <p:grpSpPr>
+        <a:xfrm>
+          <a:off x="0" y="0"/>
+          <a:ext cx="0" cy="0"/>
+          <a:chOff x="0" y="0"/>
+          <a:chExt cx="0" cy="0"/>
+        </a:xfrm>
+      </p:grpSpPr>
+      <p:sp>
+        <p:nvSpPr>
+          <p:cNvPr id="2" name="Slide Image Placeholder 1"/>
+          <p:cNvSpPr>
+            <a:spLocks noGrp="1" noRot="1" noChangeAspect="1"/>
+          </p:cNvSpPr>
+          <p:nvPr>
+            <p:ph type="sldImg"/>
+          </p:nvPr>
+        </p:nvSpPr>
+        <p:spPr/>
+      </p:sp>
+      <p:sp>
+        <p:nvSpPr>
+          <p:cNvPr id="3" name="Notes Placeholder 2"/>
+          <p:cNvSpPr>
+            <a:spLocks noGrp="1"/>
+          </p:cNvSpPr>
+          <p:nvPr>
+            <p:ph type="body" idx="1"/>
+          </p:nvPr>
+        </p:nvSpPr>
+        <p:spPr/>
+        <p:txBody>
+          <a:bodyPr/>
+          <a:lstStyle/>
+          <a:p>
+            <a:pPr lvl="0" indent="0" marL="0">
+              <a:buNone/>
+            </a:pPr>
+            <a:r>
+              <a:rPr/>
+              <a:t>نشانگرها حل حاضر و خط پیوسته حل دقیق سری بسل است؛ خطای </a:t>
+            </a:r>
+            <a:r>
+              <a:rPr/>
+              <a:t>10^{-5}</a:t>
+            </a:r>
+            <a:r>
+              <a:rPr/>
+              <a:t> تا </a:t>
+            </a:r>
+            <a:r>
+              <a:rPr/>
+              <a:t>10^{-7}</a:t>
+            </a:r>
+            <a:r>
+              <a:rPr/>
+              <a:t>.</a:t>
+            </a:r>
+          </a:p>
+        </p:txBody>
+      </p:sp>
+      <p:sp>
+        <p:nvSpPr>
+          <p:cNvPr id="4" name="Slide Number Placeholder 3"/>
+          <p:cNvSpPr>
+            <a:spLocks noGrp="1"/>
+          </p:cNvSpPr>
+          <p:nvPr>
+            <p:ph type="sldNum" sz="quarter" idx="10"/>
+          </p:nvPr>
+        </p:nvSpPr>
+        <p:spPr/>
+        <p:txBody>
+          <a:bodyPr/>
+          <a:lstStyle/>
+          <a:p>
+            <a:fld id="{18BDFEC3-8487-43E8-A154-7C12CBC1FFF2}" type="slidenum">
+              <a:rPr lang="en-US"/>
+              <a:t>25</a:t>
             </a:fld>
             <a:endParaRPr lang="en-US"/>
           </a:p>
@@ -965,7 +1498,7 @@
             </a:pPr>
             <a:r>
               <a:rPr/>
-              <a:t>اینجا اثبات می‌کنید «چرا کار شما تازه است». نام دو سه مرجعِ نزدیک را آماده داشته باشید و تفاوتتان را در یک جمله بگویید.</a:t>
+              <a:t>منبع: فصل ۱، بندهای ۱-۱ و ۱-۶.</a:t>
             </a:r>
           </a:p>
         </p:txBody>
@@ -987,7 +1520,335 @@
           <a:p>
             <a:fld id="{18BDFEC3-8487-43E8-A154-7C12CBC1FFF2}" type="slidenum">
               <a:rPr lang="en-US"/>
-              <a:t>5</a:t>
+              <a:t>4</a:t>
+            </a:fld>
+            <a:endParaRPr lang="en-US"/>
+          </a:p>
+        </p:txBody>
+      </p:sp>
+    </p:spTree>
+  </p:cSld>
+</p:notes>
+</file>
+
+<file path=ppt/notesSlides/notesSlide20.xml><?xml version="1.0" encoding="utf-8"?>
+<p:notes xmlns:a="http://schemas.openxmlformats.org/drawingml/2006/main" xmlns:r="http://schemas.openxmlformats.org/officeDocument/2006/relationships" xmlns:p="http://schemas.openxmlformats.org/presentationml/2006/main">
+  <p:cSld>
+    <p:spTree>
+      <p:nvGrpSpPr>
+        <p:cNvPr id="1" name=""/>
+        <p:cNvGrpSpPr/>
+        <p:nvPr/>
+      </p:nvGrpSpPr>
+      <p:grpSpPr>
+        <a:xfrm>
+          <a:off x="0" y="0"/>
+          <a:ext cx="0" cy="0"/>
+          <a:chOff x="0" y="0"/>
+          <a:chExt cx="0" cy="0"/>
+        </a:xfrm>
+      </p:grpSpPr>
+      <p:sp>
+        <p:nvSpPr>
+          <p:cNvPr id="2" name="Slide Image Placeholder 1"/>
+          <p:cNvSpPr>
+            <a:spLocks noGrp="1" noRot="1" noChangeAspect="1"/>
+          </p:cNvSpPr>
+          <p:nvPr>
+            <p:ph type="sldImg"/>
+          </p:nvPr>
+        </p:nvSpPr>
+        <p:spPr/>
+      </p:sp>
+      <p:sp>
+        <p:nvSpPr>
+          <p:cNvPr id="3" name="Notes Placeholder 2"/>
+          <p:cNvSpPr>
+            <a:spLocks noGrp="1"/>
+          </p:cNvSpPr>
+          <p:nvPr>
+            <p:ph type="body" idx="1"/>
+          </p:nvPr>
+        </p:nvSpPr>
+        <p:spPr/>
+        <p:txBody>
+          <a:bodyPr/>
+          <a:lstStyle/>
+          <a:p>
+            <a:pPr lvl="0" indent="0" marL="0">
+              <a:buNone/>
+            </a:pPr>
+            <a:r>
+              <a:rPr/>
+              <a:t>اگر پرسیدند «چرا مرجع تحلیلی و نه مقالهٔ چاپ‌شده؟» بگویید: حل دقیق برای همین هندسه استخراج شده، پس مقایسه بدون خطای رقمی‌سازیِ شکلِ مرجع و بدون اختلاف در فرضیات انجام می‌شود. پیشانی موج با دقت کمتر از یک فاصلهٔ شبکه ردیابی می‌شود.</a:t>
+            </a:r>
+          </a:p>
+        </p:txBody>
+      </p:sp>
+      <p:sp>
+        <p:nvSpPr>
+          <p:cNvPr id="4" name="Slide Number Placeholder 3"/>
+          <p:cNvSpPr>
+            <a:spLocks noGrp="1"/>
+          </p:cNvSpPr>
+          <p:nvPr>
+            <p:ph type="sldNum" sz="quarter" idx="10"/>
+          </p:nvPr>
+        </p:nvSpPr>
+        <p:spPr/>
+        <p:txBody>
+          <a:bodyPr/>
+          <a:lstStyle/>
+          <a:p>
+            <a:fld id="{18BDFEC3-8487-43E8-A154-7C12CBC1FFF2}" type="slidenum">
+              <a:rPr lang="en-US"/>
+              <a:t>26</a:t>
+            </a:fld>
+            <a:endParaRPr lang="en-US"/>
+          </a:p>
+        </p:txBody>
+      </p:sp>
+    </p:spTree>
+  </p:cSld>
+</p:notes>
+</file>
+
+<file path=ppt/notesSlides/notesSlide21.xml><?xml version="1.0" encoding="utf-8"?>
+<p:notes xmlns:a="http://schemas.openxmlformats.org/drawingml/2006/main" xmlns:r="http://schemas.openxmlformats.org/officeDocument/2006/relationships" xmlns:p="http://schemas.openxmlformats.org/presentationml/2006/main">
+  <p:cSld>
+    <p:spTree>
+      <p:nvGrpSpPr>
+        <p:cNvPr id="1" name=""/>
+        <p:cNvGrpSpPr/>
+        <p:nvPr/>
+      </p:nvGrpSpPr>
+      <p:grpSpPr>
+        <a:xfrm>
+          <a:off x="0" y="0"/>
+          <a:ext cx="0" cy="0"/>
+          <a:chOff x="0" y="0"/>
+          <a:chExt cx="0" cy="0"/>
+        </a:xfrm>
+      </p:grpSpPr>
+      <p:sp>
+        <p:nvSpPr>
+          <p:cNvPr id="2" name="Slide Image Placeholder 1"/>
+          <p:cNvSpPr>
+            <a:spLocks noGrp="1" noRot="1" noChangeAspect="1"/>
+          </p:cNvSpPr>
+          <p:nvPr>
+            <p:ph type="sldImg"/>
+          </p:nvPr>
+        </p:nvSpPr>
+        <p:spPr/>
+      </p:sp>
+      <p:sp>
+        <p:nvSpPr>
+          <p:cNvPr id="3" name="Notes Placeholder 2"/>
+          <p:cNvSpPr>
+            <a:spLocks noGrp="1"/>
+          </p:cNvSpPr>
+          <p:nvPr>
+            <p:ph type="body" idx="1"/>
+          </p:nvPr>
+        </p:nvSpPr>
+        <p:spPr/>
+        <p:txBody>
+          <a:bodyPr/>
+          <a:lstStyle/>
+          <a:p>
+            <a:pPr lvl="0" indent="0" marL="0">
+              <a:buNone/>
+            </a:pPr>
+            <a:r>
+              <a:rPr/>
+              <a:t>راستای محوری راستای مقیدکننده است.</a:t>
+            </a:r>
+          </a:p>
+        </p:txBody>
+      </p:sp>
+      <p:sp>
+        <p:nvSpPr>
+          <p:cNvPr id="4" name="Slide Number Placeholder 3"/>
+          <p:cNvSpPr>
+            <a:spLocks noGrp="1"/>
+          </p:cNvSpPr>
+          <p:nvPr>
+            <p:ph type="sldNum" sz="quarter" idx="10"/>
+          </p:nvPr>
+        </p:nvSpPr>
+        <p:spPr/>
+        <p:txBody>
+          <a:bodyPr/>
+          <a:lstStyle/>
+          <a:p>
+            <a:fld id="{18BDFEC3-8487-43E8-A154-7C12CBC1FFF2}" type="slidenum">
+              <a:rPr lang="en-US"/>
+              <a:t>27</a:t>
+            </a:fld>
+            <a:endParaRPr lang="en-US"/>
+          </a:p>
+        </p:txBody>
+      </p:sp>
+    </p:spTree>
+  </p:cSld>
+</p:notes>
+</file>
+
+<file path=ppt/notesSlides/notesSlide22.xml><?xml version="1.0" encoding="utf-8"?>
+<p:notes xmlns:a="http://schemas.openxmlformats.org/drawingml/2006/main" xmlns:r="http://schemas.openxmlformats.org/officeDocument/2006/relationships" xmlns:p="http://schemas.openxmlformats.org/presentationml/2006/main">
+  <p:cSld>
+    <p:spTree>
+      <p:nvGrpSpPr>
+        <p:cNvPr id="1" name=""/>
+        <p:cNvGrpSpPr/>
+        <p:nvPr/>
+      </p:nvGrpSpPr>
+      <p:grpSpPr>
+        <a:xfrm>
+          <a:off x="0" y="0"/>
+          <a:ext cx="0" cy="0"/>
+          <a:chOff x="0" y="0"/>
+          <a:chExt cx="0" cy="0"/>
+        </a:xfrm>
+      </p:grpSpPr>
+      <p:sp>
+        <p:nvSpPr>
+          <p:cNvPr id="2" name="Slide Image Placeholder 1"/>
+          <p:cNvSpPr>
+            <a:spLocks noGrp="1" noRot="1" noChangeAspect="1"/>
+          </p:cNvSpPr>
+          <p:nvPr>
+            <p:ph type="sldImg"/>
+          </p:nvPr>
+        </p:nvSpPr>
+        <p:spPr/>
+      </p:sp>
+      <p:sp>
+        <p:nvSpPr>
+          <p:cNvPr id="3" name="Notes Placeholder 2"/>
+          <p:cNvSpPr>
+            <a:spLocks noGrp="1"/>
+          </p:cNvSpPr>
+          <p:nvPr>
+            <p:ph type="body" idx="1"/>
+          </p:nvPr>
+        </p:nvSpPr>
+        <p:spPr/>
+        <p:txBody>
+          <a:bodyPr/>
+          <a:lstStyle/>
+          <a:p>
+            <a:pPr lvl="0" indent="0" marL="0">
+              <a:buNone/>
+            </a:pPr>
+            <a:r>
+              <a:rPr/>
+              <a:t>این مهم‌ترین یافتهٔ پایان‌نامه است. اینجا سرعت را کم کنید، جمله‌بندی را دقیق بگویید و توصیهٔ طراحی را صریح اعلام کنید.</a:t>
+            </a:r>
+          </a:p>
+        </p:txBody>
+      </p:sp>
+      <p:sp>
+        <p:nvSpPr>
+          <p:cNvPr id="4" name="Slide Number Placeholder 3"/>
+          <p:cNvSpPr>
+            <a:spLocks noGrp="1"/>
+          </p:cNvSpPr>
+          <p:nvPr>
+            <p:ph type="sldNum" sz="quarter" idx="10"/>
+          </p:nvPr>
+        </p:nvSpPr>
+        <p:spPr/>
+        <p:txBody>
+          <a:bodyPr/>
+          <a:lstStyle/>
+          <a:p>
+            <a:fld id="{18BDFEC3-8487-43E8-A154-7C12CBC1FFF2}" type="slidenum">
+              <a:rPr lang="en-US"/>
+              <a:t>31</a:t>
+            </a:fld>
+            <a:endParaRPr lang="en-US"/>
+          </a:p>
+        </p:txBody>
+      </p:sp>
+    </p:spTree>
+  </p:cSld>
+</p:notes>
+</file>
+
+<file path=ppt/notesSlides/notesSlide23.xml><?xml version="1.0" encoding="utf-8"?>
+<p:notes xmlns:a="http://schemas.openxmlformats.org/drawingml/2006/main" xmlns:r="http://schemas.openxmlformats.org/officeDocument/2006/relationships" xmlns:p="http://schemas.openxmlformats.org/presentationml/2006/main">
+  <p:cSld>
+    <p:spTree>
+      <p:nvGrpSpPr>
+        <p:cNvPr id="1" name=""/>
+        <p:cNvGrpSpPr/>
+        <p:nvPr/>
+      </p:nvGrpSpPr>
+      <p:grpSpPr>
+        <a:xfrm>
+          <a:off x="0" y="0"/>
+          <a:ext cx="0" cy="0"/>
+          <a:chOff x="0" y="0"/>
+          <a:chExt cx="0" cy="0"/>
+        </a:xfrm>
+      </p:grpSpPr>
+      <p:sp>
+        <p:nvSpPr>
+          <p:cNvPr id="2" name="Slide Image Placeholder 1"/>
+          <p:cNvSpPr>
+            <a:spLocks noGrp="1" noRot="1" noChangeAspect="1"/>
+          </p:cNvSpPr>
+          <p:nvPr>
+            <p:ph type="sldImg"/>
+          </p:nvPr>
+        </p:nvSpPr>
+        <p:spPr/>
+      </p:sp>
+      <p:sp>
+        <p:nvSpPr>
+          <p:cNvPr id="3" name="Notes Placeholder 2"/>
+          <p:cNvSpPr>
+            <a:spLocks noGrp="1"/>
+          </p:cNvSpPr>
+          <p:nvPr>
+            <p:ph type="body" idx="1"/>
+          </p:nvPr>
+        </p:nvSpPr>
+        <p:spPr/>
+        <p:txBody>
+          <a:bodyPr/>
+          <a:lstStyle/>
+          <a:p>
+            <a:pPr lvl="0" indent="0" marL="0">
+              <a:buNone/>
+            </a:pPr>
+            <a:r>
+              <a:rPr/>
+              <a:t>این یافته را با ذکر شرایط (پالس گاوسی) و بدون مبالغه بیان کنید.</a:t>
+            </a:r>
+          </a:p>
+        </p:txBody>
+      </p:sp>
+      <p:sp>
+        <p:nvSpPr>
+          <p:cNvPr id="4" name="Slide Number Placeholder 3"/>
+          <p:cNvSpPr>
+            <a:spLocks noGrp="1"/>
+          </p:cNvSpPr>
+          <p:nvPr>
+            <p:ph type="sldNum" sz="quarter" idx="10"/>
+          </p:nvPr>
+        </p:nvSpPr>
+        <p:spPr/>
+        <p:txBody>
+          <a:bodyPr/>
+          <a:lstStyle/>
+          <a:p>
+            <a:fld id="{18BDFEC3-8487-43E8-A154-7C12CBC1FFF2}" type="slidenum">
+              <a:rPr lang="en-US"/>
+              <a:t>33</a:t>
             </a:fld>
             <a:endParaRPr lang="en-US"/>
           </a:p>
@@ -1047,23 +1908,7 @@
             </a:pPr>
             <a:r>
               <a:rPr/>
-              <a:t>تأکید: </a:t>
-            </a:r>
-            <a:r>
-              <a:rPr/>
-              <a:t>\tau^*=0.15</a:t>
-            </a:r>
-            <a:r>
-              <a:rPr/>
-              <a:t> پارامتر بی‌بعدِ اصلی است؛ </a:t>
-            </a:r>
-            <a:r>
-              <a:rPr/>
-              <a:t>\tau_0=418</a:t>
-            </a:r>
-            <a:r>
-              <a:rPr/>
-              <a:t> s مقیاس‌گذاریِ جدارهٔ ۰٫۵ متری است، نه خاصیتِ اندازه‌گیری‌شدهٔ یک ماده. اگر پرسیدند، بگویید این یک مطالعهٔ پارامتریِ بی‌بعد است.</a:t>
+              <a:t>منبع: فصل ۱، بندهای ۱-۱ (بند چهارم) و ۱-۳. لرد–شولمن را فقط یکی از تئوری‌های تعمیم‌یافته معرفی کنید؛ مقایسهٔ تئوری‌ها در پیشینه و در نتیجهٔ ۷ می‌آید.</a:t>
             </a:r>
           </a:p>
         </p:txBody>
@@ -1085,7 +1930,7 @@
           <a:p>
             <a:fld id="{18BDFEC3-8487-43E8-A154-7C12CBC1FFF2}" type="slidenum">
               <a:rPr lang="en-US"/>
-              <a:t>7</a:t>
+              <a:t>5</a:t>
             </a:fld>
             <a:endParaRPr lang="en-US"/>
           </a:p>
@@ -1145,7 +1990,7 @@
             </a:pPr>
             <a:r>
               <a:rPr/>
-              <a:t>تأکید کنید V و A آینهٔ یکدیگرند — این نکته بعداً در یافتهٔ هم‌افزایی کلیدی می‌شود.</a:t>
+              <a:t>منبع: فصل ۱، بند ۱-۴. این چهار پرسش را در بخش نتایج دوباره به‌ترتیب پاسخ می‌دهید.</a:t>
             </a:r>
           </a:p>
         </p:txBody>
@@ -1167,7 +2012,7 @@
           <a:p>
             <a:fld id="{18BDFEC3-8487-43E8-A154-7C12CBC1FFF2}" type="slidenum">
               <a:rPr lang="en-US"/>
-              <a:t>9</a:t>
+              <a:t>6</a:t>
             </a:fld>
             <a:endParaRPr lang="en-US"/>
           </a:p>
@@ -1227,7 +2072,7 @@
             </a:pPr>
             <a:r>
               <a:rPr/>
-              <a:t>فقط همین یک معادله را نشان دهید. اگر جزئیات استخراج را خواستند، اسلاید پشتیبان (فصل ۳) را باز کنید.</a:t>
+              <a:t>منبع: فصل ۲، بند ۲-۲. این اسلاید توجیه می‌کند چرا مسئله را در صفحهٔ (r,z) و نه با تئوری پوسته حل کرده‌اید.</a:t>
             </a:r>
           </a:p>
         </p:txBody>
@@ -1249,7 +2094,7 @@
           <a:p>
             <a:fld id="{18BDFEC3-8487-43E8-A154-7C12CBC1FFF2}" type="slidenum">
               <a:rPr lang="en-US"/>
-              <a:t>10</a:t>
+              <a:t>7</a:t>
             </a:fld>
             <a:endParaRPr lang="en-US"/>
           </a:p>
@@ -1309,7 +2154,7 @@
             </a:pPr>
             <a:r>
               <a:rPr/>
-              <a:t>اگر زمان کم است، این اسلاید و اسلاید قبل را حذف یا به پشتیبان ببرید.</a:t>
+              <a:t>شکل ۲-۱ پایان‌نامه. فقط جایگاه نظریه‌ها را نشان دهید؛ دربارهٔ برتری هیچ‌کدام صحبت نکنید.</a:t>
             </a:r>
           </a:p>
         </p:txBody>
@@ -1331,7 +2176,7 @@
           <a:p>
             <a:fld id="{18BDFEC3-8487-43E8-A154-7C12CBC1FFF2}" type="slidenum">
               <a:rPr lang="en-US"/>
-              <a:t>13</a:t>
+              <a:t>8</a:t>
             </a:fld>
             <a:endParaRPr lang="en-US"/>
           </a:p>
@@ -1391,7 +2236,7 @@
             </a:pPr>
             <a:r>
               <a:rPr/>
-              <a:t>این مهم‌ترین سپرِ دفاعی شماست. آرام و با اعتمادبه‌نفس بخوانید.</a:t>
+              <a:t>منبع: فصل ۲، بند ۲-۳. نام‌ها را مرور سریع بگویید؛ پیام: روش‌ها متنوع‌اند و DQM + نیومارک در این خانواده سابقه دارد.</a:t>
             </a:r>
           </a:p>
         </p:txBody>
@@ -1413,7 +2258,7 @@
           <a:p>
             <a:fld id="{18BDFEC3-8487-43E8-A154-7C12CBC1FFF2}" type="slidenum">
               <a:rPr lang="en-US"/>
-              <a:t>14</a:t>
+              <a:t>9</a:t>
             </a:fld>
             <a:endParaRPr lang="en-US"/>
           </a:p>
@@ -1473,7 +2318,7 @@
             </a:pPr>
             <a:r>
               <a:rPr/>
-              <a:t>جابجایی شعاعی بی‌بعد سطح داخلی در برابر زمان؛ حل حاضر، مرجع و ANSYS. اختلاف ۰٫۱ تا ۰٫۲٪.</a:t>
+              <a:t>منبع: فصل ۲، بند ۲-۴. تأکید: ترکیب «DQM لایه‌ای + نیومارک» که در این پایان‌نامه به‌کار رفته، روشی جاافتاده است [۳۱، ۳۶].</a:t>
             </a:r>
           </a:p>
         </p:txBody>
@@ -1495,7 +2340,7 @@
           <a:p>
             <a:fld id="{18BDFEC3-8487-43E8-A154-7C12CBC1FFF2}" type="slidenum">
               <a:rPr lang="en-US"/>
-              <a:t>15</a:t>
+              <a:t>10</a:t>
             </a:fld>
             <a:endParaRPr lang="en-US"/>
           </a:p>
@@ -1555,23 +2400,7 @@
             </a:pPr>
             <a:r>
               <a:rPr/>
-              <a:t>نشانگرها حل حاضر و خط پیوسته حل دقیق سری بسل است؛ خطای </a:t>
-            </a:r>
-            <a:r>
-              <a:rPr/>
-              <a:t>10^{-5}</a:t>
-            </a:r>
-            <a:r>
-              <a:rPr/>
-              <a:t> تا </a:t>
-            </a:r>
-            <a:r>
-              <a:rPr/>
-              <a:t>10^{-7}</a:t>
-            </a:r>
-            <a:r>
-              <a:rPr/>
-              <a:t>.</a:t>
+              <a:t>منبع: فصل ۲، بند ۲-۵. نکتهٔ مشترک: الگوی توزیع گرافن و تخلخل در همهٔ این کارها اثر تعیین‌کننده دارد، و بیشترشان مکانیکی یا حرارتی پایا هستند.</a:t>
             </a:r>
           </a:p>
         </p:txBody>
@@ -1593,7 +2422,7 @@
           <a:p>
             <a:fld id="{18BDFEC3-8487-43E8-A154-7C12CBC1FFF2}" type="slidenum">
               <a:rPr lang="en-US"/>
-              <a:t>16</a:t>
+              <a:t>11</a:t>
             </a:fld>
             <a:endParaRPr lang="en-US"/>
           </a:p>
@@ -5105,7 +5934,7 @@
         </a:spcBef>
         <a:buFont typeface="Arial"/>
         <a:buChar char="•"/>
-        <a:defRPr kern="1200" sz="1800" lang="fa-IR" dirty="0">
+        <a:defRPr kern="1200" sz="1600" lang="fa-IR" dirty="0">
           <a:solidFill>
             <a:schemeClr val="tx1"/>
           </a:solidFill>
@@ -5120,7 +5949,7 @@
         </a:spcBef>
         <a:buFont typeface="Arial"/>
         <a:buChar char="–"/>
-        <a:defRPr kern="1200" sz="1600" lang="fa-IR" dirty="0">
+        <a:defRPr kern="1200" sz="1400" lang="fa-IR" dirty="0">
           <a:solidFill>
             <a:schemeClr val="tx1"/>
           </a:solidFill>
@@ -5493,7 +6322,1329 @@
                 <a:latin typeface="Tahoma"/>
                 <a:cs typeface="Tahoma"/>
               </a:rPr>
-              <a:t>معادلهٔ انرژی لرد-شولمن: گرما به‌صورت موج</a:t>
+              <a:t>پیشینه ۴: استوانه تحت بار ترمو-مکانیکی و نقش روش DQM</a:t>
+            </a:r>
+          </a:p>
+        </p:txBody>
+      </p:sp>
+      <p:sp>
+        <p:nvSpPr>
+          <p:cNvPr id="3" name="Content Placeholder 2"/>
+          <p:cNvSpPr>
+            <a:spLocks noGrp="1"/>
+          </p:cNvSpPr>
+          <p:nvPr>
+            <p:ph idx="1"/>
+          </p:nvPr>
+        </p:nvSpPr>
+        <p:spPr/>
+        <p:txBody>
+          <a:bodyPr/>
+          <a:lstStyle/>
+          <a:p>
+            <a:pPr lvl="0" rtl="1" algn="r"/>
+            <a:r>
+              <a:rPr lang="fa-IR" dirty="0">
+                <a:latin typeface="Tahoma"/>
+                <a:cs typeface="Tahoma"/>
+              </a:rPr>
+              <a:t>هفت‌چناری و درویزه (۲۰۰۷): DQM با شبکهٔ کم‌گره و دقت بالا [۲۳]؛ حیدرپور و همکاران (۲۰۱۲): استوانهٔ مدرج دوار با خواص وابسته به دما [۲۸].</a:t>
+            </a:r>
+          </a:p>
+          <a:p>
+            <a:pPr lvl="0" rtl="1" algn="r"/>
+            <a:r>
+              <a:rPr lang="fa-IR" dirty="0">
+                <a:latin typeface="Tahoma"/>
+                <a:cs typeface="Tahoma"/>
+              </a:rPr>
+              <a:t>ملک‌زاده و همکاران (۲۰۱۲): پاسخ گذرای پوستهٔ چندلایه با DQM در مکان و </a:t>
+            </a:r>
+            <a:r>
+              <a:rPr b="1" lang="fa-IR" dirty="0">
+                <a:latin typeface="Tahoma"/>
+                <a:cs typeface="Tahoma"/>
+              </a:rPr>
+              <a:t>نیومارک</a:t>
+            </a:r>
+            <a:r>
+              <a:rPr lang="fa-IR" dirty="0">
+                <a:latin typeface="Tahoma"/>
+                <a:cs typeface="Tahoma"/>
+              </a:rPr>
+              <a:t> در زمان [۳۱]؛ ملک‌زاده و حیدرپور (۲۰۱۲): بار متحرک با هدایت هذلولوی [۳۲].</a:t>
+            </a:r>
+          </a:p>
+          <a:p>
+            <a:pPr lvl="0" rtl="1" algn="r"/>
+            <a:r>
+              <a:rPr lang="fa-IR" dirty="0">
+                <a:latin typeface="Tahoma"/>
+                <a:cs typeface="Tahoma"/>
+              </a:rPr>
+              <a:t>ینگ و وانگ (۲۰۱۰): شوک حرارتی غیریکنواخت [۲۷]؛ کانلیکاما و همکاران (۲۰۱۳): استوانه تحت فشار داخلی [۳۵]؛ نجیبی و طالبی‌توتی (۲۰۱۷): خواص غیرخطی وابسته به دما [۳۹].</a:t>
+            </a:r>
+          </a:p>
+          <a:p>
+            <a:pPr lvl="0" rtl="1" algn="r"/>
+            <a:r>
+              <a:rPr lang="fa-IR" dirty="0">
+                <a:latin typeface="Tahoma"/>
+                <a:cs typeface="Tahoma"/>
+              </a:rPr>
+              <a:t>دانشجو و طالبی‌توتی (۲۰۱۴): DQM لایه‌ای؛ دقت و همگرایی سریع [۳۶].</a:t>
+            </a:r>
+          </a:p>
+          <a:p>
+            <a:pPr lvl="0" rtl="1" algn="r"/>
+            <a:r>
+              <a:rPr lang="fa-IR" dirty="0">
+                <a:latin typeface="Tahoma"/>
+                <a:cs typeface="Tahoma"/>
+              </a:rPr>
+              <a:t>حیدرپور و همکاران (۲۰۲۰): پوستهٔ تقویت‌شده با گرافن، بار ترمو-مکانیکی دینامیکی [۴۶]؛ رحیمی و همکاران (۲۰۲۰): تحلیل سه‌بعدی استوانهٔ متخلخل گرافنی با هالپین–تسای [۴۷].</a:t>
+            </a:r>
+          </a:p>
+        </p:txBody>
+      </p:sp>
+    </p:spTree>
+  </p:cSld>
+</p:sld>
+</file>
+
+<file path=ppt/slides/slide11.xml><?xml version="1.0" encoding="utf-8"?>
+<p:sld xmlns:a="http://schemas.openxmlformats.org/drawingml/2006/main" xmlns:r="http://schemas.openxmlformats.org/officeDocument/2006/relationships" xmlns:p="http://schemas.openxmlformats.org/presentationml/2006/main">
+  <p:cSld>
+    <p:spTree>
+      <p:nvGrpSpPr>
+        <p:cNvPr id="1" name=""/>
+        <p:cNvGrpSpPr/>
+        <p:nvPr/>
+      </p:nvGrpSpPr>
+      <p:grpSpPr>
+        <a:xfrm>
+          <a:off x="0" y="0"/>
+          <a:ext cx="0" cy="0"/>
+          <a:chOff x="0" y="0"/>
+          <a:chExt cx="0" cy="0"/>
+        </a:xfrm>
+      </p:grpSpPr>
+      <p:sp>
+        <p:nvSpPr>
+          <p:cNvPr id="2" name="Title 1"/>
+          <p:cNvSpPr>
+            <a:spLocks noGrp="1"/>
+          </p:cNvSpPr>
+          <p:nvPr>
+            <p:ph type="title"/>
+          </p:nvPr>
+        </p:nvSpPr>
+        <p:spPr/>
+        <p:txBody>
+          <a:bodyPr/>
+          <a:lstStyle/>
+          <a:p>
+            <a:pPr lvl="0" indent="0" marL="0" rtl="1" algn="r">
+              <a:buNone/>
+            </a:pPr>
+            <a:r>
+              <a:rPr lang="fa-IR" dirty="0">
+                <a:latin typeface="Tahoma"/>
+                <a:cs typeface="Tahoma"/>
+              </a:rPr>
+              <a:t>پیشینه ۵: مواد مرکب متخلخل تقویت‌شده با گرافن</a:t>
+            </a:r>
+          </a:p>
+        </p:txBody>
+      </p:sp>
+      <p:sp>
+        <p:nvSpPr>
+          <p:cNvPr id="3" name="Content Placeholder 2"/>
+          <p:cNvSpPr>
+            <a:spLocks noGrp="1"/>
+          </p:cNvSpPr>
+          <p:nvPr>
+            <p:ph idx="1"/>
+          </p:nvPr>
+        </p:nvSpPr>
+        <p:spPr/>
+        <p:txBody>
+          <a:bodyPr/>
+          <a:lstStyle/>
+          <a:p>
+            <a:pPr lvl="0" rtl="1" algn="r"/>
+            <a:r>
+              <a:rPr lang="fa-IR" dirty="0">
+                <a:latin typeface="Tahoma"/>
+                <a:cs typeface="Tahoma"/>
+              </a:rPr>
+              <a:t>یاس و رحیمی (۲۰۲۰): کمانش حرارتی تیر؛ تخلخل دمای بحرانی را کم و گرافن مقاومت را زیاد می‌کند. مدل سلول‌باز این کار، مبنای مدل تخلخل پژوهش حاضر است [۵۱].</a:t>
+            </a:r>
+          </a:p>
+          <a:p>
+            <a:pPr lvl="0" rtl="1" algn="r"/>
+            <a:r>
+              <a:rPr lang="fa-IR" dirty="0">
+                <a:latin typeface="Tahoma"/>
+                <a:cs typeface="Tahoma"/>
+              </a:rPr>
+              <a:t>مرادی‌دستجردی و بهدینان (۲۰۲۱): تنش در استوانهٔ جدارضخیم مدرج متخلخل گرافنی در حالت پایا [۵۲]؛ سلمانی و همکاران (۲۰۲۱): پس‌کمانش پوستهٔ استوانه‌ای [۵۳].</a:t>
+            </a:r>
+          </a:p>
+          <a:p>
+            <a:pPr lvl="0" rtl="1" algn="r"/>
+            <a:r>
+              <a:rPr lang="fa-IR" dirty="0">
+                <a:latin typeface="Tahoma"/>
+                <a:cs typeface="Tahoma"/>
+              </a:rPr>
+              <a:t>بابایی و همکاران (۲۰۲۲): مخروط ناقص دوار تحت بار حرارتی گذرا؛ گرافن جابجایی را کم و تخلخل آن را زیاد می‌کند [۵۵].</a:t>
+            </a:r>
+          </a:p>
+          <a:p>
+            <a:pPr lvl="0" rtl="1" algn="r"/>
+            <a:r>
+              <a:rPr lang="fa-IR" dirty="0">
+                <a:latin typeface="Tahoma"/>
+                <a:cs typeface="Tahoma"/>
+              </a:rPr>
+              <a:t>چو (۲۰۲۳)، ژانگ و همکاران (۲۰۲۳): پانل استوانه‌ای؛ پاسخ به مقدار و الگوی توزیع گرافن و تخلخل بسیار وابسته است؛ تبدیل کسر وزنی به حجمی [۵۷، ۵۸، ۶۰].</a:t>
+            </a:r>
+          </a:p>
+          <a:p>
+            <a:pPr lvl="0" rtl="1" algn="r"/>
+            <a:r>
+              <a:rPr lang="fa-IR" dirty="0">
+                <a:latin typeface="Tahoma"/>
+                <a:cs typeface="Tahoma"/>
+              </a:rPr>
+              <a:t>هوانگ و همکاران (۲۰۲۴)، جمشیدی و عارف (۲۰۲۴)، سیتلی و همکاران (۲۰۲۴): کمانش مخروط، رفتار الاستیک استوانه، خمش تیر [۶۱–۶۳].</a:t>
+            </a:r>
+          </a:p>
+        </p:txBody>
+      </p:sp>
+    </p:spTree>
+  </p:cSld>
+</p:sld>
+</file>
+
+<file path=ppt/slides/slide12.xml><?xml version="1.0" encoding="utf-8"?>
+<p:sld xmlns:a="http://schemas.openxmlformats.org/drawingml/2006/main" xmlns:r="http://schemas.openxmlformats.org/officeDocument/2006/relationships" xmlns:p="http://schemas.openxmlformats.org/presentationml/2006/main">
+  <p:cSld>
+    <p:spTree>
+      <p:nvGrpSpPr>
+        <p:cNvPr id="1" name=""/>
+        <p:cNvGrpSpPr/>
+        <p:nvPr/>
+      </p:nvGrpSpPr>
+      <p:grpSpPr>
+        <a:xfrm>
+          <a:off x="0" y="0"/>
+          <a:ext cx="0" cy="0"/>
+          <a:chOff x="0" y="0"/>
+          <a:chExt cx="0" cy="0"/>
+        </a:xfrm>
+      </p:grpSpPr>
+      <p:sp>
+        <p:nvSpPr>
+          <p:cNvPr id="2" name="Title 1"/>
+          <p:cNvSpPr>
+            <a:spLocks noGrp="1"/>
+          </p:cNvSpPr>
+          <p:nvPr>
+            <p:ph type="title"/>
+          </p:nvPr>
+        </p:nvSpPr>
+        <p:spPr/>
+        <p:txBody>
+          <a:bodyPr/>
+          <a:lstStyle/>
+          <a:p>
+            <a:pPr lvl="0" indent="0" marL="0" rtl="1" algn="r">
+              <a:buNone/>
+            </a:pPr>
+            <a:r>
+              <a:rPr lang="fa-IR" dirty="0">
+                <a:latin typeface="Tahoma"/>
+                <a:cs typeface="Tahoma"/>
+              </a:rPr>
+              <a:t>پیشینه ۶: ترموالاستیسیتهٔ تعمیم‌یافته در سازه‌های مدرج</a:t>
+            </a:r>
+          </a:p>
+        </p:txBody>
+      </p:sp>
+      <p:sp>
+        <p:nvSpPr>
+          <p:cNvPr id="3" name="Content Placeholder 2"/>
+          <p:cNvSpPr>
+            <a:spLocks noGrp="1"/>
+          </p:cNvSpPr>
+          <p:nvPr>
+            <p:ph idx="1"/>
+          </p:nvPr>
+        </p:nvSpPr>
+        <p:spPr/>
+        <p:txBody>
+          <a:bodyPr/>
+          <a:lstStyle/>
+          <a:p>
+            <a:pPr lvl="0" rtl="1" algn="r"/>
+            <a:r>
+              <a:rPr lang="fa-IR" dirty="0">
+                <a:latin typeface="Tahoma"/>
+                <a:cs typeface="Tahoma"/>
+              </a:rPr>
+              <a:t>باهتویی و اسلامی (۲۰۰۷): پوستهٔ استوانه‌ای مدرج تحت شوک حرارتی؛ مقایسهٔ لرد–شولمن و گرین–لیندزی (اجزای محدود + لاپلاس) [۶۴، ۶۵].</a:t>
+            </a:r>
+          </a:p>
+          <a:p>
+            <a:pPr lvl="0" rtl="1" algn="r"/>
+            <a:r>
+              <a:rPr lang="fa-IR" dirty="0">
+                <a:latin typeface="Tahoma"/>
+                <a:cs typeface="Tahoma"/>
+              </a:rPr>
+              <a:t>بگری و اسلامی (۲۰۰۸): دیسک حلقوی مدرج با لرد–شولمن [۶۶]؛ حسینی و ابول‌بشری (۲۰۱۲): موج ترموالاستیک در استوانه با گرین–نقدی [۶۷].</a:t>
+            </a:r>
+          </a:p>
+          <a:p>
+            <a:pPr lvl="0" rtl="1" algn="r"/>
+            <a:r>
+              <a:rPr lang="fa-IR" dirty="0">
+                <a:latin typeface="Tahoma"/>
+                <a:cs typeface="Tahoma"/>
+              </a:rPr>
+              <a:t>حیدرپور و ملک‌زاده (۲۰۱۹): کرهٔ مدرج چندلایه با لرد–شولمن، DQM لایه‌ای + نیومارک [۶۸]؛ حیدرپور و همکاران (۲۰۱۹): پوستهٔ کروی گرافنی — نزدیک‌ترین کار به چارچوب پژوهش حاضر [۳].</a:t>
+            </a:r>
+          </a:p>
+          <a:p>
+            <a:pPr lvl="0" rtl="1" algn="r"/>
+            <a:r>
+              <a:rPr lang="fa-IR" dirty="0">
+                <a:latin typeface="Tahoma"/>
+                <a:cs typeface="Tahoma"/>
+              </a:rPr>
+              <a:t>حیدرپور و همکاران (۲۰۲۰): پوستهٔ استوانه‌ای با لایهٔ پیزوالکتریک (قرارداد بی‌بعدسازی فصل ۴) [۶۹]؛ مخروط ناقص گرافنی دوار (مبنای معادلات فصل ۳) [۷۰].</a:t>
+            </a:r>
+          </a:p>
+          <a:p>
+            <a:pPr lvl="0" rtl="1" algn="r"/>
+            <a:r>
+              <a:rPr lang="fa-IR" dirty="0">
+                <a:latin typeface="Tahoma"/>
+                <a:cs typeface="Tahoma"/>
+              </a:rPr>
+              <a:t>حسینی (۲۰۲۱، ۲۰۲۲)، کاظمی و همکاران (۲۰۲۳): انتشار موج حرارتی با گرین–نقدی در استوانه و فراماده [۷۱–۷۳].</a:t>
+            </a:r>
+          </a:p>
+        </p:txBody>
+      </p:sp>
+    </p:spTree>
+  </p:cSld>
+</p:sld>
+</file>
+
+<file path=ppt/slides/slide13.xml><?xml version="1.0" encoding="utf-8"?>
+<p:sld xmlns:a="http://schemas.openxmlformats.org/drawingml/2006/main" xmlns:r="http://schemas.openxmlformats.org/officeDocument/2006/relationships" xmlns:p="http://schemas.openxmlformats.org/presentationml/2006/main">
+  <p:cSld>
+    <p:spTree>
+      <p:nvGrpSpPr>
+        <p:cNvPr id="1" name=""/>
+        <p:cNvGrpSpPr/>
+        <p:nvPr/>
+      </p:nvGrpSpPr>
+      <p:grpSpPr>
+        <a:xfrm>
+          <a:off x="0" y="0"/>
+          <a:ext cx="0" cy="0"/>
+          <a:chOff x="0" y="0"/>
+          <a:chExt cx="0" cy="0"/>
+        </a:xfrm>
+      </p:grpSpPr>
+      <p:sp>
+        <p:nvSpPr>
+          <p:cNvPr id="2" name="Title 1"/>
+          <p:cNvSpPr>
+            <a:spLocks noGrp="1"/>
+          </p:cNvSpPr>
+          <p:nvPr>
+            <p:ph type="title"/>
+          </p:nvPr>
+        </p:nvSpPr>
+        <p:spPr/>
+        <p:txBody>
+          <a:bodyPr/>
+          <a:lstStyle/>
+          <a:p>
+            <a:pPr lvl="0" indent="0" marL="0" rtl="1" algn="r">
+              <a:buNone/>
+            </a:pPr>
+            <a:r>
+              <a:rPr lang="fa-IR" dirty="0">
+                <a:latin typeface="Tahoma"/>
+                <a:cs typeface="Tahoma"/>
+              </a:rPr>
+              <a:t>جمع‌بندی پیشینه: چهار شکاف پژوهشی</a:t>
+            </a:r>
+          </a:p>
+        </p:txBody>
+      </p:sp>
+      <mc:AlternateContent xmlns:mc="http://schemas.openxmlformats.org/markup-compatibility/2006">
+        <mc:Choice xmlns:a14="http://schemas.microsoft.com/office/drawing/2010/main" Requires="a14">
+          <p:sp>
+            <p:nvSpPr>
+              <p:cNvPr id="3" name="Content Placeholder 2"/>
+              <p:cNvSpPr>
+                <a:spLocks noGrp="1"/>
+              </p:cNvSpPr>
+              <p:nvPr>
+                <p:ph idx="1"/>
+              </p:nvPr>
+            </p:nvSpPr>
+            <p:spPr/>
+            <p:txBody>
+              <a:bodyPr/>
+              <a:lstStyle/>
+              <a:p>
+                <a:pPr lvl="0" rtl="1" algn="r"/>
+                <a:r>
+                  <a:rPr lang="fa-IR" dirty="0">
+                    <a:latin typeface="Tahoma"/>
+                    <a:cs typeface="Tahoma"/>
+                  </a:rPr>
+                  <a:t>سه شاخه جداگانه بالغ شده‌اند: ترموالاستیک استوانه‌های کامپوزیتی، مدل‌سازی مواد متخلخل گرافنی و تئوری‌های تعمیم‌یافته؛ بررسی هم‌زمانشان به‌ندرت انجام شده است.</a:t>
+                </a:r>
+              </a:p>
+              <a:p>
+                <a:pPr lvl="0" rtl="1" algn="r"/>
+                <a:r>
+                  <a:rPr b="1" lang="fa-IR" dirty="0">
+                    <a:latin typeface="Tahoma"/>
+                    <a:cs typeface="Tahoma"/>
+                  </a:rPr>
+                  <a:t>۱.</a:t>
+                </a:r>
+                <a:r>
+                  <a:rPr lang="fa-IR" dirty="0">
+                    <a:latin typeface="Tahoma"/>
+                    <a:cs typeface="Tahoma"/>
+                  </a:rPr>
+                  <a:t> کارهای گذرا اغلب بر تئوری پوسته‌اند؛ حل کاملاً دوبعدی </a:t>
+                </a:r>
+                <a14:m>
+                  <m:oMath xmlns:m="http://schemas.openxmlformats.org/officeDocument/2006/math">
+                    <m:r>
+                      <m:rPr>
+                        <m:sty m:val="p"/>
+                      </m:rPr>
+                      <m:t>(</m:t>
+                    </m:r>
+                    <m:r>
+                      <m:t>r</m:t>
+                    </m:r>
+                    <m:r>
+                      <m:rPr>
+                        <m:sty m:val="p"/>
+                      </m:rPr>
+                      <m:t>,</m:t>
+                    </m:r>
+                    <m:r>
+                      <m:t>z</m:t>
+                    </m:r>
+                    <m:r>
+                      <m:rPr>
+                        <m:sty m:val="p"/>
+                      </m:rPr>
+                      <m:t>)</m:t>
+                    </m:r>
+                  </m:oMath>
+                </a14:m>
+                <a:r>
+                  <a:rPr lang="fa-IR" dirty="0">
+                    <a:latin typeface="Tahoma"/>
+                    <a:cs typeface="Tahoma"/>
+                  </a:rPr>
+                  <a:t> برای استوانهٔ جدارضخیم کمتر به‌کار رفته است.</a:t>
+                </a:r>
+              </a:p>
+              <a:p>
+                <a:pPr lvl="0" rtl="1" algn="r"/>
+                <a:r>
+                  <a:rPr b="1" lang="fa-IR" dirty="0">
+                    <a:latin typeface="Tahoma"/>
+                    <a:cs typeface="Tahoma"/>
+                  </a:rPr>
+                  <a:t>۲.</a:t>
+                </a:r>
+                <a:r>
+                  <a:rPr lang="fa-IR" dirty="0">
+                    <a:latin typeface="Tahoma"/>
+                    <a:cs typeface="Tahoma"/>
+                  </a:rPr>
+                  <a:t> تحلیل‌های استوانهٔ متخلخل گرافنی عمدتاً مکانیکی یا حرارتیِ پایا و بر پایهٔ فوریه‌اند.</a:t>
+                </a:r>
+              </a:p>
+              <a:p>
+                <a:pPr lvl="0" rtl="1" algn="r"/>
+                <a:r>
+                  <a:rPr b="1" lang="fa-IR" dirty="0">
+                    <a:latin typeface="Tahoma"/>
+                    <a:cs typeface="Tahoma"/>
+                  </a:rPr>
+                  <a:t>۳.</a:t>
+                </a:r>
+                <a:r>
+                  <a:rPr lang="fa-IR" dirty="0">
+                    <a:latin typeface="Tahoma"/>
+                    <a:cs typeface="Tahoma"/>
+                  </a:rPr>
+                  <a:t> کارهای لرد–شولمن با DQM لایه‌ای و نیومارک بر کره، مخروط ناقص یا پوسته‌اند؛ استوانهٔ جدارضخیم چندلایه با گرافن و تخلخل هم‌زمان پوشش داده نشده است.</a:t>
+                </a:r>
+              </a:p>
+              <a:p>
+                <a:pPr lvl="0" rtl="1" algn="r"/>
+                <a:r>
+                  <a:rPr b="1" lang="fa-IR" dirty="0">
+                    <a:latin typeface="Tahoma"/>
+                    <a:cs typeface="Tahoma"/>
+                  </a:rPr>
+                  <a:t>۴.</a:t>
+                </a:r>
+                <a:r>
+                  <a:rPr lang="fa-IR" dirty="0">
+                    <a:latin typeface="Tahoma"/>
+                    <a:cs typeface="Tahoma"/>
+                  </a:rPr>
+                  <a:t> برهم‌کنش کاملِ الگوهای گرافن و تخلخل (ماتریس ۵×۵) و مقایسهٔ نظریه‌ها در یک مسئلهٔ استوانه‌ای گزارش نشده است.</a:t>
+                </a:r>
+              </a:p>
+            </p:txBody>
+          </p:sp>
+        </mc:Choice>
+      </mc:AlternateContent>
+    </p:spTree>
+  </p:cSld>
+</p:sld>
+</file>
+
+<file path=ppt/slides/slide14.xml><?xml version="1.0" encoding="utf-8"?>
+<p:sld xmlns:a="http://schemas.openxmlformats.org/drawingml/2006/main" xmlns:r="http://schemas.openxmlformats.org/officeDocument/2006/relationships" xmlns:p="http://schemas.openxmlformats.org/presentationml/2006/main">
+  <p:cSld>
+    <p:spTree>
+      <p:nvGrpSpPr>
+        <p:cNvPr id="1" name=""/>
+        <p:cNvGrpSpPr/>
+        <p:nvPr/>
+      </p:nvGrpSpPr>
+      <p:grpSpPr>
+        <a:xfrm>
+          <a:off x="0" y="0"/>
+          <a:ext cx="0" cy="0"/>
+          <a:chOff x="0" y="0"/>
+          <a:chExt cx="0" cy="0"/>
+        </a:xfrm>
+      </p:grpSpPr>
+      <p:sp>
+        <p:nvSpPr>
+          <p:cNvPr id="2" name="Title 1"/>
+          <p:cNvSpPr>
+            <a:spLocks noGrp="1"/>
+          </p:cNvSpPr>
+          <p:nvPr>
+            <p:ph type="title"/>
+          </p:nvPr>
+        </p:nvSpPr>
+        <p:spPr/>
+        <p:txBody>
+          <a:bodyPr/>
+          <a:lstStyle/>
+          <a:p>
+            <a:pPr lvl="0" indent="0" marL="0" rtl="1" algn="r">
+              <a:buNone/>
+            </a:pPr>
+            <a:r>
+              <a:rPr lang="fa-IR" dirty="0">
+                <a:latin typeface="Tahoma"/>
+                <a:cs typeface="Tahoma"/>
+              </a:rPr>
+              <a:t>جایگاه پژوهش حاضر در ادبیات</a:t>
+            </a:r>
+          </a:p>
+        </p:txBody>
+      </p:sp>
+      <mc:AlternateContent xmlns:mc="http://schemas.openxmlformats.org/markup-compatibility/2006">
+        <mc:Choice xmlns:a14="http://schemas.microsoft.com/office/drawing/2010/main" Requires="a14">
+          <p:sp>
+            <p:nvSpPr>
+              <p:cNvPr id="3" name="Content Placeholder 2"/>
+              <p:cNvSpPr>
+                <a:spLocks noGrp="1"/>
+              </p:cNvSpPr>
+              <p:nvPr>
+                <p:ph idx="1"/>
+              </p:nvPr>
+            </p:nvSpPr>
+            <p:spPr/>
+            <p:txBody>
+              <a:bodyPr/>
+              <a:lstStyle/>
+              <a:p>
+                <a:pPr lvl="0" rtl="1" algn="r"/>
+                <a:r>
+                  <a:rPr lang="fa-IR" dirty="0">
+                    <a:latin typeface="Tahoma"/>
+                    <a:cs typeface="Tahoma"/>
+                  </a:rPr>
+                  <a:t>تحلیل ترموالاستیک گذرا و کاملاً ممزوج برای استوانهٔ توخالیِ جدارضخیمِ چندلایهٔ متخلخل تقویت‌شده با گرافن.</a:t>
+                </a:r>
+              </a:p>
+              <a:p>
+                <a:pPr lvl="0" rtl="1" algn="r"/>
+                <a:r>
+                  <a:rPr lang="fa-IR" dirty="0">
+                    <a:latin typeface="Tahoma"/>
+                    <a:cs typeface="Tahoma"/>
+                  </a:rPr>
+                  <a:t>خواص مؤثر: هالپین–تسای، قاعدهٔ مخلوط‌ها و مدل سلول‌باز.</a:t>
+                </a:r>
+              </a:p>
+              <a:p>
+                <a:pPr lvl="0" rtl="1" algn="r"/>
+                <a:r>
+                  <a:rPr lang="fa-IR" dirty="0">
+                    <a:latin typeface="Tahoma"/>
+                    <a:cs typeface="Tahoma"/>
+                  </a:rPr>
+                  <a:t>معادلات به‌صورت دوبعدی در صفحهٔ </a:t>
+                </a:r>
+                <a14:m>
+                  <m:oMath xmlns:m="http://schemas.openxmlformats.org/officeDocument/2006/math">
+                    <m:r>
+                      <m:rPr>
+                        <m:sty m:val="p"/>
+                      </m:rPr>
+                      <m:t>(</m:t>
+                    </m:r>
+                    <m:r>
+                      <m:t>r</m:t>
+                    </m:r>
+                    <m:r>
+                      <m:rPr>
+                        <m:sty m:val="p"/>
+                      </m:rPr>
+                      <m:t>,</m:t>
+                    </m:r>
+                    <m:r>
+                      <m:t>z</m:t>
+                    </m:r>
+                    <m:r>
+                      <m:rPr>
+                        <m:sty m:val="p"/>
+                      </m:rPr>
+                      <m:t>)</m:t>
+                    </m:r>
+                  </m:oMath>
+                </a14:m>
+                <a:r>
+                  <a:rPr lang="fa-IR" dirty="0">
+                    <a:latin typeface="Tahoma"/>
+                    <a:cs typeface="Tahoma"/>
+                  </a:rPr>
+                  <a:t> و بدون تحویل به فرضیات پوسته.</a:t>
+                </a:r>
+              </a:p>
+              <a:p>
+                <a:pPr lvl="0" rtl="1" algn="r"/>
+                <a:r>
+                  <a:rPr lang="fa-IR" dirty="0">
+                    <a:latin typeface="Tahoma"/>
+                    <a:cs typeface="Tahoma"/>
+                  </a:rPr>
+                  <a:t>گسسته‌سازی: DQM لایه‌ای (گره‌های چبیشف–گاوس–لوباتو) در مکان و نیومارک در زمان.</a:t>
+                </a:r>
+              </a:p>
+              <a:p>
+                <a:pPr lvl="0" rtl="1" algn="r"/>
+                <a:r>
+                  <a:rPr lang="fa-IR" dirty="0">
+                    <a:latin typeface="Tahoma"/>
+                    <a:cs typeface="Tahoma"/>
+                  </a:rPr>
+                  <a:t>گرافن و تخلخل، هر یک در پنج الگوی UD، O، X، V و A.</a:t>
+                </a:r>
+              </a:p>
+            </p:txBody>
+          </p:sp>
+        </mc:Choice>
+      </mc:AlternateContent>
+    </p:spTree>
+  </p:cSld>
+</p:sld>
+</file>
+
+<file path=ppt/slides/slide15.xml><?xml version="1.0" encoding="utf-8"?>
+<p:sld xmlns:a="http://schemas.openxmlformats.org/drawingml/2006/main" xmlns:r="http://schemas.openxmlformats.org/officeDocument/2006/relationships" xmlns:p="http://schemas.openxmlformats.org/presentationml/2006/main">
+  <p:cSld>
+    <p:spTree>
+      <p:nvGrpSpPr>
+        <p:cNvPr id="1" name=""/>
+        <p:cNvGrpSpPr/>
+        <p:nvPr/>
+      </p:nvGrpSpPr>
+      <p:grpSpPr>
+        <a:xfrm>
+          <a:off x="0" y="0"/>
+          <a:ext cx="0" cy="0"/>
+          <a:chOff x="0" y="0"/>
+          <a:chExt cx="0" cy="0"/>
+        </a:xfrm>
+      </p:grpSpPr>
+      <p:sp>
+        <p:nvSpPr>
+          <p:cNvPr id="2" name="Title 1"/>
+          <p:cNvSpPr>
+            <a:spLocks noGrp="1"/>
+          </p:cNvSpPr>
+          <p:nvPr>
+            <p:ph type="title"/>
+          </p:nvPr>
+        </p:nvSpPr>
+        <p:spPr/>
+        <p:txBody>
+          <a:bodyPr/>
+          <a:lstStyle/>
+          <a:p>
+            <a:pPr lvl="0" indent="0" marL="0" rtl="1" algn="r">
+              <a:buNone/>
+            </a:pPr>
+            <a:r>
+              <a:rPr lang="fa-IR" dirty="0">
+                <a:latin typeface="Tahoma"/>
+                <a:cs typeface="Tahoma"/>
+              </a:rPr>
+              <a:t>استوانهٔ توخالیِ هفت‌لایه با خواص متغیر در ضخامت</a:t>
+            </a:r>
+          </a:p>
+        </p:txBody>
+      </p:sp>
+      <p:pic>
+        <p:nvPicPr>
+          <p:cNvPr descr="../figures_ch123/geometry_schematic.png" id="0" name="Picture 1"/>
+          <p:cNvPicPr>
+            <a:picLocks noGrp="1" noChangeAspect="1"/>
+          </p:cNvPicPr>
+          <p:nvPr/>
+        </p:nvPicPr>
+        <p:blipFill>
+          <a:blip r:embed="rId2"/>
+          <a:stretch>
+            <a:fillRect/>
+          </a:stretch>
+        </p:blipFill>
+        <p:spPr bwMode="auto">
+          <a:xfrm>
+            <a:off x="1358900" y="1193800"/>
+            <a:ext cx="6438900" cy="3390900"/>
+          </a:xfrm>
+          <a:prstGeom prst="rect">
+            <a:avLst/>
+          </a:prstGeom>
+          <a:noFill/>
+          <a:ln w="9525">
+            <a:noFill/>
+            <a:headEnd/>
+            <a:tailEnd/>
+          </a:ln>
+        </p:spPr>
+      </p:pic>
+    </p:spTree>
+  </p:cSld>
+</p:sld>
+</file>
+
+<file path=ppt/slides/slide16.xml><?xml version="1.0" encoding="utf-8"?>
+<p:sld xmlns:a="http://schemas.openxmlformats.org/drawingml/2006/main" xmlns:r="http://schemas.openxmlformats.org/officeDocument/2006/relationships" xmlns:p="http://schemas.openxmlformats.org/presentationml/2006/main">
+  <p:cSld>
+    <p:spTree>
+      <p:nvGrpSpPr>
+        <p:cNvPr id="1" name=""/>
+        <p:cNvGrpSpPr/>
+        <p:nvPr/>
+      </p:nvGrpSpPr>
+      <p:grpSpPr>
+        <a:xfrm>
+          <a:off x="0" y="0"/>
+          <a:ext cx="0" cy="0"/>
+          <a:chOff x="0" y="0"/>
+          <a:chExt cx="0" cy="0"/>
+        </a:xfrm>
+      </p:grpSpPr>
+      <p:sp>
+        <p:nvSpPr>
+          <p:cNvPr id="2" name="Title 1"/>
+          <p:cNvSpPr>
+            <a:spLocks noGrp="1"/>
+          </p:cNvSpPr>
+          <p:nvPr>
+            <p:ph type="title"/>
+          </p:nvPr>
+        </p:nvSpPr>
+        <p:spPr/>
+        <p:txBody>
+          <a:bodyPr/>
+          <a:lstStyle/>
+          <a:p>
+            <a:pPr lvl="0" indent="0" marL="0" rtl="1" algn="r">
+              <a:buNone/>
+            </a:pPr>
+            <a:r>
+              <a:rPr lang="fa-IR" dirty="0">
+                <a:latin typeface="Tahoma"/>
+                <a:cs typeface="Tahoma"/>
+              </a:rPr>
+              <a:t>حالت مرجع و شرایط مرزی</a:t>
+            </a:r>
+          </a:p>
+        </p:txBody>
+      </p:sp>
+      <mc:AlternateContent xmlns:mc="http://schemas.openxmlformats.org/markup-compatibility/2006">
+        <mc:Choice xmlns:a14="http://schemas.microsoft.com/office/drawing/2010/main" Requires="a14">
+          <p:sp>
+            <p:nvSpPr>
+              <p:cNvPr id="3" name="Content Placeholder 2"/>
+              <p:cNvSpPr>
+                <a:spLocks noGrp="1"/>
+              </p:cNvSpPr>
+              <p:nvPr>
+                <p:ph idx="1"/>
+              </p:nvPr>
+            </p:nvSpPr>
+            <p:spPr/>
+            <p:txBody>
+              <a:bodyPr/>
+              <a:lstStyle/>
+              <a:p>
+                <a:pPr lvl="0" rtl="1" algn="r"/>
+                <a:r>
+                  <a:rPr lang="fa-IR" dirty="0">
+                    <a:latin typeface="Tahoma"/>
+                    <a:cs typeface="Tahoma"/>
+                  </a:rPr>
+                  <a:t>ابعاد: </a:t>
+                </a:r>
+                <a14:m>
+                  <m:oMath xmlns:m="http://schemas.openxmlformats.org/officeDocument/2006/math">
+                    <m:sSub>
+                      <m:e>
+                        <m:r>
+                          <m:t>R</m:t>
+                        </m:r>
+                      </m:e>
+                      <m:sub>
+                        <m:r>
+                          <m:t>i</m:t>
+                        </m:r>
+                      </m:sub>
+                    </m:sSub>
+                    <m:r>
+                      <m:rPr>
+                        <m:sty m:val="p"/>
+                      </m:rPr>
+                      <m:t>=</m:t>
+                    </m:r>
+                    <m:r>
+                      <m:t>1</m:t>
+                    </m:r>
+                  </m:oMath>
+                </a14:m>
+                <a:r>
+                  <a:rPr lang="fa-IR" dirty="0">
+                    <a:latin typeface="Tahoma"/>
+                    <a:cs typeface="Tahoma"/>
+                  </a:rPr>
+                  <a:t> m، </a:t>
+                </a:r>
+                <a14:m>
+                  <m:oMath xmlns:m="http://schemas.openxmlformats.org/officeDocument/2006/math">
+                    <m:sSub>
+                      <m:e>
+                        <m:r>
+                          <m:t>R</m:t>
+                        </m:r>
+                      </m:e>
+                      <m:sub>
+                        <m:r>
+                          <m:t>o</m:t>
+                        </m:r>
+                      </m:sub>
+                    </m:sSub>
+                    <m:r>
+                      <m:rPr>
+                        <m:sty m:val="p"/>
+                      </m:rPr>
+                      <m:t>=</m:t>
+                    </m:r>
+                    <m:r>
+                      <m:t>1.5</m:t>
+                    </m:r>
+                  </m:oMath>
+                </a14:m>
+                <a:r>
+                  <a:rPr lang="fa-IR" dirty="0">
+                    <a:latin typeface="Tahoma"/>
+                    <a:cs typeface="Tahoma"/>
+                  </a:rPr>
+                  <a:t> m، طول </a:t>
+                </a:r>
+                <a14:m>
+                  <m:oMath xmlns:m="http://schemas.openxmlformats.org/officeDocument/2006/math">
+                    <m:r>
+                      <m:t>L</m:t>
+                    </m:r>
+                    <m:r>
+                      <m:rPr>
+                        <m:sty m:val="p"/>
+                      </m:rPr>
+                      <m:t>=</m:t>
+                    </m:r>
+                    <m:r>
+                      <m:t>2.1</m:t>
+                    </m:r>
+                  </m:oMath>
+                </a14:m>
+                <a:r>
+                  <a:rPr lang="fa-IR" dirty="0">
+                    <a:latin typeface="Tahoma"/>
+                    <a:cs typeface="Tahoma"/>
+                  </a:rPr>
+                  <a:t> m.</a:t>
+                </a:r>
+              </a:p>
+              <a:p>
+                <a:pPr lvl="0" rtl="1" algn="r"/>
+                <a:r>
+                  <a:rPr lang="fa-IR" dirty="0">
+                    <a:latin typeface="Tahoma"/>
+                    <a:cs typeface="Tahoma"/>
+                  </a:rPr>
+                  <a:t>حرارت: سطح داخلی </a:t>
+                </a:r>
+                <a14:m>
+                  <m:oMath xmlns:m="http://schemas.openxmlformats.org/officeDocument/2006/math">
+                    <m:r>
+                      <m:t>300</m:t>
+                    </m:r>
+                    <m:r>
+                      <m:rPr>
+                        <m:sty m:val="p"/>
+                      </m:rPr>
+                      <m:t>→</m:t>
+                    </m:r>
+                    <m:r>
+                      <m:t>600</m:t>
+                    </m:r>
+                  </m:oMath>
+                </a14:m>
+                <a:r>
+                  <a:rPr lang="fa-IR" dirty="0">
+                    <a:latin typeface="Tahoma"/>
+                    <a:cs typeface="Tahoma"/>
+                  </a:rPr>
+                  <a:t> K؛ سطح خارجی همرفت با </a:t>
+                </a:r>
+                <a14:m>
+                  <m:oMath xmlns:m="http://schemas.openxmlformats.org/officeDocument/2006/math">
+                    <m:sSub>
+                      <m:e>
+                        <m:r>
+                          <m:t>h</m:t>
+                        </m:r>
+                      </m:e>
+                      <m:sub>
+                        <m:r>
+                          <m:t>c</m:t>
+                        </m:r>
+                      </m:sub>
+                    </m:sSub>
+                    <m:r>
+                      <m:rPr>
+                        <m:sty m:val="p"/>
+                      </m:rPr>
+                      <m:t>=</m:t>
+                    </m:r>
+                    <m:r>
+                      <m:t>10</m:t>
+                    </m:r>
+                  </m:oMath>
+                </a14:m>
+                <a:r>
+                  <a:rPr lang="fa-IR" dirty="0">
+                    <a:latin typeface="Tahoma"/>
+                    <a:cs typeface="Tahoma"/>
+                  </a:rPr>
+                  <a:t> W/m²K.</a:t>
+                </a:r>
+              </a:p>
+              <a:p>
+                <a:pPr lvl="0" rtl="1" algn="r"/>
+                <a:r>
+                  <a:rPr lang="fa-IR" dirty="0">
+                    <a:latin typeface="Tahoma"/>
+                    <a:cs typeface="Tahoma"/>
+                  </a:rPr>
+                  <a:t>مکانیک: فشار داخلی </a:t>
+                </a:r>
+                <a14:m>
+                  <m:oMath xmlns:m="http://schemas.openxmlformats.org/officeDocument/2006/math">
+                    <m:sSub>
+                      <m:e>
+                        <m:r>
+                          <m:t>P</m:t>
+                        </m:r>
+                      </m:e>
+                      <m:sub>
+                        <m:r>
+                          <m:t>i</m:t>
+                        </m:r>
+                      </m:sub>
+                    </m:sSub>
+                    <m:r>
+                      <m:rPr>
+                        <m:sty m:val="p"/>
+                      </m:rPr>
+                      <m:t>=</m:t>
+                    </m:r>
+                    <m:r>
+                      <m:t>50</m:t>
+                    </m:r>
+                  </m:oMath>
+                </a14:m>
+                <a:r>
+                  <a:rPr lang="fa-IR" dirty="0">
+                    <a:latin typeface="Tahoma"/>
+                    <a:cs typeface="Tahoma"/>
+                  </a:rPr>
+                  <a:t> MPa؛ انتهاها تکیه‌گاه ساده و عایق.</a:t>
+                </a:r>
+              </a:p>
+              <a:p>
+                <a:pPr lvl="0" rtl="1" algn="r"/>
+                <a14:m>
+                  <m:oMath xmlns:m="http://schemas.openxmlformats.org/officeDocument/2006/math">
+                    <m:sSup>
+                      <m:e>
+                        <m:r>
+                          <m:t>τ</m:t>
+                        </m:r>
+                      </m:e>
+                      <m:sup>
+                        <m:r>
+                          <m:rPr>
+                            <m:sty m:val="p"/>
+                          </m:rPr>
+                          <m:t>*</m:t>
+                        </m:r>
+                      </m:sup>
+                    </m:sSup>
+                    <m:r>
+                      <m:rPr>
+                        <m:sty m:val="p"/>
+                      </m:rPr>
+                      <m:t>≈</m:t>
+                    </m:r>
+                    <m:r>
+                      <m:t>0.15</m:t>
+                    </m:r>
+                  </m:oMath>
+                </a14:m>
+                <a:r>
+                  <a:rPr lang="fa-IR" dirty="0">
+                    <a:latin typeface="Tahoma"/>
+                    <a:cs typeface="Tahoma"/>
+                  </a:rPr>
+                  <a:t> (معادل </a:t>
+                </a:r>
+                <a14:m>
+                  <m:oMath xmlns:m="http://schemas.openxmlformats.org/officeDocument/2006/math">
+                    <m:sSub>
+                      <m:e>
+                        <m:r>
+                          <m:t>τ</m:t>
+                        </m:r>
+                      </m:e>
+                      <m:sub>
+                        <m:r>
+                          <m:t>0</m:t>
+                        </m:r>
+                      </m:sub>
+                    </m:sSub>
+                    <m:r>
+                      <m:rPr>
+                        <m:sty m:val="p"/>
+                      </m:rPr>
+                      <m:t>=</m:t>
+                    </m:r>
+                    <m:r>
+                      <m:t>418</m:t>
+                    </m:r>
+                  </m:oMath>
+                </a14:m>
+                <a:r>
+                  <a:rPr lang="fa-IR" dirty="0">
+                    <a:latin typeface="Tahoma"/>
+                    <a:cs typeface="Tahoma"/>
+                  </a:rPr>
+                  <a:t> s)؛ زمان کل ۳۰۰۰ ثانیه.</a:t>
+                </a:r>
+              </a:p>
+              <a:p>
+                <a:pPr lvl="0" rtl="1" algn="r"/>
+                <a:r>
+                  <a:rPr lang="fa-IR" dirty="0">
+                    <a:latin typeface="Tahoma"/>
+                    <a:cs typeface="Tahoma"/>
+                  </a:rPr>
+                  <a:t>خواص: </a:t>
+                </a:r>
+                <a:r>
+                  <a:rPr b="1" lang="fa-IR" dirty="0">
+                    <a:latin typeface="Tahoma"/>
+                    <a:cs typeface="Tahoma"/>
+                  </a:rPr>
+                  <a:t>هالپین-تسای</a:t>
+                </a:r>
+                <a:r>
+                  <a:rPr lang="fa-IR" dirty="0">
+                    <a:latin typeface="Tahoma"/>
+                    <a:cs typeface="Tahoma"/>
+                  </a:rPr>
+                  <a:t> + قانون مخلوط‌ها؛ تخلخل: </a:t>
+                </a:r>
+                <a:r>
+                  <a:rPr b="1" lang="fa-IR" dirty="0">
+                    <a:latin typeface="Tahoma"/>
+                    <a:cs typeface="Tahoma"/>
+                  </a:rPr>
+                  <a:t>سلول باز</a:t>
+                </a:r>
+                <a:r>
+                  <a:rPr lang="fa-IR" dirty="0">
+                    <a:latin typeface="Tahoma"/>
+                    <a:cs typeface="Tahoma"/>
+                  </a:rPr>
+                  <a:t>.</a:t>
+                </a:r>
+              </a:p>
+            </p:txBody>
+          </p:sp>
+        </mc:Choice>
+      </mc:AlternateContent>
+    </p:spTree>
+  </p:cSld>
+</p:sld>
+</file>
+
+<file path=ppt/slides/slide17.xml><?xml version="1.0" encoding="utf-8"?>
+<p:sld xmlns:a="http://schemas.openxmlformats.org/drawingml/2006/main" xmlns:r="http://schemas.openxmlformats.org/officeDocument/2006/relationships" xmlns:p="http://schemas.openxmlformats.org/presentationml/2006/main">
+  <p:cSld>
+    <p:spTree>
+      <p:nvGrpSpPr>
+        <p:cNvPr id="1" name=""/>
+        <p:cNvGrpSpPr/>
+        <p:nvPr/>
+      </p:nvGrpSpPr>
+      <p:grpSpPr>
+        <a:xfrm>
+          <a:off x="0" y="0"/>
+          <a:ext cx="0" cy="0"/>
+          <a:chOff x="0" y="0"/>
+          <a:chExt cx="0" cy="0"/>
+        </a:xfrm>
+      </p:grpSpPr>
+      <p:sp>
+        <p:nvSpPr>
+          <p:cNvPr id="2" name="Title 1"/>
+          <p:cNvSpPr>
+            <a:spLocks noGrp="1"/>
+          </p:cNvSpPr>
+          <p:nvPr>
+            <p:ph type="title"/>
+          </p:nvPr>
+        </p:nvSpPr>
+        <p:spPr/>
+        <p:txBody>
+          <a:bodyPr/>
+          <a:lstStyle/>
+          <a:p>
+            <a:pPr lvl="0" indent="0" marL="0" rtl="1" algn="r">
+              <a:buNone/>
+            </a:pPr>
+            <a:r>
+              <a:rPr lang="fa-IR" dirty="0">
+                <a:latin typeface="Tahoma"/>
+                <a:cs typeface="Tahoma"/>
+              </a:rPr>
+              <a:t>پنج الگوی توزیع گرافن در ضخامت</a:t>
+            </a:r>
+          </a:p>
+        </p:txBody>
+      </p:sp>
+      <p:pic>
+        <p:nvPicPr>
+          <p:cNvPr descr="../figures_ch123/GPL_patterns_schematic.png" id="0" name="Picture 1"/>
+          <p:cNvPicPr>
+            <a:picLocks noGrp="1" noChangeAspect="1"/>
+          </p:cNvPicPr>
+          <p:nvPr/>
+        </p:nvPicPr>
+        <p:blipFill>
+          <a:blip r:embed="rId2"/>
+          <a:stretch>
+            <a:fillRect/>
+          </a:stretch>
+        </p:blipFill>
+        <p:spPr bwMode="auto">
+          <a:xfrm>
+            <a:off x="2374900" y="1193800"/>
+            <a:ext cx="4381500" cy="3390900"/>
+          </a:xfrm>
+          <a:prstGeom prst="rect">
+            <a:avLst/>
+          </a:prstGeom>
+          <a:noFill/>
+          <a:ln w="9525">
+            <a:noFill/>
+            <a:headEnd/>
+            <a:tailEnd/>
+          </a:ln>
+        </p:spPr>
+      </p:pic>
+    </p:spTree>
+  </p:cSld>
+</p:sld>
+</file>
+
+<file path=ppt/slides/slide18.xml><?xml version="1.0" encoding="utf-8"?>
+<p:sld xmlns:a="http://schemas.openxmlformats.org/drawingml/2006/main" xmlns:r="http://schemas.openxmlformats.org/officeDocument/2006/relationships" xmlns:p="http://schemas.openxmlformats.org/presentationml/2006/main">
+  <p:cSld>
+    <p:spTree>
+      <p:nvGrpSpPr>
+        <p:cNvPr id="1" name=""/>
+        <p:cNvGrpSpPr/>
+        <p:nvPr/>
+      </p:nvGrpSpPr>
+      <p:grpSpPr>
+        <a:xfrm>
+          <a:off x="0" y="0"/>
+          <a:ext cx="0" cy="0"/>
+          <a:chOff x="0" y="0"/>
+          <a:chExt cx="0" cy="0"/>
+        </a:xfrm>
+      </p:grpSpPr>
+      <p:sp>
+        <p:nvSpPr>
+          <p:cNvPr id="2" name="Title 1"/>
+          <p:cNvSpPr>
+            <a:spLocks noGrp="1"/>
+          </p:cNvSpPr>
+          <p:nvPr>
+            <p:ph type="title"/>
+          </p:nvPr>
+        </p:nvSpPr>
+        <p:spPr/>
+        <p:txBody>
+          <a:bodyPr/>
+          <a:lstStyle/>
+          <a:p>
+            <a:pPr lvl="0" indent="0" marL="0" rtl="1" algn="r">
+              <a:buNone/>
+            </a:pPr>
+            <a:r>
+              <a:rPr lang="fa-IR" dirty="0">
+                <a:latin typeface="Tahoma"/>
+                <a:cs typeface="Tahoma"/>
+              </a:rPr>
+              <a:t>پنج الگوی توزیع تخلخل در ضخامت</a:t>
+            </a:r>
+          </a:p>
+        </p:txBody>
+      </p:sp>
+      <p:pic>
+        <p:nvPicPr>
+          <p:cNvPr descr="../figures_ch123/porosity_patterns_schematic.png" id="0" name="Picture 1"/>
+          <p:cNvPicPr>
+            <a:picLocks noGrp="1" noChangeAspect="1"/>
+          </p:cNvPicPr>
+          <p:nvPr/>
+        </p:nvPicPr>
+        <p:blipFill>
+          <a:blip r:embed="rId3"/>
+          <a:stretch>
+            <a:fillRect/>
+          </a:stretch>
+        </p:blipFill>
+        <p:spPr bwMode="auto">
+          <a:xfrm>
+            <a:off x="2070100" y="1193800"/>
+            <a:ext cx="5016500" cy="3390900"/>
+          </a:xfrm>
+          <a:prstGeom prst="rect">
+            <a:avLst/>
+          </a:prstGeom>
+          <a:noFill/>
+          <a:ln w="9525">
+            <a:noFill/>
+            <a:headEnd/>
+            <a:tailEnd/>
+          </a:ln>
+        </p:spPr>
+      </p:pic>
+    </p:spTree>
+  </p:cSld>
+</p:sld>
+</file>
+
+<file path=ppt/slides/slide19.xml><?xml version="1.0" encoding="utf-8"?>
+<p:sld xmlns:a="http://schemas.openxmlformats.org/drawingml/2006/main" xmlns:r="http://schemas.openxmlformats.org/officeDocument/2006/relationships" xmlns:p="http://schemas.openxmlformats.org/presentationml/2006/main">
+  <p:cSld>
+    <p:spTree>
+      <p:nvGrpSpPr>
+        <p:cNvPr id="1" name=""/>
+        <p:cNvGrpSpPr/>
+        <p:nvPr/>
+      </p:nvGrpSpPr>
+      <p:grpSpPr>
+        <a:xfrm>
+          <a:off x="0" y="0"/>
+          <a:ext cx="0" cy="0"/>
+          <a:chOff x="0" y="0"/>
+          <a:chExt cx="0" cy="0"/>
+        </a:xfrm>
+      </p:grpSpPr>
+      <p:sp>
+        <p:nvSpPr>
+          <p:cNvPr id="2" name="Title 1"/>
+          <p:cNvSpPr>
+            <a:spLocks noGrp="1"/>
+          </p:cNvSpPr>
+          <p:nvPr>
+            <p:ph type="title"/>
+          </p:nvPr>
+        </p:nvSpPr>
+        <p:spPr/>
+        <p:txBody>
+          <a:bodyPr/>
+          <a:lstStyle/>
+          <a:p>
+            <a:pPr lvl="0" indent="0" marL="0" rtl="1" algn="r">
+              <a:buNone/>
+            </a:pPr>
+            <a:r>
+              <a:rPr lang="fa-IR" dirty="0">
+                <a:latin typeface="Tahoma"/>
+                <a:cs typeface="Tahoma"/>
+              </a:rPr>
+              <a:t>معادلهٔ انرژی لرد–شولمن</a:t>
             </a:r>
           </a:p>
         </p:txBody>
@@ -5917,7 +8068,153 @@
 </p:sld>
 </file>
 
-<file path=ppt/slides/slide11.xml><?xml version="1.0" encoding="utf-8"?>
+<file path=ppt/slides/slide2.xml><?xml version="1.0" encoding="utf-8"?>
+<p:sld xmlns:a="http://schemas.openxmlformats.org/drawingml/2006/main" xmlns:r="http://schemas.openxmlformats.org/officeDocument/2006/relationships" xmlns:p="http://schemas.openxmlformats.org/presentationml/2006/main">
+  <p:cSld>
+    <p:spTree>
+      <p:nvGrpSpPr>
+        <p:cNvPr id="1" name=""/>
+        <p:cNvGrpSpPr/>
+        <p:nvPr/>
+      </p:nvGrpSpPr>
+      <p:grpSpPr>
+        <a:xfrm>
+          <a:off x="0" y="0"/>
+          <a:ext cx="0" cy="0"/>
+          <a:chOff x="0" y="0"/>
+          <a:chExt cx="0" cy="0"/>
+        </a:xfrm>
+      </p:grpSpPr>
+      <p:sp>
+        <p:nvSpPr>
+          <p:cNvPr id="2" name="Title 1"/>
+          <p:cNvSpPr>
+            <a:spLocks noGrp="1"/>
+          </p:cNvSpPr>
+          <p:nvPr>
+            <p:ph type="title"/>
+          </p:nvPr>
+        </p:nvSpPr>
+        <p:spPr/>
+        <p:txBody>
+          <a:bodyPr/>
+          <a:lstStyle/>
+          <a:p>
+            <a:pPr lvl="0" indent="0" marL="0" rtl="1" algn="r">
+              <a:buNone/>
+            </a:pPr>
+            <a:r>
+              <a:rPr lang="fa-IR" dirty="0">
+                <a:latin typeface="Tahoma"/>
+                <a:cs typeface="Tahoma"/>
+              </a:rPr>
+              <a:t>فهرست مطالب</a:t>
+            </a:r>
+          </a:p>
+        </p:txBody>
+      </p:sp>
+      <p:sp>
+        <p:nvSpPr>
+          <p:cNvPr id="3" name="Content Placeholder 2"/>
+          <p:cNvSpPr>
+            <a:spLocks noGrp="1"/>
+          </p:cNvSpPr>
+          <p:nvPr>
+            <p:ph idx="1"/>
+          </p:nvPr>
+        </p:nvSpPr>
+        <p:spPr/>
+        <p:txBody>
+          <a:bodyPr/>
+          <a:lstStyle/>
+          <a:p>
+            <a:pPr lvl="0" rtl="1" algn="r"/>
+            <a:r>
+              <a:rPr lang="fa-IR" dirty="0">
+                <a:latin typeface="Tahoma"/>
+                <a:cs typeface="Tahoma"/>
+              </a:rPr>
+              <a:t>بیان مسئله و هدف پژوهش</a:t>
+            </a:r>
+          </a:p>
+          <a:p>
+            <a:pPr lvl="0" rtl="1" algn="r"/>
+            <a:r>
+              <a:rPr lang="fa-IR" dirty="0">
+                <a:latin typeface="Tahoma"/>
+                <a:cs typeface="Tahoma"/>
+              </a:rPr>
+              <a:t>پیشینهٔ پژوهش: تئوری‌ها، سازه‌های مدرج، مواد متخلخل، ترموالاستیسیتهٔ تعمیم‌یافته</a:t>
+            </a:r>
+          </a:p>
+          <a:p>
+            <a:pPr lvl="0" rtl="1" algn="r"/>
+            <a:r>
+              <a:rPr lang="fa-IR" dirty="0">
+                <a:latin typeface="Tahoma"/>
+                <a:cs typeface="Tahoma"/>
+              </a:rPr>
+              <a:t>شکاف تحقیقاتی و جایگاه پژوهش</a:t>
+            </a:r>
+          </a:p>
+          <a:p>
+            <a:pPr lvl="0" rtl="1" algn="r"/>
+            <a:r>
+              <a:rPr lang="fa-IR" dirty="0">
+                <a:latin typeface="Tahoma"/>
+                <a:cs typeface="Tahoma"/>
+              </a:rPr>
+              <a:t>مدل‌سازی: هندسه، مواد و الگوها</a:t>
+            </a:r>
+          </a:p>
+          <a:p>
+            <a:pPr lvl="0" rtl="1" algn="r"/>
+            <a:r>
+              <a:rPr lang="fa-IR" dirty="0">
+                <a:latin typeface="Tahoma"/>
+                <a:cs typeface="Tahoma"/>
+              </a:rPr>
+              <a:t>معادلات حاکم و روش حل عددی</a:t>
+            </a:r>
+          </a:p>
+          <a:p>
+            <a:pPr lvl="0" rtl="1" algn="r"/>
+            <a:r>
+              <a:rPr lang="fa-IR" dirty="0">
+                <a:latin typeface="Tahoma"/>
+                <a:cs typeface="Tahoma"/>
+              </a:rPr>
+              <a:t>صحت‌سنجی و همگرایی</a:t>
+            </a:r>
+          </a:p>
+          <a:p>
+            <a:pPr lvl="0" rtl="1" algn="r"/>
+            <a:r>
+              <a:rPr lang="fa-IR" dirty="0">
+                <a:latin typeface="Tahoma"/>
+                <a:cs typeface="Tahoma"/>
+              </a:rPr>
+              <a:t>نتایج و بحث</a:t>
+            </a:r>
+          </a:p>
+          <a:p>
+            <a:pPr lvl="0" rtl="1" algn="r"/>
+            <a:r>
+              <a:rPr lang="fa-IR" dirty="0">
+                <a:latin typeface="Tahoma"/>
+                <a:cs typeface="Tahoma"/>
+              </a:rPr>
+              <a:t>نوآوری‌ها، نتیجه‌گیری و پیشنهادها</a:t>
+            </a:r>
+          </a:p>
+        </p:txBody>
+      </p:sp>
+    </p:spTree>
+  </p:cSld>
+</p:sld>
+</file>
+
+<file path=ppt/slides/slide20.xml><?xml version="1.0" encoding="utf-8"?>
 <p:sld xmlns:a="http://schemas.openxmlformats.org/drawingml/2006/main" xmlns:r="http://schemas.openxmlformats.org/officeDocument/2006/relationships" xmlns:p="http://schemas.openxmlformats.org/presentationml/2006/main">
   <p:cSld>
     <p:spTree>
@@ -6168,7 +8465,7 @@
 </p:sld>
 </file>
 
-<file path=ppt/slides/slide12.xml><?xml version="1.0" encoding="utf-8"?>
+<file path=ppt/slides/slide21.xml><?xml version="1.0" encoding="utf-8"?>
 <p:sld xmlns:a="http://schemas.openxmlformats.org/drawingml/2006/main" xmlns:r="http://schemas.openxmlformats.org/officeDocument/2006/relationships" xmlns:p="http://schemas.openxmlformats.org/presentationml/2006/main">
   <p:cSld>
     <p:spTree>
@@ -6248,7 +8545,7 @@
 </p:sld>
 </file>
 
-<file path=ppt/slides/slide13.xml><?xml version="1.0" encoding="utf-8"?>
+<file path=ppt/slides/slide22.xml><?xml version="1.0" encoding="utf-8"?>
 <p:sld xmlns:a="http://schemas.openxmlformats.org/drawingml/2006/main" xmlns:r="http://schemas.openxmlformats.org/officeDocument/2006/relationships" xmlns:p="http://schemas.openxmlformats.org/presentationml/2006/main">
   <p:cSld>
     <p:spTree>
@@ -6328,7 +8625,7 @@
 </p:sld>
 </file>
 
-<file path=ppt/slides/slide14.xml><?xml version="1.0" encoding="utf-8"?>
+<file path=ppt/slides/slide23.xml><?xml version="1.0" encoding="utf-8"?>
 <p:sld xmlns:a="http://schemas.openxmlformats.org/drawingml/2006/main" xmlns:r="http://schemas.openxmlformats.org/officeDocument/2006/relationships" xmlns:p="http://schemas.openxmlformats.org/presentationml/2006/main">
   <p:cSld>
     <p:spTree>
@@ -6651,7 +8948,7 @@
 </p:sld>
 </file>
 
-<file path=ppt/slides/slide15.xml><?xml version="1.0" encoding="utf-8"?>
+<file path=ppt/slides/slide24.xml><?xml version="1.0" encoding="utf-8"?>
 <p:sld xmlns:a="http://schemas.openxmlformats.org/drawingml/2006/main" xmlns:r="http://schemas.openxmlformats.org/officeDocument/2006/relationships" xmlns:p="http://schemas.openxmlformats.org/presentationml/2006/main">
   <p:cSld>
     <p:spTree>
@@ -6731,7 +9028,7 @@
 </p:sld>
 </file>
 
-<file path=ppt/slides/slide16.xml><?xml version="1.0" encoding="utf-8"?>
+<file path=ppt/slides/slide25.xml><?xml version="1.0" encoding="utf-8"?>
 <p:sld xmlns:a="http://schemas.openxmlformats.org/drawingml/2006/main" xmlns:r="http://schemas.openxmlformats.org/officeDocument/2006/relationships" xmlns:p="http://schemas.openxmlformats.org/presentationml/2006/main">
   <p:cSld>
     <p:spTree>
@@ -6811,7 +9108,7 @@
 </p:sld>
 </file>
 
-<file path=ppt/slides/slide17.xml><?xml version="1.0" encoding="utf-8"?>
+<file path=ppt/slides/slide26.xml><?xml version="1.0" encoding="utf-8"?>
 <p:sld xmlns:a="http://schemas.openxmlformats.org/drawingml/2006/main" xmlns:r="http://schemas.openxmlformats.org/officeDocument/2006/relationships" xmlns:p="http://schemas.openxmlformats.org/presentationml/2006/main">
   <p:cSld>
     <p:spTree>
@@ -7067,7 +9364,7 @@
 </p:sld>
 </file>
 
-<file path=ppt/slides/slide18.xml><?xml version="1.0" encoding="utf-8"?>
+<file path=ppt/slides/slide27.xml><?xml version="1.0" encoding="utf-8"?>
 <p:sld xmlns:a="http://schemas.openxmlformats.org/drawingml/2006/main" xmlns:r="http://schemas.openxmlformats.org/officeDocument/2006/relationships" xmlns:p="http://schemas.openxmlformats.org/presentationml/2006/main">
   <p:cSld>
     <p:spTree>
@@ -7240,7 +9537,7 @@
 </p:sld>
 </file>
 
-<file path=ppt/slides/slide19.xml><?xml version="1.0" encoding="utf-8"?>
+<file path=ppt/slides/slide28.xml><?xml version="1.0" encoding="utf-8"?>
 <p:sld xmlns:a="http://schemas.openxmlformats.org/drawingml/2006/main" xmlns:r="http://schemas.openxmlformats.org/officeDocument/2006/relationships" xmlns:p="http://schemas.openxmlformats.org/presentationml/2006/main">
   <p:cSld>
     <p:spTree>
@@ -7403,143 +9700,7 @@
 </p:sld>
 </file>
 
-<file path=ppt/slides/slide2.xml><?xml version="1.0" encoding="utf-8"?>
-<p:sld xmlns:a="http://schemas.openxmlformats.org/drawingml/2006/main" xmlns:r="http://schemas.openxmlformats.org/officeDocument/2006/relationships" xmlns:p="http://schemas.openxmlformats.org/presentationml/2006/main">
-  <p:cSld>
-    <p:spTree>
-      <p:nvGrpSpPr>
-        <p:cNvPr id="1" name=""/>
-        <p:cNvGrpSpPr/>
-        <p:nvPr/>
-      </p:nvGrpSpPr>
-      <p:grpSpPr>
-        <a:xfrm>
-          <a:off x="0" y="0"/>
-          <a:ext cx="0" cy="0"/>
-          <a:chOff x="0" y="0"/>
-          <a:chExt cx="0" cy="0"/>
-        </a:xfrm>
-      </p:grpSpPr>
-      <p:sp>
-        <p:nvSpPr>
-          <p:cNvPr id="2" name="Title 1"/>
-          <p:cNvSpPr>
-            <a:spLocks noGrp="1"/>
-          </p:cNvSpPr>
-          <p:nvPr>
-            <p:ph type="title"/>
-          </p:nvPr>
-        </p:nvSpPr>
-        <p:spPr/>
-        <p:txBody>
-          <a:bodyPr/>
-          <a:lstStyle/>
-          <a:p>
-            <a:pPr lvl="0" indent="0" marL="0" rtl="1" algn="r">
-              <a:buNone/>
-            </a:pPr>
-            <a:r>
-              <a:rPr lang="fa-IR" dirty="0">
-                <a:latin typeface="Tahoma"/>
-                <a:cs typeface="Tahoma"/>
-              </a:rPr>
-              <a:t>فهرست مطالب</a:t>
-            </a:r>
-          </a:p>
-        </p:txBody>
-      </p:sp>
-      <p:sp>
-        <p:nvSpPr>
-          <p:cNvPr id="3" name="Content Placeholder 2"/>
-          <p:cNvSpPr>
-            <a:spLocks noGrp="1"/>
-          </p:cNvSpPr>
-          <p:nvPr>
-            <p:ph idx="1"/>
-          </p:nvPr>
-        </p:nvSpPr>
-        <p:spPr/>
-        <p:txBody>
-          <a:bodyPr/>
-          <a:lstStyle/>
-          <a:p>
-            <a:pPr lvl="0" rtl="1" algn="r"/>
-            <a:r>
-              <a:rPr lang="fa-IR" dirty="0">
-                <a:latin typeface="Tahoma"/>
-                <a:cs typeface="Tahoma"/>
-              </a:rPr>
-              <a:t>بیان مسئله و هدف پژوهش</a:t>
-            </a:r>
-          </a:p>
-          <a:p>
-            <a:pPr lvl="0" rtl="1" algn="r"/>
-            <a:r>
-              <a:rPr lang="fa-IR" dirty="0">
-                <a:latin typeface="Tahoma"/>
-                <a:cs typeface="Tahoma"/>
-              </a:rPr>
-              <a:t>پیشینه و شکاف تحقیقاتی</a:t>
-            </a:r>
-          </a:p>
-          <a:p>
-            <a:pPr lvl="0" rtl="1" algn="r"/>
-            <a:r>
-              <a:rPr lang="fa-IR" dirty="0">
-                <a:latin typeface="Tahoma"/>
-                <a:cs typeface="Tahoma"/>
-              </a:rPr>
-              <a:t>مدل‌سازی: هندسه، مواد و الگوها</a:t>
-            </a:r>
-          </a:p>
-          <a:p>
-            <a:pPr lvl="0" rtl="1" algn="r"/>
-            <a:r>
-              <a:rPr lang="fa-IR" dirty="0">
-                <a:latin typeface="Tahoma"/>
-                <a:cs typeface="Tahoma"/>
-              </a:rPr>
-              <a:t>معادلات حاکم و روش حل عددی</a:t>
-            </a:r>
-          </a:p>
-          <a:p>
-            <a:pPr lvl="0" rtl="1" algn="r"/>
-            <a:r>
-              <a:rPr lang="fa-IR" dirty="0">
-                <a:latin typeface="Tahoma"/>
-                <a:cs typeface="Tahoma"/>
-              </a:rPr>
-              <a:t>صحت‌سنجی و همگرایی</a:t>
-            </a:r>
-          </a:p>
-          <a:p>
-            <a:pPr lvl="0" rtl="1" algn="r"/>
-            <a:r>
-              <a:rPr lang="fa-IR" dirty="0">
-                <a:latin typeface="Tahoma"/>
-                <a:cs typeface="Tahoma"/>
-              </a:rPr>
-              <a:t>نتایج و بحث</a:t>
-            </a:r>
-          </a:p>
-          <a:p>
-            <a:pPr lvl="0" rtl="1" algn="r"/>
-            <a:r>
-              <a:rPr lang="fa-IR" dirty="0">
-                <a:latin typeface="Tahoma"/>
-                <a:cs typeface="Tahoma"/>
-              </a:rPr>
-              <a:t>نوآوری‌ها، نتیجه‌گیری و پیشنهادها</a:t>
-            </a:r>
-          </a:p>
-        </p:txBody>
-      </p:sp>
-    </p:spTree>
-  </p:cSld>
-</p:sld>
-</file>
-
-<file path=ppt/slides/slide20.xml><?xml version="1.0" encoding="utf-8"?>
+<file path=ppt/slides/slide29.xml><?xml version="1.0" encoding="utf-8"?>
 <p:sld xmlns:a="http://schemas.openxmlformats.org/drawingml/2006/main" xmlns:r="http://schemas.openxmlformats.org/officeDocument/2006/relationships" xmlns:p="http://schemas.openxmlformats.org/presentationml/2006/main">
   <p:cSld>
     <p:spTree>
@@ -7716,7 +9877,113 @@
 </p:sld>
 </file>
 
-<file path=ppt/slides/slide21.xml><?xml version="1.0" encoding="utf-8"?>
+<file path=ppt/slides/slide3.xml><?xml version="1.0" encoding="utf-8"?>
+<p:sld xmlns:a="http://schemas.openxmlformats.org/drawingml/2006/main" xmlns:r="http://schemas.openxmlformats.org/officeDocument/2006/relationships" xmlns:p="http://schemas.openxmlformats.org/presentationml/2006/main">
+  <p:cSld>
+    <p:spTree>
+      <p:nvGrpSpPr>
+        <p:cNvPr id="1" name=""/>
+        <p:cNvGrpSpPr/>
+        <p:nvPr/>
+      </p:nvGrpSpPr>
+      <p:grpSpPr>
+        <a:xfrm>
+          <a:off x="0" y="0"/>
+          <a:ext cx="0" cy="0"/>
+          <a:chOff x="0" y="0"/>
+          <a:chExt cx="0" cy="0"/>
+        </a:xfrm>
+      </p:grpSpPr>
+      <p:sp>
+        <p:nvSpPr>
+          <p:cNvPr id="2" name="Title 1"/>
+          <p:cNvSpPr>
+            <a:spLocks noGrp="1"/>
+          </p:cNvSpPr>
+          <p:nvPr>
+            <p:ph type="title"/>
+          </p:nvPr>
+        </p:nvSpPr>
+        <p:spPr/>
+        <p:txBody>
+          <a:bodyPr/>
+          <a:lstStyle/>
+          <a:p>
+            <a:pPr lvl="0" indent="0" marL="0" rtl="1" algn="r">
+              <a:buNone/>
+            </a:pPr>
+            <a:r>
+              <a:rPr lang="fa-IR" dirty="0">
+                <a:latin typeface="Tahoma"/>
+                <a:cs typeface="Tahoma"/>
+              </a:rPr>
+              <a:t>استوانه‌های جدارضخیم: سازه‌ای پرکاربرد در معرض بارهای حرارتی سریع</a:t>
+            </a:r>
+          </a:p>
+        </p:txBody>
+      </p:sp>
+      <p:sp>
+        <p:nvSpPr>
+          <p:cNvPr id="3" name="Content Placeholder 2"/>
+          <p:cNvSpPr>
+            <a:spLocks noGrp="1"/>
+          </p:cNvSpPr>
+          <p:nvPr>
+            <p:ph idx="1"/>
+          </p:nvPr>
+        </p:nvSpPr>
+        <p:spPr/>
+        <p:txBody>
+          <a:bodyPr/>
+          <a:lstStyle/>
+          <a:p>
+            <a:pPr lvl="0" rtl="1" algn="r"/>
+            <a:r>
+              <a:rPr lang="fa-IR" dirty="0">
+                <a:latin typeface="Tahoma"/>
+                <a:cs typeface="Tahoma"/>
+              </a:rPr>
+              <a:t>سیلندرها استوانه‌هایی توخالی و معمولاً جدارضخیم‌اند و بارهای محوری، برشی، پیچشی، خمشی، هیدرواستاتیک و هیدرودینامیک را تحمل می‌کنند.</a:t>
+            </a:r>
+          </a:p>
+          <a:p>
+            <a:pPr lvl="0" rtl="1" algn="r"/>
+            <a:r>
+              <a:rPr lang="fa-IR" dirty="0">
+                <a:latin typeface="Tahoma"/>
+                <a:cs typeface="Tahoma"/>
+              </a:rPr>
+              <a:t>کاربرد: مخازن نگهداری و انتقال سیال، فضاپیماها، رآکتورهای هسته‌ای، مبدل‌های حرارتی.</a:t>
+            </a:r>
+          </a:p>
+          <a:p>
+            <a:pPr lvl="0" rtl="1" algn="r"/>
+            <a:r>
+              <a:rPr lang="fa-IR" dirty="0">
+                <a:latin typeface="Tahoma"/>
+                <a:cs typeface="Tahoma"/>
+              </a:rPr>
+              <a:t>این اجزا اغلب در معرض بارهای حرارتیِ سریع و شدید قرار می‌گیرند.</a:t>
+            </a:r>
+          </a:p>
+          <a:p>
+            <a:pPr lvl="0" rtl="1" algn="r"/>
+            <a:r>
+              <a:rPr lang="fa-IR" dirty="0">
+                <a:latin typeface="Tahoma"/>
+                <a:cs typeface="Tahoma"/>
+              </a:rPr>
+              <a:t>پیش‌بینی دقیق دما و تنش‌های حرارتیِ گذرا برای ایمنی و طول عمر سازه حیاتی است.</a:t>
+            </a:r>
+          </a:p>
+        </p:txBody>
+      </p:sp>
+    </p:spTree>
+  </p:cSld>
+</p:sld>
+</file>
+
+<file path=ppt/slides/slide30.xml><?xml version="1.0" encoding="utf-8"?>
 <p:sld xmlns:a="http://schemas.openxmlformats.org/drawingml/2006/main" xmlns:r="http://schemas.openxmlformats.org/officeDocument/2006/relationships" xmlns:p="http://schemas.openxmlformats.org/presentationml/2006/main">
   <p:cSld>
     <p:spTree>
@@ -7879,7 +10146,7 @@
 </p:sld>
 </file>
 
-<file path=ppt/slides/slide22.xml><?xml version="1.0" encoding="utf-8"?>
+<file path=ppt/slides/slide31.xml><?xml version="1.0" encoding="utf-8"?>
 <p:sld xmlns:a="http://schemas.openxmlformats.org/drawingml/2006/main" xmlns:r="http://schemas.openxmlformats.org/officeDocument/2006/relationships" xmlns:p="http://schemas.openxmlformats.org/presentationml/2006/main">
   <p:cSld>
     <p:spTree>
@@ -8072,7 +10339,7 @@
 </p:sld>
 </file>
 
-<file path=ppt/slides/slide23.xml><?xml version="1.0" encoding="utf-8"?>
+<file path=ppt/slides/slide32.xml><?xml version="1.0" encoding="utf-8"?>
 <p:sld xmlns:a="http://schemas.openxmlformats.org/drawingml/2006/main" xmlns:r="http://schemas.openxmlformats.org/officeDocument/2006/relationships" xmlns:p="http://schemas.openxmlformats.org/presentationml/2006/main">
   <p:cSld>
     <p:spTree>
@@ -8235,7 +10502,7 @@
 </p:sld>
 </file>
 
-<file path=ppt/slides/slide24.xml><?xml version="1.0" encoding="utf-8"?>
+<file path=ppt/slides/slide33.xml><?xml version="1.0" encoding="utf-8"?>
 <p:sld xmlns:a="http://schemas.openxmlformats.org/drawingml/2006/main" xmlns:r="http://schemas.openxmlformats.org/officeDocument/2006/relationships" xmlns:p="http://schemas.openxmlformats.org/presentationml/2006/main">
   <p:cSld>
     <p:spTree>
@@ -8280,7 +10547,7 @@
                 <a:latin typeface="Tahoma"/>
                 <a:cs typeface="Tahoma"/>
               </a:rPr>
-              <a:t>نتیجه ۶: در شوک گاوسی، فوریه دما را ۲٫۵ برابر کم‌برآورد می‌کند</a:t>
+              <a:t>نتیجه ۶: در شوک گاوسی، بیشینهٔ دمای فوریه حدود ۲٫۵ برابر کمتر است</a:t>
             </a:r>
           </a:p>
         </p:txBody>
@@ -8306,21 +10573,7 @@
                 <a:latin typeface="Tahoma"/>
                 <a:cs typeface="Tahoma"/>
               </a:rPr>
-              <a:t>مدل کلاسیک در شوک کوتاه‌مدت </a:t>
-            </a:r>
-            <a:r>
-              <a:rPr b="1" lang="fa-IR" dirty="0">
-                <a:latin typeface="Tahoma"/>
-                <a:cs typeface="Tahoma"/>
-              </a:rPr>
-              <a:t>غیرمحافظه‌کارانه</a:t>
-            </a:r>
-            <a:r>
-              <a:rPr lang="fa-IR" dirty="0">
-                <a:latin typeface="Tahoma"/>
-                <a:cs typeface="Tahoma"/>
-              </a:rPr>
-              <a:t> است.</a:t>
+              <a:t>در شوک کوتاه‌مدت، انتخاب مدل هدایت بر پیش‌بینی بیشینهٔ دما اثر زیادی دارد.</a:t>
             </a:r>
           </a:p>
           <a:p>
@@ -8384,7 +10637,7 @@
 </p:sld>
 </file>
 
-<file path=ppt/slides/slide25.xml><?xml version="1.0" encoding="utf-8"?>
+<file path=ppt/slides/slide34.xml><?xml version="1.0" encoding="utf-8"?>
 <p:sld xmlns:a="http://schemas.openxmlformats.org/drawingml/2006/main" xmlns:r="http://schemas.openxmlformats.org/officeDocument/2006/relationships" xmlns:p="http://schemas.openxmlformats.org/presentationml/2006/main">
   <p:cSld>
     <p:spTree>
@@ -8540,7 +10793,7 @@
 </p:sld>
 </file>
 
-<file path=ppt/slides/slide26.xml><?xml version="1.0" encoding="utf-8"?>
+<file path=ppt/slides/slide35.xml><?xml version="1.0" encoding="utf-8"?>
 <p:sld xmlns:a="http://schemas.openxmlformats.org/drawingml/2006/main" xmlns:r="http://schemas.openxmlformats.org/officeDocument/2006/relationships" xmlns:p="http://schemas.openxmlformats.org/presentationml/2006/main">
   <p:cSld>
     <p:spTree>
@@ -8729,7 +10982,7 @@
 </p:sld>
 </file>
 
-<file path=ppt/slides/slide27.xml><?xml version="1.0" encoding="utf-8"?>
+<file path=ppt/slides/slide36.xml><?xml version="1.0" encoding="utf-8"?>
 <p:sld xmlns:a="http://schemas.openxmlformats.org/drawingml/2006/main" xmlns:r="http://schemas.openxmlformats.org/officeDocument/2006/relationships" xmlns:p="http://schemas.openxmlformats.org/presentationml/2006/main">
   <p:cSld>
     <p:spTree>
@@ -8795,7 +11048,7 @@
                 <a:latin typeface="Tahoma"/>
                 <a:cs typeface="Tahoma"/>
               </a:rPr>
-              <a:t>برای </a:t>
+              <a:t>در </a:t>
             </a:r>
             <a:r>
               <a:rPr b="1" lang="fa-IR" dirty="0">
@@ -8809,21 +11062,7 @@
                 <a:latin typeface="Tahoma"/>
                 <a:cs typeface="Tahoma"/>
               </a:rPr>
-              <a:t>، لرد-شولمن </a:t>
-            </a:r>
-            <a:r>
-              <a:rPr b="1" lang="fa-IR" dirty="0">
-                <a:latin typeface="Tahoma"/>
-                <a:cs typeface="Tahoma"/>
-              </a:rPr>
-              <a:t>ضروری</a:t>
-            </a:r>
-            <a:r>
-              <a:rPr lang="fa-IR" dirty="0">
-                <a:latin typeface="Tahoma"/>
-                <a:cs typeface="Tahoma"/>
-              </a:rPr>
-              <a:t> است؛ فوریه دما و تنش گذرا را به‌شدت کم‌برآورد می‌کند.</a:t>
+              <a:t>، پیش‌بینی دما و تنش به انتخاب مدل هدایت حساس است؛ در پالس گاوسی فوریه بیشینهٔ دما را حدود ۲٫۵ برابر کمتر می‌دهد.</a:t>
             </a:r>
           </a:p>
           <a:p>
@@ -8898,7 +11137,7 @@
 </p:sld>
 </file>
 
-<file path=ppt/slides/slide28.xml><?xml version="1.0" encoding="utf-8"?>
+<file path=ppt/slides/slide37.xml><?xml version="1.0" encoding="utf-8"?>
 <p:sld xmlns:a="http://schemas.openxmlformats.org/drawingml/2006/main" xmlns:r="http://schemas.openxmlformats.org/officeDocument/2006/relationships" xmlns:p="http://schemas.openxmlformats.org/presentationml/2006/main">
   <p:cSld>
     <p:spTree>
@@ -9115,7 +11354,7 @@
 </p:sld>
 </file>
 
-<file path=ppt/slides/slide29.xml><?xml version="1.0" encoding="utf-8"?>
+<file path=ppt/slides/slide38.xml><?xml version="1.0" encoding="utf-8"?>
 <p:sld xmlns:a="http://schemas.openxmlformats.org/drawingml/2006/main" xmlns:r="http://schemas.openxmlformats.org/officeDocument/2006/relationships" xmlns:p="http://schemas.openxmlformats.org/presentationml/2006/main">
   <p:cSld>
     <p:spTree>
@@ -9193,7 +11432,7 @@
 </p:sld>
 </file>
 
-<file path=ppt/slides/slide3.xml><?xml version="1.0" encoding="utf-8"?>
+<file path=ppt/slides/slide39.xml><?xml version="1.0" encoding="utf-8"?>
 <p:sld xmlns:a="http://schemas.openxmlformats.org/drawingml/2006/main" xmlns:r="http://schemas.openxmlformats.org/officeDocument/2006/relationships" xmlns:p="http://schemas.openxmlformats.org/presentationml/2006/main">
   <p:cSld>
     <p:spTree>
@@ -9233,156 +11472,17 @@
                 <a:latin typeface="Tahoma"/>
                 <a:cs typeface="Tahoma"/>
               </a:rPr>
-              <a:t>چرا تئوری کلاسیک فوریه کافی نیست؟</a:t>
-            </a:r>
-          </a:p>
-        </p:txBody>
-      </p:sp>
-      <mc:AlternateContent xmlns:mc="http://schemas.openxmlformats.org/markup-compatibility/2006">
-        <mc:Choice xmlns:a14="http://schemas.microsoft.com/office/drawing/2010/main" Requires="a14">
-          <p:sp>
-            <p:nvSpPr>
-              <p:cNvPr id="3" name="Content Placeholder 2"/>
-              <p:cNvSpPr>
-                <a:spLocks noGrp="1"/>
-              </p:cNvSpPr>
-              <p:nvPr>
-                <p:ph idx="1"/>
-              </p:nvPr>
-            </p:nvSpPr>
-            <p:spPr/>
-            <p:txBody>
-              <a:bodyPr/>
-              <a:lstStyle/>
-              <a:p>
-                <a:pPr lvl="0" rtl="1" algn="r"/>
-                <a:r>
-                  <a:rPr lang="fa-IR" dirty="0">
-                    <a:latin typeface="Tahoma"/>
-                    <a:cs typeface="Tahoma"/>
-                  </a:rPr>
-                  <a:t>تئوری فوریه سرعت انتشار حرارت را </a:t>
-                </a:r>
-                <a:r>
-                  <a:rPr b="1" lang="fa-IR" dirty="0">
-                    <a:latin typeface="Tahoma"/>
-                    <a:cs typeface="Tahoma"/>
-                  </a:rPr>
-                  <a:t>بی‌نهایت</a:t>
-                </a:r>
-                <a:r>
-                  <a:rPr lang="fa-IR" dirty="0">
-                    <a:latin typeface="Tahoma"/>
-                    <a:cs typeface="Tahoma"/>
-                  </a:rPr>
-                  <a:t> فرض می‌کند.</a:t>
-                </a:r>
-              </a:p>
-              <a:p>
-                <a:pPr lvl="0" rtl="1" algn="r"/>
-                <a:r>
-                  <a:rPr lang="fa-IR" dirty="0">
-                    <a:latin typeface="Tahoma"/>
-                    <a:cs typeface="Tahoma"/>
-                  </a:rPr>
-                  <a:t>این فرض در </a:t>
-                </a:r>
-                <a:r>
-                  <a:rPr b="1" lang="fa-IR" dirty="0">
-                    <a:latin typeface="Tahoma"/>
-                    <a:cs typeface="Tahoma"/>
-                  </a:rPr>
-                  <a:t>شوک حرارتی و زمان‌های کوتاه</a:t>
-                </a:r>
-                <a:r>
-                  <a:rPr lang="fa-IR" dirty="0">
-                    <a:latin typeface="Tahoma"/>
-                    <a:cs typeface="Tahoma"/>
-                  </a:rPr>
-                  <a:t> غیرفیزیکی است.</a:t>
-                </a:r>
-              </a:p>
-              <a:p>
-                <a:pPr lvl="0" rtl="1" algn="r"/>
-                <a:r>
-                  <a:rPr lang="fa-IR" dirty="0">
-                    <a:latin typeface="Tahoma"/>
-                    <a:cs typeface="Tahoma"/>
-                  </a:rPr>
-                  <a:t>تئوری لرد-شولمن با زمان تخفیف </a:t>
-                </a:r>
-                <a14:m>
-                  <m:oMath xmlns:m="http://schemas.openxmlformats.org/officeDocument/2006/math">
-                    <m:sSub>
-                      <m:e>
-                        <m:r>
-                          <m:t>τ</m:t>
-                        </m:r>
-                      </m:e>
-                      <m:sub>
-                        <m:r>
-                          <m:t>0</m:t>
-                        </m:r>
-                      </m:sub>
-                    </m:sSub>
-                  </m:oMath>
-                </a14:m>
-                <a:r>
-                  <a:rPr lang="fa-IR" dirty="0">
-                    <a:latin typeface="Tahoma"/>
-                    <a:cs typeface="Tahoma"/>
-                  </a:rPr>
-                  <a:t> معادلهٔ انرژی را </a:t>
-                </a:r>
-                <a:r>
-                  <a:rPr b="1" lang="fa-IR" dirty="0">
-                    <a:latin typeface="Tahoma"/>
-                    <a:cs typeface="Tahoma"/>
-                  </a:rPr>
-                  <a:t>هذلولوی</a:t>
-                </a:r>
-                <a:r>
-                  <a:rPr lang="fa-IR" dirty="0">
-                    <a:latin typeface="Tahoma"/>
-                    <a:cs typeface="Tahoma"/>
-                  </a:rPr>
-                  <a:t> می‌کند: حرارت به‌صورت </a:t>
-                </a:r>
-                <a:r>
-                  <a:rPr b="1" lang="fa-IR" dirty="0">
-                    <a:latin typeface="Tahoma"/>
-                    <a:cs typeface="Tahoma"/>
-                  </a:rPr>
-                  <a:t>موج با سرعت محدود</a:t>
-                </a:r>
-                <a:r>
-                  <a:rPr lang="fa-IR" dirty="0">
-                    <a:latin typeface="Tahoma"/>
-                    <a:cs typeface="Tahoma"/>
-                  </a:rPr>
-                  <a:t> منتشر می‌شود.</a:t>
-                </a:r>
-              </a:p>
-              <a:p>
-                <a:pPr lvl="0" rtl="1" algn="r"/>
-                <a:r>
-                  <a:rPr lang="fa-IR" dirty="0">
-                    <a:latin typeface="Tahoma"/>
-                    <a:cs typeface="Tahoma"/>
-                  </a:rPr>
-                  <a:t>کاربرد: مخازن تحت فشار، محفظه‌های احتراق و سامانه‌های حفاظت حرارتی.</a:t>
-                </a:r>
-              </a:p>
-            </p:txBody>
-          </p:sp>
-        </mc:Choice>
-      </mc:AlternateContent>
+              <a:t>اسلایدهای پشتیبان</a:t>
+            </a:r>
+          </a:p>
+        </p:txBody>
+      </p:sp>
     </p:spTree>
   </p:cSld>
 </p:sld>
 </file>
 
-<file path=ppt/slides/slide30.xml><?xml version="1.0" encoding="utf-8"?>
+<file path=ppt/slides/slide4.xml><?xml version="1.0" encoding="utf-8"?>
 <p:sld xmlns:a="http://schemas.openxmlformats.org/drawingml/2006/main" xmlns:r="http://schemas.openxmlformats.org/officeDocument/2006/relationships" xmlns:p="http://schemas.openxmlformats.org/presentationml/2006/main">
   <p:cSld>
     <p:spTree>
@@ -9422,7 +11522,73 @@
                 <a:latin typeface="Tahoma"/>
                 <a:cs typeface="Tahoma"/>
               </a:rPr>
-              <a:t>اسلایدهای پشتیبان</a:t>
+              <a:t>مواد نوین: گرافن برای استحکام، تخلخل برای سبکی و عایق‌بودن</a:t>
+            </a:r>
+          </a:p>
+        </p:txBody>
+      </p:sp>
+      <p:sp>
+        <p:nvSpPr>
+          <p:cNvPr id="3" name="Content Placeholder 2"/>
+          <p:cNvSpPr>
+            <a:spLocks noGrp="1"/>
+          </p:cNvSpPr>
+          <p:nvPr>
+            <p:ph idx="1"/>
+          </p:nvPr>
+        </p:nvSpPr>
+        <p:spPr/>
+        <p:txBody>
+          <a:bodyPr/>
+          <a:lstStyle/>
+          <a:p>
+            <a:pPr lvl="0" rtl="1" algn="r"/>
+            <a:r>
+              <a:rPr lang="fa-IR" dirty="0">
+                <a:latin typeface="Tahoma"/>
+                <a:cs typeface="Tahoma"/>
+              </a:rPr>
+              <a:t>نانولوله‌های کربنی (۱۹۹۱) و گرافن (۲۰۰۴): استحکام و مدول بسیار زیاد، رسانش الکتریکی و حرارتی عالی [۱].</a:t>
+            </a:r>
+          </a:p>
+          <a:p>
+            <a:pPr lvl="0" rtl="1" algn="r"/>
+            <a:r>
+              <a:rPr lang="fa-IR" dirty="0">
+                <a:latin typeface="Tahoma"/>
+                <a:cs typeface="Tahoma"/>
+              </a:rPr>
+              <a:t>نانوکامپوزیت‌های گرافنی از کامپوزیت‌های نانولوله و نانوگرافیت خواص مکانیکی بهتری نشان داده‌اند؛ سطح تماس زیاد، انتقال بار را بهبود می‌دهد.</a:t>
+            </a:r>
+          </a:p>
+          <a:p>
+            <a:pPr lvl="0" rtl="1" algn="r"/>
+            <a:r>
+              <a:rPr lang="fa-IR" dirty="0">
+                <a:latin typeface="Tahoma"/>
+                <a:cs typeface="Tahoma"/>
+              </a:rPr>
+              <a:t>مواد متخلخل: سبک، جاذب انرژی، با سطح ویژهٔ زیاد و مقاوم در برابر حرارت؛ اما تخلخل استحکام را کم می‌کند.</a:t>
+            </a:r>
+          </a:p>
+          <a:p>
+            <a:pPr lvl="0" rtl="1" algn="r"/>
+            <a:r>
+              <a:rPr lang="fa-IR" dirty="0">
+                <a:latin typeface="Tahoma"/>
+                <a:cs typeface="Tahoma"/>
+              </a:rPr>
+              <a:t>افزودن ورقه‌های گرافنی به مادهٔ متخلخل یکی از راه‌های جبران این افت است [۲].</a:t>
+            </a:r>
+          </a:p>
+          <a:p>
+            <a:pPr lvl="0" rtl="1" algn="r"/>
+            <a:r>
+              <a:rPr lang="fa-IR" dirty="0">
+                <a:latin typeface="Tahoma"/>
+                <a:cs typeface="Tahoma"/>
+              </a:rPr>
+              <a:t>ترکیب این دو در ماده‌ای مدرجِ لایه‌ای، توزیع هدفمند ماده در ضخامت را ممکن می‌کند.</a:t>
             </a:r>
           </a:p>
         </p:txBody>
@@ -9432,7 +11598,7 @@
 </p:sld>
 </file>
 
-<file path=ppt/slides/slide31.xml><?xml version="1.0" encoding="utf-8"?>
+<file path=ppt/slides/slide40.xml><?xml version="1.0" encoding="utf-8"?>
 <p:sld xmlns:a="http://schemas.openxmlformats.org/drawingml/2006/main" xmlns:r="http://schemas.openxmlformats.org/officeDocument/2006/relationships" xmlns:p="http://schemas.openxmlformats.org/presentationml/2006/main">
   <p:cSld>
     <p:spTree>
@@ -9623,7 +11789,7 @@
 </p:sld>
 </file>
 
-<file path=ppt/slides/slide32.xml><?xml version="1.0" encoding="utf-8"?>
+<file path=ppt/slides/slide41.xml><?xml version="1.0" encoding="utf-8"?>
 <p:sld xmlns:a="http://schemas.openxmlformats.org/drawingml/2006/main" xmlns:r="http://schemas.openxmlformats.org/officeDocument/2006/relationships" xmlns:p="http://schemas.openxmlformats.org/presentationml/2006/main">
   <p:cSld>
     <p:spTree>
@@ -9776,7 +11942,7 @@
 </p:sld>
 </file>
 
-<file path=ppt/slides/slide4.xml><?xml version="1.0" encoding="utf-8"?>
+<file path=ppt/slides/slide5.xml><?xml version="1.0" encoding="utf-8"?>
 <p:sld xmlns:a="http://schemas.openxmlformats.org/drawingml/2006/main" xmlns:r="http://schemas.openxmlformats.org/officeDocument/2006/relationships" xmlns:p="http://schemas.openxmlformats.org/presentationml/2006/main">
   <p:cSld>
     <p:spTree>
@@ -9816,7 +11982,7 @@
                 <a:latin typeface="Tahoma"/>
                 <a:cs typeface="Tahoma"/>
               </a:rPr>
-              <a:t>هدف پژوهش</a:t>
+              <a:t>مسئله: پاسخ ترموالاستیک گذرا؛ انتخاب مدل هدایت و الگوی ماده</a:t>
             </a:r>
           </a:p>
         </p:txBody>
@@ -9844,35 +12010,7 @@
                     <a:latin typeface="Tahoma"/>
                     <a:cs typeface="Tahoma"/>
                   </a:rPr>
-                  <a:t>حلِ </a:t>
-                </a:r>
-                <a:r>
-                  <a:rPr b="1" lang="fa-IR" dirty="0">
-                    <a:latin typeface="Tahoma"/>
-                    <a:cs typeface="Tahoma"/>
-                  </a:rPr>
-                  <a:t>کاملاً ممزوجِ</a:t>
-                </a:r>
-                <a:r>
-                  <a:rPr lang="fa-IR" dirty="0">
-                    <a:latin typeface="Tahoma"/>
-                    <a:cs typeface="Tahoma"/>
-                  </a:rPr>
-                  <a:t> معادلات لرد-شولمن برای استوانهٔ </a:t>
-                </a:r>
-                <a:r>
-                  <a:rPr b="1" lang="fa-IR" dirty="0">
-                    <a:latin typeface="Tahoma"/>
-                    <a:cs typeface="Tahoma"/>
-                  </a:rPr>
-                  <a:t>چندلایهٔ متخلخلِ تقویت‌شده با گرافن</a:t>
-                </a:r>
-                <a:r>
-                  <a:rPr lang="fa-IR" dirty="0">
-                    <a:latin typeface="Tahoma"/>
-                    <a:cs typeface="Tahoma"/>
-                  </a:rPr>
-                  <a:t>.</a:t>
+                  <a:t>قانون فوریه سرعت انتشار حرارت را نامحدود می‌گیرد؛ در بارهای حرارتی پیچیده مانند شوک حرارتی و بار انفجاری دقت کافی ندارد [۳].</a:t>
                 </a:r>
               </a:p>
               <a:p>
@@ -9882,56 +12020,7 @@
                     <a:latin typeface="Tahoma"/>
                     <a:cs typeface="Tahoma"/>
                   </a:rPr>
-                  <a:t>بررسی </a:t>
-                </a:r>
-                <a:r>
-                  <a:rPr b="1" lang="fa-IR" dirty="0">
-                    <a:latin typeface="Tahoma"/>
-                    <a:cs typeface="Tahoma"/>
-                  </a:rPr>
-                  <a:t>دما، تنش، کرنش و جابجایی</a:t>
-                </a:r>
-                <a:r>
-                  <a:rPr lang="fa-IR" dirty="0">
-                    <a:latin typeface="Tahoma"/>
-                    <a:cs typeface="Tahoma"/>
-                  </a:rPr>
-                  <a:t> در فضای دوبعدی </a:t>
-                </a:r>
-                <a14:m>
-                  <m:oMath xmlns:m="http://schemas.openxmlformats.org/officeDocument/2006/math">
-                    <m:r>
-                      <m:rPr>
-                        <m:sty m:val="p"/>
-                      </m:rPr>
-                      <m:t>(</m:t>
-                    </m:r>
-                    <m:r>
-                      <m:t>r</m:t>
-                    </m:r>
-                    <m:r>
-                      <m:rPr>
-                        <m:sty m:val="p"/>
-                      </m:rPr>
-                      <m:t>,</m:t>
-                    </m:r>
-                    <m:r>
-                      <m:t>z</m:t>
-                    </m:r>
-                    <m:r>
-                      <m:rPr>
-                        <m:sty m:val="p"/>
-                      </m:rPr>
-                      <m:t>)</m:t>
-                    </m:r>
-                  </m:oMath>
-                </a14:m>
-                <a:r>
-                  <a:rPr lang="fa-IR" dirty="0">
-                    <a:latin typeface="Tahoma"/>
-                    <a:cs typeface="Tahoma"/>
-                  </a:rPr>
-                  <a:t>.</a:t>
+                  <a:t>تئوری‌های غیرممزوج، دما و جابجایی را مستقل حساب می‌کنند.</a:t>
                 </a:r>
               </a:p>
               <a:p>
@@ -9941,248 +12030,53 @@
                     <a:latin typeface="Tahoma"/>
                     <a:cs typeface="Tahoma"/>
                   </a:rPr>
-                  <a:t>کمّی‌سازی اثر </a:t>
+                  <a:t>برای دقت بیشتر، تئوری‌های تعمیم‌یافته و ممزوج معرفی شده‌اند؛ یکی از آن‌ها تئوری لرد–شولمن (۱۹۶۷) با زمان تخفیف </a:t>
                 </a:r>
+                <a14:m>
+                  <m:oMath xmlns:m="http://schemas.openxmlformats.org/officeDocument/2006/math">
+                    <m:sSub>
+                      <m:e>
+                        <m:r>
+                          <m:t>τ</m:t>
+                        </m:r>
+                      </m:e>
+                      <m:sub>
+                        <m:r>
+                          <m:t>0</m:t>
+                        </m:r>
+                      </m:sub>
+                    </m:sSub>
+                  </m:oMath>
+                </a14:m>
+                <a:r>
+                  <a:rPr lang="fa-IR" dirty="0">
+                    <a:latin typeface="Tahoma"/>
+                    <a:cs typeface="Tahoma"/>
+                  </a:rPr>
+                  <a:t> است [۴].</a:t>
+                </a:r>
+              </a:p>
+              <a:p>
+                <a:pPr lvl="0" rtl="1" algn="r"/>
                 <a:r>
                   <a:rPr b="1" lang="fa-IR" dirty="0">
                     <a:latin typeface="Tahoma"/>
                     <a:cs typeface="Tahoma"/>
                   </a:rPr>
-                  <a:t>الگوهای پنج‌گانهٔ</a:t>
+                  <a:t>مسئلهٔ این پژوهش:</a:t>
                 </a:r>
                 <a:r>
                   <a:rPr lang="fa-IR" dirty="0">
                     <a:latin typeface="Tahoma"/>
                     <a:cs typeface="Tahoma"/>
                   </a:rPr>
-                  <a:t> گرافن و تخلخل (UD, O, X, V, A).</a:t>
-                </a:r>
-              </a:p>
-              <a:p>
-                <a:pPr lvl="0" rtl="1" algn="r"/>
-                <a:r>
-                  <a:rPr lang="fa-IR" dirty="0">
-                    <a:latin typeface="Tahoma"/>
-                    <a:cs typeface="Tahoma"/>
-                  </a:rPr>
-                  <a:t>مقایسهٔ </a:t>
-                </a:r>
-                <a:r>
-                  <a:rPr b="1" lang="fa-IR" dirty="0">
-                    <a:latin typeface="Tahoma"/>
-                    <a:cs typeface="Tahoma"/>
-                  </a:rPr>
-                  <a:t>چهار تئوری</a:t>
-                </a:r>
-                <a:r>
-                  <a:rPr lang="fa-IR" dirty="0">
-                    <a:latin typeface="Tahoma"/>
-                    <a:cs typeface="Tahoma"/>
-                  </a:rPr>
-                  <a:t> ترموالاستیسیته.</a:t>
-                </a:r>
-              </a:p>
-              <a:p>
-                <a:pPr lvl="0" rtl="1" algn="r"/>
-                <a:r>
-                  <a:rPr lang="fa-IR" dirty="0">
-                    <a:latin typeface="Tahoma"/>
-                    <a:cs typeface="Tahoma"/>
-                  </a:rPr>
-                  <a:t>ارائهٔ یک </a:t>
-                </a:r>
-                <a:r>
-                  <a:rPr b="1" lang="fa-IR" dirty="0">
-                    <a:latin typeface="Tahoma"/>
-                    <a:cs typeface="Tahoma"/>
-                  </a:rPr>
-                  <a:t>توصیهٔ طراحی</a:t>
-                </a:r>
-                <a:r>
-                  <a:rPr lang="fa-IR" dirty="0">
-                    <a:latin typeface="Tahoma"/>
-                    <a:cs typeface="Tahoma"/>
-                  </a:rPr>
-                  <a:t> برای حفاظت حرارتی.</a:t>
+                  <a:t> توزیع دما، تنش، کرنش و جابجایی در استوانهٔ متخلخلِ تقویت‌شده با پلاکت‌های گرافنی تحت بار ترمو-مکانیکی.</a:t>
                 </a:r>
               </a:p>
             </p:txBody>
           </p:sp>
         </mc:Choice>
       </mc:AlternateContent>
-    </p:spTree>
-  </p:cSld>
-</p:sld>
-</file>
-
-<file path=ppt/slides/slide5.xml><?xml version="1.0" encoding="utf-8"?>
-<p:sld xmlns:a="http://schemas.openxmlformats.org/drawingml/2006/main" xmlns:r="http://schemas.openxmlformats.org/officeDocument/2006/relationships" xmlns:p="http://schemas.openxmlformats.org/presentationml/2006/main">
-  <p:cSld>
-    <p:spTree>
-      <p:nvGrpSpPr>
-        <p:cNvPr id="1" name=""/>
-        <p:cNvGrpSpPr/>
-        <p:nvPr/>
-      </p:nvGrpSpPr>
-      <p:grpSpPr>
-        <a:xfrm>
-          <a:off x="0" y="0"/>
-          <a:ext cx="0" cy="0"/>
-          <a:chOff x="0" y="0"/>
-          <a:chExt cx="0" cy="0"/>
-        </a:xfrm>
-      </p:grpSpPr>
-      <p:sp>
-        <p:nvSpPr>
-          <p:cNvPr id="2" name="Title 1"/>
-          <p:cNvSpPr>
-            <a:spLocks noGrp="1"/>
-          </p:cNvSpPr>
-          <p:nvPr>
-            <p:ph type="title"/>
-          </p:nvPr>
-        </p:nvSpPr>
-        <p:spPr/>
-        <p:txBody>
-          <a:bodyPr/>
-          <a:lstStyle/>
-          <a:p>
-            <a:pPr lvl="0" indent="0" marL="0" rtl="1" algn="r">
-              <a:buNone/>
-            </a:pPr>
-            <a:r>
-              <a:rPr lang="fa-IR" dirty="0">
-                <a:latin typeface="Tahoma"/>
-                <a:cs typeface="Tahoma"/>
-              </a:rPr>
-              <a:t>شکاف تحقیقاتی: حل ممزوج دوبعدی با ماتریس کامل الگوها</a:t>
-            </a:r>
-          </a:p>
-        </p:txBody>
-      </p:sp>
-      <p:sp>
-        <p:nvSpPr>
-          <p:cNvPr id="3" name="Content Placeholder 2"/>
-          <p:cNvSpPr>
-            <a:spLocks noGrp="1"/>
-          </p:cNvSpPr>
-          <p:nvPr>
-            <p:ph idx="1"/>
-          </p:nvPr>
-        </p:nvSpPr>
-        <p:spPr/>
-        <p:txBody>
-          <a:bodyPr/>
-          <a:lstStyle/>
-          <a:p>
-            <a:pPr lvl="0" rtl="1" algn="r"/>
-            <a:r>
-              <a:rPr lang="fa-IR" dirty="0">
-                <a:latin typeface="Tahoma"/>
-                <a:cs typeface="Tahoma"/>
-              </a:rPr>
-              <a:t>مطالعات پیشین: هدایت </a:t>
-            </a:r>
-            <a:r>
-              <a:rPr b="1" lang="fa-IR" dirty="0">
-                <a:latin typeface="Tahoma"/>
-                <a:cs typeface="Tahoma"/>
-              </a:rPr>
-              <a:t>کلاسیک فوریه</a:t>
-            </a:r>
-            <a:r>
-              <a:rPr lang="fa-IR" dirty="0">
-                <a:latin typeface="Tahoma"/>
-                <a:cs typeface="Tahoma"/>
-              </a:rPr>
-              <a:t>، یا حل </a:t>
-            </a:r>
-            <a:r>
-              <a:rPr b="1" lang="fa-IR" dirty="0">
-                <a:latin typeface="Tahoma"/>
-                <a:cs typeface="Tahoma"/>
-              </a:rPr>
-              <a:t>غیرممزوج</a:t>
-            </a:r>
-            <a:r>
-              <a:rPr lang="fa-IR" dirty="0">
-                <a:latin typeface="Tahoma"/>
-                <a:cs typeface="Tahoma"/>
-              </a:rPr>
-              <a:t>، یا هندسهٔ </a:t>
-            </a:r>
-            <a:r>
-              <a:rPr b="1" lang="fa-IR" dirty="0">
-                <a:latin typeface="Tahoma"/>
-                <a:cs typeface="Tahoma"/>
-              </a:rPr>
-              <a:t>یک‌بعدی</a:t>
-            </a:r>
-            <a:r>
-              <a:rPr lang="fa-IR" dirty="0">
-                <a:latin typeface="Tahoma"/>
-                <a:cs typeface="Tahoma"/>
-              </a:rPr>
-              <a:t>.</a:t>
-            </a:r>
-          </a:p>
-          <a:p>
-            <a:pPr lvl="0" rtl="1" algn="r"/>
-            <a:r>
-              <a:rPr lang="fa-IR" dirty="0">
-                <a:latin typeface="Tahoma"/>
-                <a:cs typeface="Tahoma"/>
-              </a:rPr>
-              <a:t>اثر گرافن و تخلخل غالباً </a:t>
-            </a:r>
-            <a:r>
-              <a:rPr b="1" lang="fa-IR" dirty="0">
-                <a:latin typeface="Tahoma"/>
-                <a:cs typeface="Tahoma"/>
-              </a:rPr>
-              <a:t>جداگانه</a:t>
-            </a:r>
-            <a:r>
-              <a:rPr lang="fa-IR" dirty="0">
-                <a:latin typeface="Tahoma"/>
-                <a:cs typeface="Tahoma"/>
-              </a:rPr>
-              <a:t> بررسی شده است.</a:t>
-            </a:r>
-          </a:p>
-          <a:p>
-            <a:pPr lvl="0" rtl="1" algn="r"/>
-            <a:r>
-              <a:rPr b="1" lang="fa-IR" dirty="0">
-                <a:latin typeface="Tahoma"/>
-                <a:cs typeface="Tahoma"/>
-              </a:rPr>
-              <a:t>شکاف:</a:t>
-            </a:r>
-            <a:r>
-              <a:rPr lang="fa-IR" dirty="0">
-                <a:latin typeface="Tahoma"/>
-                <a:cs typeface="Tahoma"/>
-              </a:rPr>
-              <a:t> حل ممزوج لرد-شولمن برای استوانهٔ چندلایهٔ متخلخلِ گرافنی در دو بُعد، با </a:t>
-            </a:r>
-            <a:r>
-              <a:rPr b="1" lang="fa-IR" dirty="0">
-                <a:latin typeface="Tahoma"/>
-                <a:cs typeface="Tahoma"/>
-              </a:rPr>
-              <a:t>ماتریس کاملِ برهم‌کنش الگوها</a:t>
-            </a:r>
-            <a:r>
-              <a:rPr lang="fa-IR" dirty="0">
-                <a:latin typeface="Tahoma"/>
-                <a:cs typeface="Tahoma"/>
-              </a:rPr>
-              <a:t>.</a:t>
-            </a:r>
-          </a:p>
-        </p:txBody>
-      </p:sp>
     </p:spTree>
   </p:cSld>
 </p:sld>
@@ -10228,41 +12122,84 @@
                 <a:latin typeface="Tahoma"/>
                 <a:cs typeface="Tahoma"/>
               </a:rPr>
-              <a:t>استوانهٔ توخالیِ هفت‌لایه با خواص متغیر در ضخامت</a:t>
-            </a:r>
-          </a:p>
-        </p:txBody>
-      </p:sp>
-      <p:pic>
-        <p:nvPicPr>
-          <p:cNvPr descr="../figures_ch123/geometry_schematic.png" id="0" name="Picture 1"/>
-          <p:cNvPicPr>
-            <a:picLocks noGrp="1" noChangeAspect="1"/>
-          </p:cNvPicPr>
-          <p:nvPr/>
-        </p:nvPicPr>
-        <p:blipFill>
-          <a:blip r:embed="rId2"/>
-          <a:stretch>
-            <a:fillRect/>
-          </a:stretch>
-        </p:blipFill>
-        <p:spPr bwMode="auto">
-          <a:xfrm>
-            <a:off x="1358900" y="1193800"/>
-            <a:ext cx="6438900" cy="3390900"/>
-          </a:xfrm>
-          <a:prstGeom prst="rect">
-            <a:avLst/>
-          </a:prstGeom>
-          <a:noFill/>
-          <a:ln w="9525">
-            <a:noFill/>
-            <a:headEnd/>
-            <a:tailEnd/>
-          </a:ln>
-        </p:spPr>
-      </p:pic>
+              <a:t>هدف و پرسش‌های پژوهش</a:t>
+            </a:r>
+          </a:p>
+        </p:txBody>
+      </p:sp>
+      <p:sp>
+        <p:nvSpPr>
+          <p:cNvPr id="3" name="Content Placeholder 2"/>
+          <p:cNvSpPr>
+            <a:spLocks noGrp="1"/>
+          </p:cNvSpPr>
+          <p:nvPr>
+            <p:ph idx="1"/>
+          </p:nvPr>
+        </p:nvSpPr>
+        <p:spPr/>
+        <p:txBody>
+          <a:bodyPr/>
+          <a:lstStyle/>
+          <a:p>
+            <a:pPr lvl="0" rtl="1" algn="r"/>
+            <a:r>
+              <a:rPr b="1" lang="fa-IR" dirty="0">
+                <a:latin typeface="Tahoma"/>
+                <a:cs typeface="Tahoma"/>
+              </a:rPr>
+              <a:t>هدف:</a:t>
+            </a:r>
+            <a:r>
+              <a:rPr lang="fa-IR" dirty="0">
+                <a:latin typeface="Tahoma"/>
+                <a:cs typeface="Tahoma"/>
+              </a:rPr>
+              <a:t> تحلیل ترموالاستیک استوانهٔ توخالیِ متخلخل تقویت‌شده با پلاکت‌های گرافنی تحت بار ترمو-مکانیکی، برای الگوهای مختلف گرافن و تخلخل در ضخامت.</a:t>
+            </a:r>
+          </a:p>
+          <a:p>
+            <a:pPr lvl="0" rtl="1" algn="r"/>
+            <a:r>
+              <a:rPr lang="fa-IR" dirty="0">
+                <a:latin typeface="Tahoma"/>
+                <a:cs typeface="Tahoma"/>
+              </a:rPr>
+              <a:t>پاسخ دما، تنش و جابجایی با سرعت متناهی موج حرارتی چه تفاوتی با هدایت فوریه دارد؟</a:t>
+            </a:r>
+          </a:p>
+          <a:p>
+            <a:pPr lvl="0" rtl="1" algn="r"/>
+            <a:r>
+              <a:rPr lang="fa-IR" dirty="0">
+                <a:latin typeface="Tahoma"/>
+                <a:cs typeface="Tahoma"/>
+              </a:rPr>
+              <a:t>الگوی گرافن و الگو و شدت تخلخل چگونه بر بیشینهٔ دما، تنش و جابجایی اثر می‌گذارند؟</a:t>
+            </a:r>
+          </a:p>
+          <a:p>
+            <a:pPr lvl="0" rtl="1" algn="r"/>
+            <a:r>
+              <a:rPr lang="fa-IR" dirty="0">
+                <a:latin typeface="Tahoma"/>
+                <a:cs typeface="Tahoma"/>
+              </a:rPr>
+              <a:t>برهم‌کنش هم‌زمان دو الگو هم‌افزاست یا خنثی‌کننده؟</a:t>
+            </a:r>
+          </a:p>
+          <a:p>
+            <a:pPr lvl="0" rtl="1" algn="r"/>
+            <a:r>
+              <a:rPr lang="fa-IR" dirty="0">
+                <a:latin typeface="Tahoma"/>
+                <a:cs typeface="Tahoma"/>
+              </a:rPr>
+              <a:t>اثر کسر وزنی، نسبت ابعادی، زمان تخفیف، تکیه‌گاه، فشار و ضخامت بر پاسخ گذرا چیست؟</a:t>
+            </a:r>
+          </a:p>
+        </p:txBody>
+      </p:sp>
     </p:spTree>
   </p:cSld>
 </p:sld>
@@ -10308,343 +12245,98 @@
                 <a:latin typeface="Tahoma"/>
                 <a:cs typeface="Tahoma"/>
               </a:rPr>
-              <a:t>حالت مرجع و شرایط مرزی</a:t>
-            </a:r>
-          </a:p>
-        </p:txBody>
-      </p:sp>
-      <mc:AlternateContent xmlns:mc="http://schemas.openxmlformats.org/markup-compatibility/2006">
-        <mc:Choice xmlns:a14="http://schemas.microsoft.com/office/drawing/2010/main" Requires="a14">
-          <p:sp>
-            <p:nvSpPr>
-              <p:cNvPr id="3" name="Content Placeholder 2"/>
-              <p:cNvSpPr>
-                <a:spLocks noGrp="1"/>
-              </p:cNvSpPr>
-              <p:nvPr>
-                <p:ph idx="1"/>
-              </p:nvPr>
-            </p:nvSpPr>
-            <p:spPr/>
-            <p:txBody>
-              <a:bodyPr/>
-              <a:lstStyle/>
-              <a:p>
-                <a:pPr lvl="0" rtl="1" algn="r"/>
-                <a:r>
-                  <a:rPr lang="fa-IR" dirty="0">
-                    <a:latin typeface="Tahoma"/>
-                    <a:cs typeface="Tahoma"/>
-                  </a:rPr>
-                  <a:t>ابعاد: </a:t>
-                </a:r>
-                <a14:m>
-                  <m:oMath xmlns:m="http://schemas.openxmlformats.org/officeDocument/2006/math">
-                    <m:sSub>
-                      <m:e>
-                        <m:r>
-                          <m:t>R</m:t>
-                        </m:r>
-                      </m:e>
-                      <m:sub>
-                        <m:r>
-                          <m:t>i</m:t>
-                        </m:r>
-                      </m:sub>
-                    </m:sSub>
-                    <m:r>
-                      <m:rPr>
-                        <m:sty m:val="p"/>
-                      </m:rPr>
-                      <m:t>=</m:t>
-                    </m:r>
-                    <m:r>
-                      <m:t>1</m:t>
-                    </m:r>
-                  </m:oMath>
-                </a14:m>
-                <a:r>
-                  <a:rPr lang="fa-IR" dirty="0">
-                    <a:latin typeface="Tahoma"/>
-                    <a:cs typeface="Tahoma"/>
-                  </a:rPr>
-                  <a:t> m، </a:t>
-                </a:r>
-                <a14:m>
-                  <m:oMath xmlns:m="http://schemas.openxmlformats.org/officeDocument/2006/math">
-                    <m:sSub>
-                      <m:e>
-                        <m:r>
-                          <m:t>R</m:t>
-                        </m:r>
-                      </m:e>
-                      <m:sub>
-                        <m:r>
-                          <m:t>o</m:t>
-                        </m:r>
-                      </m:sub>
-                    </m:sSub>
-                    <m:r>
-                      <m:rPr>
-                        <m:sty m:val="p"/>
-                      </m:rPr>
-                      <m:t>=</m:t>
-                    </m:r>
-                    <m:r>
-                      <m:t>1.5</m:t>
-                    </m:r>
-                  </m:oMath>
-                </a14:m>
-                <a:r>
-                  <a:rPr lang="fa-IR" dirty="0">
-                    <a:latin typeface="Tahoma"/>
-                    <a:cs typeface="Tahoma"/>
-                  </a:rPr>
-                  <a:t> m، طول </a:t>
-                </a:r>
-                <a14:m>
-                  <m:oMath xmlns:m="http://schemas.openxmlformats.org/officeDocument/2006/math">
-                    <m:r>
-                      <m:t>L</m:t>
-                    </m:r>
-                    <m:r>
-                      <m:rPr>
-                        <m:sty m:val="p"/>
-                      </m:rPr>
-                      <m:t>=</m:t>
-                    </m:r>
-                    <m:r>
-                      <m:t>2.1</m:t>
-                    </m:r>
-                  </m:oMath>
-                </a14:m>
-                <a:r>
-                  <a:rPr lang="fa-IR" dirty="0">
-                    <a:latin typeface="Tahoma"/>
-                    <a:cs typeface="Tahoma"/>
-                  </a:rPr>
-                  <a:t> m.</a:t>
-                </a:r>
-              </a:p>
-              <a:p>
-                <a:pPr lvl="0" rtl="1" algn="r"/>
-                <a:r>
-                  <a:rPr lang="fa-IR" dirty="0">
-                    <a:latin typeface="Tahoma"/>
-                    <a:cs typeface="Tahoma"/>
-                  </a:rPr>
-                  <a:t>حرارت: سطح داخلی </a:t>
-                </a:r>
-                <a14:m>
-                  <m:oMath xmlns:m="http://schemas.openxmlformats.org/officeDocument/2006/math">
-                    <m:r>
-                      <m:t>300</m:t>
-                    </m:r>
-                    <m:r>
-                      <m:rPr>
-                        <m:sty m:val="p"/>
-                      </m:rPr>
-                      <m:t>→</m:t>
-                    </m:r>
-                    <m:r>
-                      <m:t>600</m:t>
-                    </m:r>
-                  </m:oMath>
-                </a14:m>
-                <a:r>
-                  <a:rPr lang="fa-IR" dirty="0">
-                    <a:latin typeface="Tahoma"/>
-                    <a:cs typeface="Tahoma"/>
-                  </a:rPr>
-                  <a:t> K؛ سطح خارجی همرفت با </a:t>
-                </a:r>
-                <a14:m>
-                  <m:oMath xmlns:m="http://schemas.openxmlformats.org/officeDocument/2006/math">
-                    <m:sSub>
-                      <m:e>
-                        <m:r>
-                          <m:t>h</m:t>
-                        </m:r>
-                      </m:e>
-                      <m:sub>
-                        <m:r>
-                          <m:t>c</m:t>
-                        </m:r>
-                      </m:sub>
-                    </m:sSub>
-                    <m:r>
-                      <m:rPr>
-                        <m:sty m:val="p"/>
-                      </m:rPr>
-                      <m:t>=</m:t>
-                    </m:r>
-                    <m:r>
-                      <m:t>10</m:t>
-                    </m:r>
-                  </m:oMath>
-                </a14:m>
-                <a:r>
-                  <a:rPr lang="fa-IR" dirty="0">
-                    <a:latin typeface="Tahoma"/>
-                    <a:cs typeface="Tahoma"/>
-                  </a:rPr>
-                  <a:t> W/m²K.</a:t>
-                </a:r>
-              </a:p>
-              <a:p>
-                <a:pPr lvl="0" rtl="1" algn="r"/>
-                <a:r>
-                  <a:rPr lang="fa-IR" dirty="0">
-                    <a:latin typeface="Tahoma"/>
-                    <a:cs typeface="Tahoma"/>
-                  </a:rPr>
-                  <a:t>مکانیک: فشار داخلی </a:t>
-                </a:r>
-                <a14:m>
-                  <m:oMath xmlns:m="http://schemas.openxmlformats.org/officeDocument/2006/math">
-                    <m:sSub>
-                      <m:e>
-                        <m:r>
-                          <m:t>P</m:t>
-                        </m:r>
-                      </m:e>
-                      <m:sub>
-                        <m:r>
-                          <m:t>i</m:t>
-                        </m:r>
-                      </m:sub>
-                    </m:sSub>
-                    <m:r>
-                      <m:rPr>
-                        <m:sty m:val="p"/>
-                      </m:rPr>
-                      <m:t>=</m:t>
-                    </m:r>
-                    <m:r>
-                      <m:t>50</m:t>
-                    </m:r>
-                  </m:oMath>
-                </a14:m>
-                <a:r>
-                  <a:rPr lang="fa-IR" dirty="0">
-                    <a:latin typeface="Tahoma"/>
-                    <a:cs typeface="Tahoma"/>
-                  </a:rPr>
-                  <a:t> MPa؛ انتهاها تکیه‌گاه ساده و عایق.</a:t>
-                </a:r>
-              </a:p>
-              <a:p>
-                <a:pPr lvl="0" rtl="1" algn="r"/>
-                <a14:m>
-                  <m:oMath xmlns:m="http://schemas.openxmlformats.org/officeDocument/2006/math">
-                    <m:sSup>
-                      <m:e>
-                        <m:r>
-                          <m:t>τ</m:t>
-                        </m:r>
-                      </m:e>
-                      <m:sup>
-                        <m:r>
-                          <m:rPr>
-                            <m:sty m:val="p"/>
-                          </m:rPr>
-                          <m:t>*</m:t>
-                        </m:r>
-                      </m:sup>
-                    </m:sSup>
-                    <m:r>
-                      <m:rPr>
-                        <m:sty m:val="p"/>
-                      </m:rPr>
-                      <m:t>≈</m:t>
-                    </m:r>
-                    <m:r>
-                      <m:t>0.15</m:t>
-                    </m:r>
-                  </m:oMath>
-                </a14:m>
-                <a:r>
-                  <a:rPr lang="fa-IR" dirty="0">
-                    <a:latin typeface="Tahoma"/>
-                    <a:cs typeface="Tahoma"/>
-                  </a:rPr>
-                  <a:t> (معادل </a:t>
-                </a:r>
-                <a14:m>
-                  <m:oMath xmlns:m="http://schemas.openxmlformats.org/officeDocument/2006/math">
-                    <m:sSub>
-                      <m:e>
-                        <m:r>
-                          <m:t>τ</m:t>
-                        </m:r>
-                      </m:e>
-                      <m:sub>
-                        <m:r>
-                          <m:t>0</m:t>
-                        </m:r>
-                      </m:sub>
-                    </m:sSub>
-                    <m:r>
-                      <m:rPr>
-                        <m:sty m:val="p"/>
-                      </m:rPr>
-                      <m:t>=</m:t>
-                    </m:r>
-                    <m:r>
-                      <m:t>418</m:t>
-                    </m:r>
-                  </m:oMath>
-                </a14:m>
-                <a:r>
-                  <a:rPr lang="fa-IR" dirty="0">
-                    <a:latin typeface="Tahoma"/>
-                    <a:cs typeface="Tahoma"/>
-                  </a:rPr>
-                  <a:t> s)؛ زمان کل ۳۰۰۰ ثانیه.</a:t>
-                </a:r>
-              </a:p>
-              <a:p>
-                <a:pPr lvl="0" rtl="1" algn="r"/>
-                <a:r>
-                  <a:rPr lang="fa-IR" dirty="0">
-                    <a:latin typeface="Tahoma"/>
-                    <a:cs typeface="Tahoma"/>
-                  </a:rPr>
-                  <a:t>خواص: </a:t>
-                </a:r>
-                <a:r>
-                  <a:rPr b="1" lang="fa-IR" dirty="0">
-                    <a:latin typeface="Tahoma"/>
-                    <a:cs typeface="Tahoma"/>
-                  </a:rPr>
-                  <a:t>هالپین-تسای</a:t>
-                </a:r>
-                <a:r>
-                  <a:rPr lang="fa-IR" dirty="0">
-                    <a:latin typeface="Tahoma"/>
-                    <a:cs typeface="Tahoma"/>
-                  </a:rPr>
-                  <a:t> + قانون مخلوط‌ها؛ تخلخل: </a:t>
-                </a:r>
-                <a:r>
-                  <a:rPr b="1" lang="fa-IR" dirty="0">
-                    <a:latin typeface="Tahoma"/>
-                    <a:cs typeface="Tahoma"/>
-                  </a:rPr>
-                  <a:t>سلول باز</a:t>
-                </a:r>
-                <a:r>
-                  <a:rPr lang="fa-IR" dirty="0">
-                    <a:latin typeface="Tahoma"/>
-                    <a:cs typeface="Tahoma"/>
-                  </a:rPr>
-                  <a:t>.</a:t>
-                </a:r>
-              </a:p>
-            </p:txBody>
-          </p:sp>
-        </mc:Choice>
-      </mc:AlternateContent>
+              <a:t>پیشینه ۱: تئوری‌های تحلیل استوانه — از پوسته تا الاستیسیتهٔ سه‌بعدی</a:t>
+            </a:r>
+          </a:p>
+        </p:txBody>
+      </p:sp>
+      <p:sp>
+        <p:nvSpPr>
+          <p:cNvPr id="3" name="Content Placeholder 2"/>
+          <p:cNvSpPr>
+            <a:spLocks noGrp="1"/>
+          </p:cNvSpPr>
+          <p:nvPr>
+            <p:ph idx="1"/>
+          </p:nvPr>
+        </p:nvSpPr>
+        <p:spPr/>
+        <p:txBody>
+          <a:bodyPr/>
+          <a:lstStyle/>
+          <a:p>
+            <a:pPr lvl="0" rtl="1" algn="r"/>
+            <a:r>
+              <a:rPr lang="fa-IR" dirty="0">
+                <a:latin typeface="Tahoma"/>
+                <a:cs typeface="Tahoma"/>
+              </a:rPr>
+              <a:t>تئوری‌های پوسته و ورق: کلاسیک، برشی مرتبهٔ اول و مراتب بالا [۵].</a:t>
+            </a:r>
+          </a:p>
+          <a:p>
+            <a:pPr lvl="0" rtl="1" algn="r"/>
+            <a:r>
+              <a:rPr b="1" lang="fa-IR" dirty="0">
+                <a:latin typeface="Tahoma"/>
+                <a:cs typeface="Tahoma"/>
+              </a:rPr>
+              <a:t>کلاسیک:</a:t>
+            </a:r>
+            <a:r>
+              <a:rPr lang="fa-IR" dirty="0">
+                <a:latin typeface="Tahoma"/>
+                <a:cs typeface="Tahoma"/>
+              </a:rPr>
+              <a:t> از کرنش عمودی و برش عرضی صرف‌نظر می‌کند؛ با افزایش ضخامت دقتش کم می‌شود.</a:t>
+            </a:r>
+          </a:p>
+          <a:p>
+            <a:pPr lvl="0" rtl="1" algn="r"/>
+            <a:r>
+              <a:rPr b="1" lang="fa-IR" dirty="0">
+                <a:latin typeface="Tahoma"/>
+                <a:cs typeface="Tahoma"/>
+              </a:rPr>
+              <a:t>برشی مرتبهٔ اول:</a:t>
+            </a:r>
+            <a:r>
+              <a:rPr lang="fa-IR" dirty="0">
+                <a:latin typeface="Tahoma"/>
+                <a:cs typeface="Tahoma"/>
+              </a:rPr>
+              <a:t> برش عرضی و اینرسی چرخشی را وارد می‌کند اما کرنش برشی را ثابت می‌گیرد (ضریب تصحیح برشی)؛ مراتب بالاتر جملات بیشتری نگه می‌دارند.</a:t>
+            </a:r>
+          </a:p>
+          <a:p>
+            <a:pPr lvl="0" rtl="1" algn="r"/>
+            <a:r>
+              <a:rPr lang="fa-IR" dirty="0">
+                <a:latin typeface="Tahoma"/>
+                <a:cs typeface="Tahoma"/>
+              </a:rPr>
+              <a:t>مزیت پوسته‌ها: حجم محاسباتی کم؛ ضعف: افت دقت در ضخامت زیاد و در رفتار محلی.</a:t>
+            </a:r>
+          </a:p>
+          <a:p>
+            <a:pPr lvl="0" rtl="1" algn="r"/>
+            <a:r>
+              <a:rPr b="1" lang="fa-IR" dirty="0">
+                <a:latin typeface="Tahoma"/>
+                <a:cs typeface="Tahoma"/>
+              </a:rPr>
+              <a:t>راه‌حل:</a:t>
+            </a:r>
+            <a:r>
+              <a:rPr lang="fa-IR" dirty="0">
+                <a:latin typeface="Tahoma"/>
+                <a:cs typeface="Tahoma"/>
+              </a:rPr>
+              <a:t> الاستیسیتهٔ سه‌بعدی و ترموالاستیسیتهٔ سه‌بعدی — جابجایی، تنش و کرنش در هر نقطه.</a:t>
+            </a:r>
+          </a:p>
+        </p:txBody>
+      </p:sp>
     </p:spTree>
   </p:cSld>
 </p:sld>
@@ -10677,7 +12369,12 @@
             <p:ph type="title"/>
           </p:nvPr>
         </p:nvSpPr>
-        <p:spPr/>
+        <p:spPr>
+          <a:xfrm>
+            <a:off x="457200" y="150000"/>
+            <a:ext cx="8229600" cy="700000"/>
+          </a:xfrm>
+        </p:spPr>
         <p:txBody>
           <a:bodyPr/>
           <a:lstStyle/>
@@ -10690,29 +12387,86 @@
                 <a:latin typeface="Tahoma"/>
                 <a:cs typeface="Tahoma"/>
               </a:rPr>
-              <a:t>پنج الگوی توزیع گرافن در ضخامت</a:t>
+              <a:t>پیشینه ۲: خانوادهٔ تئوری‌های ترموالاستیسیته</a:t>
+            </a:r>
+          </a:p>
+        </p:txBody>
+      </p:sp>
+      <p:sp>
+        <p:nvSpPr>
+          <p:cNvPr id="4" name="Text Placeholder 3"/>
+          <p:cNvSpPr>
+            <a:spLocks noGrp="1"/>
+          </p:cNvSpPr>
+          <p:nvPr>
+            <p:ph idx="2" sz="half" type="body"/>
+          </p:nvPr>
+        </p:nvSpPr>
+        <p:spPr/>
+        <p:txBody>
+          <a:bodyPr/>
+          <a:lstStyle/>
+          <a:p>
+            <a:pPr lvl="0" rtl="1" algn="r"/>
+            <a:r>
+              <a:rPr b="1" lang="fa-IR" dirty="0">
+                <a:latin typeface="Tahoma"/>
+                <a:cs typeface="Tahoma"/>
+              </a:rPr>
+              <a:t>کلاسیک</a:t>
+            </a:r>
+            <a:r>
+              <a:rPr lang="fa-IR" dirty="0">
+                <a:latin typeface="Tahoma"/>
+                <a:cs typeface="Tahoma"/>
+              </a:rPr>
+              <a:t> (فوریه، سرعت موج نامحدود): غیرممزوج و ممزوج. </a:t>
+            </a:r>
+            <a:r>
+              <a:rPr b="1" lang="fa-IR" dirty="0">
+                <a:latin typeface="Tahoma"/>
+                <a:cs typeface="Tahoma"/>
+              </a:rPr>
+              <a:t>تعمیم‌یافته</a:t>
+            </a:r>
+            <a:r>
+              <a:rPr lang="fa-IR" dirty="0">
+                <a:latin typeface="Tahoma"/>
+                <a:cs typeface="Tahoma"/>
+              </a:rPr>
+              <a:t> (هذلولوی، سرعت موج متناهی، «صوت دوم»): لرد–شولمن، گرین–لیندزی، گرین–نقدی، تأخیر دوفازی.</a:t>
+            </a:r>
+          </a:p>
+          <a:p>
+            <a:pPr lvl="0" rtl="1" algn="r"/>
+            <a:r>
+              <a:rPr lang="fa-IR" dirty="0">
+                <a:latin typeface="Tahoma"/>
+                <a:cs typeface="Tahoma"/>
+              </a:rPr>
+              <a:t>مرور جامع: شاکری‌اسکی و همکاران (۲۰۲۱) [۷۸].</a:t>
             </a:r>
           </a:p>
         </p:txBody>
       </p:sp>
       <p:pic>
         <p:nvPicPr>
-          <p:cNvPr descr="../figures_ch123/GPL_patterns_schematic.png" id="0" name="Picture 1"/>
+          <p:cNvPr descr="../figures_ch123/theory_taxonomy.png" id="0" name="Picture 1"/>
           <p:cNvPicPr>
             <a:picLocks noGrp="1" noChangeAspect="1"/>
           </p:cNvPicPr>
           <p:nvPr/>
         </p:nvPicPr>
         <p:blipFill>
-          <a:blip r:embed="rId2"/>
+          <a:blip r:embed="rId3"/>
           <a:stretch>
             <a:fillRect/>
           </a:stretch>
         </p:blipFill>
         <p:spPr bwMode="auto">
           <a:xfrm>
-            <a:off x="2374900" y="1193800"/>
-            <a:ext cx="4381500" cy="3390900"/>
+            <a:off x="647700" y="876300"/>
+            <a:ext cx="7848600" cy="2921000"/>
           </a:xfrm>
           <a:prstGeom prst="rect">
             <a:avLst/>
@@ -10770,41 +12524,77 @@
                 <a:latin typeface="Tahoma"/>
                 <a:cs typeface="Tahoma"/>
               </a:rPr>
-              <a:t>پنج الگوی توزیع تخلخل در ضخامت</a:t>
-            </a:r>
-          </a:p>
-        </p:txBody>
-      </p:sp>
-      <p:pic>
-        <p:nvPicPr>
-          <p:cNvPr descr="../figures_ch123/porosity_patterns_schematic.png" id="0" name="Picture 1"/>
-          <p:cNvPicPr>
-            <a:picLocks noGrp="1" noChangeAspect="1"/>
-          </p:cNvPicPr>
-          <p:nvPr/>
-        </p:nvPicPr>
-        <p:blipFill>
-          <a:blip r:embed="rId3"/>
-          <a:stretch>
-            <a:fillRect/>
-          </a:stretch>
-        </p:blipFill>
-        <p:spPr bwMode="auto">
-          <a:xfrm>
-            <a:off x="2070100" y="1193800"/>
-            <a:ext cx="5016500" cy="3390900"/>
-          </a:xfrm>
-          <a:prstGeom prst="rect">
-            <a:avLst/>
-          </a:prstGeom>
-          <a:noFill/>
-          <a:ln w="9525">
-            <a:noFill/>
-            <a:headEnd/>
-            <a:tailEnd/>
-          </a:ln>
-        </p:spPr>
-      </p:pic>
+              <a:t>پیشینه ۳: استوانه، کره، مخروط و دیسکِ مدرج و کامپوزیتی</a:t>
+            </a:r>
+          </a:p>
+        </p:txBody>
+      </p:sp>
+      <p:sp>
+        <p:nvSpPr>
+          <p:cNvPr id="3" name="Content Placeholder 2"/>
+          <p:cNvSpPr>
+            <a:spLocks noGrp="1"/>
+          </p:cNvSpPr>
+          <p:nvPr>
+            <p:ph idx="1"/>
+          </p:nvPr>
+        </p:nvSpPr>
+        <p:spPr/>
+        <p:txBody>
+          <a:bodyPr/>
+          <a:lstStyle/>
+          <a:p>
+            <a:pPr lvl="0" rtl="1" algn="r"/>
+            <a:r>
+              <a:rPr lang="fa-IR" dirty="0">
+                <a:latin typeface="Tahoma"/>
+                <a:cs typeface="Tahoma"/>
+              </a:rPr>
+              <a:t>پلتیر و ول (۲۰۰۶)، جباری و همکاران (۲۰۰۶): حل دقیق و تحلیلیِ پوسته و استوانهٔ مدرج تابعی (بسل و انتگرال فوریه) [۸، ۹].</a:t>
+            </a:r>
+          </a:p>
+          <a:p>
+            <a:pPr lvl="0" rtl="1" algn="r"/>
+            <a:r>
+              <a:rPr lang="fa-IR" dirty="0">
+                <a:latin typeface="Tahoma"/>
+                <a:cs typeface="Tahoma"/>
+              </a:rPr>
+              <a:t>چن و لین (۲۰۰۸)، پنگ و لی (۲۰۱۰): تنش در استوانه و کرهٔ مدرج؛ بار ترمو-مکانیکی با انتگرال‌گیری عددی [۱۰، ۱۱].</a:t>
+            </a:r>
+          </a:p>
+          <a:p>
+            <a:pPr lvl="0" rtl="1" algn="r"/>
+            <a:r>
+              <a:rPr lang="fa-IR" dirty="0">
+                <a:latin typeface="Tahoma"/>
+                <a:cs typeface="Tahoma"/>
+              </a:rPr>
+              <a:t>ملک‌زاده و همکاران (۲۰۱۲): استوانهٔ مدرج تحت بار حرارتی متحرک با هدایت هذلولوی [۱۲]؛ بورلاینکو و همکاران (۲۰۱۷): اجزای محدود [۱۴].</a:t>
+            </a:r>
+          </a:p>
+          <a:p>
+            <a:pPr lvl="0" rtl="1" algn="r"/>
+            <a:r>
+              <a:rPr lang="fa-IR" dirty="0">
+                <a:latin typeface="Tahoma"/>
+                <a:cs typeface="Tahoma"/>
+              </a:rPr>
+              <a:t>علی‌بیگ‌لو (۲۰۲۰)، هوانگ و همکاران (۲۰۲۱): استوانه و پانل تقویت‌شده با پلاکت‌های گرافنی؛ اثر کسر وزنی، الگو و ابعاد [۱۶، ۱۸].</a:t>
+            </a:r>
+          </a:p>
+          <a:p>
+            <a:pPr lvl="0" rtl="1" algn="r"/>
+            <a:r>
+              <a:rPr lang="fa-IR" dirty="0">
+                <a:latin typeface="Tahoma"/>
+                <a:cs typeface="Tahoma"/>
+              </a:rPr>
+              <a:t>ژانگ و همکاران (۲۰۲۰)، شیا و همکاران (۲۰۲۲): دیسک حلقوی مدرج با DQM و نیومارک [۱۷، ۲۱]؛ الفار و همکاران (۲۰۲۳): آزمایش شوک حرارتی [۲۰].</a:t>
+            </a:r>
+          </a:p>
+        </p:txBody>
+      </p:sp>
     </p:spTree>
   </p:cSld>
 </p:sld>

</xml_diff>

<commit_message>
Defense slides R2: merge four literature slides into one slide of 7 key studies
Co-Authored-By: Claude Sonnet 5.5 <noreply@anthropic.com>
</commit_message>
<xml_diff>
--- a/claude/defense/DEFENSE_SLIDES_FA_R2.pptx
+++ b/claude/defense/DEFENSE_SLIDES_FA_R2.pptx
@@ -5,7 +5,7 @@
     <p:sldMasterId id="2147483648" r:id="rId1"/>
   </p:sldMasterIdLst>
   <p:notesMasterIdLst>
-    <p:notesMasterId r:id="rId43"/>
+    <p:notesMasterId r:id="rId40"/>
   </p:notesMasterIdLst>
   <p:sldIdLst>
     <p:sldId id="256" r:id="rId2"/>
@@ -46,9 +46,6 @@
     <p:sldId id="291" r:id="rId37"/>
     <p:sldId id="292" r:id="rId38"/>
     <p:sldId id="293" r:id="rId39"/>
-    <p:sldId id="294" r:id="rId40"/>
-    <p:sldId id="295" r:id="rId41"/>
-    <p:sldId id="296" r:id="rId42"/>
   </p:sldIdLst>
   <p:sldSz cx="9144000" cy="5143500" type="screen16x9"/>
   <p:notesSz cx="6858000" cy="9144000"/>
@@ -646,7 +643,23 @@
             </a:pPr>
             <a:r>
               <a:rPr/>
-              <a:t>منبع: فصل ۲، بند ۲-۶. مرجع‌های نزدیک را نام ببرید: [۳]، [۶۸]، [۷۰]. اگر داور پرسید «تفاوت شما با کار حیدرپور چیست؟» پاسخ در اسلاید بعد است.</a:t>
+              <a:t>تأکید: </a:t>
+            </a:r>
+            <a:r>
+              <a:rPr/>
+              <a:t>\tau^*=0.15</a:t>
+            </a:r>
+            <a:r>
+              <a:rPr/>
+              <a:t> پارامتر بی‌بعدِ اصلی است؛ </a:t>
+            </a:r>
+            <a:r>
+              <a:rPr/>
+              <a:t>\tau_0=418</a:t>
+            </a:r>
+            <a:r>
+              <a:rPr/>
+              <a:t> s مقیاس‌گذاریِ جدارهٔ ۰٫۵ متری است، نه خاصیتِ اندازه‌گیری‌شدهٔ یک ماده. اگر پرسیدند، بگویید این یک مطالعهٔ پارامتریِ بی‌بعد است.</a:t>
             </a:r>
           </a:p>
         </p:txBody>
@@ -668,7 +681,7 @@
           <a:p>
             <a:fld id="{18BDFEC3-8487-43E8-A154-7C12CBC1FFF2}" type="slidenum">
               <a:rPr lang="en-US"/>
-              <a:t>12</a:t>
+              <a:t>13</a:t>
             </a:fld>
             <a:endParaRPr lang="en-US"/>
           </a:p>
@@ -728,7 +741,7 @@
             </a:pPr>
             <a:r>
               <a:rPr/>
-              <a:t>منبع: فصل ۲، بند ۲-۷. «تا آنجا که در این مرور بررسی شد» را بگویید؛ ادعای مطلق نکنید.</a:t>
+              <a:t>تأکید کنید V و A آینهٔ یکدیگرند — این نکته بعداً در یافتهٔ هم‌افزایی کلیدی می‌شود.</a:t>
             </a:r>
           </a:p>
         </p:txBody>
@@ -750,7 +763,7 @@
           <a:p>
             <a:fld id="{18BDFEC3-8487-43E8-A154-7C12CBC1FFF2}" type="slidenum">
               <a:rPr lang="en-US"/>
-              <a:t>13</a:t>
+              <a:t>15</a:t>
             </a:fld>
             <a:endParaRPr lang="en-US"/>
           </a:p>
@@ -810,7 +823,7 @@
             </a:pPr>
             <a:r>
               <a:rPr/>
-              <a:t>منبع: فصل ۲، بند ۲-۷ (بند پایانی). هر مورد این فهرست یکی از شکاف‌های اسلاید قبل را پاسخ می‌دهد.</a:t>
+              <a:t>فقط همین یک معادله را نشان دهید. اگر جزئیات استخراج را خواستند، اسلاید پشتیبان (فصل ۳) را باز کنید.</a:t>
             </a:r>
           </a:p>
         </p:txBody>
@@ -832,7 +845,7 @@
           <a:p>
             <a:fld id="{18BDFEC3-8487-43E8-A154-7C12CBC1FFF2}" type="slidenum">
               <a:rPr lang="en-US"/>
-              <a:t>14</a:t>
+              <a:t>16</a:t>
             </a:fld>
             <a:endParaRPr lang="en-US"/>
           </a:p>
@@ -892,23 +905,7 @@
             </a:pPr>
             <a:r>
               <a:rPr/>
-              <a:t>تأکید: </a:t>
-            </a:r>
-            <a:r>
-              <a:rPr/>
-              <a:t>\tau^*=0.15</a:t>
-            </a:r>
-            <a:r>
-              <a:rPr/>
-              <a:t> پارامتر بی‌بعدِ اصلی است؛ </a:t>
-            </a:r>
-            <a:r>
-              <a:rPr/>
-              <a:t>\tau_0=418</a:t>
-            </a:r>
-            <a:r>
-              <a:rPr/>
-              <a:t> s مقیاس‌گذاریِ جدارهٔ ۰٫۵ متری است، نه خاصیتِ اندازه‌گیری‌شدهٔ یک ماده. اگر پرسیدند، بگویید این یک مطالعهٔ پارامتریِ بی‌بعد است.</a:t>
+              <a:t>اگر زمان کم است، این اسلاید و اسلاید قبل را حذف یا به پشتیبان ببرید.</a:t>
             </a:r>
           </a:p>
         </p:txBody>
@@ -930,7 +927,7 @@
           <a:p>
             <a:fld id="{18BDFEC3-8487-43E8-A154-7C12CBC1FFF2}" type="slidenum">
               <a:rPr lang="en-US"/>
-              <a:t>16</a:t>
+              <a:t>19</a:t>
             </a:fld>
             <a:endParaRPr lang="en-US"/>
           </a:p>
@@ -990,7 +987,7 @@
             </a:pPr>
             <a:r>
               <a:rPr/>
-              <a:t>تأکید کنید V و A آینهٔ یکدیگرند — این نکته بعداً در یافتهٔ هم‌افزایی کلیدی می‌شود.</a:t>
+              <a:t>این مهم‌ترین سپرِ دفاعی شماست. آرام و با اعتمادبه‌نفس بخوانید.</a:t>
             </a:r>
           </a:p>
         </p:txBody>
@@ -1012,7 +1009,7 @@
           <a:p>
             <a:fld id="{18BDFEC3-8487-43E8-A154-7C12CBC1FFF2}" type="slidenum">
               <a:rPr lang="en-US"/>
-              <a:t>18</a:t>
+              <a:t>20</a:t>
             </a:fld>
             <a:endParaRPr lang="en-US"/>
           </a:p>
@@ -1072,7 +1069,7 @@
             </a:pPr>
             <a:r>
               <a:rPr/>
-              <a:t>فقط همین یک معادله را نشان دهید. اگر جزئیات استخراج را خواستند، اسلاید پشتیبان (فصل ۳) را باز کنید.</a:t>
+              <a:t>جابجایی شعاعی بی‌بعد سطح داخلی در برابر زمان؛ حل حاضر، مرجع و ANSYS. اختلاف ۰٫۱ تا ۰٫۲٪.</a:t>
             </a:r>
           </a:p>
         </p:txBody>
@@ -1094,7 +1091,7 @@
           <a:p>
             <a:fld id="{18BDFEC3-8487-43E8-A154-7C12CBC1FFF2}" type="slidenum">
               <a:rPr lang="en-US"/>
-              <a:t>19</a:t>
+              <a:t>21</a:t>
             </a:fld>
             <a:endParaRPr lang="en-US"/>
           </a:p>
@@ -1154,7 +1151,23 @@
             </a:pPr>
             <a:r>
               <a:rPr/>
-              <a:t>اگر زمان کم است، این اسلاید و اسلاید قبل را حذف یا به پشتیبان ببرید.</a:t>
+              <a:t>نشانگرها حل حاضر و خط پیوسته حل دقیق سری بسل است؛ خطای </a:t>
+            </a:r>
+            <a:r>
+              <a:rPr/>
+              <a:t>10^{-5}</a:t>
+            </a:r>
+            <a:r>
+              <a:rPr/>
+              <a:t> تا </a:t>
+            </a:r>
+            <a:r>
+              <a:rPr/>
+              <a:t>10^{-7}</a:t>
+            </a:r>
+            <a:r>
+              <a:rPr/>
+              <a:t>.</a:t>
             </a:r>
           </a:p>
         </p:txBody>
@@ -1236,7 +1249,7 @@
             </a:pPr>
             <a:r>
               <a:rPr/>
-              <a:t>این مهم‌ترین سپرِ دفاعی شماست. آرام و با اعتمادبه‌نفس بخوانید.</a:t>
+              <a:t>اگر پرسیدند «چرا مرجع تحلیلی و نه مقالهٔ چاپ‌شده؟» بگویید: حل دقیق برای همین هندسه استخراج شده، پس مقایسه بدون خطای رقمی‌سازیِ شکلِ مرجع و بدون اختلاف در فرضیات انجام می‌شود. پیشانی موج با دقت کمتر از یک فاصلهٔ شبکه ردیابی می‌شود.</a:t>
             </a:r>
           </a:p>
         </p:txBody>
@@ -1318,7 +1331,7 @@
             </a:pPr>
             <a:r>
               <a:rPr/>
-              <a:t>جابجایی شعاعی بی‌بعد سطح داخلی در برابر زمان؛ حل حاضر، مرجع و ANSYS. اختلاف ۰٫۱ تا ۰٫۲٪.</a:t>
+              <a:t>راستای محوری راستای مقیدکننده است.</a:t>
             </a:r>
           </a:p>
         </p:txBody>
@@ -1400,23 +1413,7 @@
             </a:pPr>
             <a:r>
               <a:rPr/>
-              <a:t>نشانگرها حل حاضر و خط پیوسته حل دقیق سری بسل است؛ خطای </a:t>
-            </a:r>
-            <a:r>
-              <a:rPr/>
-              <a:t>10^{-5}</a:t>
-            </a:r>
-            <a:r>
-              <a:rPr/>
-              <a:t> تا </a:t>
-            </a:r>
-            <a:r>
-              <a:rPr/>
-              <a:t>10^{-7}</a:t>
-            </a:r>
-            <a:r>
-              <a:rPr/>
-              <a:t>.</a:t>
+              <a:t>این مهم‌ترین یافتهٔ پایان‌نامه است. اینجا سرعت را کم کنید، جمله‌بندی را دقیق بگویید و توصیهٔ طراحی را صریح اعلام کنید.</a:t>
             </a:r>
           </a:p>
         </p:txBody>
@@ -1438,7 +1435,7 @@
           <a:p>
             <a:fld id="{18BDFEC3-8487-43E8-A154-7C12CBC1FFF2}" type="slidenum">
               <a:rPr lang="en-US"/>
-              <a:t>25</a:t>
+              <a:t>28</a:t>
             </a:fld>
             <a:endParaRPr lang="en-US"/>
           </a:p>
@@ -1580,7 +1577,7 @@
             </a:pPr>
             <a:r>
               <a:rPr/>
-              <a:t>اگر پرسیدند «چرا مرجع تحلیلی و نه مقالهٔ چاپ‌شده؟» بگویید: حل دقیق برای همین هندسه استخراج شده، پس مقایسه بدون خطای رقمی‌سازیِ شکلِ مرجع و بدون اختلاف در فرضیات انجام می‌شود. پیشانی موج با دقت کمتر از یک فاصلهٔ شبکه ردیابی می‌شود.</a:t>
+              <a:t>این یافته را با ذکر شرایط (پالس گاوسی) و بدون مبالغه بیان کنید.</a:t>
             </a:r>
           </a:p>
         </p:txBody>
@@ -1602,253 +1599,7 @@
           <a:p>
             <a:fld id="{18BDFEC3-8487-43E8-A154-7C12CBC1FFF2}" type="slidenum">
               <a:rPr lang="en-US"/>
-              <a:t>26</a:t>
-            </a:fld>
-            <a:endParaRPr lang="en-US"/>
-          </a:p>
-        </p:txBody>
-      </p:sp>
-    </p:spTree>
-  </p:cSld>
-</p:notes>
-</file>
-
-<file path=ppt/notesSlides/notesSlide21.xml><?xml version="1.0" encoding="utf-8"?>
-<p:notes xmlns:a="http://schemas.openxmlformats.org/drawingml/2006/main" xmlns:r="http://schemas.openxmlformats.org/officeDocument/2006/relationships" xmlns:p="http://schemas.openxmlformats.org/presentationml/2006/main">
-  <p:cSld>
-    <p:spTree>
-      <p:nvGrpSpPr>
-        <p:cNvPr id="1" name=""/>
-        <p:cNvGrpSpPr/>
-        <p:nvPr/>
-      </p:nvGrpSpPr>
-      <p:grpSpPr>
-        <a:xfrm>
-          <a:off x="0" y="0"/>
-          <a:ext cx="0" cy="0"/>
-          <a:chOff x="0" y="0"/>
-          <a:chExt cx="0" cy="0"/>
-        </a:xfrm>
-      </p:grpSpPr>
-      <p:sp>
-        <p:nvSpPr>
-          <p:cNvPr id="2" name="Slide Image Placeholder 1"/>
-          <p:cNvSpPr>
-            <a:spLocks noGrp="1" noRot="1" noChangeAspect="1"/>
-          </p:cNvSpPr>
-          <p:nvPr>
-            <p:ph type="sldImg"/>
-          </p:nvPr>
-        </p:nvSpPr>
-        <p:spPr/>
-      </p:sp>
-      <p:sp>
-        <p:nvSpPr>
-          <p:cNvPr id="3" name="Notes Placeholder 2"/>
-          <p:cNvSpPr>
-            <a:spLocks noGrp="1"/>
-          </p:cNvSpPr>
-          <p:nvPr>
-            <p:ph type="body" idx="1"/>
-          </p:nvPr>
-        </p:nvSpPr>
-        <p:spPr/>
-        <p:txBody>
-          <a:bodyPr/>
-          <a:lstStyle/>
-          <a:p>
-            <a:pPr lvl="0" indent="0" marL="0">
-              <a:buNone/>
-            </a:pPr>
-            <a:r>
-              <a:rPr/>
-              <a:t>راستای محوری راستای مقیدکننده است.</a:t>
-            </a:r>
-          </a:p>
-        </p:txBody>
-      </p:sp>
-      <p:sp>
-        <p:nvSpPr>
-          <p:cNvPr id="4" name="Slide Number Placeholder 3"/>
-          <p:cNvSpPr>
-            <a:spLocks noGrp="1"/>
-          </p:cNvSpPr>
-          <p:nvPr>
-            <p:ph type="sldNum" sz="quarter" idx="10"/>
-          </p:nvPr>
-        </p:nvSpPr>
-        <p:spPr/>
-        <p:txBody>
-          <a:bodyPr/>
-          <a:lstStyle/>
-          <a:p>
-            <a:fld id="{18BDFEC3-8487-43E8-A154-7C12CBC1FFF2}" type="slidenum">
-              <a:rPr lang="en-US"/>
-              <a:t>27</a:t>
-            </a:fld>
-            <a:endParaRPr lang="en-US"/>
-          </a:p>
-        </p:txBody>
-      </p:sp>
-    </p:spTree>
-  </p:cSld>
-</p:notes>
-</file>
-
-<file path=ppt/notesSlides/notesSlide22.xml><?xml version="1.0" encoding="utf-8"?>
-<p:notes xmlns:a="http://schemas.openxmlformats.org/drawingml/2006/main" xmlns:r="http://schemas.openxmlformats.org/officeDocument/2006/relationships" xmlns:p="http://schemas.openxmlformats.org/presentationml/2006/main">
-  <p:cSld>
-    <p:spTree>
-      <p:nvGrpSpPr>
-        <p:cNvPr id="1" name=""/>
-        <p:cNvGrpSpPr/>
-        <p:nvPr/>
-      </p:nvGrpSpPr>
-      <p:grpSpPr>
-        <a:xfrm>
-          <a:off x="0" y="0"/>
-          <a:ext cx="0" cy="0"/>
-          <a:chOff x="0" y="0"/>
-          <a:chExt cx="0" cy="0"/>
-        </a:xfrm>
-      </p:grpSpPr>
-      <p:sp>
-        <p:nvSpPr>
-          <p:cNvPr id="2" name="Slide Image Placeholder 1"/>
-          <p:cNvSpPr>
-            <a:spLocks noGrp="1" noRot="1" noChangeAspect="1"/>
-          </p:cNvSpPr>
-          <p:nvPr>
-            <p:ph type="sldImg"/>
-          </p:nvPr>
-        </p:nvSpPr>
-        <p:spPr/>
-      </p:sp>
-      <p:sp>
-        <p:nvSpPr>
-          <p:cNvPr id="3" name="Notes Placeholder 2"/>
-          <p:cNvSpPr>
-            <a:spLocks noGrp="1"/>
-          </p:cNvSpPr>
-          <p:nvPr>
-            <p:ph type="body" idx="1"/>
-          </p:nvPr>
-        </p:nvSpPr>
-        <p:spPr/>
-        <p:txBody>
-          <a:bodyPr/>
-          <a:lstStyle/>
-          <a:p>
-            <a:pPr lvl="0" indent="0" marL="0">
-              <a:buNone/>
-            </a:pPr>
-            <a:r>
-              <a:rPr/>
-              <a:t>این مهم‌ترین یافتهٔ پایان‌نامه است. اینجا سرعت را کم کنید، جمله‌بندی را دقیق بگویید و توصیهٔ طراحی را صریح اعلام کنید.</a:t>
-            </a:r>
-          </a:p>
-        </p:txBody>
-      </p:sp>
-      <p:sp>
-        <p:nvSpPr>
-          <p:cNvPr id="4" name="Slide Number Placeholder 3"/>
-          <p:cNvSpPr>
-            <a:spLocks noGrp="1"/>
-          </p:cNvSpPr>
-          <p:nvPr>
-            <p:ph type="sldNum" sz="quarter" idx="10"/>
-          </p:nvPr>
-        </p:nvSpPr>
-        <p:spPr/>
-        <p:txBody>
-          <a:bodyPr/>
-          <a:lstStyle/>
-          <a:p>
-            <a:fld id="{18BDFEC3-8487-43E8-A154-7C12CBC1FFF2}" type="slidenum">
-              <a:rPr lang="en-US"/>
-              <a:t>31</a:t>
-            </a:fld>
-            <a:endParaRPr lang="en-US"/>
-          </a:p>
-        </p:txBody>
-      </p:sp>
-    </p:spTree>
-  </p:cSld>
-</p:notes>
-</file>
-
-<file path=ppt/notesSlides/notesSlide23.xml><?xml version="1.0" encoding="utf-8"?>
-<p:notes xmlns:a="http://schemas.openxmlformats.org/drawingml/2006/main" xmlns:r="http://schemas.openxmlformats.org/officeDocument/2006/relationships" xmlns:p="http://schemas.openxmlformats.org/presentationml/2006/main">
-  <p:cSld>
-    <p:spTree>
-      <p:nvGrpSpPr>
-        <p:cNvPr id="1" name=""/>
-        <p:cNvGrpSpPr/>
-        <p:nvPr/>
-      </p:nvGrpSpPr>
-      <p:grpSpPr>
-        <a:xfrm>
-          <a:off x="0" y="0"/>
-          <a:ext cx="0" cy="0"/>
-          <a:chOff x="0" y="0"/>
-          <a:chExt cx="0" cy="0"/>
-        </a:xfrm>
-      </p:grpSpPr>
-      <p:sp>
-        <p:nvSpPr>
-          <p:cNvPr id="2" name="Slide Image Placeholder 1"/>
-          <p:cNvSpPr>
-            <a:spLocks noGrp="1" noRot="1" noChangeAspect="1"/>
-          </p:cNvSpPr>
-          <p:nvPr>
-            <p:ph type="sldImg"/>
-          </p:nvPr>
-        </p:nvSpPr>
-        <p:spPr/>
-      </p:sp>
-      <p:sp>
-        <p:nvSpPr>
-          <p:cNvPr id="3" name="Notes Placeholder 2"/>
-          <p:cNvSpPr>
-            <a:spLocks noGrp="1"/>
-          </p:cNvSpPr>
-          <p:nvPr>
-            <p:ph type="body" idx="1"/>
-          </p:nvPr>
-        </p:nvSpPr>
-        <p:spPr/>
-        <p:txBody>
-          <a:bodyPr/>
-          <a:lstStyle/>
-          <a:p>
-            <a:pPr lvl="0" indent="0" marL="0">
-              <a:buNone/>
-            </a:pPr>
-            <a:r>
-              <a:rPr/>
-              <a:t>این یافته را با ذکر شرایط (پالس گاوسی) و بدون مبالغه بیان کنید.</a:t>
-            </a:r>
-          </a:p>
-        </p:txBody>
-      </p:sp>
-      <p:sp>
-        <p:nvSpPr>
-          <p:cNvPr id="4" name="Slide Number Placeholder 3"/>
-          <p:cNvSpPr>
-            <a:spLocks noGrp="1"/>
-          </p:cNvSpPr>
-          <p:nvPr>
-            <p:ph type="sldNum" sz="quarter" idx="10"/>
-          </p:nvPr>
-        </p:nvSpPr>
-        <p:spPr/>
-        <p:txBody>
-          <a:bodyPr/>
-          <a:lstStyle/>
-          <a:p>
-            <a:fld id="{18BDFEC3-8487-43E8-A154-7C12CBC1FFF2}" type="slidenum">
-              <a:rPr lang="en-US"/>
-              <a:t>33</a:t>
+              <a:t>30</a:t>
             </a:fld>
             <a:endParaRPr lang="en-US"/>
           </a:p>
@@ -2236,7 +1987,7 @@
             </a:pPr>
             <a:r>
               <a:rPr/>
-              <a:t>منبع: فصل ۲، بند ۲-۳. نام‌ها را مرور سریع بگویید؛ پیام: روش‌ها متنوع‌اند و DQM + نیومارک در این خانواده سابقه دارد.</a:t>
+              <a:t>منبع: فصل ۲، بندهای ۲-۳ تا ۲-۶ (خلاصه‌شده). ردیف‌های ۱ و ۲: روش DQM + نیومارک و هدایت هذلولوی در استوانه. ردیف‌های ۳ تا ۵: گرافن و تخلخل (مدل سلول‌باز مبنای مدل تخلخل شماست). ردیف‌های ۶ و ۷: ترموالاستیسیتهٔ تعمیم‌یافته؛ [۳]، [۶۸]، [۷۰] نزدیک‌ترین مرجع‌ها و مبنای معادلات (فصل ۳) و قرارداد بی‌بعدسازی (فصل ۴) هستند. اگر داور فهرست کامل‌تر خواست، فصل ۲ را ارجاع دهید. اگر پرسید «تفاوت شما با کار حیدرپور چیست؟» پاسخ در اسلایدهای بعد است: استوانهٔ جدارضخیم، گرافن و تخلخل هم‌زمان، ماتریس ۵×۵.</a:t>
             </a:r>
           </a:p>
         </p:txBody>
@@ -2318,7 +2069,7 @@
             </a:pPr>
             <a:r>
               <a:rPr/>
-              <a:t>منبع: فصل ۲، بند ۲-۴. تأکید: ترکیب «DQM لایه‌ای + نیومارک» که در این پایان‌نامه به‌کار رفته، روشی جاافتاده است [۳۱، ۳۶].</a:t>
+              <a:t>منبع: فصل ۲، بند ۲-۷. «تا آنجا که در این مرور بررسی شد» را بگویید؛ ادعای مطلق نکنید.</a:t>
             </a:r>
           </a:p>
         </p:txBody>
@@ -2400,7 +2151,7 @@
             </a:pPr>
             <a:r>
               <a:rPr/>
-              <a:t>منبع: فصل ۲، بند ۲-۵. نکتهٔ مشترک: الگوی توزیع گرافن و تخلخل در همهٔ این کارها اثر تعیین‌کننده دارد، و بیشترشان مکانیکی یا حرارتی پایا هستند.</a:t>
+              <a:t>منبع: فصل ۲، بند ۲-۷ (بند پایانی). هر مورد این فهرست یکی از شکاف‌های اسلاید قبل را پاسخ می‌دهد.</a:t>
             </a:r>
           </a:p>
         </p:txBody>
@@ -6322,368 +6073,6 @@
                 <a:latin typeface="Tahoma"/>
                 <a:cs typeface="Tahoma"/>
               </a:rPr>
-              <a:t>پیشینه ۴: استوانه تحت بار ترمو-مکانیکی و نقش روش DQM</a:t>
-            </a:r>
-          </a:p>
-        </p:txBody>
-      </p:sp>
-      <p:sp>
-        <p:nvSpPr>
-          <p:cNvPr id="3" name="Content Placeholder 2"/>
-          <p:cNvSpPr>
-            <a:spLocks noGrp="1"/>
-          </p:cNvSpPr>
-          <p:nvPr>
-            <p:ph idx="1"/>
-          </p:nvPr>
-        </p:nvSpPr>
-        <p:spPr/>
-        <p:txBody>
-          <a:bodyPr/>
-          <a:lstStyle/>
-          <a:p>
-            <a:pPr lvl="0" rtl="1" algn="r"/>
-            <a:r>
-              <a:rPr lang="fa-IR" dirty="0">
-                <a:latin typeface="Tahoma"/>
-                <a:cs typeface="Tahoma"/>
-              </a:rPr>
-              <a:t>هفت‌چناری و درویزه (۲۰۰۷): DQM با شبکهٔ کم‌گره و دقت بالا [۲۳]؛ حیدرپور و همکاران (۲۰۱۲): استوانهٔ مدرج دوار با خواص وابسته به دما [۲۸].</a:t>
-            </a:r>
-          </a:p>
-          <a:p>
-            <a:pPr lvl="0" rtl="1" algn="r"/>
-            <a:r>
-              <a:rPr lang="fa-IR" dirty="0">
-                <a:latin typeface="Tahoma"/>
-                <a:cs typeface="Tahoma"/>
-              </a:rPr>
-              <a:t>ملک‌زاده و همکاران (۲۰۱۲): پاسخ گذرای پوستهٔ چندلایه با DQM در مکان و </a:t>
-            </a:r>
-            <a:r>
-              <a:rPr b="1" lang="fa-IR" dirty="0">
-                <a:latin typeface="Tahoma"/>
-                <a:cs typeface="Tahoma"/>
-              </a:rPr>
-              <a:t>نیومارک</a:t>
-            </a:r>
-            <a:r>
-              <a:rPr lang="fa-IR" dirty="0">
-                <a:latin typeface="Tahoma"/>
-                <a:cs typeface="Tahoma"/>
-              </a:rPr>
-              <a:t> در زمان [۳۱]؛ ملک‌زاده و حیدرپور (۲۰۱۲): بار متحرک با هدایت هذلولوی [۳۲].</a:t>
-            </a:r>
-          </a:p>
-          <a:p>
-            <a:pPr lvl="0" rtl="1" algn="r"/>
-            <a:r>
-              <a:rPr lang="fa-IR" dirty="0">
-                <a:latin typeface="Tahoma"/>
-                <a:cs typeface="Tahoma"/>
-              </a:rPr>
-              <a:t>ینگ و وانگ (۲۰۱۰): شوک حرارتی غیریکنواخت [۲۷]؛ کانلیکاما و همکاران (۲۰۱۳): استوانه تحت فشار داخلی [۳۵]؛ نجیبی و طالبی‌توتی (۲۰۱۷): خواص غیرخطی وابسته به دما [۳۹].</a:t>
-            </a:r>
-          </a:p>
-          <a:p>
-            <a:pPr lvl="0" rtl="1" algn="r"/>
-            <a:r>
-              <a:rPr lang="fa-IR" dirty="0">
-                <a:latin typeface="Tahoma"/>
-                <a:cs typeface="Tahoma"/>
-              </a:rPr>
-              <a:t>دانشجو و طالبی‌توتی (۲۰۱۴): DQM لایه‌ای؛ دقت و همگرایی سریع [۳۶].</a:t>
-            </a:r>
-          </a:p>
-          <a:p>
-            <a:pPr lvl="0" rtl="1" algn="r"/>
-            <a:r>
-              <a:rPr lang="fa-IR" dirty="0">
-                <a:latin typeface="Tahoma"/>
-                <a:cs typeface="Tahoma"/>
-              </a:rPr>
-              <a:t>حیدرپور و همکاران (۲۰۲۰): پوستهٔ تقویت‌شده با گرافن، بار ترمو-مکانیکی دینامیکی [۴۶]؛ رحیمی و همکاران (۲۰۲۰): تحلیل سه‌بعدی استوانهٔ متخلخل گرافنی با هالپین–تسای [۴۷].</a:t>
-            </a:r>
-          </a:p>
-        </p:txBody>
-      </p:sp>
-    </p:spTree>
-  </p:cSld>
-</p:sld>
-</file>
-
-<file path=ppt/slides/slide11.xml><?xml version="1.0" encoding="utf-8"?>
-<p:sld xmlns:a="http://schemas.openxmlformats.org/drawingml/2006/main" xmlns:r="http://schemas.openxmlformats.org/officeDocument/2006/relationships" xmlns:p="http://schemas.openxmlformats.org/presentationml/2006/main">
-  <p:cSld>
-    <p:spTree>
-      <p:nvGrpSpPr>
-        <p:cNvPr id="1" name=""/>
-        <p:cNvGrpSpPr/>
-        <p:nvPr/>
-      </p:nvGrpSpPr>
-      <p:grpSpPr>
-        <a:xfrm>
-          <a:off x="0" y="0"/>
-          <a:ext cx="0" cy="0"/>
-          <a:chOff x="0" y="0"/>
-          <a:chExt cx="0" cy="0"/>
-        </a:xfrm>
-      </p:grpSpPr>
-      <p:sp>
-        <p:nvSpPr>
-          <p:cNvPr id="2" name="Title 1"/>
-          <p:cNvSpPr>
-            <a:spLocks noGrp="1"/>
-          </p:cNvSpPr>
-          <p:nvPr>
-            <p:ph type="title"/>
-          </p:nvPr>
-        </p:nvSpPr>
-        <p:spPr/>
-        <p:txBody>
-          <a:bodyPr/>
-          <a:lstStyle/>
-          <a:p>
-            <a:pPr lvl="0" indent="0" marL="0" rtl="1" algn="r">
-              <a:buNone/>
-            </a:pPr>
-            <a:r>
-              <a:rPr lang="fa-IR" dirty="0">
-                <a:latin typeface="Tahoma"/>
-                <a:cs typeface="Tahoma"/>
-              </a:rPr>
-              <a:t>پیشینه ۵: مواد مرکب متخلخل تقویت‌شده با گرافن</a:t>
-            </a:r>
-          </a:p>
-        </p:txBody>
-      </p:sp>
-      <p:sp>
-        <p:nvSpPr>
-          <p:cNvPr id="3" name="Content Placeholder 2"/>
-          <p:cNvSpPr>
-            <a:spLocks noGrp="1"/>
-          </p:cNvSpPr>
-          <p:nvPr>
-            <p:ph idx="1"/>
-          </p:nvPr>
-        </p:nvSpPr>
-        <p:spPr/>
-        <p:txBody>
-          <a:bodyPr/>
-          <a:lstStyle/>
-          <a:p>
-            <a:pPr lvl="0" rtl="1" algn="r"/>
-            <a:r>
-              <a:rPr lang="fa-IR" dirty="0">
-                <a:latin typeface="Tahoma"/>
-                <a:cs typeface="Tahoma"/>
-              </a:rPr>
-              <a:t>یاس و رحیمی (۲۰۲۰): کمانش حرارتی تیر؛ تخلخل دمای بحرانی را کم و گرافن مقاومت را زیاد می‌کند. مدل سلول‌باز این کار، مبنای مدل تخلخل پژوهش حاضر است [۵۱].</a:t>
-            </a:r>
-          </a:p>
-          <a:p>
-            <a:pPr lvl="0" rtl="1" algn="r"/>
-            <a:r>
-              <a:rPr lang="fa-IR" dirty="0">
-                <a:latin typeface="Tahoma"/>
-                <a:cs typeface="Tahoma"/>
-              </a:rPr>
-              <a:t>مرادی‌دستجردی و بهدینان (۲۰۲۱): تنش در استوانهٔ جدارضخیم مدرج متخلخل گرافنی در حالت پایا [۵۲]؛ سلمانی و همکاران (۲۰۲۱): پس‌کمانش پوستهٔ استوانه‌ای [۵۳].</a:t>
-            </a:r>
-          </a:p>
-          <a:p>
-            <a:pPr lvl="0" rtl="1" algn="r"/>
-            <a:r>
-              <a:rPr lang="fa-IR" dirty="0">
-                <a:latin typeface="Tahoma"/>
-                <a:cs typeface="Tahoma"/>
-              </a:rPr>
-              <a:t>بابایی و همکاران (۲۰۲۲): مخروط ناقص دوار تحت بار حرارتی گذرا؛ گرافن جابجایی را کم و تخلخل آن را زیاد می‌کند [۵۵].</a:t>
-            </a:r>
-          </a:p>
-          <a:p>
-            <a:pPr lvl="0" rtl="1" algn="r"/>
-            <a:r>
-              <a:rPr lang="fa-IR" dirty="0">
-                <a:latin typeface="Tahoma"/>
-                <a:cs typeface="Tahoma"/>
-              </a:rPr>
-              <a:t>چو (۲۰۲۳)، ژانگ و همکاران (۲۰۲۳): پانل استوانه‌ای؛ پاسخ به مقدار و الگوی توزیع گرافن و تخلخل بسیار وابسته است؛ تبدیل کسر وزنی به حجمی [۵۷، ۵۸، ۶۰].</a:t>
-            </a:r>
-          </a:p>
-          <a:p>
-            <a:pPr lvl="0" rtl="1" algn="r"/>
-            <a:r>
-              <a:rPr lang="fa-IR" dirty="0">
-                <a:latin typeface="Tahoma"/>
-                <a:cs typeface="Tahoma"/>
-              </a:rPr>
-              <a:t>هوانگ و همکاران (۲۰۲۴)، جمشیدی و عارف (۲۰۲۴)، سیتلی و همکاران (۲۰۲۴): کمانش مخروط، رفتار الاستیک استوانه، خمش تیر [۶۱–۶۳].</a:t>
-            </a:r>
-          </a:p>
-        </p:txBody>
-      </p:sp>
-    </p:spTree>
-  </p:cSld>
-</p:sld>
-</file>
-
-<file path=ppt/slides/slide12.xml><?xml version="1.0" encoding="utf-8"?>
-<p:sld xmlns:a="http://schemas.openxmlformats.org/drawingml/2006/main" xmlns:r="http://schemas.openxmlformats.org/officeDocument/2006/relationships" xmlns:p="http://schemas.openxmlformats.org/presentationml/2006/main">
-  <p:cSld>
-    <p:spTree>
-      <p:nvGrpSpPr>
-        <p:cNvPr id="1" name=""/>
-        <p:cNvGrpSpPr/>
-        <p:nvPr/>
-      </p:nvGrpSpPr>
-      <p:grpSpPr>
-        <a:xfrm>
-          <a:off x="0" y="0"/>
-          <a:ext cx="0" cy="0"/>
-          <a:chOff x="0" y="0"/>
-          <a:chExt cx="0" cy="0"/>
-        </a:xfrm>
-      </p:grpSpPr>
-      <p:sp>
-        <p:nvSpPr>
-          <p:cNvPr id="2" name="Title 1"/>
-          <p:cNvSpPr>
-            <a:spLocks noGrp="1"/>
-          </p:cNvSpPr>
-          <p:nvPr>
-            <p:ph type="title"/>
-          </p:nvPr>
-        </p:nvSpPr>
-        <p:spPr/>
-        <p:txBody>
-          <a:bodyPr/>
-          <a:lstStyle/>
-          <a:p>
-            <a:pPr lvl="0" indent="0" marL="0" rtl="1" algn="r">
-              <a:buNone/>
-            </a:pPr>
-            <a:r>
-              <a:rPr lang="fa-IR" dirty="0">
-                <a:latin typeface="Tahoma"/>
-                <a:cs typeface="Tahoma"/>
-              </a:rPr>
-              <a:t>پیشینه ۶: ترموالاستیسیتهٔ تعمیم‌یافته در سازه‌های مدرج</a:t>
-            </a:r>
-          </a:p>
-        </p:txBody>
-      </p:sp>
-      <p:sp>
-        <p:nvSpPr>
-          <p:cNvPr id="3" name="Content Placeholder 2"/>
-          <p:cNvSpPr>
-            <a:spLocks noGrp="1"/>
-          </p:cNvSpPr>
-          <p:nvPr>
-            <p:ph idx="1"/>
-          </p:nvPr>
-        </p:nvSpPr>
-        <p:spPr/>
-        <p:txBody>
-          <a:bodyPr/>
-          <a:lstStyle/>
-          <a:p>
-            <a:pPr lvl="0" rtl="1" algn="r"/>
-            <a:r>
-              <a:rPr lang="fa-IR" dirty="0">
-                <a:latin typeface="Tahoma"/>
-                <a:cs typeface="Tahoma"/>
-              </a:rPr>
-              <a:t>باهتویی و اسلامی (۲۰۰۷): پوستهٔ استوانه‌ای مدرج تحت شوک حرارتی؛ مقایسهٔ لرد–شولمن و گرین–لیندزی (اجزای محدود + لاپلاس) [۶۴، ۶۵].</a:t>
-            </a:r>
-          </a:p>
-          <a:p>
-            <a:pPr lvl="0" rtl="1" algn="r"/>
-            <a:r>
-              <a:rPr lang="fa-IR" dirty="0">
-                <a:latin typeface="Tahoma"/>
-                <a:cs typeface="Tahoma"/>
-              </a:rPr>
-              <a:t>بگری و اسلامی (۲۰۰۸): دیسک حلقوی مدرج با لرد–شولمن [۶۶]؛ حسینی و ابول‌بشری (۲۰۱۲): موج ترموالاستیک در استوانه با گرین–نقدی [۶۷].</a:t>
-            </a:r>
-          </a:p>
-          <a:p>
-            <a:pPr lvl="0" rtl="1" algn="r"/>
-            <a:r>
-              <a:rPr lang="fa-IR" dirty="0">
-                <a:latin typeface="Tahoma"/>
-                <a:cs typeface="Tahoma"/>
-              </a:rPr>
-              <a:t>حیدرپور و ملک‌زاده (۲۰۱۹): کرهٔ مدرج چندلایه با لرد–شولمن، DQM لایه‌ای + نیومارک [۶۸]؛ حیدرپور و همکاران (۲۰۱۹): پوستهٔ کروی گرافنی — نزدیک‌ترین کار به چارچوب پژوهش حاضر [۳].</a:t>
-            </a:r>
-          </a:p>
-          <a:p>
-            <a:pPr lvl="0" rtl="1" algn="r"/>
-            <a:r>
-              <a:rPr lang="fa-IR" dirty="0">
-                <a:latin typeface="Tahoma"/>
-                <a:cs typeface="Tahoma"/>
-              </a:rPr>
-              <a:t>حیدرپور و همکاران (۲۰۲۰): پوستهٔ استوانه‌ای با لایهٔ پیزوالکتریک (قرارداد بی‌بعدسازی فصل ۴) [۶۹]؛ مخروط ناقص گرافنی دوار (مبنای معادلات فصل ۳) [۷۰].</a:t>
-            </a:r>
-          </a:p>
-          <a:p>
-            <a:pPr lvl="0" rtl="1" algn="r"/>
-            <a:r>
-              <a:rPr lang="fa-IR" dirty="0">
-                <a:latin typeface="Tahoma"/>
-                <a:cs typeface="Tahoma"/>
-              </a:rPr>
-              <a:t>حسینی (۲۰۲۱، ۲۰۲۲)، کاظمی و همکاران (۲۰۲۳): انتشار موج حرارتی با گرین–نقدی در استوانه و فراماده [۷۱–۷۳].</a:t>
-            </a:r>
-          </a:p>
-        </p:txBody>
-      </p:sp>
-    </p:spTree>
-  </p:cSld>
-</p:sld>
-</file>
-
-<file path=ppt/slides/slide13.xml><?xml version="1.0" encoding="utf-8"?>
-<p:sld xmlns:a="http://schemas.openxmlformats.org/drawingml/2006/main" xmlns:r="http://schemas.openxmlformats.org/officeDocument/2006/relationships" xmlns:p="http://schemas.openxmlformats.org/presentationml/2006/main">
-  <p:cSld>
-    <p:spTree>
-      <p:nvGrpSpPr>
-        <p:cNvPr id="1" name=""/>
-        <p:cNvGrpSpPr/>
-        <p:nvPr/>
-      </p:nvGrpSpPr>
-      <p:grpSpPr>
-        <a:xfrm>
-          <a:off x="0" y="0"/>
-          <a:ext cx="0" cy="0"/>
-          <a:chOff x="0" y="0"/>
-          <a:chExt cx="0" cy="0"/>
-        </a:xfrm>
-      </p:grpSpPr>
-      <p:sp>
-        <p:nvSpPr>
-          <p:cNvPr id="2" name="Title 1"/>
-          <p:cNvSpPr>
-            <a:spLocks noGrp="1"/>
-          </p:cNvSpPr>
-          <p:nvPr>
-            <p:ph type="title"/>
-          </p:nvPr>
-        </p:nvSpPr>
-        <p:spPr/>
-        <p:txBody>
-          <a:bodyPr/>
-          <a:lstStyle/>
-          <a:p>
-            <a:pPr lvl="0" indent="0" marL="0" rtl="1" algn="r">
-              <a:buNone/>
-            </a:pPr>
-            <a:r>
-              <a:rPr lang="fa-IR" dirty="0">
-                <a:latin typeface="Tahoma"/>
-                <a:cs typeface="Tahoma"/>
-              </a:rPr>
               <a:t>جمع‌بندی پیشینه: چهار شکاف پژوهشی</a:t>
             </a:r>
           </a:p>
@@ -6827,7 +6216,7 @@
 </p:sld>
 </file>
 
-<file path=ppt/slides/slide14.xml><?xml version="1.0" encoding="utf-8"?>
+<file path=ppt/slides/slide11.xml><?xml version="1.0" encoding="utf-8"?>
 <p:sld xmlns:a="http://schemas.openxmlformats.org/drawingml/2006/main" xmlns:r="http://schemas.openxmlformats.org/officeDocument/2006/relationships" xmlns:p="http://schemas.openxmlformats.org/presentationml/2006/main">
   <p:cSld>
     <p:spTree>
@@ -6982,7 +6371,7 @@
 </p:sld>
 </file>
 
-<file path=ppt/slides/slide15.xml><?xml version="1.0" encoding="utf-8"?>
+<file path=ppt/slides/slide12.xml><?xml version="1.0" encoding="utf-8"?>
 <p:sld xmlns:a="http://schemas.openxmlformats.org/drawingml/2006/main" xmlns:r="http://schemas.openxmlformats.org/officeDocument/2006/relationships" xmlns:p="http://schemas.openxmlformats.org/presentationml/2006/main">
   <p:cSld>
     <p:spTree>
@@ -7062,7 +6451,7 @@
 </p:sld>
 </file>
 
-<file path=ppt/slides/slide16.xml><?xml version="1.0" encoding="utf-8"?>
+<file path=ppt/slides/slide13.xml><?xml version="1.0" encoding="utf-8"?>
 <p:sld xmlns:a="http://schemas.openxmlformats.org/drawingml/2006/main" xmlns:r="http://schemas.openxmlformats.org/officeDocument/2006/relationships" xmlns:p="http://schemas.openxmlformats.org/presentationml/2006/main">
   <p:cSld>
     <p:spTree>
@@ -7444,7 +6833,7 @@
 </p:sld>
 </file>
 
-<file path=ppt/slides/slide17.xml><?xml version="1.0" encoding="utf-8"?>
+<file path=ppt/slides/slide14.xml><?xml version="1.0" encoding="utf-8"?>
 <p:sld xmlns:a="http://schemas.openxmlformats.org/drawingml/2006/main" xmlns:r="http://schemas.openxmlformats.org/officeDocument/2006/relationships" xmlns:p="http://schemas.openxmlformats.org/presentationml/2006/main">
   <p:cSld>
     <p:spTree>
@@ -7524,7 +6913,7 @@
 </p:sld>
 </file>
 
-<file path=ppt/slides/slide18.xml><?xml version="1.0" encoding="utf-8"?>
+<file path=ppt/slides/slide15.xml><?xml version="1.0" encoding="utf-8"?>
 <p:sld xmlns:a="http://schemas.openxmlformats.org/drawingml/2006/main" xmlns:r="http://schemas.openxmlformats.org/officeDocument/2006/relationships" xmlns:p="http://schemas.openxmlformats.org/presentationml/2006/main">
   <p:cSld>
     <p:spTree>
@@ -7604,7 +6993,7 @@
 </p:sld>
 </file>
 
-<file path=ppt/slides/slide19.xml><?xml version="1.0" encoding="utf-8"?>
+<file path=ppt/slides/slide16.xml><?xml version="1.0" encoding="utf-8"?>
 <p:sld xmlns:a="http://schemas.openxmlformats.org/drawingml/2006/main" xmlns:r="http://schemas.openxmlformats.org/officeDocument/2006/relationships" xmlns:p="http://schemas.openxmlformats.org/presentationml/2006/main">
   <p:cSld>
     <p:spTree>
@@ -8068,153 +7457,7 @@
 </p:sld>
 </file>
 
-<file path=ppt/slides/slide2.xml><?xml version="1.0" encoding="utf-8"?>
-<p:sld xmlns:a="http://schemas.openxmlformats.org/drawingml/2006/main" xmlns:r="http://schemas.openxmlformats.org/officeDocument/2006/relationships" xmlns:p="http://schemas.openxmlformats.org/presentationml/2006/main">
-  <p:cSld>
-    <p:spTree>
-      <p:nvGrpSpPr>
-        <p:cNvPr id="1" name=""/>
-        <p:cNvGrpSpPr/>
-        <p:nvPr/>
-      </p:nvGrpSpPr>
-      <p:grpSpPr>
-        <a:xfrm>
-          <a:off x="0" y="0"/>
-          <a:ext cx="0" cy="0"/>
-          <a:chOff x="0" y="0"/>
-          <a:chExt cx="0" cy="0"/>
-        </a:xfrm>
-      </p:grpSpPr>
-      <p:sp>
-        <p:nvSpPr>
-          <p:cNvPr id="2" name="Title 1"/>
-          <p:cNvSpPr>
-            <a:spLocks noGrp="1"/>
-          </p:cNvSpPr>
-          <p:nvPr>
-            <p:ph type="title"/>
-          </p:nvPr>
-        </p:nvSpPr>
-        <p:spPr/>
-        <p:txBody>
-          <a:bodyPr/>
-          <a:lstStyle/>
-          <a:p>
-            <a:pPr lvl="0" indent="0" marL="0" rtl="1" algn="r">
-              <a:buNone/>
-            </a:pPr>
-            <a:r>
-              <a:rPr lang="fa-IR" dirty="0">
-                <a:latin typeface="Tahoma"/>
-                <a:cs typeface="Tahoma"/>
-              </a:rPr>
-              <a:t>فهرست مطالب</a:t>
-            </a:r>
-          </a:p>
-        </p:txBody>
-      </p:sp>
-      <p:sp>
-        <p:nvSpPr>
-          <p:cNvPr id="3" name="Content Placeholder 2"/>
-          <p:cNvSpPr>
-            <a:spLocks noGrp="1"/>
-          </p:cNvSpPr>
-          <p:nvPr>
-            <p:ph idx="1"/>
-          </p:nvPr>
-        </p:nvSpPr>
-        <p:spPr/>
-        <p:txBody>
-          <a:bodyPr/>
-          <a:lstStyle/>
-          <a:p>
-            <a:pPr lvl="0" rtl="1" algn="r"/>
-            <a:r>
-              <a:rPr lang="fa-IR" dirty="0">
-                <a:latin typeface="Tahoma"/>
-                <a:cs typeface="Tahoma"/>
-              </a:rPr>
-              <a:t>بیان مسئله و هدف پژوهش</a:t>
-            </a:r>
-          </a:p>
-          <a:p>
-            <a:pPr lvl="0" rtl="1" algn="r"/>
-            <a:r>
-              <a:rPr lang="fa-IR" dirty="0">
-                <a:latin typeface="Tahoma"/>
-                <a:cs typeface="Tahoma"/>
-              </a:rPr>
-              <a:t>پیشینهٔ پژوهش: تئوری‌ها، سازه‌های مدرج، مواد متخلخل، ترموالاستیسیتهٔ تعمیم‌یافته</a:t>
-            </a:r>
-          </a:p>
-          <a:p>
-            <a:pPr lvl="0" rtl="1" algn="r"/>
-            <a:r>
-              <a:rPr lang="fa-IR" dirty="0">
-                <a:latin typeface="Tahoma"/>
-                <a:cs typeface="Tahoma"/>
-              </a:rPr>
-              <a:t>شکاف تحقیقاتی و جایگاه پژوهش</a:t>
-            </a:r>
-          </a:p>
-          <a:p>
-            <a:pPr lvl="0" rtl="1" algn="r"/>
-            <a:r>
-              <a:rPr lang="fa-IR" dirty="0">
-                <a:latin typeface="Tahoma"/>
-                <a:cs typeface="Tahoma"/>
-              </a:rPr>
-              <a:t>مدل‌سازی: هندسه، مواد و الگوها</a:t>
-            </a:r>
-          </a:p>
-          <a:p>
-            <a:pPr lvl="0" rtl="1" algn="r"/>
-            <a:r>
-              <a:rPr lang="fa-IR" dirty="0">
-                <a:latin typeface="Tahoma"/>
-                <a:cs typeface="Tahoma"/>
-              </a:rPr>
-              <a:t>معادلات حاکم و روش حل عددی</a:t>
-            </a:r>
-          </a:p>
-          <a:p>
-            <a:pPr lvl="0" rtl="1" algn="r"/>
-            <a:r>
-              <a:rPr lang="fa-IR" dirty="0">
-                <a:latin typeface="Tahoma"/>
-                <a:cs typeface="Tahoma"/>
-              </a:rPr>
-              <a:t>صحت‌سنجی و همگرایی</a:t>
-            </a:r>
-          </a:p>
-          <a:p>
-            <a:pPr lvl="0" rtl="1" algn="r"/>
-            <a:r>
-              <a:rPr lang="fa-IR" dirty="0">
-                <a:latin typeface="Tahoma"/>
-                <a:cs typeface="Tahoma"/>
-              </a:rPr>
-              <a:t>نتایج و بحث</a:t>
-            </a:r>
-          </a:p>
-          <a:p>
-            <a:pPr lvl="0" rtl="1" algn="r"/>
-            <a:r>
-              <a:rPr lang="fa-IR" dirty="0">
-                <a:latin typeface="Tahoma"/>
-                <a:cs typeface="Tahoma"/>
-              </a:rPr>
-              <a:t>نوآوری‌ها، نتیجه‌گیری و پیشنهادها</a:t>
-            </a:r>
-          </a:p>
-        </p:txBody>
-      </p:sp>
-    </p:spTree>
-  </p:cSld>
-</p:sld>
-</file>
-
-<file path=ppt/slides/slide20.xml><?xml version="1.0" encoding="utf-8"?>
+<file path=ppt/slides/slide17.xml><?xml version="1.0" encoding="utf-8"?>
 <p:sld xmlns:a="http://schemas.openxmlformats.org/drawingml/2006/main" xmlns:r="http://schemas.openxmlformats.org/officeDocument/2006/relationships" xmlns:p="http://schemas.openxmlformats.org/presentationml/2006/main">
   <p:cSld>
     <p:spTree>
@@ -8465,7 +7708,7 @@
 </p:sld>
 </file>
 
-<file path=ppt/slides/slide21.xml><?xml version="1.0" encoding="utf-8"?>
+<file path=ppt/slides/slide18.xml><?xml version="1.0" encoding="utf-8"?>
 <p:sld xmlns:a="http://schemas.openxmlformats.org/drawingml/2006/main" xmlns:r="http://schemas.openxmlformats.org/officeDocument/2006/relationships" xmlns:p="http://schemas.openxmlformats.org/presentationml/2006/main">
   <p:cSld>
     <p:spTree>
@@ -8545,7 +7788,7 @@
 </p:sld>
 </file>
 
-<file path=ppt/slides/slide22.xml><?xml version="1.0" encoding="utf-8"?>
+<file path=ppt/slides/slide19.xml><?xml version="1.0" encoding="utf-8"?>
 <p:sld xmlns:a="http://schemas.openxmlformats.org/drawingml/2006/main" xmlns:r="http://schemas.openxmlformats.org/officeDocument/2006/relationships" xmlns:p="http://schemas.openxmlformats.org/presentationml/2006/main">
   <p:cSld>
     <p:spTree>
@@ -8625,7 +7868,153 @@
 </p:sld>
 </file>
 
-<file path=ppt/slides/slide23.xml><?xml version="1.0" encoding="utf-8"?>
+<file path=ppt/slides/slide2.xml><?xml version="1.0" encoding="utf-8"?>
+<p:sld xmlns:a="http://schemas.openxmlformats.org/drawingml/2006/main" xmlns:r="http://schemas.openxmlformats.org/officeDocument/2006/relationships" xmlns:p="http://schemas.openxmlformats.org/presentationml/2006/main">
+  <p:cSld>
+    <p:spTree>
+      <p:nvGrpSpPr>
+        <p:cNvPr id="1" name=""/>
+        <p:cNvGrpSpPr/>
+        <p:nvPr/>
+      </p:nvGrpSpPr>
+      <p:grpSpPr>
+        <a:xfrm>
+          <a:off x="0" y="0"/>
+          <a:ext cx="0" cy="0"/>
+          <a:chOff x="0" y="0"/>
+          <a:chExt cx="0" cy="0"/>
+        </a:xfrm>
+      </p:grpSpPr>
+      <p:sp>
+        <p:nvSpPr>
+          <p:cNvPr id="2" name="Title 1"/>
+          <p:cNvSpPr>
+            <a:spLocks noGrp="1"/>
+          </p:cNvSpPr>
+          <p:nvPr>
+            <p:ph type="title"/>
+          </p:nvPr>
+        </p:nvSpPr>
+        <p:spPr/>
+        <p:txBody>
+          <a:bodyPr/>
+          <a:lstStyle/>
+          <a:p>
+            <a:pPr lvl="0" indent="0" marL="0" rtl="1" algn="r">
+              <a:buNone/>
+            </a:pPr>
+            <a:r>
+              <a:rPr lang="fa-IR" dirty="0">
+                <a:latin typeface="Tahoma"/>
+                <a:cs typeface="Tahoma"/>
+              </a:rPr>
+              <a:t>فهرست مطالب</a:t>
+            </a:r>
+          </a:p>
+        </p:txBody>
+      </p:sp>
+      <p:sp>
+        <p:nvSpPr>
+          <p:cNvPr id="3" name="Content Placeholder 2"/>
+          <p:cNvSpPr>
+            <a:spLocks noGrp="1"/>
+          </p:cNvSpPr>
+          <p:nvPr>
+            <p:ph idx="1"/>
+          </p:nvPr>
+        </p:nvSpPr>
+        <p:spPr/>
+        <p:txBody>
+          <a:bodyPr/>
+          <a:lstStyle/>
+          <a:p>
+            <a:pPr lvl="0" rtl="1" algn="r"/>
+            <a:r>
+              <a:rPr lang="fa-IR" dirty="0">
+                <a:latin typeface="Tahoma"/>
+                <a:cs typeface="Tahoma"/>
+              </a:rPr>
+              <a:t>بیان مسئله و هدف پژوهش</a:t>
+            </a:r>
+          </a:p>
+          <a:p>
+            <a:pPr lvl="0" rtl="1" algn="r"/>
+            <a:r>
+              <a:rPr lang="fa-IR" dirty="0">
+                <a:latin typeface="Tahoma"/>
+                <a:cs typeface="Tahoma"/>
+              </a:rPr>
+              <a:t>پیشینهٔ پژوهش: تئوری‌ها، سازه‌های مدرج، مواد متخلخل، ترموالاستیسیتهٔ تعمیم‌یافته</a:t>
+            </a:r>
+          </a:p>
+          <a:p>
+            <a:pPr lvl="0" rtl="1" algn="r"/>
+            <a:r>
+              <a:rPr lang="fa-IR" dirty="0">
+                <a:latin typeface="Tahoma"/>
+                <a:cs typeface="Tahoma"/>
+              </a:rPr>
+              <a:t>شکاف تحقیقاتی و جایگاه پژوهش</a:t>
+            </a:r>
+          </a:p>
+          <a:p>
+            <a:pPr lvl="0" rtl="1" algn="r"/>
+            <a:r>
+              <a:rPr lang="fa-IR" dirty="0">
+                <a:latin typeface="Tahoma"/>
+                <a:cs typeface="Tahoma"/>
+              </a:rPr>
+              <a:t>مدل‌سازی: هندسه، مواد و الگوها</a:t>
+            </a:r>
+          </a:p>
+          <a:p>
+            <a:pPr lvl="0" rtl="1" algn="r"/>
+            <a:r>
+              <a:rPr lang="fa-IR" dirty="0">
+                <a:latin typeface="Tahoma"/>
+                <a:cs typeface="Tahoma"/>
+              </a:rPr>
+              <a:t>معادلات حاکم و روش حل عددی</a:t>
+            </a:r>
+          </a:p>
+          <a:p>
+            <a:pPr lvl="0" rtl="1" algn="r"/>
+            <a:r>
+              <a:rPr lang="fa-IR" dirty="0">
+                <a:latin typeface="Tahoma"/>
+                <a:cs typeface="Tahoma"/>
+              </a:rPr>
+              <a:t>صحت‌سنجی و همگرایی</a:t>
+            </a:r>
+          </a:p>
+          <a:p>
+            <a:pPr lvl="0" rtl="1" algn="r"/>
+            <a:r>
+              <a:rPr lang="fa-IR" dirty="0">
+                <a:latin typeface="Tahoma"/>
+                <a:cs typeface="Tahoma"/>
+              </a:rPr>
+              <a:t>نتایج و بحث</a:t>
+            </a:r>
+          </a:p>
+          <a:p>
+            <a:pPr lvl="0" rtl="1" algn="r"/>
+            <a:r>
+              <a:rPr lang="fa-IR" dirty="0">
+                <a:latin typeface="Tahoma"/>
+                <a:cs typeface="Tahoma"/>
+              </a:rPr>
+              <a:t>نوآوری‌ها، نتیجه‌گیری و پیشنهادها</a:t>
+            </a:r>
+          </a:p>
+        </p:txBody>
+      </p:sp>
+    </p:spTree>
+  </p:cSld>
+</p:sld>
+</file>
+
+<file path=ppt/slides/slide20.xml><?xml version="1.0" encoding="utf-8"?>
 <p:sld xmlns:a="http://schemas.openxmlformats.org/drawingml/2006/main" xmlns:r="http://schemas.openxmlformats.org/officeDocument/2006/relationships" xmlns:p="http://schemas.openxmlformats.org/presentationml/2006/main">
   <p:cSld>
     <p:spTree>
@@ -8948,7 +8337,7 @@
 </p:sld>
 </file>
 
-<file path=ppt/slides/slide24.xml><?xml version="1.0" encoding="utf-8"?>
+<file path=ppt/slides/slide21.xml><?xml version="1.0" encoding="utf-8"?>
 <p:sld xmlns:a="http://schemas.openxmlformats.org/drawingml/2006/main" xmlns:r="http://schemas.openxmlformats.org/officeDocument/2006/relationships" xmlns:p="http://schemas.openxmlformats.org/presentationml/2006/main">
   <p:cSld>
     <p:spTree>
@@ -9028,7 +8417,7 @@
 </p:sld>
 </file>
 
-<file path=ppt/slides/slide25.xml><?xml version="1.0" encoding="utf-8"?>
+<file path=ppt/slides/slide22.xml><?xml version="1.0" encoding="utf-8"?>
 <p:sld xmlns:a="http://schemas.openxmlformats.org/drawingml/2006/main" xmlns:r="http://schemas.openxmlformats.org/officeDocument/2006/relationships" xmlns:p="http://schemas.openxmlformats.org/presentationml/2006/main">
   <p:cSld>
     <p:spTree>
@@ -9108,7 +8497,7 @@
 </p:sld>
 </file>
 
-<file path=ppt/slides/slide26.xml><?xml version="1.0" encoding="utf-8"?>
+<file path=ppt/slides/slide23.xml><?xml version="1.0" encoding="utf-8"?>
 <p:sld xmlns:a="http://schemas.openxmlformats.org/drawingml/2006/main" xmlns:r="http://schemas.openxmlformats.org/officeDocument/2006/relationships" xmlns:p="http://schemas.openxmlformats.org/presentationml/2006/main">
   <p:cSld>
     <p:spTree>
@@ -9364,7 +8753,7 @@
 </p:sld>
 </file>
 
-<file path=ppt/slides/slide27.xml><?xml version="1.0" encoding="utf-8"?>
+<file path=ppt/slides/slide24.xml><?xml version="1.0" encoding="utf-8"?>
 <p:sld xmlns:a="http://schemas.openxmlformats.org/drawingml/2006/main" xmlns:r="http://schemas.openxmlformats.org/officeDocument/2006/relationships" xmlns:p="http://schemas.openxmlformats.org/presentationml/2006/main">
   <p:cSld>
     <p:spTree>
@@ -9537,7 +8926,7 @@
 </p:sld>
 </file>
 
-<file path=ppt/slides/slide28.xml><?xml version="1.0" encoding="utf-8"?>
+<file path=ppt/slides/slide25.xml><?xml version="1.0" encoding="utf-8"?>
 <p:sld xmlns:a="http://schemas.openxmlformats.org/drawingml/2006/main" xmlns:r="http://schemas.openxmlformats.org/officeDocument/2006/relationships" xmlns:p="http://schemas.openxmlformats.org/presentationml/2006/main">
   <p:cSld>
     <p:spTree>
@@ -9700,7 +9089,7 @@
 </p:sld>
 </file>
 
-<file path=ppt/slides/slide29.xml><?xml version="1.0" encoding="utf-8"?>
+<file path=ppt/slides/slide26.xml><?xml version="1.0" encoding="utf-8"?>
 <p:sld xmlns:a="http://schemas.openxmlformats.org/drawingml/2006/main" xmlns:r="http://schemas.openxmlformats.org/officeDocument/2006/relationships" xmlns:p="http://schemas.openxmlformats.org/presentationml/2006/main">
   <p:cSld>
     <p:spTree>
@@ -9877,113 +9266,7 @@
 </p:sld>
 </file>
 
-<file path=ppt/slides/slide3.xml><?xml version="1.0" encoding="utf-8"?>
-<p:sld xmlns:a="http://schemas.openxmlformats.org/drawingml/2006/main" xmlns:r="http://schemas.openxmlformats.org/officeDocument/2006/relationships" xmlns:p="http://schemas.openxmlformats.org/presentationml/2006/main">
-  <p:cSld>
-    <p:spTree>
-      <p:nvGrpSpPr>
-        <p:cNvPr id="1" name=""/>
-        <p:cNvGrpSpPr/>
-        <p:nvPr/>
-      </p:nvGrpSpPr>
-      <p:grpSpPr>
-        <a:xfrm>
-          <a:off x="0" y="0"/>
-          <a:ext cx="0" cy="0"/>
-          <a:chOff x="0" y="0"/>
-          <a:chExt cx="0" cy="0"/>
-        </a:xfrm>
-      </p:grpSpPr>
-      <p:sp>
-        <p:nvSpPr>
-          <p:cNvPr id="2" name="Title 1"/>
-          <p:cNvSpPr>
-            <a:spLocks noGrp="1"/>
-          </p:cNvSpPr>
-          <p:nvPr>
-            <p:ph type="title"/>
-          </p:nvPr>
-        </p:nvSpPr>
-        <p:spPr/>
-        <p:txBody>
-          <a:bodyPr/>
-          <a:lstStyle/>
-          <a:p>
-            <a:pPr lvl="0" indent="0" marL="0" rtl="1" algn="r">
-              <a:buNone/>
-            </a:pPr>
-            <a:r>
-              <a:rPr lang="fa-IR" dirty="0">
-                <a:latin typeface="Tahoma"/>
-                <a:cs typeface="Tahoma"/>
-              </a:rPr>
-              <a:t>استوانه‌های جدارضخیم: سازه‌ای پرکاربرد در معرض بارهای حرارتی سریع</a:t>
-            </a:r>
-          </a:p>
-        </p:txBody>
-      </p:sp>
-      <p:sp>
-        <p:nvSpPr>
-          <p:cNvPr id="3" name="Content Placeholder 2"/>
-          <p:cNvSpPr>
-            <a:spLocks noGrp="1"/>
-          </p:cNvSpPr>
-          <p:nvPr>
-            <p:ph idx="1"/>
-          </p:nvPr>
-        </p:nvSpPr>
-        <p:spPr/>
-        <p:txBody>
-          <a:bodyPr/>
-          <a:lstStyle/>
-          <a:p>
-            <a:pPr lvl="0" rtl="1" algn="r"/>
-            <a:r>
-              <a:rPr lang="fa-IR" dirty="0">
-                <a:latin typeface="Tahoma"/>
-                <a:cs typeface="Tahoma"/>
-              </a:rPr>
-              <a:t>سیلندرها استوانه‌هایی توخالی و معمولاً جدارضخیم‌اند و بارهای محوری، برشی، پیچشی، خمشی، هیدرواستاتیک و هیدرودینامیک را تحمل می‌کنند.</a:t>
-            </a:r>
-          </a:p>
-          <a:p>
-            <a:pPr lvl="0" rtl="1" algn="r"/>
-            <a:r>
-              <a:rPr lang="fa-IR" dirty="0">
-                <a:latin typeface="Tahoma"/>
-                <a:cs typeface="Tahoma"/>
-              </a:rPr>
-              <a:t>کاربرد: مخازن نگهداری و انتقال سیال، فضاپیماها، رآکتورهای هسته‌ای، مبدل‌های حرارتی.</a:t>
-            </a:r>
-          </a:p>
-          <a:p>
-            <a:pPr lvl="0" rtl="1" algn="r"/>
-            <a:r>
-              <a:rPr lang="fa-IR" dirty="0">
-                <a:latin typeface="Tahoma"/>
-                <a:cs typeface="Tahoma"/>
-              </a:rPr>
-              <a:t>این اجزا اغلب در معرض بارهای حرارتیِ سریع و شدید قرار می‌گیرند.</a:t>
-            </a:r>
-          </a:p>
-          <a:p>
-            <a:pPr lvl="0" rtl="1" algn="r"/>
-            <a:r>
-              <a:rPr lang="fa-IR" dirty="0">
-                <a:latin typeface="Tahoma"/>
-                <a:cs typeface="Tahoma"/>
-              </a:rPr>
-              <a:t>پیش‌بینی دقیق دما و تنش‌های حرارتیِ گذرا برای ایمنی و طول عمر سازه حیاتی است.</a:t>
-            </a:r>
-          </a:p>
-        </p:txBody>
-      </p:sp>
-    </p:spTree>
-  </p:cSld>
-</p:sld>
-</file>
-
-<file path=ppt/slides/slide30.xml><?xml version="1.0" encoding="utf-8"?>
+<file path=ppt/slides/slide27.xml><?xml version="1.0" encoding="utf-8"?>
 <p:sld xmlns:a="http://schemas.openxmlformats.org/drawingml/2006/main" xmlns:r="http://schemas.openxmlformats.org/officeDocument/2006/relationships" xmlns:p="http://schemas.openxmlformats.org/presentationml/2006/main">
   <p:cSld>
     <p:spTree>
@@ -10146,7 +9429,7 @@
 </p:sld>
 </file>
 
-<file path=ppt/slides/slide31.xml><?xml version="1.0" encoding="utf-8"?>
+<file path=ppt/slides/slide28.xml><?xml version="1.0" encoding="utf-8"?>
 <p:sld xmlns:a="http://schemas.openxmlformats.org/drawingml/2006/main" xmlns:r="http://schemas.openxmlformats.org/officeDocument/2006/relationships" xmlns:p="http://schemas.openxmlformats.org/presentationml/2006/main">
   <p:cSld>
     <p:spTree>
@@ -10339,7 +9622,7 @@
 </p:sld>
 </file>
 
-<file path=ppt/slides/slide32.xml><?xml version="1.0" encoding="utf-8"?>
+<file path=ppt/slides/slide29.xml><?xml version="1.0" encoding="utf-8"?>
 <p:sld xmlns:a="http://schemas.openxmlformats.org/drawingml/2006/main" xmlns:r="http://schemas.openxmlformats.org/officeDocument/2006/relationships" xmlns:p="http://schemas.openxmlformats.org/presentationml/2006/main">
   <p:cSld>
     <p:spTree>
@@ -10502,7 +9785,113 @@
 </p:sld>
 </file>
 
-<file path=ppt/slides/slide33.xml><?xml version="1.0" encoding="utf-8"?>
+<file path=ppt/slides/slide3.xml><?xml version="1.0" encoding="utf-8"?>
+<p:sld xmlns:a="http://schemas.openxmlformats.org/drawingml/2006/main" xmlns:r="http://schemas.openxmlformats.org/officeDocument/2006/relationships" xmlns:p="http://schemas.openxmlformats.org/presentationml/2006/main">
+  <p:cSld>
+    <p:spTree>
+      <p:nvGrpSpPr>
+        <p:cNvPr id="1" name=""/>
+        <p:cNvGrpSpPr/>
+        <p:nvPr/>
+      </p:nvGrpSpPr>
+      <p:grpSpPr>
+        <a:xfrm>
+          <a:off x="0" y="0"/>
+          <a:ext cx="0" cy="0"/>
+          <a:chOff x="0" y="0"/>
+          <a:chExt cx="0" cy="0"/>
+        </a:xfrm>
+      </p:grpSpPr>
+      <p:sp>
+        <p:nvSpPr>
+          <p:cNvPr id="2" name="Title 1"/>
+          <p:cNvSpPr>
+            <a:spLocks noGrp="1"/>
+          </p:cNvSpPr>
+          <p:nvPr>
+            <p:ph type="title"/>
+          </p:nvPr>
+        </p:nvSpPr>
+        <p:spPr/>
+        <p:txBody>
+          <a:bodyPr/>
+          <a:lstStyle/>
+          <a:p>
+            <a:pPr lvl="0" indent="0" marL="0" rtl="1" algn="r">
+              <a:buNone/>
+            </a:pPr>
+            <a:r>
+              <a:rPr lang="fa-IR" dirty="0">
+                <a:latin typeface="Tahoma"/>
+                <a:cs typeface="Tahoma"/>
+              </a:rPr>
+              <a:t>استوانه‌های جدارضخیم: سازه‌ای پرکاربرد در معرض بارهای حرارتی سریع</a:t>
+            </a:r>
+          </a:p>
+        </p:txBody>
+      </p:sp>
+      <p:sp>
+        <p:nvSpPr>
+          <p:cNvPr id="3" name="Content Placeholder 2"/>
+          <p:cNvSpPr>
+            <a:spLocks noGrp="1"/>
+          </p:cNvSpPr>
+          <p:nvPr>
+            <p:ph idx="1"/>
+          </p:nvPr>
+        </p:nvSpPr>
+        <p:spPr/>
+        <p:txBody>
+          <a:bodyPr/>
+          <a:lstStyle/>
+          <a:p>
+            <a:pPr lvl="0" rtl="1" algn="r"/>
+            <a:r>
+              <a:rPr lang="fa-IR" dirty="0">
+                <a:latin typeface="Tahoma"/>
+                <a:cs typeface="Tahoma"/>
+              </a:rPr>
+              <a:t>سیلندرها استوانه‌هایی توخالی و معمولاً جدارضخیم‌اند و بارهای محوری، برشی، پیچشی، خمشی، هیدرواستاتیک و هیدرودینامیک را تحمل می‌کنند.</a:t>
+            </a:r>
+          </a:p>
+          <a:p>
+            <a:pPr lvl="0" rtl="1" algn="r"/>
+            <a:r>
+              <a:rPr lang="fa-IR" dirty="0">
+                <a:latin typeface="Tahoma"/>
+                <a:cs typeface="Tahoma"/>
+              </a:rPr>
+              <a:t>کاربرد: مخازن نگهداری و انتقال سیال، فضاپیماها، رآکتورهای هسته‌ای، مبدل‌های حرارتی.</a:t>
+            </a:r>
+          </a:p>
+          <a:p>
+            <a:pPr lvl="0" rtl="1" algn="r"/>
+            <a:r>
+              <a:rPr lang="fa-IR" dirty="0">
+                <a:latin typeface="Tahoma"/>
+                <a:cs typeface="Tahoma"/>
+              </a:rPr>
+              <a:t>این اجزا اغلب در معرض بارهای حرارتیِ سریع و شدید قرار می‌گیرند.</a:t>
+            </a:r>
+          </a:p>
+          <a:p>
+            <a:pPr lvl="0" rtl="1" algn="r"/>
+            <a:r>
+              <a:rPr lang="fa-IR" dirty="0">
+                <a:latin typeface="Tahoma"/>
+                <a:cs typeface="Tahoma"/>
+              </a:rPr>
+              <a:t>پیش‌بینی دقیق دما و تنش‌های حرارتیِ گذرا برای ایمنی و طول عمر سازه حیاتی است.</a:t>
+            </a:r>
+          </a:p>
+        </p:txBody>
+      </p:sp>
+    </p:spTree>
+  </p:cSld>
+</p:sld>
+</file>
+
+<file path=ppt/slides/slide30.xml><?xml version="1.0" encoding="utf-8"?>
 <p:sld xmlns:a="http://schemas.openxmlformats.org/drawingml/2006/main" xmlns:r="http://schemas.openxmlformats.org/officeDocument/2006/relationships" xmlns:p="http://schemas.openxmlformats.org/presentationml/2006/main">
   <p:cSld>
     <p:spTree>
@@ -10637,7 +10026,7 @@
 </p:sld>
 </file>
 
-<file path=ppt/slides/slide34.xml><?xml version="1.0" encoding="utf-8"?>
+<file path=ppt/slides/slide31.xml><?xml version="1.0" encoding="utf-8"?>
 <p:sld xmlns:a="http://schemas.openxmlformats.org/drawingml/2006/main" xmlns:r="http://schemas.openxmlformats.org/officeDocument/2006/relationships" xmlns:p="http://schemas.openxmlformats.org/presentationml/2006/main">
   <p:cSld>
     <p:spTree>
@@ -10793,6 +10182,567 @@
 </p:sld>
 </file>
 
+<file path=ppt/slides/slide32.xml><?xml version="1.0" encoding="utf-8"?>
+<p:sld xmlns:a="http://schemas.openxmlformats.org/drawingml/2006/main" xmlns:r="http://schemas.openxmlformats.org/officeDocument/2006/relationships" xmlns:p="http://schemas.openxmlformats.org/presentationml/2006/main">
+  <p:cSld>
+    <p:spTree>
+      <p:nvGrpSpPr>
+        <p:cNvPr id="1" name=""/>
+        <p:cNvGrpSpPr/>
+        <p:nvPr/>
+      </p:nvGrpSpPr>
+      <p:grpSpPr>
+        <a:xfrm>
+          <a:off x="0" y="0"/>
+          <a:ext cx="0" cy="0"/>
+          <a:chOff x="0" y="0"/>
+          <a:chExt cx="0" cy="0"/>
+        </a:xfrm>
+      </p:grpSpPr>
+      <p:sp>
+        <p:nvSpPr>
+          <p:cNvPr id="2" name="Title 1"/>
+          <p:cNvSpPr>
+            <a:spLocks noGrp="1"/>
+          </p:cNvSpPr>
+          <p:nvPr>
+            <p:ph type="title"/>
+          </p:nvPr>
+        </p:nvSpPr>
+        <p:spPr/>
+        <p:txBody>
+          <a:bodyPr/>
+          <a:lstStyle/>
+          <a:p>
+            <a:pPr lvl="0" indent="0" marL="0" rtl="1" algn="r">
+              <a:buNone/>
+            </a:pPr>
+            <a:r>
+              <a:rPr lang="fa-IR" dirty="0">
+                <a:latin typeface="Tahoma"/>
+                <a:cs typeface="Tahoma"/>
+              </a:rPr>
+              <a:t>نوآوری‌های پژوهش</a:t>
+            </a:r>
+          </a:p>
+        </p:txBody>
+      </p:sp>
+      <p:sp>
+        <p:nvSpPr>
+          <p:cNvPr id="3" name="Content Placeholder 2"/>
+          <p:cNvSpPr>
+            <a:spLocks noGrp="1"/>
+          </p:cNvSpPr>
+          <p:nvPr>
+            <p:ph idx="1"/>
+          </p:nvPr>
+        </p:nvSpPr>
+        <p:spPr/>
+        <p:txBody>
+          <a:bodyPr/>
+          <a:lstStyle/>
+          <a:p>
+            <a:pPr lvl="0" indent="-342900" marL="342900" rtl="1" algn="r">
+              <a:buAutoNum type="arabicPeriod"/>
+            </a:pPr>
+            <a:r>
+              <a:rPr lang="fa-IR" dirty="0">
+                <a:latin typeface="Tahoma"/>
+                <a:cs typeface="Tahoma"/>
+              </a:rPr>
+              <a:t>حل </a:t>
+            </a:r>
+            <a:r>
+              <a:rPr b="1" lang="fa-IR" dirty="0">
+                <a:latin typeface="Tahoma"/>
+                <a:cs typeface="Tahoma"/>
+              </a:rPr>
+              <a:t>کاملاً ممزوج</a:t>
+            </a:r>
+            <a:r>
+              <a:rPr lang="fa-IR" dirty="0">
+                <a:latin typeface="Tahoma"/>
+                <a:cs typeface="Tahoma"/>
+              </a:rPr>
+              <a:t> لرد-شولمن برای استوانهٔ چندلایهٔ متخلخلِ گرافنی با DQM لایه‌ایِ دوبعدی.</a:t>
+            </a:r>
+          </a:p>
+          <a:p>
+            <a:pPr lvl="0" indent="-342900" marL="342900" rtl="1" algn="r">
+              <a:buAutoNum type="arabicPeriod"/>
+            </a:pPr>
+            <a:r>
+              <a:rPr b="1" lang="fa-IR" dirty="0">
+                <a:latin typeface="Tahoma"/>
+                <a:cs typeface="Tahoma"/>
+              </a:rPr>
+              <a:t>برهم‌کنش هم‌افزای V-گرافن و A-تخلخل</a:t>
+            </a:r>
+            <a:r>
+              <a:rPr lang="fa-IR" dirty="0">
+                <a:latin typeface="Tahoma"/>
+                <a:cs typeface="Tahoma"/>
+              </a:rPr>
+              <a:t> و </a:t>
+            </a:r>
+            <a:r>
+              <a:rPr b="1" lang="fa-IR" dirty="0">
+                <a:latin typeface="Tahoma"/>
+                <a:cs typeface="Tahoma"/>
+              </a:rPr>
+              <a:t>ماتریس کامل ۵×۵</a:t>
+            </a:r>
+            <a:r>
+              <a:rPr lang="fa-IR" dirty="0">
+                <a:latin typeface="Tahoma"/>
+                <a:cs typeface="Tahoma"/>
+              </a:rPr>
+              <a:t> که در مراجع پیشین همتا ندارد.</a:t>
+            </a:r>
+          </a:p>
+          <a:p>
+            <a:pPr lvl="0" indent="-342900" marL="342900" rtl="1" algn="r">
+              <a:buAutoNum type="arabicPeriod"/>
+            </a:pPr>
+            <a:r>
+              <a:rPr lang="fa-IR" dirty="0">
+                <a:latin typeface="Tahoma"/>
+                <a:cs typeface="Tahoma"/>
+              </a:rPr>
+              <a:t>رفتار </a:t>
+            </a:r>
+            <a:r>
+              <a:rPr b="1" lang="fa-IR" dirty="0">
+                <a:latin typeface="Tahoma"/>
+                <a:cs typeface="Tahoma"/>
+              </a:rPr>
+              <a:t>«قله-قعر»</a:t>
+            </a:r>
+            <a:r>
+              <a:rPr lang="fa-IR" dirty="0">
+                <a:latin typeface="Tahoma"/>
+                <a:cs typeface="Tahoma"/>
+              </a:rPr>
+              <a:t> و آینه‌ایِ الگوها و پیوند آن با سرشت موجی هدایت.</a:t>
+            </a:r>
+          </a:p>
+          <a:p>
+            <a:pPr lvl="0" indent="-342900" marL="342900" rtl="1" algn="r">
+              <a:buAutoNum type="arabicPeriod"/>
+            </a:pPr>
+            <a:r>
+              <a:rPr lang="fa-IR" dirty="0">
+                <a:latin typeface="Tahoma"/>
+                <a:cs typeface="Tahoma"/>
+              </a:rPr>
+              <a:t>سه مطالعهٔ گسترشی: شش انتگرال‌گیر زمانی، چهار روش مکانی، چهار تئوری.</a:t>
+            </a:r>
+          </a:p>
+          <a:p>
+            <a:pPr lvl="0" indent="-342900" marL="342900" rtl="1" algn="r">
+              <a:buAutoNum type="arabicPeriod"/>
+            </a:pPr>
+            <a:r>
+              <a:rPr lang="fa-IR" dirty="0">
+                <a:latin typeface="Tahoma"/>
+                <a:cs typeface="Tahoma"/>
+              </a:rPr>
+              <a:t>صحت‌سنجی </a:t>
+            </a:r>
+            <a:r>
+              <a:rPr b="1" lang="fa-IR" dirty="0">
+                <a:latin typeface="Tahoma"/>
+                <a:cs typeface="Tahoma"/>
+              </a:rPr>
+              <a:t>کمّی</a:t>
+            </a:r>
+            <a:r>
+              <a:rPr lang="fa-IR" dirty="0">
+                <a:latin typeface="Tahoma"/>
+                <a:cs typeface="Tahoma"/>
+              </a:rPr>
+              <a:t> موج صوت دوم در برابر حل دقیق تحلیلی.</a:t>
+            </a:r>
+          </a:p>
+        </p:txBody>
+      </p:sp>
+    </p:spTree>
+  </p:cSld>
+</p:sld>
+</file>
+
+<file path=ppt/slides/slide33.xml><?xml version="1.0" encoding="utf-8"?>
+<p:sld xmlns:a="http://schemas.openxmlformats.org/drawingml/2006/main" xmlns:r="http://schemas.openxmlformats.org/officeDocument/2006/relationships" xmlns:p="http://schemas.openxmlformats.org/presentationml/2006/main">
+  <p:cSld>
+    <p:spTree>
+      <p:nvGrpSpPr>
+        <p:cNvPr id="1" name=""/>
+        <p:cNvGrpSpPr/>
+        <p:nvPr/>
+      </p:nvGrpSpPr>
+      <p:grpSpPr>
+        <a:xfrm>
+          <a:off x="0" y="0"/>
+          <a:ext cx="0" cy="0"/>
+          <a:chOff x="0" y="0"/>
+          <a:chExt cx="0" cy="0"/>
+        </a:xfrm>
+      </p:grpSpPr>
+      <p:sp>
+        <p:nvSpPr>
+          <p:cNvPr id="2" name="Title 1"/>
+          <p:cNvSpPr>
+            <a:spLocks noGrp="1"/>
+          </p:cNvSpPr>
+          <p:nvPr>
+            <p:ph type="title"/>
+          </p:nvPr>
+        </p:nvSpPr>
+        <p:spPr/>
+        <p:txBody>
+          <a:bodyPr/>
+          <a:lstStyle/>
+          <a:p>
+            <a:pPr lvl="0" indent="0" marL="0" rtl="1" algn="r">
+              <a:buNone/>
+            </a:pPr>
+            <a:r>
+              <a:rPr lang="fa-IR" dirty="0">
+                <a:latin typeface="Tahoma"/>
+                <a:cs typeface="Tahoma"/>
+              </a:rPr>
+              <a:t>نتیجه‌گیری</a:t>
+            </a:r>
+          </a:p>
+        </p:txBody>
+      </p:sp>
+      <p:sp>
+        <p:nvSpPr>
+          <p:cNvPr id="3" name="Content Placeholder 2"/>
+          <p:cNvSpPr>
+            <a:spLocks noGrp="1"/>
+          </p:cNvSpPr>
+          <p:nvPr>
+            <p:ph idx="1"/>
+          </p:nvPr>
+        </p:nvSpPr>
+        <p:spPr/>
+        <p:txBody>
+          <a:bodyPr/>
+          <a:lstStyle/>
+          <a:p>
+            <a:pPr lvl="0" rtl="1" algn="r"/>
+            <a:r>
+              <a:rPr lang="fa-IR" dirty="0">
+                <a:latin typeface="Tahoma"/>
+                <a:cs typeface="Tahoma"/>
+              </a:rPr>
+              <a:t>در </a:t>
+            </a:r>
+            <a:r>
+              <a:rPr b="1" lang="fa-IR" dirty="0">
+                <a:latin typeface="Tahoma"/>
+                <a:cs typeface="Tahoma"/>
+              </a:rPr>
+              <a:t>شوک حرارتی گذرا</a:t>
+            </a:r>
+            <a:r>
+              <a:rPr lang="fa-IR" dirty="0">
+                <a:latin typeface="Tahoma"/>
+                <a:cs typeface="Tahoma"/>
+              </a:rPr>
+              <a:t>، پیش‌بینی دما و تنش به انتخاب مدل هدایت حساس است؛ در پالس گاوسی فوریه بیشینهٔ دما را حدود ۲٫۵ برابر کمتر می‌دهد.</a:t>
+            </a:r>
+          </a:p>
+          <a:p>
+            <a:pPr lvl="0" rtl="1" algn="r"/>
+            <a:r>
+              <a:rPr lang="fa-IR" dirty="0">
+                <a:latin typeface="Tahoma"/>
+                <a:cs typeface="Tahoma"/>
+              </a:rPr>
+              <a:t>از دیدگاه طراحی، </a:t>
+            </a:r>
+            <a:r>
+              <a:rPr b="1" lang="fa-IR" dirty="0">
+                <a:latin typeface="Tahoma"/>
+                <a:cs typeface="Tahoma"/>
+              </a:rPr>
+              <a:t>هم‌راستاسازی گرافن و تخلخل (V-A)</a:t>
+            </a:r>
+            <a:r>
+              <a:rPr lang="fa-IR" dirty="0">
+                <a:latin typeface="Tahoma"/>
+                <a:cs typeface="Tahoma"/>
+              </a:rPr>
+              <a:t> بهترین رفتار حرارتی را با کمترین جریمهٔ تنش می‌دهد.</a:t>
+            </a:r>
+          </a:p>
+          <a:p>
+            <a:pPr lvl="0" rtl="1" algn="r"/>
+            <a:r>
+              <a:rPr lang="fa-IR" dirty="0">
+                <a:latin typeface="Tahoma"/>
+                <a:cs typeface="Tahoma"/>
+              </a:rPr>
+              <a:t>انتخاب الگو باید </a:t>
+            </a:r>
+            <a:r>
+              <a:rPr b="1" lang="fa-IR" dirty="0">
+                <a:latin typeface="Tahoma"/>
+                <a:cs typeface="Tahoma"/>
+              </a:rPr>
+              <a:t>هم‌زمان</a:t>
+            </a:r>
+            <a:r>
+              <a:rPr lang="fa-IR" dirty="0">
+                <a:latin typeface="Tahoma"/>
+                <a:cs typeface="Tahoma"/>
+              </a:rPr>
+              <a:t> از منظر دما و تنش سنجیده شود.</a:t>
+            </a:r>
+          </a:p>
+          <a:p>
+            <a:pPr lvl="0" rtl="1" algn="r"/>
+            <a:r>
+              <a:rPr b="1" lang="fa-IR" dirty="0">
+                <a:latin typeface="Tahoma"/>
+                <a:cs typeface="Tahoma"/>
+              </a:rPr>
+              <a:t>DQM لایه‌ای + نیومارک</a:t>
+            </a:r>
+            <a:r>
+              <a:rPr lang="fa-IR" dirty="0">
+                <a:latin typeface="Tahoma"/>
+                <a:cs typeface="Tahoma"/>
+              </a:rPr>
+              <a:t> ابزاری کارآمد و صحت‌سنجی‌شده است.</a:t>
+            </a:r>
+          </a:p>
+        </p:txBody>
+      </p:sp>
+    </p:spTree>
+  </p:cSld>
+</p:sld>
+</file>
+
+<file path=ppt/slides/slide34.xml><?xml version="1.0" encoding="utf-8"?>
+<p:sld xmlns:a="http://schemas.openxmlformats.org/drawingml/2006/main" xmlns:r="http://schemas.openxmlformats.org/officeDocument/2006/relationships" xmlns:p="http://schemas.openxmlformats.org/presentationml/2006/main">
+  <p:cSld>
+    <p:spTree>
+      <p:nvGrpSpPr>
+        <p:cNvPr id="1" name=""/>
+        <p:cNvGrpSpPr/>
+        <p:nvPr/>
+      </p:nvGrpSpPr>
+      <p:grpSpPr>
+        <a:xfrm>
+          <a:off x="0" y="0"/>
+          <a:ext cx="0" cy="0"/>
+          <a:chOff x="0" y="0"/>
+          <a:chExt cx="0" cy="0"/>
+        </a:xfrm>
+      </p:grpSpPr>
+      <p:sp>
+        <p:nvSpPr>
+          <p:cNvPr id="2" name="Title 1"/>
+          <p:cNvSpPr>
+            <a:spLocks noGrp="1"/>
+          </p:cNvSpPr>
+          <p:nvPr>
+            <p:ph type="title"/>
+          </p:nvPr>
+        </p:nvSpPr>
+        <p:spPr/>
+        <p:txBody>
+          <a:bodyPr/>
+          <a:lstStyle/>
+          <a:p>
+            <a:pPr lvl="0" indent="0" marL="0" rtl="1" algn="r">
+              <a:buNone/>
+            </a:pPr>
+            <a:r>
+              <a:rPr lang="fa-IR" dirty="0">
+                <a:latin typeface="Tahoma"/>
+                <a:cs typeface="Tahoma"/>
+              </a:rPr>
+              <a:t>محدودیت‌ها و پیشنهادها</a:t>
+            </a:r>
+          </a:p>
+        </p:txBody>
+      </p:sp>
+      <p:sp>
+        <p:nvSpPr>
+          <p:cNvPr id="3" name="Content Placeholder 2"/>
+          <p:cNvSpPr>
+            <a:spLocks noGrp="1"/>
+          </p:cNvSpPr>
+          <p:nvPr>
+            <p:ph idx="1"/>
+          </p:nvPr>
+        </p:nvSpPr>
+        <p:spPr/>
+        <p:txBody>
+          <a:bodyPr/>
+          <a:lstStyle/>
+          <a:p>
+            <a:pPr lvl="0" indent="0" marL="0" rtl="1" algn="r">
+              <a:buNone/>
+            </a:pPr>
+            <a:r>
+              <a:rPr b="1" lang="fa-IR" dirty="0">
+                <a:latin typeface="Tahoma"/>
+                <a:cs typeface="Tahoma"/>
+              </a:rPr>
+              <a:t>محدودیت‌ها</a:t>
+            </a:r>
+          </a:p>
+          <a:p>
+            <a:pPr lvl="0" rtl="1" algn="r"/>
+            <a:r>
+              <a:rPr lang="fa-IR" dirty="0">
+                <a:latin typeface="Tahoma"/>
+                <a:cs typeface="Tahoma"/>
+              </a:rPr>
+              <a:t>خواص مادی </a:t>
+            </a:r>
+            <a:r>
+              <a:rPr b="1" lang="fa-IR" dirty="0">
+                <a:latin typeface="Tahoma"/>
+                <a:cs typeface="Tahoma"/>
+              </a:rPr>
+              <a:t>مستقل از دما</a:t>
+            </a:r>
+            <a:r>
+              <a:rPr lang="fa-IR" dirty="0">
+                <a:latin typeface="Tahoma"/>
+                <a:cs typeface="Tahoma"/>
+              </a:rPr>
+              <a:t>.</a:t>
+            </a:r>
+          </a:p>
+          <a:p>
+            <a:pPr lvl="0" rtl="1" algn="r"/>
+            <a:r>
+              <a:rPr lang="fa-IR" dirty="0">
+                <a:latin typeface="Tahoma"/>
+                <a:cs typeface="Tahoma"/>
+              </a:rPr>
+              <a:t>مدل </a:t>
+            </a:r>
+            <a:r>
+              <a:rPr b="1" lang="fa-IR" dirty="0">
+                <a:latin typeface="Tahoma"/>
+                <a:cs typeface="Tahoma"/>
+              </a:rPr>
+              <a:t>الاستیک خطی</a:t>
+            </a:r>
+            <a:r>
+              <a:rPr lang="fa-IR" dirty="0">
+                <a:latin typeface="Tahoma"/>
+                <a:cs typeface="Tahoma"/>
+              </a:rPr>
+              <a:t>، بدون معیار آسیب/شکست.</a:t>
+            </a:r>
+          </a:p>
+          <a:p>
+            <a:pPr lvl="0" rtl="1" algn="r"/>
+            <a:r>
+              <a:rPr lang="fa-IR" dirty="0">
+                <a:latin typeface="Tahoma"/>
+                <a:cs typeface="Tahoma"/>
+              </a:rPr>
+              <a:t>پیوند </a:t>
+            </a:r>
+            <a:r>
+              <a:rPr b="1" lang="fa-IR" dirty="0">
+                <a:latin typeface="Tahoma"/>
+                <a:cs typeface="Tahoma"/>
+              </a:rPr>
+              <a:t>کامل</a:t>
+            </a:r>
+            <a:r>
+              <a:rPr lang="fa-IR" dirty="0">
+                <a:latin typeface="Tahoma"/>
+                <a:cs typeface="Tahoma"/>
+              </a:rPr>
+              <a:t> بین‌لایه‌ای (بدون مقاومت حرارتی فصل‌مشترک).</a:t>
+            </a:r>
+          </a:p>
+          <a:p>
+            <a:pPr lvl="0" indent="0" marL="0" rtl="1" algn="r">
+              <a:buNone/>
+            </a:pPr>
+            <a:r>
+              <a:rPr b="1" lang="fa-IR" dirty="0">
+                <a:latin typeface="Tahoma"/>
+                <a:cs typeface="Tahoma"/>
+              </a:rPr>
+              <a:t>پیشنهادها</a:t>
+            </a:r>
+          </a:p>
+          <a:p>
+            <a:pPr lvl="0" rtl="1" algn="r"/>
+            <a:r>
+              <a:rPr lang="fa-IR" dirty="0">
+                <a:latin typeface="Tahoma"/>
+                <a:cs typeface="Tahoma"/>
+              </a:rPr>
+              <a:t>وابستگی خواص به دما و رفتار </a:t>
+            </a:r>
+            <a:r>
+              <a:rPr b="1" lang="fa-IR" dirty="0">
+                <a:latin typeface="Tahoma"/>
+                <a:cs typeface="Tahoma"/>
+              </a:rPr>
+              <a:t>غیرخطی/آسیب</a:t>
+            </a:r>
+            <a:r>
+              <a:rPr lang="fa-IR" dirty="0">
+                <a:latin typeface="Tahoma"/>
+                <a:cs typeface="Tahoma"/>
+              </a:rPr>
+              <a:t>؛ </a:t>
+            </a:r>
+            <a:r>
+              <a:rPr b="1" lang="fa-IR" dirty="0">
+                <a:latin typeface="Tahoma"/>
+                <a:cs typeface="Tahoma"/>
+              </a:rPr>
+              <a:t>مقاومت حرارتی فصل‌مشترک</a:t>
+            </a:r>
+            <a:r>
+              <a:rPr lang="fa-IR" dirty="0">
+                <a:latin typeface="Tahoma"/>
+                <a:cs typeface="Tahoma"/>
+              </a:rPr>
+              <a:t>.</a:t>
+            </a:r>
+          </a:p>
+          <a:p>
+            <a:pPr lvl="0" rtl="1" algn="r"/>
+            <a:r>
+              <a:rPr b="1" lang="fa-IR" dirty="0">
+                <a:latin typeface="Tahoma"/>
+                <a:cs typeface="Tahoma"/>
+              </a:rPr>
+              <a:t>صحت‌سنجی تجربی</a:t>
+            </a:r>
+            <a:r>
+              <a:rPr lang="fa-IR" dirty="0">
+                <a:latin typeface="Tahoma"/>
+                <a:cs typeface="Tahoma"/>
+              </a:rPr>
+              <a:t> و نمودار طراحیِ مهندسی بر پایهٔ یافتهٔ V-A.</a:t>
+            </a:r>
+          </a:p>
+        </p:txBody>
+      </p:sp>
+    </p:spTree>
+  </p:cSld>
+</p:sld>
+</file>
+
 <file path=ppt/slides/slide35.xml><?xml version="1.0" encoding="utf-8"?>
 <p:sld xmlns:a="http://schemas.openxmlformats.org/drawingml/2006/main" xmlns:r="http://schemas.openxmlformats.org/officeDocument/2006/relationships" xmlns:p="http://schemas.openxmlformats.org/presentationml/2006/main">
   <p:cSld>
@@ -10833,7 +10783,7 @@
                 <a:latin typeface="Tahoma"/>
                 <a:cs typeface="Tahoma"/>
               </a:rPr>
-              <a:t>نوآوری‌های پژوهش</a:t>
+              <a:t>با تشکر از توجه شما</a:t>
             </a:r>
           </a:p>
         </p:txBody>
@@ -10853,126 +10803,15 @@
           <a:bodyPr/>
           <a:lstStyle/>
           <a:p>
-            <a:pPr lvl="0" indent="-342900" marL="342900" rtl="1" algn="r">
-              <a:buAutoNum type="arabicPeriod"/>
+            <a:pPr lvl="0" indent="0" marL="0" rtl="1" algn="r">
+              <a:buNone/>
             </a:pPr>
             <a:r>
               <a:rPr lang="fa-IR" dirty="0">
                 <a:latin typeface="Tahoma"/>
                 <a:cs typeface="Tahoma"/>
               </a:rPr>
-              <a:t>حل </a:t>
-            </a:r>
-            <a:r>
-              <a:rPr b="1" lang="fa-IR" dirty="0">
-                <a:latin typeface="Tahoma"/>
-                <a:cs typeface="Tahoma"/>
-              </a:rPr>
-              <a:t>کاملاً ممزوج</a:t>
-            </a:r>
-            <a:r>
-              <a:rPr lang="fa-IR" dirty="0">
-                <a:latin typeface="Tahoma"/>
-                <a:cs typeface="Tahoma"/>
-              </a:rPr>
-              <a:t> لرد-شولمن برای استوانهٔ چندلایهٔ متخلخلِ گرافنی با DQM لایه‌ایِ دوبعدی.</a:t>
-            </a:r>
-          </a:p>
-          <a:p>
-            <a:pPr lvl="0" indent="-342900" marL="342900" rtl="1" algn="r">
-              <a:buAutoNum type="arabicPeriod"/>
-            </a:pPr>
-            <a:r>
-              <a:rPr b="1" lang="fa-IR" dirty="0">
-                <a:latin typeface="Tahoma"/>
-                <a:cs typeface="Tahoma"/>
-              </a:rPr>
-              <a:t>برهم‌کنش هم‌افزای V-گرافن و A-تخلخل</a:t>
-            </a:r>
-            <a:r>
-              <a:rPr lang="fa-IR" dirty="0">
-                <a:latin typeface="Tahoma"/>
-                <a:cs typeface="Tahoma"/>
-              </a:rPr>
-              <a:t> و </a:t>
-            </a:r>
-            <a:r>
-              <a:rPr b="1" lang="fa-IR" dirty="0">
-                <a:latin typeface="Tahoma"/>
-                <a:cs typeface="Tahoma"/>
-              </a:rPr>
-              <a:t>ماتریس کامل ۵×۵</a:t>
-            </a:r>
-            <a:r>
-              <a:rPr lang="fa-IR" dirty="0">
-                <a:latin typeface="Tahoma"/>
-                <a:cs typeface="Tahoma"/>
-              </a:rPr>
-              <a:t> که در مراجع پیشین همتا ندارد.</a:t>
-            </a:r>
-          </a:p>
-          <a:p>
-            <a:pPr lvl="0" indent="-342900" marL="342900" rtl="1" algn="r">
-              <a:buAutoNum type="arabicPeriod"/>
-            </a:pPr>
-            <a:r>
-              <a:rPr lang="fa-IR" dirty="0">
-                <a:latin typeface="Tahoma"/>
-                <a:cs typeface="Tahoma"/>
-              </a:rPr>
-              <a:t>رفتار </a:t>
-            </a:r>
-            <a:r>
-              <a:rPr b="1" lang="fa-IR" dirty="0">
-                <a:latin typeface="Tahoma"/>
-                <a:cs typeface="Tahoma"/>
-              </a:rPr>
-              <a:t>«قله-قعر»</a:t>
-            </a:r>
-            <a:r>
-              <a:rPr lang="fa-IR" dirty="0">
-                <a:latin typeface="Tahoma"/>
-                <a:cs typeface="Tahoma"/>
-              </a:rPr>
-              <a:t> و آینه‌ایِ الگوها و پیوند آن با سرشت موجی هدایت.</a:t>
-            </a:r>
-          </a:p>
-          <a:p>
-            <a:pPr lvl="0" indent="-342900" marL="342900" rtl="1" algn="r">
-              <a:buAutoNum type="arabicPeriod"/>
-            </a:pPr>
-            <a:r>
-              <a:rPr lang="fa-IR" dirty="0">
-                <a:latin typeface="Tahoma"/>
-                <a:cs typeface="Tahoma"/>
-              </a:rPr>
-              <a:t>سه مطالعهٔ گسترشی: شش انتگرال‌گیر زمانی، چهار روش مکانی، چهار تئوری.</a:t>
-            </a:r>
-          </a:p>
-          <a:p>
-            <a:pPr lvl="0" indent="-342900" marL="342900" rtl="1" algn="r">
-              <a:buAutoNum type="arabicPeriod"/>
-            </a:pPr>
-            <a:r>
-              <a:rPr lang="fa-IR" dirty="0">
-                <a:latin typeface="Tahoma"/>
-                <a:cs typeface="Tahoma"/>
-              </a:rPr>
-              <a:t>صحت‌سنجی </a:t>
-            </a:r>
-            <a:r>
-              <a:rPr b="1" lang="fa-IR" dirty="0">
-                <a:latin typeface="Tahoma"/>
-                <a:cs typeface="Tahoma"/>
-              </a:rPr>
-              <a:t>کمّی</a:t>
-            </a:r>
-            <a:r>
-              <a:rPr lang="fa-IR" dirty="0">
-                <a:latin typeface="Tahoma"/>
-                <a:cs typeface="Tahoma"/>
-              </a:rPr>
-              <a:t> موج صوت دوم در برابر حل دقیق تحلیلی.</a:t>
+              <a:t>پرسش و پاسخ</a:t>
             </a:r>
           </a:p>
         </p:txBody>
@@ -11022,112 +10861,7 @@
                 <a:latin typeface="Tahoma"/>
                 <a:cs typeface="Tahoma"/>
               </a:rPr>
-              <a:t>نتیجه‌گیری</a:t>
-            </a:r>
-          </a:p>
-        </p:txBody>
-      </p:sp>
-      <p:sp>
-        <p:nvSpPr>
-          <p:cNvPr id="3" name="Content Placeholder 2"/>
-          <p:cNvSpPr>
-            <a:spLocks noGrp="1"/>
-          </p:cNvSpPr>
-          <p:nvPr>
-            <p:ph idx="1"/>
-          </p:nvPr>
-        </p:nvSpPr>
-        <p:spPr/>
-        <p:txBody>
-          <a:bodyPr/>
-          <a:lstStyle/>
-          <a:p>
-            <a:pPr lvl="0" rtl="1" algn="r"/>
-            <a:r>
-              <a:rPr lang="fa-IR" dirty="0">
-                <a:latin typeface="Tahoma"/>
-                <a:cs typeface="Tahoma"/>
-              </a:rPr>
-              <a:t>در </a:t>
-            </a:r>
-            <a:r>
-              <a:rPr b="1" lang="fa-IR" dirty="0">
-                <a:latin typeface="Tahoma"/>
-                <a:cs typeface="Tahoma"/>
-              </a:rPr>
-              <a:t>شوک حرارتی گذرا</a:t>
-            </a:r>
-            <a:r>
-              <a:rPr lang="fa-IR" dirty="0">
-                <a:latin typeface="Tahoma"/>
-                <a:cs typeface="Tahoma"/>
-              </a:rPr>
-              <a:t>، پیش‌بینی دما و تنش به انتخاب مدل هدایت حساس است؛ در پالس گاوسی فوریه بیشینهٔ دما را حدود ۲٫۵ برابر کمتر می‌دهد.</a:t>
-            </a:r>
-          </a:p>
-          <a:p>
-            <a:pPr lvl="0" rtl="1" algn="r"/>
-            <a:r>
-              <a:rPr lang="fa-IR" dirty="0">
-                <a:latin typeface="Tahoma"/>
-                <a:cs typeface="Tahoma"/>
-              </a:rPr>
-              <a:t>از دیدگاه طراحی، </a:t>
-            </a:r>
-            <a:r>
-              <a:rPr b="1" lang="fa-IR" dirty="0">
-                <a:latin typeface="Tahoma"/>
-                <a:cs typeface="Tahoma"/>
-              </a:rPr>
-              <a:t>هم‌راستاسازی گرافن و تخلخل (V-A)</a:t>
-            </a:r>
-            <a:r>
-              <a:rPr lang="fa-IR" dirty="0">
-                <a:latin typeface="Tahoma"/>
-                <a:cs typeface="Tahoma"/>
-              </a:rPr>
-              <a:t> بهترین رفتار حرارتی را با کمترین جریمهٔ تنش می‌دهد.</a:t>
-            </a:r>
-          </a:p>
-          <a:p>
-            <a:pPr lvl="0" rtl="1" algn="r"/>
-            <a:r>
-              <a:rPr lang="fa-IR" dirty="0">
-                <a:latin typeface="Tahoma"/>
-                <a:cs typeface="Tahoma"/>
-              </a:rPr>
-              <a:t>انتخاب الگو باید </a:t>
-            </a:r>
-            <a:r>
-              <a:rPr b="1" lang="fa-IR" dirty="0">
-                <a:latin typeface="Tahoma"/>
-                <a:cs typeface="Tahoma"/>
-              </a:rPr>
-              <a:t>هم‌زمان</a:t>
-            </a:r>
-            <a:r>
-              <a:rPr lang="fa-IR" dirty="0">
-                <a:latin typeface="Tahoma"/>
-                <a:cs typeface="Tahoma"/>
-              </a:rPr>
-              <a:t> از منظر دما و تنش سنجیده شود.</a:t>
-            </a:r>
-          </a:p>
-          <a:p>
-            <a:pPr lvl="0" rtl="1" algn="r"/>
-            <a:r>
-              <a:rPr b="1" lang="fa-IR" dirty="0">
-                <a:latin typeface="Tahoma"/>
-                <a:cs typeface="Tahoma"/>
-              </a:rPr>
-              <a:t>DQM لایه‌ای + نیومارک</a:t>
-            </a:r>
-            <a:r>
-              <a:rPr lang="fa-IR" dirty="0">
-                <a:latin typeface="Tahoma"/>
-                <a:cs typeface="Tahoma"/>
-              </a:rPr>
-              <a:t> ابزاری کارآمد و صحت‌سنجی‌شده است.</a:t>
+              <a:t>اسلایدهای پشتیبان</a:t>
             </a:r>
           </a:p>
         </p:txBody>
@@ -11138,467 +10872,6 @@
 </file>
 
 <file path=ppt/slides/slide37.xml><?xml version="1.0" encoding="utf-8"?>
-<p:sld xmlns:a="http://schemas.openxmlformats.org/drawingml/2006/main" xmlns:r="http://schemas.openxmlformats.org/officeDocument/2006/relationships" xmlns:p="http://schemas.openxmlformats.org/presentationml/2006/main">
-  <p:cSld>
-    <p:spTree>
-      <p:nvGrpSpPr>
-        <p:cNvPr id="1" name=""/>
-        <p:cNvGrpSpPr/>
-        <p:nvPr/>
-      </p:nvGrpSpPr>
-      <p:grpSpPr>
-        <a:xfrm>
-          <a:off x="0" y="0"/>
-          <a:ext cx="0" cy="0"/>
-          <a:chOff x="0" y="0"/>
-          <a:chExt cx="0" cy="0"/>
-        </a:xfrm>
-      </p:grpSpPr>
-      <p:sp>
-        <p:nvSpPr>
-          <p:cNvPr id="2" name="Title 1"/>
-          <p:cNvSpPr>
-            <a:spLocks noGrp="1"/>
-          </p:cNvSpPr>
-          <p:nvPr>
-            <p:ph type="title"/>
-          </p:nvPr>
-        </p:nvSpPr>
-        <p:spPr/>
-        <p:txBody>
-          <a:bodyPr/>
-          <a:lstStyle/>
-          <a:p>
-            <a:pPr lvl="0" indent="0" marL="0" rtl="1" algn="r">
-              <a:buNone/>
-            </a:pPr>
-            <a:r>
-              <a:rPr lang="fa-IR" dirty="0">
-                <a:latin typeface="Tahoma"/>
-                <a:cs typeface="Tahoma"/>
-              </a:rPr>
-              <a:t>محدودیت‌ها و پیشنهادها</a:t>
-            </a:r>
-          </a:p>
-        </p:txBody>
-      </p:sp>
-      <p:sp>
-        <p:nvSpPr>
-          <p:cNvPr id="3" name="Content Placeholder 2"/>
-          <p:cNvSpPr>
-            <a:spLocks noGrp="1"/>
-          </p:cNvSpPr>
-          <p:nvPr>
-            <p:ph idx="1"/>
-          </p:nvPr>
-        </p:nvSpPr>
-        <p:spPr/>
-        <p:txBody>
-          <a:bodyPr/>
-          <a:lstStyle/>
-          <a:p>
-            <a:pPr lvl="0" indent="0" marL="0" rtl="1" algn="r">
-              <a:buNone/>
-            </a:pPr>
-            <a:r>
-              <a:rPr b="1" lang="fa-IR" dirty="0">
-                <a:latin typeface="Tahoma"/>
-                <a:cs typeface="Tahoma"/>
-              </a:rPr>
-              <a:t>محدودیت‌ها</a:t>
-            </a:r>
-          </a:p>
-          <a:p>
-            <a:pPr lvl="0" rtl="1" algn="r"/>
-            <a:r>
-              <a:rPr lang="fa-IR" dirty="0">
-                <a:latin typeface="Tahoma"/>
-                <a:cs typeface="Tahoma"/>
-              </a:rPr>
-              <a:t>خواص مادی </a:t>
-            </a:r>
-            <a:r>
-              <a:rPr b="1" lang="fa-IR" dirty="0">
-                <a:latin typeface="Tahoma"/>
-                <a:cs typeface="Tahoma"/>
-              </a:rPr>
-              <a:t>مستقل از دما</a:t>
-            </a:r>
-            <a:r>
-              <a:rPr lang="fa-IR" dirty="0">
-                <a:latin typeface="Tahoma"/>
-                <a:cs typeface="Tahoma"/>
-              </a:rPr>
-              <a:t>.</a:t>
-            </a:r>
-          </a:p>
-          <a:p>
-            <a:pPr lvl="0" rtl="1" algn="r"/>
-            <a:r>
-              <a:rPr lang="fa-IR" dirty="0">
-                <a:latin typeface="Tahoma"/>
-                <a:cs typeface="Tahoma"/>
-              </a:rPr>
-              <a:t>مدل </a:t>
-            </a:r>
-            <a:r>
-              <a:rPr b="1" lang="fa-IR" dirty="0">
-                <a:latin typeface="Tahoma"/>
-                <a:cs typeface="Tahoma"/>
-              </a:rPr>
-              <a:t>الاستیک خطی</a:t>
-            </a:r>
-            <a:r>
-              <a:rPr lang="fa-IR" dirty="0">
-                <a:latin typeface="Tahoma"/>
-                <a:cs typeface="Tahoma"/>
-              </a:rPr>
-              <a:t>، بدون معیار آسیب/شکست.</a:t>
-            </a:r>
-          </a:p>
-          <a:p>
-            <a:pPr lvl="0" rtl="1" algn="r"/>
-            <a:r>
-              <a:rPr lang="fa-IR" dirty="0">
-                <a:latin typeface="Tahoma"/>
-                <a:cs typeface="Tahoma"/>
-              </a:rPr>
-              <a:t>پیوند </a:t>
-            </a:r>
-            <a:r>
-              <a:rPr b="1" lang="fa-IR" dirty="0">
-                <a:latin typeface="Tahoma"/>
-                <a:cs typeface="Tahoma"/>
-              </a:rPr>
-              <a:t>کامل</a:t>
-            </a:r>
-            <a:r>
-              <a:rPr lang="fa-IR" dirty="0">
-                <a:latin typeface="Tahoma"/>
-                <a:cs typeface="Tahoma"/>
-              </a:rPr>
-              <a:t> بین‌لایه‌ای (بدون مقاومت حرارتی فصل‌مشترک).</a:t>
-            </a:r>
-          </a:p>
-          <a:p>
-            <a:pPr lvl="0" indent="0" marL="0" rtl="1" algn="r">
-              <a:buNone/>
-            </a:pPr>
-            <a:r>
-              <a:rPr b="1" lang="fa-IR" dirty="0">
-                <a:latin typeface="Tahoma"/>
-                <a:cs typeface="Tahoma"/>
-              </a:rPr>
-              <a:t>پیشنهادها</a:t>
-            </a:r>
-          </a:p>
-          <a:p>
-            <a:pPr lvl="0" rtl="1" algn="r"/>
-            <a:r>
-              <a:rPr lang="fa-IR" dirty="0">
-                <a:latin typeface="Tahoma"/>
-                <a:cs typeface="Tahoma"/>
-              </a:rPr>
-              <a:t>وابستگی خواص به دما و رفتار </a:t>
-            </a:r>
-            <a:r>
-              <a:rPr b="1" lang="fa-IR" dirty="0">
-                <a:latin typeface="Tahoma"/>
-                <a:cs typeface="Tahoma"/>
-              </a:rPr>
-              <a:t>غیرخطی/آسیب</a:t>
-            </a:r>
-            <a:r>
-              <a:rPr lang="fa-IR" dirty="0">
-                <a:latin typeface="Tahoma"/>
-                <a:cs typeface="Tahoma"/>
-              </a:rPr>
-              <a:t>؛ </a:t>
-            </a:r>
-            <a:r>
-              <a:rPr b="1" lang="fa-IR" dirty="0">
-                <a:latin typeface="Tahoma"/>
-                <a:cs typeface="Tahoma"/>
-              </a:rPr>
-              <a:t>مقاومت حرارتی فصل‌مشترک</a:t>
-            </a:r>
-            <a:r>
-              <a:rPr lang="fa-IR" dirty="0">
-                <a:latin typeface="Tahoma"/>
-                <a:cs typeface="Tahoma"/>
-              </a:rPr>
-              <a:t>.</a:t>
-            </a:r>
-          </a:p>
-          <a:p>
-            <a:pPr lvl="0" rtl="1" algn="r"/>
-            <a:r>
-              <a:rPr b="1" lang="fa-IR" dirty="0">
-                <a:latin typeface="Tahoma"/>
-                <a:cs typeface="Tahoma"/>
-              </a:rPr>
-              <a:t>صحت‌سنجی تجربی</a:t>
-            </a:r>
-            <a:r>
-              <a:rPr lang="fa-IR" dirty="0">
-                <a:latin typeface="Tahoma"/>
-                <a:cs typeface="Tahoma"/>
-              </a:rPr>
-              <a:t> و نمودار طراحیِ مهندسی بر پایهٔ یافتهٔ V-A.</a:t>
-            </a:r>
-          </a:p>
-        </p:txBody>
-      </p:sp>
-    </p:spTree>
-  </p:cSld>
-</p:sld>
-</file>
-
-<file path=ppt/slides/slide38.xml><?xml version="1.0" encoding="utf-8"?>
-<p:sld xmlns:a="http://schemas.openxmlformats.org/drawingml/2006/main" xmlns:r="http://schemas.openxmlformats.org/officeDocument/2006/relationships" xmlns:p="http://schemas.openxmlformats.org/presentationml/2006/main">
-  <p:cSld>
-    <p:spTree>
-      <p:nvGrpSpPr>
-        <p:cNvPr id="1" name=""/>
-        <p:cNvGrpSpPr/>
-        <p:nvPr/>
-      </p:nvGrpSpPr>
-      <p:grpSpPr>
-        <a:xfrm>
-          <a:off x="0" y="0"/>
-          <a:ext cx="0" cy="0"/>
-          <a:chOff x="0" y="0"/>
-          <a:chExt cx="0" cy="0"/>
-        </a:xfrm>
-      </p:grpSpPr>
-      <p:sp>
-        <p:nvSpPr>
-          <p:cNvPr id="2" name="Title 1"/>
-          <p:cNvSpPr>
-            <a:spLocks noGrp="1"/>
-          </p:cNvSpPr>
-          <p:nvPr>
-            <p:ph type="title"/>
-          </p:nvPr>
-        </p:nvSpPr>
-        <p:spPr/>
-        <p:txBody>
-          <a:bodyPr/>
-          <a:lstStyle/>
-          <a:p>
-            <a:pPr lvl="0" indent="0" marL="0" rtl="1" algn="r">
-              <a:buNone/>
-            </a:pPr>
-            <a:r>
-              <a:rPr lang="fa-IR" dirty="0">
-                <a:latin typeface="Tahoma"/>
-                <a:cs typeface="Tahoma"/>
-              </a:rPr>
-              <a:t>با تشکر از توجه شما</a:t>
-            </a:r>
-          </a:p>
-        </p:txBody>
-      </p:sp>
-      <p:sp>
-        <p:nvSpPr>
-          <p:cNvPr id="3" name="Content Placeholder 2"/>
-          <p:cNvSpPr>
-            <a:spLocks noGrp="1"/>
-          </p:cNvSpPr>
-          <p:nvPr>
-            <p:ph idx="1"/>
-          </p:nvPr>
-        </p:nvSpPr>
-        <p:spPr/>
-        <p:txBody>
-          <a:bodyPr/>
-          <a:lstStyle/>
-          <a:p>
-            <a:pPr lvl="0" indent="0" marL="0" rtl="1" algn="r">
-              <a:buNone/>
-            </a:pPr>
-            <a:r>
-              <a:rPr lang="fa-IR" dirty="0">
-                <a:latin typeface="Tahoma"/>
-                <a:cs typeface="Tahoma"/>
-              </a:rPr>
-              <a:t>پرسش و پاسخ</a:t>
-            </a:r>
-          </a:p>
-        </p:txBody>
-      </p:sp>
-    </p:spTree>
-  </p:cSld>
-</p:sld>
-</file>
-
-<file path=ppt/slides/slide39.xml><?xml version="1.0" encoding="utf-8"?>
-<p:sld xmlns:a="http://schemas.openxmlformats.org/drawingml/2006/main" xmlns:r="http://schemas.openxmlformats.org/officeDocument/2006/relationships" xmlns:p="http://schemas.openxmlformats.org/presentationml/2006/main">
-  <p:cSld>
-    <p:spTree>
-      <p:nvGrpSpPr>
-        <p:cNvPr id="1" name=""/>
-        <p:cNvGrpSpPr/>
-        <p:nvPr/>
-      </p:nvGrpSpPr>
-      <p:grpSpPr>
-        <a:xfrm>
-          <a:off x="0" y="0"/>
-          <a:ext cx="0" cy="0"/>
-          <a:chOff x="0" y="0"/>
-          <a:chExt cx="0" cy="0"/>
-        </a:xfrm>
-      </p:grpSpPr>
-      <p:sp>
-        <p:nvSpPr>
-          <p:cNvPr id="2" name="Title 1"/>
-          <p:cNvSpPr>
-            <a:spLocks noGrp="1"/>
-          </p:cNvSpPr>
-          <p:nvPr>
-            <p:ph type="title"/>
-          </p:nvPr>
-        </p:nvSpPr>
-        <p:spPr/>
-        <p:txBody>
-          <a:bodyPr/>
-          <a:lstStyle/>
-          <a:p>
-            <a:pPr lvl="0" indent="0" marL="0" rtl="1" algn="r">
-              <a:buNone/>
-            </a:pPr>
-            <a:r>
-              <a:rPr lang="fa-IR" dirty="0">
-                <a:latin typeface="Tahoma"/>
-                <a:cs typeface="Tahoma"/>
-              </a:rPr>
-              <a:t>اسلایدهای پشتیبان</a:t>
-            </a:r>
-          </a:p>
-        </p:txBody>
-      </p:sp>
-    </p:spTree>
-  </p:cSld>
-</p:sld>
-</file>
-
-<file path=ppt/slides/slide4.xml><?xml version="1.0" encoding="utf-8"?>
-<p:sld xmlns:a="http://schemas.openxmlformats.org/drawingml/2006/main" xmlns:r="http://schemas.openxmlformats.org/officeDocument/2006/relationships" xmlns:p="http://schemas.openxmlformats.org/presentationml/2006/main">
-  <p:cSld>
-    <p:spTree>
-      <p:nvGrpSpPr>
-        <p:cNvPr id="1" name=""/>
-        <p:cNvGrpSpPr/>
-        <p:nvPr/>
-      </p:nvGrpSpPr>
-      <p:grpSpPr>
-        <a:xfrm>
-          <a:off x="0" y="0"/>
-          <a:ext cx="0" cy="0"/>
-          <a:chOff x="0" y="0"/>
-          <a:chExt cx="0" cy="0"/>
-        </a:xfrm>
-      </p:grpSpPr>
-      <p:sp>
-        <p:nvSpPr>
-          <p:cNvPr id="2" name="Title 1"/>
-          <p:cNvSpPr>
-            <a:spLocks noGrp="1"/>
-          </p:cNvSpPr>
-          <p:nvPr>
-            <p:ph type="title"/>
-          </p:nvPr>
-        </p:nvSpPr>
-        <p:spPr/>
-        <p:txBody>
-          <a:bodyPr/>
-          <a:lstStyle/>
-          <a:p>
-            <a:pPr lvl="0" indent="0" marL="0" rtl="1" algn="r">
-              <a:buNone/>
-            </a:pPr>
-            <a:r>
-              <a:rPr lang="fa-IR" dirty="0">
-                <a:latin typeface="Tahoma"/>
-                <a:cs typeface="Tahoma"/>
-              </a:rPr>
-              <a:t>مواد نوین: گرافن برای استحکام، تخلخل برای سبکی و عایق‌بودن</a:t>
-            </a:r>
-          </a:p>
-        </p:txBody>
-      </p:sp>
-      <p:sp>
-        <p:nvSpPr>
-          <p:cNvPr id="3" name="Content Placeholder 2"/>
-          <p:cNvSpPr>
-            <a:spLocks noGrp="1"/>
-          </p:cNvSpPr>
-          <p:nvPr>
-            <p:ph idx="1"/>
-          </p:nvPr>
-        </p:nvSpPr>
-        <p:spPr/>
-        <p:txBody>
-          <a:bodyPr/>
-          <a:lstStyle/>
-          <a:p>
-            <a:pPr lvl="0" rtl="1" algn="r"/>
-            <a:r>
-              <a:rPr lang="fa-IR" dirty="0">
-                <a:latin typeface="Tahoma"/>
-                <a:cs typeface="Tahoma"/>
-              </a:rPr>
-              <a:t>نانولوله‌های کربنی (۱۹۹۱) و گرافن (۲۰۰۴): استحکام و مدول بسیار زیاد، رسانش الکتریکی و حرارتی عالی [۱].</a:t>
-            </a:r>
-          </a:p>
-          <a:p>
-            <a:pPr lvl="0" rtl="1" algn="r"/>
-            <a:r>
-              <a:rPr lang="fa-IR" dirty="0">
-                <a:latin typeface="Tahoma"/>
-                <a:cs typeface="Tahoma"/>
-              </a:rPr>
-              <a:t>نانوکامپوزیت‌های گرافنی از کامپوزیت‌های نانولوله و نانوگرافیت خواص مکانیکی بهتری نشان داده‌اند؛ سطح تماس زیاد، انتقال بار را بهبود می‌دهد.</a:t>
-            </a:r>
-          </a:p>
-          <a:p>
-            <a:pPr lvl="0" rtl="1" algn="r"/>
-            <a:r>
-              <a:rPr lang="fa-IR" dirty="0">
-                <a:latin typeface="Tahoma"/>
-                <a:cs typeface="Tahoma"/>
-              </a:rPr>
-              <a:t>مواد متخلخل: سبک، جاذب انرژی، با سطح ویژهٔ زیاد و مقاوم در برابر حرارت؛ اما تخلخل استحکام را کم می‌کند.</a:t>
-            </a:r>
-          </a:p>
-          <a:p>
-            <a:pPr lvl="0" rtl="1" algn="r"/>
-            <a:r>
-              <a:rPr lang="fa-IR" dirty="0">
-                <a:latin typeface="Tahoma"/>
-                <a:cs typeface="Tahoma"/>
-              </a:rPr>
-              <a:t>افزودن ورقه‌های گرافنی به مادهٔ متخلخل یکی از راه‌های جبران این افت است [۲].</a:t>
-            </a:r>
-          </a:p>
-          <a:p>
-            <a:pPr lvl="0" rtl="1" algn="r"/>
-            <a:r>
-              <a:rPr lang="fa-IR" dirty="0">
-                <a:latin typeface="Tahoma"/>
-                <a:cs typeface="Tahoma"/>
-              </a:rPr>
-              <a:t>ترکیب این دو در ماده‌ای مدرجِ لایه‌ای، توزیع هدفمند ماده در ضخامت را ممکن می‌کند.</a:t>
-            </a:r>
-          </a:p>
-        </p:txBody>
-      </p:sp>
-    </p:spTree>
-  </p:cSld>
-</p:sld>
-</file>
-
-<file path=ppt/slides/slide40.xml><?xml version="1.0" encoding="utf-8"?>
 <p:sld xmlns:a="http://schemas.openxmlformats.org/drawingml/2006/main" xmlns:r="http://schemas.openxmlformats.org/officeDocument/2006/relationships" xmlns:p="http://schemas.openxmlformats.org/presentationml/2006/main">
   <p:cSld>
     <p:spTree>
@@ -11789,7 +11062,7 @@
 </p:sld>
 </file>
 
-<file path=ppt/slides/slide41.xml><?xml version="1.0" encoding="utf-8"?>
+<file path=ppt/slides/slide38.xml><?xml version="1.0" encoding="utf-8"?>
 <p:sld xmlns:a="http://schemas.openxmlformats.org/drawingml/2006/main" xmlns:r="http://schemas.openxmlformats.org/officeDocument/2006/relationships" xmlns:p="http://schemas.openxmlformats.org/presentationml/2006/main">
   <p:cSld>
     <p:spTree>
@@ -11937,6 +11210,122 @@
           </a:ln>
         </p:spPr>
       </p:pic>
+    </p:spTree>
+  </p:cSld>
+</p:sld>
+</file>
+
+<file path=ppt/slides/slide4.xml><?xml version="1.0" encoding="utf-8"?>
+<p:sld xmlns:a="http://schemas.openxmlformats.org/drawingml/2006/main" xmlns:r="http://schemas.openxmlformats.org/officeDocument/2006/relationships" xmlns:p="http://schemas.openxmlformats.org/presentationml/2006/main">
+  <p:cSld>
+    <p:spTree>
+      <p:nvGrpSpPr>
+        <p:cNvPr id="1" name=""/>
+        <p:cNvGrpSpPr/>
+        <p:nvPr/>
+      </p:nvGrpSpPr>
+      <p:grpSpPr>
+        <a:xfrm>
+          <a:off x="0" y="0"/>
+          <a:ext cx="0" cy="0"/>
+          <a:chOff x="0" y="0"/>
+          <a:chExt cx="0" cy="0"/>
+        </a:xfrm>
+      </p:grpSpPr>
+      <p:sp>
+        <p:nvSpPr>
+          <p:cNvPr id="2" name="Title 1"/>
+          <p:cNvSpPr>
+            <a:spLocks noGrp="1"/>
+          </p:cNvSpPr>
+          <p:nvPr>
+            <p:ph type="title"/>
+          </p:nvPr>
+        </p:nvSpPr>
+        <p:spPr/>
+        <p:txBody>
+          <a:bodyPr/>
+          <a:lstStyle/>
+          <a:p>
+            <a:pPr lvl="0" indent="0" marL="0" rtl="1" algn="r">
+              <a:buNone/>
+            </a:pPr>
+            <a:r>
+              <a:rPr lang="fa-IR" dirty="0">
+                <a:latin typeface="Tahoma"/>
+                <a:cs typeface="Tahoma"/>
+              </a:rPr>
+              <a:t>مواد نوین: گرافن برای استحکام، تخلخل برای سبکی و عایق‌بودن</a:t>
+            </a:r>
+          </a:p>
+        </p:txBody>
+      </p:sp>
+      <p:sp>
+        <p:nvSpPr>
+          <p:cNvPr id="3" name="Content Placeholder 2"/>
+          <p:cNvSpPr>
+            <a:spLocks noGrp="1"/>
+          </p:cNvSpPr>
+          <p:nvPr>
+            <p:ph idx="1"/>
+          </p:nvPr>
+        </p:nvSpPr>
+        <p:spPr/>
+        <p:txBody>
+          <a:bodyPr/>
+          <a:lstStyle/>
+          <a:p>
+            <a:pPr lvl="0" rtl="1" algn="r"/>
+            <a:r>
+              <a:rPr lang="fa-IR" dirty="0">
+                <a:latin typeface="Tahoma"/>
+                <a:cs typeface="Tahoma"/>
+              </a:rPr>
+              <a:t>نانولوله‌های کربنی (۱۹۹۱) و گرافن (۲۰۰۴): استحکام و مدول بسیار زیاد، رسانش الکتریکی و حرارتی عالی [۱].</a:t>
+            </a:r>
+          </a:p>
+          <a:p>
+            <a:pPr lvl="0" rtl="1" algn="r"/>
+            <a:r>
+              <a:rPr lang="fa-IR" dirty="0">
+                <a:latin typeface="Tahoma"/>
+                <a:cs typeface="Tahoma"/>
+              </a:rPr>
+              <a:t>نانوکامپوزیت‌های گرافنی از کامپوزیت‌های نانولوله و نانوگرافیت خواص مکانیکی بهتری نشان داده‌اند؛ سطح تماس زیاد، انتقال بار را بهبود می‌دهد.</a:t>
+            </a:r>
+          </a:p>
+          <a:p>
+            <a:pPr lvl="0" rtl="1" algn="r"/>
+            <a:r>
+              <a:rPr lang="fa-IR" dirty="0">
+                <a:latin typeface="Tahoma"/>
+                <a:cs typeface="Tahoma"/>
+              </a:rPr>
+              <a:t>مواد متخلخل: سبک، جاذب انرژی، با سطح ویژهٔ زیاد و مقاوم در برابر حرارت؛ اما تخلخل استحکام را کم می‌کند.</a:t>
+            </a:r>
+          </a:p>
+          <a:p>
+            <a:pPr lvl="0" rtl="1" algn="r"/>
+            <a:r>
+              <a:rPr lang="fa-IR" dirty="0">
+                <a:latin typeface="Tahoma"/>
+                <a:cs typeface="Tahoma"/>
+              </a:rPr>
+              <a:t>افزودن ورقه‌های گرافنی به مادهٔ متخلخل یکی از راه‌های جبران این افت است [۲].</a:t>
+            </a:r>
+          </a:p>
+          <a:p>
+            <a:pPr lvl="0" rtl="1" algn="r"/>
+            <a:r>
+              <a:rPr lang="fa-IR" dirty="0">
+                <a:latin typeface="Tahoma"/>
+                <a:cs typeface="Tahoma"/>
+              </a:rPr>
+              <a:t>ترکیب این دو در ماده‌ای مدرجِ لایه‌ای، توزیع هدفمند ماده در ضخامت را ممکن می‌کند.</a:t>
+            </a:r>
+          </a:p>
+        </p:txBody>
+      </p:sp>
     </p:spTree>
   </p:cSld>
 </p:sld>
@@ -12524,7 +11913,7 @@
                 <a:latin typeface="Tahoma"/>
                 <a:cs typeface="Tahoma"/>
               </a:rPr>
-              <a:t>پیشینه ۳: استوانه، کره، مخروط و دیسکِ مدرج و کامپوزیتی</a:t>
+              <a:t>پیشینه ۳: مهم‌ترین پژوهش‌های پیشین</a:t>
             </a:r>
           </a:p>
         </p:txBody>
@@ -12550,7 +11939,7 @@
                 <a:latin typeface="Tahoma"/>
                 <a:cs typeface="Tahoma"/>
               </a:rPr>
-              <a:t>پلتیر و ول (۲۰۰۶)، جباری و همکاران (۲۰۰۶): حل دقیق و تحلیلیِ پوسته و استوانهٔ مدرج تابعی (بسل و انتگرال فوریه) [۸، ۹].</a:t>
+              <a:t>ملک‌زاده و همکاران (۲۰۱۲): پاسخ گذرای پوستهٔ چندلایه، DQM + نیومارک [۳۱].</a:t>
             </a:r>
           </a:p>
           <a:p>
@@ -12560,7 +11949,7 @@
                 <a:latin typeface="Tahoma"/>
                 <a:cs typeface="Tahoma"/>
               </a:rPr>
-              <a:t>چن و لین (۲۰۰۸)، پنگ و لی (۲۰۱۰): تنش در استوانه و کرهٔ مدرج؛ بار ترمو-مکانیکی با انتگرال‌گیری عددی [۱۰، ۱۱].</a:t>
+              <a:t>ملک‌زاده و حیدرپور (۲۰۱۲): بار ترمو-مکانیکی متحرک، هدایت هذلولوی [۳۲].</a:t>
             </a:r>
           </a:p>
           <a:p>
@@ -12570,7 +11959,7 @@
                 <a:latin typeface="Tahoma"/>
                 <a:cs typeface="Tahoma"/>
               </a:rPr>
-              <a:t>ملک‌زاده و همکاران (۲۰۱۲): استوانهٔ مدرج تحت بار حرارتی متحرک با هدایت هذلولوی [۱۲]؛ بورلاینکو و همکاران (۲۰۱۷): اجزای محدود [۱۴].</a:t>
+              <a:t>حیدرپور و همکاران (۲۰۲۰): پوستهٔ استوانه‌ایِ گرافنی، بار ترمو-مکانیکی دینامیکی [۴۶].</a:t>
             </a:r>
           </a:p>
           <a:p>
@@ -12580,7 +11969,7 @@
                 <a:latin typeface="Tahoma"/>
                 <a:cs typeface="Tahoma"/>
               </a:rPr>
-              <a:t>علی‌بیگ‌لو (۲۰۲۰)، هوانگ و همکاران (۲۰۲۱): استوانه و پانل تقویت‌شده با پلاکت‌های گرافنی؛ اثر کسر وزنی، الگو و ابعاد [۱۶، ۱۸].</a:t>
+              <a:t>رحیمی و همکاران (۲۰۲۰): تحلیل سه‌بعدی استوانهٔ متخلخلِ گرافنی با هالپین–تسای؛ یاس و رحیمی (۲۰۲۰): مدل سلول‌باز [۴۷، ۵۱].</a:t>
             </a:r>
           </a:p>
           <a:p>
@@ -12590,7 +11979,27 @@
                 <a:latin typeface="Tahoma"/>
                 <a:cs typeface="Tahoma"/>
               </a:rPr>
-              <a:t>ژانگ و همکاران (۲۰۲۰)، شیا و همکاران (۲۰۲۲): دیسک حلقوی مدرج با DQM و نیومارک [۱۷، ۲۱]؛ الفار و همکاران (۲۰۲۳): آزمایش شوک حرارتی [۲۰].</a:t>
+              <a:t>مرادی‌دستجردی و بهدینان (۲۰۲۱): تنش در استوانهٔ جدارضخیمِ مدرجِ متخلخلِ گرافنی، حالت پایا [۵۲].</a:t>
+            </a:r>
+          </a:p>
+          <a:p>
+            <a:pPr lvl="0" rtl="1" algn="r"/>
+            <a:r>
+              <a:rPr lang="fa-IR" dirty="0">
+                <a:latin typeface="Tahoma"/>
+                <a:cs typeface="Tahoma"/>
+              </a:rPr>
+              <a:t>باهتویی و اسلامی (۲۰۰۷)، بگری و اسلامی (۲۰۰۸): ترموالاستیسیتهٔ تعمیم‌یافته (لرد–شولمن) در پوستهٔ استوانه‌ای و دیسکِ مدرج [۶۴–۶۶].</a:t>
+            </a:r>
+          </a:p>
+          <a:p>
+            <a:pPr lvl="0" rtl="1" algn="r"/>
+            <a:r>
+              <a:rPr lang="fa-IR" dirty="0">
+                <a:latin typeface="Tahoma"/>
+                <a:cs typeface="Tahoma"/>
+              </a:rPr>
+              <a:t>حیدرپور و همکاران (۲۰۱۹، ۲۰۲۰): پوستهٔ کروی و مخروط ناقصِ گرافنی با لرد–شولمن، DQM لایه‌ای + نیومارک — نزدیک‌ترین کارها و مبنای فصل‌های ۳ و ۴ [۳، ۶۸–۷۰].</a:t>
             </a:r>
           </a:p>
         </p:txBody>

</xml_diff>

<commit_message>
Defense slides: split edits into separate revisions (R2 restored, R3 intro/literature rewrite, R4 merged literature slide)
Co-Authored-By: Claude Sonnet 5.5 <noreply@anthropic.com>
</commit_message>
<xml_diff>
--- a/claude/defense/DEFENSE_SLIDES_FA_R2.pptx
+++ b/claude/defense/DEFENSE_SLIDES_FA_R2.pptx
@@ -5,7 +5,7 @@
     <p:sldMasterId id="2147483648" r:id="rId1"/>
   </p:sldMasterIdLst>
   <p:notesMasterIdLst>
-    <p:notesMasterId r:id="rId40"/>
+    <p:notesMasterId r:id="rId34"/>
   </p:notesMasterIdLst>
   <p:sldIdLst>
     <p:sldId id="256" r:id="rId2"/>
@@ -40,12 +40,6 @@
     <p:sldId id="285" r:id="rId31"/>
     <p:sldId id="286" r:id="rId32"/>
     <p:sldId id="287" r:id="rId33"/>
-    <p:sldId id="288" r:id="rId34"/>
-    <p:sldId id="289" r:id="rId35"/>
-    <p:sldId id="290" r:id="rId36"/>
-    <p:sldId id="291" r:id="rId37"/>
-    <p:sldId id="292" r:id="rId38"/>
-    <p:sldId id="293" r:id="rId39"/>
   </p:sldIdLst>
   <p:sldSz cx="9144000" cy="5143500" type="screen16x9"/>
   <p:notesSz cx="6858000" cy="9144000"/>
@@ -561,7 +555,7 @@
             </a:pPr>
             <a:r>
               <a:rPr/>
-              <a:t>منبع: فصل ۱، بندهای ۱-۱ و ۱-۶. با کاربردهای ملموس شروع کنید؛ هنوز وارد نظریه نشوید.</a:t>
+              <a:t>با یک جملهٔ ملموس شروع کنید: «اگر جدارهٔ یک مخزن در چند ثانیه ۳۰۰ درجه گرم شود، مدل کلاسیک عملاً می‌گوید اثرِ آن بلافاصله به سطح بیرونی می‌رسد — که فیزیکی نیست.»</a:t>
             </a:r>
           </a:p>
         </p:txBody>
@@ -643,23 +637,7 @@
             </a:pPr>
             <a:r>
               <a:rPr/>
-              <a:t>تأکید: </a:t>
-            </a:r>
-            <a:r>
-              <a:rPr/>
-              <a:t>\tau^*=0.15</a:t>
-            </a:r>
-            <a:r>
-              <a:rPr/>
-              <a:t> پارامتر بی‌بعدِ اصلی است؛ </a:t>
-            </a:r>
-            <a:r>
-              <a:rPr/>
-              <a:t>\tau_0=418</a:t>
-            </a:r>
-            <a:r>
-              <a:rPr/>
-              <a:t> s مقیاس‌گذاریِ جدارهٔ ۰٫۵ متری است، نه خاصیتِ اندازه‌گیری‌شدهٔ یک ماده. اگر پرسیدند، بگویید این یک مطالعهٔ پارامتریِ بی‌بعد است.</a:t>
+              <a:t>اگر پرسیدند «چرا مرجع تحلیلی و نه مقالهٔ چاپ‌شده؟» بگویید: حل دقیق برای همین هندسه استخراج شده، پس مقایسه بدون خطای رقمی‌سازیِ شکلِ مرجع و بدون اختلاف در فرضیات انجام می‌شود. پیشانی موج با دقت کمتر از یک فاصلهٔ شبکه ردیابی می‌شود.</a:t>
             </a:r>
           </a:p>
         </p:txBody>
@@ -681,7 +659,7 @@
           <a:p>
             <a:fld id="{18BDFEC3-8487-43E8-A154-7C12CBC1FFF2}" type="slidenum">
               <a:rPr lang="en-US"/>
-              <a:t>13</a:t>
+              <a:t>17</a:t>
             </a:fld>
             <a:endParaRPr lang="en-US"/>
           </a:p>
@@ -741,7 +719,7 @@
             </a:pPr>
             <a:r>
               <a:rPr/>
-              <a:t>تأکید کنید V و A آینهٔ یکدیگرند — این نکته بعداً در یافتهٔ هم‌افزایی کلیدی می‌شود.</a:t>
+              <a:t>راستای محوری راستای مقیدکننده است.</a:t>
             </a:r>
           </a:p>
         </p:txBody>
@@ -763,7 +741,7 @@
           <a:p>
             <a:fld id="{18BDFEC3-8487-43E8-A154-7C12CBC1FFF2}" type="slidenum">
               <a:rPr lang="en-US"/>
-              <a:t>15</a:t>
+              <a:t>18</a:t>
             </a:fld>
             <a:endParaRPr lang="en-US"/>
           </a:p>
@@ -823,7 +801,7 @@
             </a:pPr>
             <a:r>
               <a:rPr/>
-              <a:t>فقط همین یک معادله را نشان دهید. اگر جزئیات استخراج را خواستند، اسلاید پشتیبان (فصل ۳) را باز کنید.</a:t>
+              <a:t>این مهم‌ترین یافتهٔ پایان‌نامه است. اینجا سرعت را کم کنید، جمله‌بندی را دقیق بگویید و توصیهٔ طراحی را صریح اعلام کنید.</a:t>
             </a:r>
           </a:p>
         </p:txBody>
@@ -845,7 +823,7 @@
           <a:p>
             <a:fld id="{18BDFEC3-8487-43E8-A154-7C12CBC1FFF2}" type="slidenum">
               <a:rPr lang="en-US"/>
-              <a:t>16</a:t>
+              <a:t>22</a:t>
             </a:fld>
             <a:endParaRPr lang="en-US"/>
           </a:p>
@@ -905,433 +883,7 @@
             </a:pPr>
             <a:r>
               <a:rPr/>
-              <a:t>اگر زمان کم است، این اسلاید و اسلاید قبل را حذف یا به پشتیبان ببرید.</a:t>
-            </a:r>
-          </a:p>
-        </p:txBody>
-      </p:sp>
-      <p:sp>
-        <p:nvSpPr>
-          <p:cNvPr id="4" name="Slide Number Placeholder 3"/>
-          <p:cNvSpPr>
-            <a:spLocks noGrp="1"/>
-          </p:cNvSpPr>
-          <p:nvPr>
-            <p:ph type="sldNum" sz="quarter" idx="10"/>
-          </p:nvPr>
-        </p:nvSpPr>
-        <p:spPr/>
-        <p:txBody>
-          <a:bodyPr/>
-          <a:lstStyle/>
-          <a:p>
-            <a:fld id="{18BDFEC3-8487-43E8-A154-7C12CBC1FFF2}" type="slidenum">
-              <a:rPr lang="en-US"/>
-              <a:t>19</a:t>
-            </a:fld>
-            <a:endParaRPr lang="en-US"/>
-          </a:p>
-        </p:txBody>
-      </p:sp>
-    </p:spTree>
-  </p:cSld>
-</p:notes>
-</file>
-
-<file path=ppt/notesSlides/notesSlide14.xml><?xml version="1.0" encoding="utf-8"?>
-<p:notes xmlns:a="http://schemas.openxmlformats.org/drawingml/2006/main" xmlns:r="http://schemas.openxmlformats.org/officeDocument/2006/relationships" xmlns:p="http://schemas.openxmlformats.org/presentationml/2006/main">
-  <p:cSld>
-    <p:spTree>
-      <p:nvGrpSpPr>
-        <p:cNvPr id="1" name=""/>
-        <p:cNvGrpSpPr/>
-        <p:nvPr/>
-      </p:nvGrpSpPr>
-      <p:grpSpPr>
-        <a:xfrm>
-          <a:off x="0" y="0"/>
-          <a:ext cx="0" cy="0"/>
-          <a:chOff x="0" y="0"/>
-          <a:chExt cx="0" cy="0"/>
-        </a:xfrm>
-      </p:grpSpPr>
-      <p:sp>
-        <p:nvSpPr>
-          <p:cNvPr id="2" name="Slide Image Placeholder 1"/>
-          <p:cNvSpPr>
-            <a:spLocks noGrp="1" noRot="1" noChangeAspect="1"/>
-          </p:cNvSpPr>
-          <p:nvPr>
-            <p:ph type="sldImg"/>
-          </p:nvPr>
-        </p:nvSpPr>
-        <p:spPr/>
-      </p:sp>
-      <p:sp>
-        <p:nvSpPr>
-          <p:cNvPr id="3" name="Notes Placeholder 2"/>
-          <p:cNvSpPr>
-            <a:spLocks noGrp="1"/>
-          </p:cNvSpPr>
-          <p:nvPr>
-            <p:ph type="body" idx="1"/>
-          </p:nvPr>
-        </p:nvSpPr>
-        <p:spPr/>
-        <p:txBody>
-          <a:bodyPr/>
-          <a:lstStyle/>
-          <a:p>
-            <a:pPr lvl="0" indent="0" marL="0">
-              <a:buNone/>
-            </a:pPr>
-            <a:r>
-              <a:rPr/>
-              <a:t>این مهم‌ترین سپرِ دفاعی شماست. آرام و با اعتمادبه‌نفس بخوانید.</a:t>
-            </a:r>
-          </a:p>
-        </p:txBody>
-      </p:sp>
-      <p:sp>
-        <p:nvSpPr>
-          <p:cNvPr id="4" name="Slide Number Placeholder 3"/>
-          <p:cNvSpPr>
-            <a:spLocks noGrp="1"/>
-          </p:cNvSpPr>
-          <p:nvPr>
-            <p:ph type="sldNum" sz="quarter" idx="10"/>
-          </p:nvPr>
-        </p:nvSpPr>
-        <p:spPr/>
-        <p:txBody>
-          <a:bodyPr/>
-          <a:lstStyle/>
-          <a:p>
-            <a:fld id="{18BDFEC3-8487-43E8-A154-7C12CBC1FFF2}" type="slidenum">
-              <a:rPr lang="en-US"/>
-              <a:t>20</a:t>
-            </a:fld>
-            <a:endParaRPr lang="en-US"/>
-          </a:p>
-        </p:txBody>
-      </p:sp>
-    </p:spTree>
-  </p:cSld>
-</p:notes>
-</file>
-
-<file path=ppt/notesSlides/notesSlide15.xml><?xml version="1.0" encoding="utf-8"?>
-<p:notes xmlns:a="http://schemas.openxmlformats.org/drawingml/2006/main" xmlns:r="http://schemas.openxmlformats.org/officeDocument/2006/relationships" xmlns:p="http://schemas.openxmlformats.org/presentationml/2006/main">
-  <p:cSld>
-    <p:spTree>
-      <p:nvGrpSpPr>
-        <p:cNvPr id="1" name=""/>
-        <p:cNvGrpSpPr/>
-        <p:nvPr/>
-      </p:nvGrpSpPr>
-      <p:grpSpPr>
-        <a:xfrm>
-          <a:off x="0" y="0"/>
-          <a:ext cx="0" cy="0"/>
-          <a:chOff x="0" y="0"/>
-          <a:chExt cx="0" cy="0"/>
-        </a:xfrm>
-      </p:grpSpPr>
-      <p:sp>
-        <p:nvSpPr>
-          <p:cNvPr id="2" name="Slide Image Placeholder 1"/>
-          <p:cNvSpPr>
-            <a:spLocks noGrp="1" noRot="1" noChangeAspect="1"/>
-          </p:cNvSpPr>
-          <p:nvPr>
-            <p:ph type="sldImg"/>
-          </p:nvPr>
-        </p:nvSpPr>
-        <p:spPr/>
-      </p:sp>
-      <p:sp>
-        <p:nvSpPr>
-          <p:cNvPr id="3" name="Notes Placeholder 2"/>
-          <p:cNvSpPr>
-            <a:spLocks noGrp="1"/>
-          </p:cNvSpPr>
-          <p:nvPr>
-            <p:ph type="body" idx="1"/>
-          </p:nvPr>
-        </p:nvSpPr>
-        <p:spPr/>
-        <p:txBody>
-          <a:bodyPr/>
-          <a:lstStyle/>
-          <a:p>
-            <a:pPr lvl="0" indent="0" marL="0">
-              <a:buNone/>
-            </a:pPr>
-            <a:r>
-              <a:rPr/>
-              <a:t>جابجایی شعاعی بی‌بعد سطح داخلی در برابر زمان؛ حل حاضر، مرجع و ANSYS. اختلاف ۰٫۱ تا ۰٫۲٪.</a:t>
-            </a:r>
-          </a:p>
-        </p:txBody>
-      </p:sp>
-      <p:sp>
-        <p:nvSpPr>
-          <p:cNvPr id="4" name="Slide Number Placeholder 3"/>
-          <p:cNvSpPr>
-            <a:spLocks noGrp="1"/>
-          </p:cNvSpPr>
-          <p:nvPr>
-            <p:ph type="sldNum" sz="quarter" idx="10"/>
-          </p:nvPr>
-        </p:nvSpPr>
-        <p:spPr/>
-        <p:txBody>
-          <a:bodyPr/>
-          <a:lstStyle/>
-          <a:p>
-            <a:fld id="{18BDFEC3-8487-43E8-A154-7C12CBC1FFF2}" type="slidenum">
-              <a:rPr lang="en-US"/>
-              <a:t>21</a:t>
-            </a:fld>
-            <a:endParaRPr lang="en-US"/>
-          </a:p>
-        </p:txBody>
-      </p:sp>
-    </p:spTree>
-  </p:cSld>
-</p:notes>
-</file>
-
-<file path=ppt/notesSlides/notesSlide16.xml><?xml version="1.0" encoding="utf-8"?>
-<p:notes xmlns:a="http://schemas.openxmlformats.org/drawingml/2006/main" xmlns:r="http://schemas.openxmlformats.org/officeDocument/2006/relationships" xmlns:p="http://schemas.openxmlformats.org/presentationml/2006/main">
-  <p:cSld>
-    <p:spTree>
-      <p:nvGrpSpPr>
-        <p:cNvPr id="1" name=""/>
-        <p:cNvGrpSpPr/>
-        <p:nvPr/>
-      </p:nvGrpSpPr>
-      <p:grpSpPr>
-        <a:xfrm>
-          <a:off x="0" y="0"/>
-          <a:ext cx="0" cy="0"/>
-          <a:chOff x="0" y="0"/>
-          <a:chExt cx="0" cy="0"/>
-        </a:xfrm>
-      </p:grpSpPr>
-      <p:sp>
-        <p:nvSpPr>
-          <p:cNvPr id="2" name="Slide Image Placeholder 1"/>
-          <p:cNvSpPr>
-            <a:spLocks noGrp="1" noRot="1" noChangeAspect="1"/>
-          </p:cNvSpPr>
-          <p:nvPr>
-            <p:ph type="sldImg"/>
-          </p:nvPr>
-        </p:nvSpPr>
-        <p:spPr/>
-      </p:sp>
-      <p:sp>
-        <p:nvSpPr>
-          <p:cNvPr id="3" name="Notes Placeholder 2"/>
-          <p:cNvSpPr>
-            <a:spLocks noGrp="1"/>
-          </p:cNvSpPr>
-          <p:nvPr>
-            <p:ph type="body" idx="1"/>
-          </p:nvPr>
-        </p:nvSpPr>
-        <p:spPr/>
-        <p:txBody>
-          <a:bodyPr/>
-          <a:lstStyle/>
-          <a:p>
-            <a:pPr lvl="0" indent="0" marL="0">
-              <a:buNone/>
-            </a:pPr>
-            <a:r>
-              <a:rPr/>
-              <a:t>نشانگرها حل حاضر و خط پیوسته حل دقیق سری بسل است؛ خطای </a:t>
-            </a:r>
-            <a:r>
-              <a:rPr/>
-              <a:t>10^{-5}</a:t>
-            </a:r>
-            <a:r>
-              <a:rPr/>
-              <a:t> تا </a:t>
-            </a:r>
-            <a:r>
-              <a:rPr/>
-              <a:t>10^{-7}</a:t>
-            </a:r>
-            <a:r>
-              <a:rPr/>
-              <a:t>.</a:t>
-            </a:r>
-          </a:p>
-        </p:txBody>
-      </p:sp>
-      <p:sp>
-        <p:nvSpPr>
-          <p:cNvPr id="4" name="Slide Number Placeholder 3"/>
-          <p:cNvSpPr>
-            <a:spLocks noGrp="1"/>
-          </p:cNvSpPr>
-          <p:nvPr>
-            <p:ph type="sldNum" sz="quarter" idx="10"/>
-          </p:nvPr>
-        </p:nvSpPr>
-        <p:spPr/>
-        <p:txBody>
-          <a:bodyPr/>
-          <a:lstStyle/>
-          <a:p>
-            <a:fld id="{18BDFEC3-8487-43E8-A154-7C12CBC1FFF2}" type="slidenum">
-              <a:rPr lang="en-US"/>
-              <a:t>22</a:t>
-            </a:fld>
-            <a:endParaRPr lang="en-US"/>
-          </a:p>
-        </p:txBody>
-      </p:sp>
-    </p:spTree>
-  </p:cSld>
-</p:notes>
-</file>
-
-<file path=ppt/notesSlides/notesSlide17.xml><?xml version="1.0" encoding="utf-8"?>
-<p:notes xmlns:a="http://schemas.openxmlformats.org/drawingml/2006/main" xmlns:r="http://schemas.openxmlformats.org/officeDocument/2006/relationships" xmlns:p="http://schemas.openxmlformats.org/presentationml/2006/main">
-  <p:cSld>
-    <p:spTree>
-      <p:nvGrpSpPr>
-        <p:cNvPr id="1" name=""/>
-        <p:cNvGrpSpPr/>
-        <p:nvPr/>
-      </p:nvGrpSpPr>
-      <p:grpSpPr>
-        <a:xfrm>
-          <a:off x="0" y="0"/>
-          <a:ext cx="0" cy="0"/>
-          <a:chOff x="0" y="0"/>
-          <a:chExt cx="0" cy="0"/>
-        </a:xfrm>
-      </p:grpSpPr>
-      <p:sp>
-        <p:nvSpPr>
-          <p:cNvPr id="2" name="Slide Image Placeholder 1"/>
-          <p:cNvSpPr>
-            <a:spLocks noGrp="1" noRot="1" noChangeAspect="1"/>
-          </p:cNvSpPr>
-          <p:nvPr>
-            <p:ph type="sldImg"/>
-          </p:nvPr>
-        </p:nvSpPr>
-        <p:spPr/>
-      </p:sp>
-      <p:sp>
-        <p:nvSpPr>
-          <p:cNvPr id="3" name="Notes Placeholder 2"/>
-          <p:cNvSpPr>
-            <a:spLocks noGrp="1"/>
-          </p:cNvSpPr>
-          <p:nvPr>
-            <p:ph type="body" idx="1"/>
-          </p:nvPr>
-        </p:nvSpPr>
-        <p:spPr/>
-        <p:txBody>
-          <a:bodyPr/>
-          <a:lstStyle/>
-          <a:p>
-            <a:pPr lvl="0" indent="0" marL="0">
-              <a:buNone/>
-            </a:pPr>
-            <a:r>
-              <a:rPr/>
-              <a:t>اگر پرسیدند «چرا مرجع تحلیلی و نه مقالهٔ چاپ‌شده؟» بگویید: حل دقیق برای همین هندسه استخراج شده، پس مقایسه بدون خطای رقمی‌سازیِ شکلِ مرجع و بدون اختلاف در فرضیات انجام می‌شود. پیشانی موج با دقت کمتر از یک فاصلهٔ شبکه ردیابی می‌شود.</a:t>
-            </a:r>
-          </a:p>
-        </p:txBody>
-      </p:sp>
-      <p:sp>
-        <p:nvSpPr>
-          <p:cNvPr id="4" name="Slide Number Placeholder 3"/>
-          <p:cNvSpPr>
-            <a:spLocks noGrp="1"/>
-          </p:cNvSpPr>
-          <p:nvPr>
-            <p:ph type="sldNum" sz="quarter" idx="10"/>
-          </p:nvPr>
-        </p:nvSpPr>
-        <p:spPr/>
-        <p:txBody>
-          <a:bodyPr/>
-          <a:lstStyle/>
-          <a:p>
-            <a:fld id="{18BDFEC3-8487-43E8-A154-7C12CBC1FFF2}" type="slidenum">
-              <a:rPr lang="en-US"/>
-              <a:t>23</a:t>
-            </a:fld>
-            <a:endParaRPr lang="en-US"/>
-          </a:p>
-        </p:txBody>
-      </p:sp>
-    </p:spTree>
-  </p:cSld>
-</p:notes>
-</file>
-
-<file path=ppt/notesSlides/notesSlide18.xml><?xml version="1.0" encoding="utf-8"?>
-<p:notes xmlns:a="http://schemas.openxmlformats.org/drawingml/2006/main" xmlns:r="http://schemas.openxmlformats.org/officeDocument/2006/relationships" xmlns:p="http://schemas.openxmlformats.org/presentationml/2006/main">
-  <p:cSld>
-    <p:spTree>
-      <p:nvGrpSpPr>
-        <p:cNvPr id="1" name=""/>
-        <p:cNvGrpSpPr/>
-        <p:nvPr/>
-      </p:nvGrpSpPr>
-      <p:grpSpPr>
-        <a:xfrm>
-          <a:off x="0" y="0"/>
-          <a:ext cx="0" cy="0"/>
-          <a:chOff x="0" y="0"/>
-          <a:chExt cx="0" cy="0"/>
-        </a:xfrm>
-      </p:grpSpPr>
-      <p:sp>
-        <p:nvSpPr>
-          <p:cNvPr id="2" name="Slide Image Placeholder 1"/>
-          <p:cNvSpPr>
-            <a:spLocks noGrp="1" noRot="1" noChangeAspect="1"/>
-          </p:cNvSpPr>
-          <p:nvPr>
-            <p:ph type="sldImg"/>
-          </p:nvPr>
-        </p:nvSpPr>
-        <p:spPr/>
-      </p:sp>
-      <p:sp>
-        <p:nvSpPr>
-          <p:cNvPr id="3" name="Notes Placeholder 2"/>
-          <p:cNvSpPr>
-            <a:spLocks noGrp="1"/>
-          </p:cNvSpPr>
-          <p:nvPr>
-            <p:ph type="body" idx="1"/>
-          </p:nvPr>
-        </p:nvSpPr>
-        <p:spPr/>
-        <p:txBody>
-          <a:bodyPr/>
-          <a:lstStyle/>
-          <a:p>
-            <a:pPr lvl="0" indent="0" marL="0">
-              <a:buNone/>
-            </a:pPr>
-            <a:r>
-              <a:rPr/>
-              <a:t>راستای محوری راستای مقیدکننده است.</a:t>
+              <a:t>این قوی‌ترین استدلال شما به سود تئوری تعمیم‌یافته است.</a:t>
             </a:r>
           </a:p>
         </p:txBody>
@@ -1354,88 +906,6 @@
             <a:fld id="{18BDFEC3-8487-43E8-A154-7C12CBC1FFF2}" type="slidenum">
               <a:rPr lang="en-US"/>
               <a:t>24</a:t>
-            </a:fld>
-            <a:endParaRPr lang="en-US"/>
-          </a:p>
-        </p:txBody>
-      </p:sp>
-    </p:spTree>
-  </p:cSld>
-</p:notes>
-</file>
-
-<file path=ppt/notesSlides/notesSlide19.xml><?xml version="1.0" encoding="utf-8"?>
-<p:notes xmlns:a="http://schemas.openxmlformats.org/drawingml/2006/main" xmlns:r="http://schemas.openxmlformats.org/officeDocument/2006/relationships" xmlns:p="http://schemas.openxmlformats.org/presentationml/2006/main">
-  <p:cSld>
-    <p:spTree>
-      <p:nvGrpSpPr>
-        <p:cNvPr id="1" name=""/>
-        <p:cNvGrpSpPr/>
-        <p:nvPr/>
-      </p:nvGrpSpPr>
-      <p:grpSpPr>
-        <a:xfrm>
-          <a:off x="0" y="0"/>
-          <a:ext cx="0" cy="0"/>
-          <a:chOff x="0" y="0"/>
-          <a:chExt cx="0" cy="0"/>
-        </a:xfrm>
-      </p:grpSpPr>
-      <p:sp>
-        <p:nvSpPr>
-          <p:cNvPr id="2" name="Slide Image Placeholder 1"/>
-          <p:cNvSpPr>
-            <a:spLocks noGrp="1" noRot="1" noChangeAspect="1"/>
-          </p:cNvSpPr>
-          <p:nvPr>
-            <p:ph type="sldImg"/>
-          </p:nvPr>
-        </p:nvSpPr>
-        <p:spPr/>
-      </p:sp>
-      <p:sp>
-        <p:nvSpPr>
-          <p:cNvPr id="3" name="Notes Placeholder 2"/>
-          <p:cNvSpPr>
-            <a:spLocks noGrp="1"/>
-          </p:cNvSpPr>
-          <p:nvPr>
-            <p:ph type="body" idx="1"/>
-          </p:nvPr>
-        </p:nvSpPr>
-        <p:spPr/>
-        <p:txBody>
-          <a:bodyPr/>
-          <a:lstStyle/>
-          <a:p>
-            <a:pPr lvl="0" indent="0" marL="0">
-              <a:buNone/>
-            </a:pPr>
-            <a:r>
-              <a:rPr/>
-              <a:t>این مهم‌ترین یافتهٔ پایان‌نامه است. اینجا سرعت را کم کنید، جمله‌بندی را دقیق بگویید و توصیهٔ طراحی را صریح اعلام کنید.</a:t>
-            </a:r>
-          </a:p>
-        </p:txBody>
-      </p:sp>
-      <p:sp>
-        <p:nvSpPr>
-          <p:cNvPr id="4" name="Slide Number Placeholder 3"/>
-          <p:cNvSpPr>
-            <a:spLocks noGrp="1"/>
-          </p:cNvSpPr>
-          <p:nvPr>
-            <p:ph type="sldNum" sz="quarter" idx="10"/>
-          </p:nvPr>
-        </p:nvSpPr>
-        <p:spPr/>
-        <p:txBody>
-          <a:bodyPr/>
-          <a:lstStyle/>
-          <a:p>
-            <a:fld id="{18BDFEC3-8487-43E8-A154-7C12CBC1FFF2}" type="slidenum">
-              <a:rPr lang="en-US"/>
-              <a:t>28</a:t>
             </a:fld>
             <a:endParaRPr lang="en-US"/>
           </a:p>
@@ -1495,7 +965,7 @@
             </a:pPr>
             <a:r>
               <a:rPr/>
-              <a:t>منبع: فصل ۱، بندهای ۱-۱ و ۱-۶.</a:t>
+              <a:t>اینجا اثبات می‌کنید «چرا کار شما تازه است». نام دو سه مرجعِ نزدیک را آماده داشته باشید و تفاوتتان را در یک جمله بگویید.</a:t>
             </a:r>
           </a:p>
         </p:txBody>
@@ -1517,89 +987,7 @@
           <a:p>
             <a:fld id="{18BDFEC3-8487-43E8-A154-7C12CBC1FFF2}" type="slidenum">
               <a:rPr lang="en-US"/>
-              <a:t>4</a:t>
-            </a:fld>
-            <a:endParaRPr lang="en-US"/>
-          </a:p>
-        </p:txBody>
-      </p:sp>
-    </p:spTree>
-  </p:cSld>
-</p:notes>
-</file>
-
-<file path=ppt/notesSlides/notesSlide20.xml><?xml version="1.0" encoding="utf-8"?>
-<p:notes xmlns:a="http://schemas.openxmlformats.org/drawingml/2006/main" xmlns:r="http://schemas.openxmlformats.org/officeDocument/2006/relationships" xmlns:p="http://schemas.openxmlformats.org/presentationml/2006/main">
-  <p:cSld>
-    <p:spTree>
-      <p:nvGrpSpPr>
-        <p:cNvPr id="1" name=""/>
-        <p:cNvGrpSpPr/>
-        <p:nvPr/>
-      </p:nvGrpSpPr>
-      <p:grpSpPr>
-        <a:xfrm>
-          <a:off x="0" y="0"/>
-          <a:ext cx="0" cy="0"/>
-          <a:chOff x="0" y="0"/>
-          <a:chExt cx="0" cy="0"/>
-        </a:xfrm>
-      </p:grpSpPr>
-      <p:sp>
-        <p:nvSpPr>
-          <p:cNvPr id="2" name="Slide Image Placeholder 1"/>
-          <p:cNvSpPr>
-            <a:spLocks noGrp="1" noRot="1" noChangeAspect="1"/>
-          </p:cNvSpPr>
-          <p:nvPr>
-            <p:ph type="sldImg"/>
-          </p:nvPr>
-        </p:nvSpPr>
-        <p:spPr/>
-      </p:sp>
-      <p:sp>
-        <p:nvSpPr>
-          <p:cNvPr id="3" name="Notes Placeholder 2"/>
-          <p:cNvSpPr>
-            <a:spLocks noGrp="1"/>
-          </p:cNvSpPr>
-          <p:nvPr>
-            <p:ph type="body" idx="1"/>
-          </p:nvPr>
-        </p:nvSpPr>
-        <p:spPr/>
-        <p:txBody>
-          <a:bodyPr/>
-          <a:lstStyle/>
-          <a:p>
-            <a:pPr lvl="0" indent="0" marL="0">
-              <a:buNone/>
-            </a:pPr>
-            <a:r>
-              <a:rPr/>
-              <a:t>این یافته را با ذکر شرایط (پالس گاوسی) و بدون مبالغه بیان کنید.</a:t>
-            </a:r>
-          </a:p>
-        </p:txBody>
-      </p:sp>
-      <p:sp>
-        <p:nvSpPr>
-          <p:cNvPr id="4" name="Slide Number Placeholder 3"/>
-          <p:cNvSpPr>
-            <a:spLocks noGrp="1"/>
-          </p:cNvSpPr>
-          <p:nvPr>
-            <p:ph type="sldNum" sz="quarter" idx="10"/>
-          </p:nvPr>
-        </p:nvSpPr>
-        <p:spPr/>
-        <p:txBody>
-          <a:bodyPr/>
-          <a:lstStyle/>
-          <a:p>
-            <a:fld id="{18BDFEC3-8487-43E8-A154-7C12CBC1FFF2}" type="slidenum">
-              <a:rPr lang="en-US"/>
-              <a:t>30</a:t>
+              <a:t>5</a:t>
             </a:fld>
             <a:endParaRPr lang="en-US"/>
           </a:p>
@@ -1659,7 +1047,23 @@
             </a:pPr>
             <a:r>
               <a:rPr/>
-              <a:t>منبع: فصل ۱، بندهای ۱-۱ (بند چهارم) و ۱-۳. لرد–شولمن را فقط یکی از تئوری‌های تعمیم‌یافته معرفی کنید؛ مقایسهٔ تئوری‌ها در پیشینه و در نتیجهٔ ۷ می‌آید.</a:t>
+              <a:t>تأکید: </a:t>
+            </a:r>
+            <a:r>
+              <a:rPr/>
+              <a:t>\tau^*=0.15</a:t>
+            </a:r>
+            <a:r>
+              <a:rPr/>
+              <a:t> پارامتر بی‌بعدِ اصلی است؛ </a:t>
+            </a:r>
+            <a:r>
+              <a:rPr/>
+              <a:t>\tau_0=418</a:t>
+            </a:r>
+            <a:r>
+              <a:rPr/>
+              <a:t> s مقیاس‌گذاریِ جدارهٔ ۰٫۵ متری است، نه خاصیتِ اندازه‌گیری‌شدهٔ یک ماده. اگر پرسیدند، بگویید این یک مطالعهٔ پارامتریِ بی‌بعد است.</a:t>
             </a:r>
           </a:p>
         </p:txBody>
@@ -1681,7 +1085,7 @@
           <a:p>
             <a:fld id="{18BDFEC3-8487-43E8-A154-7C12CBC1FFF2}" type="slidenum">
               <a:rPr lang="en-US"/>
-              <a:t>5</a:t>
+              <a:t>7</a:t>
             </a:fld>
             <a:endParaRPr lang="en-US"/>
           </a:p>
@@ -1741,7 +1145,7 @@
             </a:pPr>
             <a:r>
               <a:rPr/>
-              <a:t>منبع: فصل ۱، بند ۱-۴. این چهار پرسش را در بخش نتایج دوباره به‌ترتیب پاسخ می‌دهید.</a:t>
+              <a:t>تأکید کنید V و A آینهٔ یکدیگرند — این نکته بعداً در یافتهٔ هم‌افزایی کلیدی می‌شود.</a:t>
             </a:r>
           </a:p>
         </p:txBody>
@@ -1763,7 +1167,7 @@
           <a:p>
             <a:fld id="{18BDFEC3-8487-43E8-A154-7C12CBC1FFF2}" type="slidenum">
               <a:rPr lang="en-US"/>
-              <a:t>6</a:t>
+              <a:t>9</a:t>
             </a:fld>
             <a:endParaRPr lang="en-US"/>
           </a:p>
@@ -1823,7 +1227,7 @@
             </a:pPr>
             <a:r>
               <a:rPr/>
-              <a:t>منبع: فصل ۲، بند ۲-۲. این اسلاید توجیه می‌کند چرا مسئله را در صفحهٔ (r,z) و نه با تئوری پوسته حل کرده‌اید.</a:t>
+              <a:t>فقط همین یک معادله را نشان دهید. اگر جزئیات استخراج را خواستند، اسلاید پشتیبان (فصل ۳) را باز کنید.</a:t>
             </a:r>
           </a:p>
         </p:txBody>
@@ -1845,7 +1249,7 @@
           <a:p>
             <a:fld id="{18BDFEC3-8487-43E8-A154-7C12CBC1FFF2}" type="slidenum">
               <a:rPr lang="en-US"/>
-              <a:t>7</a:t>
+              <a:t>10</a:t>
             </a:fld>
             <a:endParaRPr lang="en-US"/>
           </a:p>
@@ -1905,7 +1309,7 @@
             </a:pPr>
             <a:r>
               <a:rPr/>
-              <a:t>شکل ۲-۱ پایان‌نامه. فقط جایگاه نظریه‌ها را نشان دهید؛ دربارهٔ برتری هیچ‌کدام صحبت نکنید.</a:t>
+              <a:t>اگر زمان کم است، این اسلاید و اسلاید قبل را حذف یا به پشتیبان ببرید.</a:t>
             </a:r>
           </a:p>
         </p:txBody>
@@ -1927,7 +1331,7 @@
           <a:p>
             <a:fld id="{18BDFEC3-8487-43E8-A154-7C12CBC1FFF2}" type="slidenum">
               <a:rPr lang="en-US"/>
-              <a:t>8</a:t>
+              <a:t>13</a:t>
             </a:fld>
             <a:endParaRPr lang="en-US"/>
           </a:p>
@@ -1987,7 +1391,7 @@
             </a:pPr>
             <a:r>
               <a:rPr/>
-              <a:t>منبع: فصل ۲، بندهای ۲-۳ تا ۲-۶ (خلاصه‌شده). ردیف‌های ۱ و ۲: روش DQM + نیومارک و هدایت هذلولوی در استوانه. ردیف‌های ۳ تا ۵: گرافن و تخلخل (مدل سلول‌باز مبنای مدل تخلخل شماست). ردیف‌های ۶ و ۷: ترموالاستیسیتهٔ تعمیم‌یافته؛ [۳]، [۶۸]، [۷۰] نزدیک‌ترین مرجع‌ها و مبنای معادلات (فصل ۳) و قرارداد بی‌بعدسازی (فصل ۴) هستند. اگر داور فهرست کامل‌تر خواست، فصل ۲ را ارجاع دهید. اگر پرسید «تفاوت شما با کار حیدرپور چیست؟» پاسخ در اسلایدهای بعد است: استوانهٔ جدارضخیم، گرافن و تخلخل هم‌زمان، ماتریس ۵×۵.</a:t>
+              <a:t>این مهم‌ترین سپرِ دفاعی شماست. آرام و با اعتمادبه‌نفس بخوانید.</a:t>
             </a:r>
           </a:p>
         </p:txBody>
@@ -2009,7 +1413,7 @@
           <a:p>
             <a:fld id="{18BDFEC3-8487-43E8-A154-7C12CBC1FFF2}" type="slidenum">
               <a:rPr lang="en-US"/>
-              <a:t>9</a:t>
+              <a:t>14</a:t>
             </a:fld>
             <a:endParaRPr lang="en-US"/>
           </a:p>
@@ -2069,7 +1473,7 @@
             </a:pPr>
             <a:r>
               <a:rPr/>
-              <a:t>منبع: فصل ۲، بند ۲-۷. «تا آنجا که در این مرور بررسی شد» را بگویید؛ ادعای مطلق نکنید.</a:t>
+              <a:t>جابجایی شعاعی بی‌بعد سطح داخلی در برابر زمان؛ حل حاضر، مرجع و ANSYS. اختلاف ۰٫۱ تا ۰٫۲٪.</a:t>
             </a:r>
           </a:p>
         </p:txBody>
@@ -2091,7 +1495,7 @@
           <a:p>
             <a:fld id="{18BDFEC3-8487-43E8-A154-7C12CBC1FFF2}" type="slidenum">
               <a:rPr lang="en-US"/>
-              <a:t>10</a:t>
+              <a:t>15</a:t>
             </a:fld>
             <a:endParaRPr lang="en-US"/>
           </a:p>
@@ -2151,7 +1555,23 @@
             </a:pPr>
             <a:r>
               <a:rPr/>
-              <a:t>منبع: فصل ۲، بند ۲-۷ (بند پایانی). هر مورد این فهرست یکی از شکاف‌های اسلاید قبل را پاسخ می‌دهد.</a:t>
+              <a:t>نشانگرها حل حاضر و خط پیوسته حل دقیق سری بسل است؛ خطای </a:t>
+            </a:r>
+            <a:r>
+              <a:rPr/>
+              <a:t>10^{-5}</a:t>
+            </a:r>
+            <a:r>
+              <a:rPr/>
+              <a:t> تا </a:t>
+            </a:r>
+            <a:r>
+              <a:rPr/>
+              <a:t>10^{-7}</a:t>
+            </a:r>
+            <a:r>
+              <a:rPr/>
+              <a:t>.</a:t>
             </a:r>
           </a:p>
         </p:txBody>
@@ -2173,7 +1593,7 @@
           <a:p>
             <a:fld id="{18BDFEC3-8487-43E8-A154-7C12CBC1FFF2}" type="slidenum">
               <a:rPr lang="en-US"/>
-              <a:t>11</a:t>
+              <a:t>16</a:t>
             </a:fld>
             <a:endParaRPr lang="en-US"/>
           </a:p>
@@ -5685,7 +5105,7 @@
         </a:spcBef>
         <a:buFont typeface="Arial"/>
         <a:buChar char="•"/>
-        <a:defRPr kern="1200" sz="1600" lang="fa-IR" dirty="0">
+        <a:defRPr kern="1200" sz="1800" lang="fa-IR" dirty="0">
           <a:solidFill>
             <a:schemeClr val="tx1"/>
           </a:solidFill>
@@ -5700,7 +5120,7 @@
         </a:spcBef>
         <a:buFont typeface="Arial"/>
         <a:buChar char="–"/>
-        <a:defRPr kern="1200" sz="1400" lang="fa-IR" dirty="0">
+        <a:defRPr kern="1200" sz="1600" lang="fa-IR" dirty="0">
           <a:solidFill>
             <a:schemeClr val="tx1"/>
           </a:solidFill>
@@ -6073,967 +5493,7 @@
                 <a:latin typeface="Tahoma"/>
                 <a:cs typeface="Tahoma"/>
               </a:rPr>
-              <a:t>جمع‌بندی پیشینه: چهار شکاف پژوهشی</a:t>
-            </a:r>
-          </a:p>
-        </p:txBody>
-      </p:sp>
-      <mc:AlternateContent xmlns:mc="http://schemas.openxmlformats.org/markup-compatibility/2006">
-        <mc:Choice xmlns:a14="http://schemas.microsoft.com/office/drawing/2010/main" Requires="a14">
-          <p:sp>
-            <p:nvSpPr>
-              <p:cNvPr id="3" name="Content Placeholder 2"/>
-              <p:cNvSpPr>
-                <a:spLocks noGrp="1"/>
-              </p:cNvSpPr>
-              <p:nvPr>
-                <p:ph idx="1"/>
-              </p:nvPr>
-            </p:nvSpPr>
-            <p:spPr/>
-            <p:txBody>
-              <a:bodyPr/>
-              <a:lstStyle/>
-              <a:p>
-                <a:pPr lvl="0" rtl="1" algn="r"/>
-                <a:r>
-                  <a:rPr lang="fa-IR" dirty="0">
-                    <a:latin typeface="Tahoma"/>
-                    <a:cs typeface="Tahoma"/>
-                  </a:rPr>
-                  <a:t>سه شاخه جداگانه بالغ شده‌اند: ترموالاستیک استوانه‌های کامپوزیتی، مدل‌سازی مواد متخلخل گرافنی و تئوری‌های تعمیم‌یافته؛ بررسی هم‌زمانشان به‌ندرت انجام شده است.</a:t>
-                </a:r>
-              </a:p>
-              <a:p>
-                <a:pPr lvl="0" rtl="1" algn="r"/>
-                <a:r>
-                  <a:rPr b="1" lang="fa-IR" dirty="0">
-                    <a:latin typeface="Tahoma"/>
-                    <a:cs typeface="Tahoma"/>
-                  </a:rPr>
-                  <a:t>۱.</a:t>
-                </a:r>
-                <a:r>
-                  <a:rPr lang="fa-IR" dirty="0">
-                    <a:latin typeface="Tahoma"/>
-                    <a:cs typeface="Tahoma"/>
-                  </a:rPr>
-                  <a:t> کارهای گذرا اغلب بر تئوری پوسته‌اند؛ حل کاملاً دوبعدی </a:t>
-                </a:r>
-                <a14:m>
-                  <m:oMath xmlns:m="http://schemas.openxmlformats.org/officeDocument/2006/math">
-                    <m:r>
-                      <m:rPr>
-                        <m:sty m:val="p"/>
-                      </m:rPr>
-                      <m:t>(</m:t>
-                    </m:r>
-                    <m:r>
-                      <m:t>r</m:t>
-                    </m:r>
-                    <m:r>
-                      <m:rPr>
-                        <m:sty m:val="p"/>
-                      </m:rPr>
-                      <m:t>,</m:t>
-                    </m:r>
-                    <m:r>
-                      <m:t>z</m:t>
-                    </m:r>
-                    <m:r>
-                      <m:rPr>
-                        <m:sty m:val="p"/>
-                      </m:rPr>
-                      <m:t>)</m:t>
-                    </m:r>
-                  </m:oMath>
-                </a14:m>
-                <a:r>
-                  <a:rPr lang="fa-IR" dirty="0">
-                    <a:latin typeface="Tahoma"/>
-                    <a:cs typeface="Tahoma"/>
-                  </a:rPr>
-                  <a:t> برای استوانهٔ جدارضخیم کمتر به‌کار رفته است.</a:t>
-                </a:r>
-              </a:p>
-              <a:p>
-                <a:pPr lvl="0" rtl="1" algn="r"/>
-                <a:r>
-                  <a:rPr b="1" lang="fa-IR" dirty="0">
-                    <a:latin typeface="Tahoma"/>
-                    <a:cs typeface="Tahoma"/>
-                  </a:rPr>
-                  <a:t>۲.</a:t>
-                </a:r>
-                <a:r>
-                  <a:rPr lang="fa-IR" dirty="0">
-                    <a:latin typeface="Tahoma"/>
-                    <a:cs typeface="Tahoma"/>
-                  </a:rPr>
-                  <a:t> تحلیل‌های استوانهٔ متخلخل گرافنی عمدتاً مکانیکی یا حرارتیِ پایا و بر پایهٔ فوریه‌اند.</a:t>
-                </a:r>
-              </a:p>
-              <a:p>
-                <a:pPr lvl="0" rtl="1" algn="r"/>
-                <a:r>
-                  <a:rPr b="1" lang="fa-IR" dirty="0">
-                    <a:latin typeface="Tahoma"/>
-                    <a:cs typeface="Tahoma"/>
-                  </a:rPr>
-                  <a:t>۳.</a:t>
-                </a:r>
-                <a:r>
-                  <a:rPr lang="fa-IR" dirty="0">
-                    <a:latin typeface="Tahoma"/>
-                    <a:cs typeface="Tahoma"/>
-                  </a:rPr>
-                  <a:t> کارهای لرد–شولمن با DQM لایه‌ای و نیومارک بر کره، مخروط ناقص یا پوسته‌اند؛ استوانهٔ جدارضخیم چندلایه با گرافن و تخلخل هم‌زمان پوشش داده نشده است.</a:t>
-                </a:r>
-              </a:p>
-              <a:p>
-                <a:pPr lvl="0" rtl="1" algn="r"/>
-                <a:r>
-                  <a:rPr b="1" lang="fa-IR" dirty="0">
-                    <a:latin typeface="Tahoma"/>
-                    <a:cs typeface="Tahoma"/>
-                  </a:rPr>
-                  <a:t>۴.</a:t>
-                </a:r>
-                <a:r>
-                  <a:rPr lang="fa-IR" dirty="0">
-                    <a:latin typeface="Tahoma"/>
-                    <a:cs typeface="Tahoma"/>
-                  </a:rPr>
-                  <a:t> برهم‌کنش کاملِ الگوهای گرافن و تخلخل (ماتریس ۵×۵) و مقایسهٔ نظریه‌ها در یک مسئلهٔ استوانه‌ای گزارش نشده است.</a:t>
-                </a:r>
-              </a:p>
-            </p:txBody>
-          </p:sp>
-        </mc:Choice>
-      </mc:AlternateContent>
-    </p:spTree>
-  </p:cSld>
-</p:sld>
-</file>
-
-<file path=ppt/slides/slide11.xml><?xml version="1.0" encoding="utf-8"?>
-<p:sld xmlns:a="http://schemas.openxmlformats.org/drawingml/2006/main" xmlns:r="http://schemas.openxmlformats.org/officeDocument/2006/relationships" xmlns:p="http://schemas.openxmlformats.org/presentationml/2006/main">
-  <p:cSld>
-    <p:spTree>
-      <p:nvGrpSpPr>
-        <p:cNvPr id="1" name=""/>
-        <p:cNvGrpSpPr/>
-        <p:nvPr/>
-      </p:nvGrpSpPr>
-      <p:grpSpPr>
-        <a:xfrm>
-          <a:off x="0" y="0"/>
-          <a:ext cx="0" cy="0"/>
-          <a:chOff x="0" y="0"/>
-          <a:chExt cx="0" cy="0"/>
-        </a:xfrm>
-      </p:grpSpPr>
-      <p:sp>
-        <p:nvSpPr>
-          <p:cNvPr id="2" name="Title 1"/>
-          <p:cNvSpPr>
-            <a:spLocks noGrp="1"/>
-          </p:cNvSpPr>
-          <p:nvPr>
-            <p:ph type="title"/>
-          </p:nvPr>
-        </p:nvSpPr>
-        <p:spPr/>
-        <p:txBody>
-          <a:bodyPr/>
-          <a:lstStyle/>
-          <a:p>
-            <a:pPr lvl="0" indent="0" marL="0" rtl="1" algn="r">
-              <a:buNone/>
-            </a:pPr>
-            <a:r>
-              <a:rPr lang="fa-IR" dirty="0">
-                <a:latin typeface="Tahoma"/>
-                <a:cs typeface="Tahoma"/>
-              </a:rPr>
-              <a:t>جایگاه پژوهش حاضر در ادبیات</a:t>
-            </a:r>
-          </a:p>
-        </p:txBody>
-      </p:sp>
-      <mc:AlternateContent xmlns:mc="http://schemas.openxmlformats.org/markup-compatibility/2006">
-        <mc:Choice xmlns:a14="http://schemas.microsoft.com/office/drawing/2010/main" Requires="a14">
-          <p:sp>
-            <p:nvSpPr>
-              <p:cNvPr id="3" name="Content Placeholder 2"/>
-              <p:cNvSpPr>
-                <a:spLocks noGrp="1"/>
-              </p:cNvSpPr>
-              <p:nvPr>
-                <p:ph idx="1"/>
-              </p:nvPr>
-            </p:nvSpPr>
-            <p:spPr/>
-            <p:txBody>
-              <a:bodyPr/>
-              <a:lstStyle/>
-              <a:p>
-                <a:pPr lvl="0" rtl="1" algn="r"/>
-                <a:r>
-                  <a:rPr lang="fa-IR" dirty="0">
-                    <a:latin typeface="Tahoma"/>
-                    <a:cs typeface="Tahoma"/>
-                  </a:rPr>
-                  <a:t>تحلیل ترموالاستیک گذرا و کاملاً ممزوج برای استوانهٔ توخالیِ جدارضخیمِ چندلایهٔ متخلخل تقویت‌شده با گرافن.</a:t>
-                </a:r>
-              </a:p>
-              <a:p>
-                <a:pPr lvl="0" rtl="1" algn="r"/>
-                <a:r>
-                  <a:rPr lang="fa-IR" dirty="0">
-                    <a:latin typeface="Tahoma"/>
-                    <a:cs typeface="Tahoma"/>
-                  </a:rPr>
-                  <a:t>خواص مؤثر: هالپین–تسای، قاعدهٔ مخلوط‌ها و مدل سلول‌باز.</a:t>
-                </a:r>
-              </a:p>
-              <a:p>
-                <a:pPr lvl="0" rtl="1" algn="r"/>
-                <a:r>
-                  <a:rPr lang="fa-IR" dirty="0">
-                    <a:latin typeface="Tahoma"/>
-                    <a:cs typeface="Tahoma"/>
-                  </a:rPr>
-                  <a:t>معادلات به‌صورت دوبعدی در صفحهٔ </a:t>
-                </a:r>
-                <a14:m>
-                  <m:oMath xmlns:m="http://schemas.openxmlformats.org/officeDocument/2006/math">
-                    <m:r>
-                      <m:rPr>
-                        <m:sty m:val="p"/>
-                      </m:rPr>
-                      <m:t>(</m:t>
-                    </m:r>
-                    <m:r>
-                      <m:t>r</m:t>
-                    </m:r>
-                    <m:r>
-                      <m:rPr>
-                        <m:sty m:val="p"/>
-                      </m:rPr>
-                      <m:t>,</m:t>
-                    </m:r>
-                    <m:r>
-                      <m:t>z</m:t>
-                    </m:r>
-                    <m:r>
-                      <m:rPr>
-                        <m:sty m:val="p"/>
-                      </m:rPr>
-                      <m:t>)</m:t>
-                    </m:r>
-                  </m:oMath>
-                </a14:m>
-                <a:r>
-                  <a:rPr lang="fa-IR" dirty="0">
-                    <a:latin typeface="Tahoma"/>
-                    <a:cs typeface="Tahoma"/>
-                  </a:rPr>
-                  <a:t> و بدون تحویل به فرضیات پوسته.</a:t>
-                </a:r>
-              </a:p>
-              <a:p>
-                <a:pPr lvl="0" rtl="1" algn="r"/>
-                <a:r>
-                  <a:rPr lang="fa-IR" dirty="0">
-                    <a:latin typeface="Tahoma"/>
-                    <a:cs typeface="Tahoma"/>
-                  </a:rPr>
-                  <a:t>گسسته‌سازی: DQM لایه‌ای (گره‌های چبیشف–گاوس–لوباتو) در مکان و نیومارک در زمان.</a:t>
-                </a:r>
-              </a:p>
-              <a:p>
-                <a:pPr lvl="0" rtl="1" algn="r"/>
-                <a:r>
-                  <a:rPr lang="fa-IR" dirty="0">
-                    <a:latin typeface="Tahoma"/>
-                    <a:cs typeface="Tahoma"/>
-                  </a:rPr>
-                  <a:t>گرافن و تخلخل، هر یک در پنج الگوی UD، O، X، V و A.</a:t>
-                </a:r>
-              </a:p>
-            </p:txBody>
-          </p:sp>
-        </mc:Choice>
-      </mc:AlternateContent>
-    </p:spTree>
-  </p:cSld>
-</p:sld>
-</file>
-
-<file path=ppt/slides/slide12.xml><?xml version="1.0" encoding="utf-8"?>
-<p:sld xmlns:a="http://schemas.openxmlformats.org/drawingml/2006/main" xmlns:r="http://schemas.openxmlformats.org/officeDocument/2006/relationships" xmlns:p="http://schemas.openxmlformats.org/presentationml/2006/main">
-  <p:cSld>
-    <p:spTree>
-      <p:nvGrpSpPr>
-        <p:cNvPr id="1" name=""/>
-        <p:cNvGrpSpPr/>
-        <p:nvPr/>
-      </p:nvGrpSpPr>
-      <p:grpSpPr>
-        <a:xfrm>
-          <a:off x="0" y="0"/>
-          <a:ext cx="0" cy="0"/>
-          <a:chOff x="0" y="0"/>
-          <a:chExt cx="0" cy="0"/>
-        </a:xfrm>
-      </p:grpSpPr>
-      <p:sp>
-        <p:nvSpPr>
-          <p:cNvPr id="2" name="Title 1"/>
-          <p:cNvSpPr>
-            <a:spLocks noGrp="1"/>
-          </p:cNvSpPr>
-          <p:nvPr>
-            <p:ph type="title"/>
-          </p:nvPr>
-        </p:nvSpPr>
-        <p:spPr/>
-        <p:txBody>
-          <a:bodyPr/>
-          <a:lstStyle/>
-          <a:p>
-            <a:pPr lvl="0" indent="0" marL="0" rtl="1" algn="r">
-              <a:buNone/>
-            </a:pPr>
-            <a:r>
-              <a:rPr lang="fa-IR" dirty="0">
-                <a:latin typeface="Tahoma"/>
-                <a:cs typeface="Tahoma"/>
-              </a:rPr>
-              <a:t>استوانهٔ توخالیِ هفت‌لایه با خواص متغیر در ضخامت</a:t>
-            </a:r>
-          </a:p>
-        </p:txBody>
-      </p:sp>
-      <p:pic>
-        <p:nvPicPr>
-          <p:cNvPr descr="../figures_ch123/geometry_schematic.png" id="0" name="Picture 1"/>
-          <p:cNvPicPr>
-            <a:picLocks noGrp="1" noChangeAspect="1"/>
-          </p:cNvPicPr>
-          <p:nvPr/>
-        </p:nvPicPr>
-        <p:blipFill>
-          <a:blip r:embed="rId2"/>
-          <a:stretch>
-            <a:fillRect/>
-          </a:stretch>
-        </p:blipFill>
-        <p:spPr bwMode="auto">
-          <a:xfrm>
-            <a:off x="1358900" y="1193800"/>
-            <a:ext cx="6438900" cy="3390900"/>
-          </a:xfrm>
-          <a:prstGeom prst="rect">
-            <a:avLst/>
-          </a:prstGeom>
-          <a:noFill/>
-          <a:ln w="9525">
-            <a:noFill/>
-            <a:headEnd/>
-            <a:tailEnd/>
-          </a:ln>
-        </p:spPr>
-      </p:pic>
-    </p:spTree>
-  </p:cSld>
-</p:sld>
-</file>
-
-<file path=ppt/slides/slide13.xml><?xml version="1.0" encoding="utf-8"?>
-<p:sld xmlns:a="http://schemas.openxmlformats.org/drawingml/2006/main" xmlns:r="http://schemas.openxmlformats.org/officeDocument/2006/relationships" xmlns:p="http://schemas.openxmlformats.org/presentationml/2006/main">
-  <p:cSld>
-    <p:spTree>
-      <p:nvGrpSpPr>
-        <p:cNvPr id="1" name=""/>
-        <p:cNvGrpSpPr/>
-        <p:nvPr/>
-      </p:nvGrpSpPr>
-      <p:grpSpPr>
-        <a:xfrm>
-          <a:off x="0" y="0"/>
-          <a:ext cx="0" cy="0"/>
-          <a:chOff x="0" y="0"/>
-          <a:chExt cx="0" cy="0"/>
-        </a:xfrm>
-      </p:grpSpPr>
-      <p:sp>
-        <p:nvSpPr>
-          <p:cNvPr id="2" name="Title 1"/>
-          <p:cNvSpPr>
-            <a:spLocks noGrp="1"/>
-          </p:cNvSpPr>
-          <p:nvPr>
-            <p:ph type="title"/>
-          </p:nvPr>
-        </p:nvSpPr>
-        <p:spPr/>
-        <p:txBody>
-          <a:bodyPr/>
-          <a:lstStyle/>
-          <a:p>
-            <a:pPr lvl="0" indent="0" marL="0" rtl="1" algn="r">
-              <a:buNone/>
-            </a:pPr>
-            <a:r>
-              <a:rPr lang="fa-IR" dirty="0">
-                <a:latin typeface="Tahoma"/>
-                <a:cs typeface="Tahoma"/>
-              </a:rPr>
-              <a:t>حالت مرجع و شرایط مرزی</a:t>
-            </a:r>
-          </a:p>
-        </p:txBody>
-      </p:sp>
-      <mc:AlternateContent xmlns:mc="http://schemas.openxmlformats.org/markup-compatibility/2006">
-        <mc:Choice xmlns:a14="http://schemas.microsoft.com/office/drawing/2010/main" Requires="a14">
-          <p:sp>
-            <p:nvSpPr>
-              <p:cNvPr id="3" name="Content Placeholder 2"/>
-              <p:cNvSpPr>
-                <a:spLocks noGrp="1"/>
-              </p:cNvSpPr>
-              <p:nvPr>
-                <p:ph idx="1"/>
-              </p:nvPr>
-            </p:nvSpPr>
-            <p:spPr/>
-            <p:txBody>
-              <a:bodyPr/>
-              <a:lstStyle/>
-              <a:p>
-                <a:pPr lvl="0" rtl="1" algn="r"/>
-                <a:r>
-                  <a:rPr lang="fa-IR" dirty="0">
-                    <a:latin typeface="Tahoma"/>
-                    <a:cs typeface="Tahoma"/>
-                  </a:rPr>
-                  <a:t>ابعاد: </a:t>
-                </a:r>
-                <a14:m>
-                  <m:oMath xmlns:m="http://schemas.openxmlformats.org/officeDocument/2006/math">
-                    <m:sSub>
-                      <m:e>
-                        <m:r>
-                          <m:t>R</m:t>
-                        </m:r>
-                      </m:e>
-                      <m:sub>
-                        <m:r>
-                          <m:t>i</m:t>
-                        </m:r>
-                      </m:sub>
-                    </m:sSub>
-                    <m:r>
-                      <m:rPr>
-                        <m:sty m:val="p"/>
-                      </m:rPr>
-                      <m:t>=</m:t>
-                    </m:r>
-                    <m:r>
-                      <m:t>1</m:t>
-                    </m:r>
-                  </m:oMath>
-                </a14:m>
-                <a:r>
-                  <a:rPr lang="fa-IR" dirty="0">
-                    <a:latin typeface="Tahoma"/>
-                    <a:cs typeface="Tahoma"/>
-                  </a:rPr>
-                  <a:t> m، </a:t>
-                </a:r>
-                <a14:m>
-                  <m:oMath xmlns:m="http://schemas.openxmlformats.org/officeDocument/2006/math">
-                    <m:sSub>
-                      <m:e>
-                        <m:r>
-                          <m:t>R</m:t>
-                        </m:r>
-                      </m:e>
-                      <m:sub>
-                        <m:r>
-                          <m:t>o</m:t>
-                        </m:r>
-                      </m:sub>
-                    </m:sSub>
-                    <m:r>
-                      <m:rPr>
-                        <m:sty m:val="p"/>
-                      </m:rPr>
-                      <m:t>=</m:t>
-                    </m:r>
-                    <m:r>
-                      <m:t>1.5</m:t>
-                    </m:r>
-                  </m:oMath>
-                </a14:m>
-                <a:r>
-                  <a:rPr lang="fa-IR" dirty="0">
-                    <a:latin typeface="Tahoma"/>
-                    <a:cs typeface="Tahoma"/>
-                  </a:rPr>
-                  <a:t> m، طول </a:t>
-                </a:r>
-                <a14:m>
-                  <m:oMath xmlns:m="http://schemas.openxmlformats.org/officeDocument/2006/math">
-                    <m:r>
-                      <m:t>L</m:t>
-                    </m:r>
-                    <m:r>
-                      <m:rPr>
-                        <m:sty m:val="p"/>
-                      </m:rPr>
-                      <m:t>=</m:t>
-                    </m:r>
-                    <m:r>
-                      <m:t>2.1</m:t>
-                    </m:r>
-                  </m:oMath>
-                </a14:m>
-                <a:r>
-                  <a:rPr lang="fa-IR" dirty="0">
-                    <a:latin typeface="Tahoma"/>
-                    <a:cs typeface="Tahoma"/>
-                  </a:rPr>
-                  <a:t> m.</a:t>
-                </a:r>
-              </a:p>
-              <a:p>
-                <a:pPr lvl="0" rtl="1" algn="r"/>
-                <a:r>
-                  <a:rPr lang="fa-IR" dirty="0">
-                    <a:latin typeface="Tahoma"/>
-                    <a:cs typeface="Tahoma"/>
-                  </a:rPr>
-                  <a:t>حرارت: سطح داخلی </a:t>
-                </a:r>
-                <a14:m>
-                  <m:oMath xmlns:m="http://schemas.openxmlformats.org/officeDocument/2006/math">
-                    <m:r>
-                      <m:t>300</m:t>
-                    </m:r>
-                    <m:r>
-                      <m:rPr>
-                        <m:sty m:val="p"/>
-                      </m:rPr>
-                      <m:t>→</m:t>
-                    </m:r>
-                    <m:r>
-                      <m:t>600</m:t>
-                    </m:r>
-                  </m:oMath>
-                </a14:m>
-                <a:r>
-                  <a:rPr lang="fa-IR" dirty="0">
-                    <a:latin typeface="Tahoma"/>
-                    <a:cs typeface="Tahoma"/>
-                  </a:rPr>
-                  <a:t> K؛ سطح خارجی همرفت با </a:t>
-                </a:r>
-                <a14:m>
-                  <m:oMath xmlns:m="http://schemas.openxmlformats.org/officeDocument/2006/math">
-                    <m:sSub>
-                      <m:e>
-                        <m:r>
-                          <m:t>h</m:t>
-                        </m:r>
-                      </m:e>
-                      <m:sub>
-                        <m:r>
-                          <m:t>c</m:t>
-                        </m:r>
-                      </m:sub>
-                    </m:sSub>
-                    <m:r>
-                      <m:rPr>
-                        <m:sty m:val="p"/>
-                      </m:rPr>
-                      <m:t>=</m:t>
-                    </m:r>
-                    <m:r>
-                      <m:t>10</m:t>
-                    </m:r>
-                  </m:oMath>
-                </a14:m>
-                <a:r>
-                  <a:rPr lang="fa-IR" dirty="0">
-                    <a:latin typeface="Tahoma"/>
-                    <a:cs typeface="Tahoma"/>
-                  </a:rPr>
-                  <a:t> W/m²K.</a:t>
-                </a:r>
-              </a:p>
-              <a:p>
-                <a:pPr lvl="0" rtl="1" algn="r"/>
-                <a:r>
-                  <a:rPr lang="fa-IR" dirty="0">
-                    <a:latin typeface="Tahoma"/>
-                    <a:cs typeface="Tahoma"/>
-                  </a:rPr>
-                  <a:t>مکانیک: فشار داخلی </a:t>
-                </a:r>
-                <a14:m>
-                  <m:oMath xmlns:m="http://schemas.openxmlformats.org/officeDocument/2006/math">
-                    <m:sSub>
-                      <m:e>
-                        <m:r>
-                          <m:t>P</m:t>
-                        </m:r>
-                      </m:e>
-                      <m:sub>
-                        <m:r>
-                          <m:t>i</m:t>
-                        </m:r>
-                      </m:sub>
-                    </m:sSub>
-                    <m:r>
-                      <m:rPr>
-                        <m:sty m:val="p"/>
-                      </m:rPr>
-                      <m:t>=</m:t>
-                    </m:r>
-                    <m:r>
-                      <m:t>50</m:t>
-                    </m:r>
-                  </m:oMath>
-                </a14:m>
-                <a:r>
-                  <a:rPr lang="fa-IR" dirty="0">
-                    <a:latin typeface="Tahoma"/>
-                    <a:cs typeface="Tahoma"/>
-                  </a:rPr>
-                  <a:t> MPa؛ انتهاها تکیه‌گاه ساده و عایق.</a:t>
-                </a:r>
-              </a:p>
-              <a:p>
-                <a:pPr lvl="0" rtl="1" algn="r"/>
-                <a14:m>
-                  <m:oMath xmlns:m="http://schemas.openxmlformats.org/officeDocument/2006/math">
-                    <m:sSup>
-                      <m:e>
-                        <m:r>
-                          <m:t>τ</m:t>
-                        </m:r>
-                      </m:e>
-                      <m:sup>
-                        <m:r>
-                          <m:rPr>
-                            <m:sty m:val="p"/>
-                          </m:rPr>
-                          <m:t>*</m:t>
-                        </m:r>
-                      </m:sup>
-                    </m:sSup>
-                    <m:r>
-                      <m:rPr>
-                        <m:sty m:val="p"/>
-                      </m:rPr>
-                      <m:t>≈</m:t>
-                    </m:r>
-                    <m:r>
-                      <m:t>0.15</m:t>
-                    </m:r>
-                  </m:oMath>
-                </a14:m>
-                <a:r>
-                  <a:rPr lang="fa-IR" dirty="0">
-                    <a:latin typeface="Tahoma"/>
-                    <a:cs typeface="Tahoma"/>
-                  </a:rPr>
-                  <a:t> (معادل </a:t>
-                </a:r>
-                <a14:m>
-                  <m:oMath xmlns:m="http://schemas.openxmlformats.org/officeDocument/2006/math">
-                    <m:sSub>
-                      <m:e>
-                        <m:r>
-                          <m:t>τ</m:t>
-                        </m:r>
-                      </m:e>
-                      <m:sub>
-                        <m:r>
-                          <m:t>0</m:t>
-                        </m:r>
-                      </m:sub>
-                    </m:sSub>
-                    <m:r>
-                      <m:rPr>
-                        <m:sty m:val="p"/>
-                      </m:rPr>
-                      <m:t>=</m:t>
-                    </m:r>
-                    <m:r>
-                      <m:t>418</m:t>
-                    </m:r>
-                  </m:oMath>
-                </a14:m>
-                <a:r>
-                  <a:rPr lang="fa-IR" dirty="0">
-                    <a:latin typeface="Tahoma"/>
-                    <a:cs typeface="Tahoma"/>
-                  </a:rPr>
-                  <a:t> s)؛ زمان کل ۳۰۰۰ ثانیه.</a:t>
-                </a:r>
-              </a:p>
-              <a:p>
-                <a:pPr lvl="0" rtl="1" algn="r"/>
-                <a:r>
-                  <a:rPr lang="fa-IR" dirty="0">
-                    <a:latin typeface="Tahoma"/>
-                    <a:cs typeface="Tahoma"/>
-                  </a:rPr>
-                  <a:t>خواص: </a:t>
-                </a:r>
-                <a:r>
-                  <a:rPr b="1" lang="fa-IR" dirty="0">
-                    <a:latin typeface="Tahoma"/>
-                    <a:cs typeface="Tahoma"/>
-                  </a:rPr>
-                  <a:t>هالپین-تسای</a:t>
-                </a:r>
-                <a:r>
-                  <a:rPr lang="fa-IR" dirty="0">
-                    <a:latin typeface="Tahoma"/>
-                    <a:cs typeface="Tahoma"/>
-                  </a:rPr>
-                  <a:t> + قانون مخلوط‌ها؛ تخلخل: </a:t>
-                </a:r>
-                <a:r>
-                  <a:rPr b="1" lang="fa-IR" dirty="0">
-                    <a:latin typeface="Tahoma"/>
-                    <a:cs typeface="Tahoma"/>
-                  </a:rPr>
-                  <a:t>سلول باز</a:t>
-                </a:r>
-                <a:r>
-                  <a:rPr lang="fa-IR" dirty="0">
-                    <a:latin typeface="Tahoma"/>
-                    <a:cs typeface="Tahoma"/>
-                  </a:rPr>
-                  <a:t>.</a:t>
-                </a:r>
-              </a:p>
-            </p:txBody>
-          </p:sp>
-        </mc:Choice>
-      </mc:AlternateContent>
-    </p:spTree>
-  </p:cSld>
-</p:sld>
-</file>
-
-<file path=ppt/slides/slide14.xml><?xml version="1.0" encoding="utf-8"?>
-<p:sld xmlns:a="http://schemas.openxmlformats.org/drawingml/2006/main" xmlns:r="http://schemas.openxmlformats.org/officeDocument/2006/relationships" xmlns:p="http://schemas.openxmlformats.org/presentationml/2006/main">
-  <p:cSld>
-    <p:spTree>
-      <p:nvGrpSpPr>
-        <p:cNvPr id="1" name=""/>
-        <p:cNvGrpSpPr/>
-        <p:nvPr/>
-      </p:nvGrpSpPr>
-      <p:grpSpPr>
-        <a:xfrm>
-          <a:off x="0" y="0"/>
-          <a:ext cx="0" cy="0"/>
-          <a:chOff x="0" y="0"/>
-          <a:chExt cx="0" cy="0"/>
-        </a:xfrm>
-      </p:grpSpPr>
-      <p:sp>
-        <p:nvSpPr>
-          <p:cNvPr id="2" name="Title 1"/>
-          <p:cNvSpPr>
-            <a:spLocks noGrp="1"/>
-          </p:cNvSpPr>
-          <p:nvPr>
-            <p:ph type="title"/>
-          </p:nvPr>
-        </p:nvSpPr>
-        <p:spPr/>
-        <p:txBody>
-          <a:bodyPr/>
-          <a:lstStyle/>
-          <a:p>
-            <a:pPr lvl="0" indent="0" marL="0" rtl="1" algn="r">
-              <a:buNone/>
-            </a:pPr>
-            <a:r>
-              <a:rPr lang="fa-IR" dirty="0">
-                <a:latin typeface="Tahoma"/>
-                <a:cs typeface="Tahoma"/>
-              </a:rPr>
-              <a:t>پنج الگوی توزیع گرافن در ضخامت</a:t>
-            </a:r>
-          </a:p>
-        </p:txBody>
-      </p:sp>
-      <p:pic>
-        <p:nvPicPr>
-          <p:cNvPr descr="../figures_ch123/GPL_patterns_schematic.png" id="0" name="Picture 1"/>
-          <p:cNvPicPr>
-            <a:picLocks noGrp="1" noChangeAspect="1"/>
-          </p:cNvPicPr>
-          <p:nvPr/>
-        </p:nvPicPr>
-        <p:blipFill>
-          <a:blip r:embed="rId2"/>
-          <a:stretch>
-            <a:fillRect/>
-          </a:stretch>
-        </p:blipFill>
-        <p:spPr bwMode="auto">
-          <a:xfrm>
-            <a:off x="2374900" y="1193800"/>
-            <a:ext cx="4381500" cy="3390900"/>
-          </a:xfrm>
-          <a:prstGeom prst="rect">
-            <a:avLst/>
-          </a:prstGeom>
-          <a:noFill/>
-          <a:ln w="9525">
-            <a:noFill/>
-            <a:headEnd/>
-            <a:tailEnd/>
-          </a:ln>
-        </p:spPr>
-      </p:pic>
-    </p:spTree>
-  </p:cSld>
-</p:sld>
-</file>
-
-<file path=ppt/slides/slide15.xml><?xml version="1.0" encoding="utf-8"?>
-<p:sld xmlns:a="http://schemas.openxmlformats.org/drawingml/2006/main" xmlns:r="http://schemas.openxmlformats.org/officeDocument/2006/relationships" xmlns:p="http://schemas.openxmlformats.org/presentationml/2006/main">
-  <p:cSld>
-    <p:spTree>
-      <p:nvGrpSpPr>
-        <p:cNvPr id="1" name=""/>
-        <p:cNvGrpSpPr/>
-        <p:nvPr/>
-      </p:nvGrpSpPr>
-      <p:grpSpPr>
-        <a:xfrm>
-          <a:off x="0" y="0"/>
-          <a:ext cx="0" cy="0"/>
-          <a:chOff x="0" y="0"/>
-          <a:chExt cx="0" cy="0"/>
-        </a:xfrm>
-      </p:grpSpPr>
-      <p:sp>
-        <p:nvSpPr>
-          <p:cNvPr id="2" name="Title 1"/>
-          <p:cNvSpPr>
-            <a:spLocks noGrp="1"/>
-          </p:cNvSpPr>
-          <p:nvPr>
-            <p:ph type="title"/>
-          </p:nvPr>
-        </p:nvSpPr>
-        <p:spPr/>
-        <p:txBody>
-          <a:bodyPr/>
-          <a:lstStyle/>
-          <a:p>
-            <a:pPr lvl="0" indent="0" marL="0" rtl="1" algn="r">
-              <a:buNone/>
-            </a:pPr>
-            <a:r>
-              <a:rPr lang="fa-IR" dirty="0">
-                <a:latin typeface="Tahoma"/>
-                <a:cs typeface="Tahoma"/>
-              </a:rPr>
-              <a:t>پنج الگوی توزیع تخلخل در ضخامت</a:t>
-            </a:r>
-          </a:p>
-        </p:txBody>
-      </p:sp>
-      <p:pic>
-        <p:nvPicPr>
-          <p:cNvPr descr="../figures_ch123/porosity_patterns_schematic.png" id="0" name="Picture 1"/>
-          <p:cNvPicPr>
-            <a:picLocks noGrp="1" noChangeAspect="1"/>
-          </p:cNvPicPr>
-          <p:nvPr/>
-        </p:nvPicPr>
-        <p:blipFill>
-          <a:blip r:embed="rId3"/>
-          <a:stretch>
-            <a:fillRect/>
-          </a:stretch>
-        </p:blipFill>
-        <p:spPr bwMode="auto">
-          <a:xfrm>
-            <a:off x="2070100" y="1193800"/>
-            <a:ext cx="5016500" cy="3390900"/>
-          </a:xfrm>
-          <a:prstGeom prst="rect">
-            <a:avLst/>
-          </a:prstGeom>
-          <a:noFill/>
-          <a:ln w="9525">
-            <a:noFill/>
-            <a:headEnd/>
-            <a:tailEnd/>
-          </a:ln>
-        </p:spPr>
-      </p:pic>
-    </p:spTree>
-  </p:cSld>
-</p:sld>
-</file>
-
-<file path=ppt/slides/slide16.xml><?xml version="1.0" encoding="utf-8"?>
-<p:sld xmlns:a="http://schemas.openxmlformats.org/drawingml/2006/main" xmlns:r="http://schemas.openxmlformats.org/officeDocument/2006/relationships" xmlns:p="http://schemas.openxmlformats.org/presentationml/2006/main">
-  <p:cSld>
-    <p:spTree>
-      <p:nvGrpSpPr>
-        <p:cNvPr id="1" name=""/>
-        <p:cNvGrpSpPr/>
-        <p:nvPr/>
-      </p:nvGrpSpPr>
-      <p:grpSpPr>
-        <a:xfrm>
-          <a:off x="0" y="0"/>
-          <a:ext cx="0" cy="0"/>
-          <a:chOff x="0" y="0"/>
-          <a:chExt cx="0" cy="0"/>
-        </a:xfrm>
-      </p:grpSpPr>
-      <p:sp>
-        <p:nvSpPr>
-          <p:cNvPr id="2" name="Title 1"/>
-          <p:cNvSpPr>
-            <a:spLocks noGrp="1"/>
-          </p:cNvSpPr>
-          <p:nvPr>
-            <p:ph type="title"/>
-          </p:nvPr>
-        </p:nvSpPr>
-        <p:spPr/>
-        <p:txBody>
-          <a:bodyPr/>
-          <a:lstStyle/>
-          <a:p>
-            <a:pPr lvl="0" indent="0" marL="0" rtl="1" algn="r">
-              <a:buNone/>
-            </a:pPr>
-            <a:r>
-              <a:rPr lang="fa-IR" dirty="0">
-                <a:latin typeface="Tahoma"/>
-                <a:cs typeface="Tahoma"/>
-              </a:rPr>
-              <a:t>معادلهٔ انرژی لرد–شولمن</a:t>
+              <a:t>معادلهٔ انرژی لرد-شولمن: گرما به‌صورت موج</a:t>
             </a:r>
           </a:p>
         </p:txBody>
@@ -7457,7 +5917,7 @@
 </p:sld>
 </file>
 
-<file path=ppt/slides/slide17.xml><?xml version="1.0" encoding="utf-8"?>
+<file path=ppt/slides/slide11.xml><?xml version="1.0" encoding="utf-8"?>
 <p:sld xmlns:a="http://schemas.openxmlformats.org/drawingml/2006/main" xmlns:r="http://schemas.openxmlformats.org/officeDocument/2006/relationships" xmlns:p="http://schemas.openxmlformats.org/presentationml/2006/main">
   <p:cSld>
     <p:spTree>
@@ -7708,7 +6168,7 @@
 </p:sld>
 </file>
 
-<file path=ppt/slides/slide18.xml><?xml version="1.0" encoding="utf-8"?>
+<file path=ppt/slides/slide12.xml><?xml version="1.0" encoding="utf-8"?>
 <p:sld xmlns:a="http://schemas.openxmlformats.org/drawingml/2006/main" xmlns:r="http://schemas.openxmlformats.org/officeDocument/2006/relationships" xmlns:p="http://schemas.openxmlformats.org/presentationml/2006/main">
   <p:cSld>
     <p:spTree>
@@ -7788,7 +6248,7 @@
 </p:sld>
 </file>
 
-<file path=ppt/slides/slide19.xml><?xml version="1.0" encoding="utf-8"?>
+<file path=ppt/slides/slide13.xml><?xml version="1.0" encoding="utf-8"?>
 <p:sld xmlns:a="http://schemas.openxmlformats.org/drawingml/2006/main" xmlns:r="http://schemas.openxmlformats.org/officeDocument/2006/relationships" xmlns:p="http://schemas.openxmlformats.org/presentationml/2006/main">
   <p:cSld>
     <p:spTree>
@@ -7868,153 +6328,7 @@
 </p:sld>
 </file>
 
-<file path=ppt/slides/slide2.xml><?xml version="1.0" encoding="utf-8"?>
-<p:sld xmlns:a="http://schemas.openxmlformats.org/drawingml/2006/main" xmlns:r="http://schemas.openxmlformats.org/officeDocument/2006/relationships" xmlns:p="http://schemas.openxmlformats.org/presentationml/2006/main">
-  <p:cSld>
-    <p:spTree>
-      <p:nvGrpSpPr>
-        <p:cNvPr id="1" name=""/>
-        <p:cNvGrpSpPr/>
-        <p:nvPr/>
-      </p:nvGrpSpPr>
-      <p:grpSpPr>
-        <a:xfrm>
-          <a:off x="0" y="0"/>
-          <a:ext cx="0" cy="0"/>
-          <a:chOff x="0" y="0"/>
-          <a:chExt cx="0" cy="0"/>
-        </a:xfrm>
-      </p:grpSpPr>
-      <p:sp>
-        <p:nvSpPr>
-          <p:cNvPr id="2" name="Title 1"/>
-          <p:cNvSpPr>
-            <a:spLocks noGrp="1"/>
-          </p:cNvSpPr>
-          <p:nvPr>
-            <p:ph type="title"/>
-          </p:nvPr>
-        </p:nvSpPr>
-        <p:spPr/>
-        <p:txBody>
-          <a:bodyPr/>
-          <a:lstStyle/>
-          <a:p>
-            <a:pPr lvl="0" indent="0" marL="0" rtl="1" algn="r">
-              <a:buNone/>
-            </a:pPr>
-            <a:r>
-              <a:rPr lang="fa-IR" dirty="0">
-                <a:latin typeface="Tahoma"/>
-                <a:cs typeface="Tahoma"/>
-              </a:rPr>
-              <a:t>فهرست مطالب</a:t>
-            </a:r>
-          </a:p>
-        </p:txBody>
-      </p:sp>
-      <p:sp>
-        <p:nvSpPr>
-          <p:cNvPr id="3" name="Content Placeholder 2"/>
-          <p:cNvSpPr>
-            <a:spLocks noGrp="1"/>
-          </p:cNvSpPr>
-          <p:nvPr>
-            <p:ph idx="1"/>
-          </p:nvPr>
-        </p:nvSpPr>
-        <p:spPr/>
-        <p:txBody>
-          <a:bodyPr/>
-          <a:lstStyle/>
-          <a:p>
-            <a:pPr lvl="0" rtl="1" algn="r"/>
-            <a:r>
-              <a:rPr lang="fa-IR" dirty="0">
-                <a:latin typeface="Tahoma"/>
-                <a:cs typeface="Tahoma"/>
-              </a:rPr>
-              <a:t>بیان مسئله و هدف پژوهش</a:t>
-            </a:r>
-          </a:p>
-          <a:p>
-            <a:pPr lvl="0" rtl="1" algn="r"/>
-            <a:r>
-              <a:rPr lang="fa-IR" dirty="0">
-                <a:latin typeface="Tahoma"/>
-                <a:cs typeface="Tahoma"/>
-              </a:rPr>
-              <a:t>پیشینهٔ پژوهش: تئوری‌ها، سازه‌های مدرج، مواد متخلخل، ترموالاستیسیتهٔ تعمیم‌یافته</a:t>
-            </a:r>
-          </a:p>
-          <a:p>
-            <a:pPr lvl="0" rtl="1" algn="r"/>
-            <a:r>
-              <a:rPr lang="fa-IR" dirty="0">
-                <a:latin typeface="Tahoma"/>
-                <a:cs typeface="Tahoma"/>
-              </a:rPr>
-              <a:t>شکاف تحقیقاتی و جایگاه پژوهش</a:t>
-            </a:r>
-          </a:p>
-          <a:p>
-            <a:pPr lvl="0" rtl="1" algn="r"/>
-            <a:r>
-              <a:rPr lang="fa-IR" dirty="0">
-                <a:latin typeface="Tahoma"/>
-                <a:cs typeface="Tahoma"/>
-              </a:rPr>
-              <a:t>مدل‌سازی: هندسه، مواد و الگوها</a:t>
-            </a:r>
-          </a:p>
-          <a:p>
-            <a:pPr lvl="0" rtl="1" algn="r"/>
-            <a:r>
-              <a:rPr lang="fa-IR" dirty="0">
-                <a:latin typeface="Tahoma"/>
-                <a:cs typeface="Tahoma"/>
-              </a:rPr>
-              <a:t>معادلات حاکم و روش حل عددی</a:t>
-            </a:r>
-          </a:p>
-          <a:p>
-            <a:pPr lvl="0" rtl="1" algn="r"/>
-            <a:r>
-              <a:rPr lang="fa-IR" dirty="0">
-                <a:latin typeface="Tahoma"/>
-                <a:cs typeface="Tahoma"/>
-              </a:rPr>
-              <a:t>صحت‌سنجی و همگرایی</a:t>
-            </a:r>
-          </a:p>
-          <a:p>
-            <a:pPr lvl="0" rtl="1" algn="r"/>
-            <a:r>
-              <a:rPr lang="fa-IR" dirty="0">
-                <a:latin typeface="Tahoma"/>
-                <a:cs typeface="Tahoma"/>
-              </a:rPr>
-              <a:t>نتایج و بحث</a:t>
-            </a:r>
-          </a:p>
-          <a:p>
-            <a:pPr lvl="0" rtl="1" algn="r"/>
-            <a:r>
-              <a:rPr lang="fa-IR" dirty="0">
-                <a:latin typeface="Tahoma"/>
-                <a:cs typeface="Tahoma"/>
-              </a:rPr>
-              <a:t>نوآوری‌ها، نتیجه‌گیری و پیشنهادها</a:t>
-            </a:r>
-          </a:p>
-        </p:txBody>
-      </p:sp>
-    </p:spTree>
-  </p:cSld>
-</p:sld>
-</file>
-
-<file path=ppt/slides/slide20.xml><?xml version="1.0" encoding="utf-8"?>
+<file path=ppt/slides/slide14.xml><?xml version="1.0" encoding="utf-8"?>
 <p:sld xmlns:a="http://schemas.openxmlformats.org/drawingml/2006/main" xmlns:r="http://schemas.openxmlformats.org/officeDocument/2006/relationships" xmlns:p="http://schemas.openxmlformats.org/presentationml/2006/main">
   <p:cSld>
     <p:spTree>
@@ -8337,7 +6651,7 @@
 </p:sld>
 </file>
 
-<file path=ppt/slides/slide21.xml><?xml version="1.0" encoding="utf-8"?>
+<file path=ppt/slides/slide15.xml><?xml version="1.0" encoding="utf-8"?>
 <p:sld xmlns:a="http://schemas.openxmlformats.org/drawingml/2006/main" xmlns:r="http://schemas.openxmlformats.org/officeDocument/2006/relationships" xmlns:p="http://schemas.openxmlformats.org/presentationml/2006/main">
   <p:cSld>
     <p:spTree>
@@ -8417,7 +6731,7 @@
 </p:sld>
 </file>
 
-<file path=ppt/slides/slide22.xml><?xml version="1.0" encoding="utf-8"?>
+<file path=ppt/slides/slide16.xml><?xml version="1.0" encoding="utf-8"?>
 <p:sld xmlns:a="http://schemas.openxmlformats.org/drawingml/2006/main" xmlns:r="http://schemas.openxmlformats.org/officeDocument/2006/relationships" xmlns:p="http://schemas.openxmlformats.org/presentationml/2006/main">
   <p:cSld>
     <p:spTree>
@@ -8497,7 +6811,7 @@
 </p:sld>
 </file>
 
-<file path=ppt/slides/slide23.xml><?xml version="1.0" encoding="utf-8"?>
+<file path=ppt/slides/slide17.xml><?xml version="1.0" encoding="utf-8"?>
 <p:sld xmlns:a="http://schemas.openxmlformats.org/drawingml/2006/main" xmlns:r="http://schemas.openxmlformats.org/officeDocument/2006/relationships" xmlns:p="http://schemas.openxmlformats.org/presentationml/2006/main">
   <p:cSld>
     <p:spTree>
@@ -8753,7 +7067,7 @@
 </p:sld>
 </file>
 
-<file path=ppt/slides/slide24.xml><?xml version="1.0" encoding="utf-8"?>
+<file path=ppt/slides/slide18.xml><?xml version="1.0" encoding="utf-8"?>
 <p:sld xmlns:a="http://schemas.openxmlformats.org/drawingml/2006/main" xmlns:r="http://schemas.openxmlformats.org/officeDocument/2006/relationships" xmlns:p="http://schemas.openxmlformats.org/presentationml/2006/main">
   <p:cSld>
     <p:spTree>
@@ -8926,7 +7240,7 @@
 </p:sld>
 </file>
 
-<file path=ppt/slides/slide25.xml><?xml version="1.0" encoding="utf-8"?>
+<file path=ppt/slides/slide19.xml><?xml version="1.0" encoding="utf-8"?>
 <p:sld xmlns:a="http://schemas.openxmlformats.org/drawingml/2006/main" xmlns:r="http://schemas.openxmlformats.org/officeDocument/2006/relationships" xmlns:p="http://schemas.openxmlformats.org/presentationml/2006/main">
   <p:cSld>
     <p:spTree>
@@ -9089,7 +7403,143 @@
 </p:sld>
 </file>
 
-<file path=ppt/slides/slide26.xml><?xml version="1.0" encoding="utf-8"?>
+<file path=ppt/slides/slide2.xml><?xml version="1.0" encoding="utf-8"?>
+<p:sld xmlns:a="http://schemas.openxmlformats.org/drawingml/2006/main" xmlns:r="http://schemas.openxmlformats.org/officeDocument/2006/relationships" xmlns:p="http://schemas.openxmlformats.org/presentationml/2006/main">
+  <p:cSld>
+    <p:spTree>
+      <p:nvGrpSpPr>
+        <p:cNvPr id="1" name=""/>
+        <p:cNvGrpSpPr/>
+        <p:nvPr/>
+      </p:nvGrpSpPr>
+      <p:grpSpPr>
+        <a:xfrm>
+          <a:off x="0" y="0"/>
+          <a:ext cx="0" cy="0"/>
+          <a:chOff x="0" y="0"/>
+          <a:chExt cx="0" cy="0"/>
+        </a:xfrm>
+      </p:grpSpPr>
+      <p:sp>
+        <p:nvSpPr>
+          <p:cNvPr id="2" name="Title 1"/>
+          <p:cNvSpPr>
+            <a:spLocks noGrp="1"/>
+          </p:cNvSpPr>
+          <p:nvPr>
+            <p:ph type="title"/>
+          </p:nvPr>
+        </p:nvSpPr>
+        <p:spPr/>
+        <p:txBody>
+          <a:bodyPr/>
+          <a:lstStyle/>
+          <a:p>
+            <a:pPr lvl="0" indent="0" marL="0" rtl="1" algn="r">
+              <a:buNone/>
+            </a:pPr>
+            <a:r>
+              <a:rPr lang="fa-IR" dirty="0">
+                <a:latin typeface="Tahoma"/>
+                <a:cs typeface="Tahoma"/>
+              </a:rPr>
+              <a:t>فهرست مطالب</a:t>
+            </a:r>
+          </a:p>
+        </p:txBody>
+      </p:sp>
+      <p:sp>
+        <p:nvSpPr>
+          <p:cNvPr id="3" name="Content Placeholder 2"/>
+          <p:cNvSpPr>
+            <a:spLocks noGrp="1"/>
+          </p:cNvSpPr>
+          <p:nvPr>
+            <p:ph idx="1"/>
+          </p:nvPr>
+        </p:nvSpPr>
+        <p:spPr/>
+        <p:txBody>
+          <a:bodyPr/>
+          <a:lstStyle/>
+          <a:p>
+            <a:pPr lvl="0" rtl="1" algn="r"/>
+            <a:r>
+              <a:rPr lang="fa-IR" dirty="0">
+                <a:latin typeface="Tahoma"/>
+                <a:cs typeface="Tahoma"/>
+              </a:rPr>
+              <a:t>بیان مسئله و هدف پژوهش</a:t>
+            </a:r>
+          </a:p>
+          <a:p>
+            <a:pPr lvl="0" rtl="1" algn="r"/>
+            <a:r>
+              <a:rPr lang="fa-IR" dirty="0">
+                <a:latin typeface="Tahoma"/>
+                <a:cs typeface="Tahoma"/>
+              </a:rPr>
+              <a:t>پیشینه و شکاف تحقیقاتی</a:t>
+            </a:r>
+          </a:p>
+          <a:p>
+            <a:pPr lvl="0" rtl="1" algn="r"/>
+            <a:r>
+              <a:rPr lang="fa-IR" dirty="0">
+                <a:latin typeface="Tahoma"/>
+                <a:cs typeface="Tahoma"/>
+              </a:rPr>
+              <a:t>مدل‌سازی: هندسه، مواد و الگوها</a:t>
+            </a:r>
+          </a:p>
+          <a:p>
+            <a:pPr lvl="0" rtl="1" algn="r"/>
+            <a:r>
+              <a:rPr lang="fa-IR" dirty="0">
+                <a:latin typeface="Tahoma"/>
+                <a:cs typeface="Tahoma"/>
+              </a:rPr>
+              <a:t>معادلات حاکم و روش حل عددی</a:t>
+            </a:r>
+          </a:p>
+          <a:p>
+            <a:pPr lvl="0" rtl="1" algn="r"/>
+            <a:r>
+              <a:rPr lang="fa-IR" dirty="0">
+                <a:latin typeface="Tahoma"/>
+                <a:cs typeface="Tahoma"/>
+              </a:rPr>
+              <a:t>صحت‌سنجی و همگرایی</a:t>
+            </a:r>
+          </a:p>
+          <a:p>
+            <a:pPr lvl="0" rtl="1" algn="r"/>
+            <a:r>
+              <a:rPr lang="fa-IR" dirty="0">
+                <a:latin typeface="Tahoma"/>
+                <a:cs typeface="Tahoma"/>
+              </a:rPr>
+              <a:t>نتایج و بحث</a:t>
+            </a:r>
+          </a:p>
+          <a:p>
+            <a:pPr lvl="0" rtl="1" algn="r"/>
+            <a:r>
+              <a:rPr lang="fa-IR" dirty="0">
+                <a:latin typeface="Tahoma"/>
+                <a:cs typeface="Tahoma"/>
+              </a:rPr>
+              <a:t>نوآوری‌ها، نتیجه‌گیری و پیشنهادها</a:t>
+            </a:r>
+          </a:p>
+        </p:txBody>
+      </p:sp>
+    </p:spTree>
+  </p:cSld>
+</p:sld>
+</file>
+
+<file path=ppt/slides/slide20.xml><?xml version="1.0" encoding="utf-8"?>
 <p:sld xmlns:a="http://schemas.openxmlformats.org/drawingml/2006/main" xmlns:r="http://schemas.openxmlformats.org/officeDocument/2006/relationships" xmlns:p="http://schemas.openxmlformats.org/presentationml/2006/main">
   <p:cSld>
     <p:spTree>
@@ -9266,7 +7716,7 @@
 </p:sld>
 </file>
 
-<file path=ppt/slides/slide27.xml><?xml version="1.0" encoding="utf-8"?>
+<file path=ppt/slides/slide21.xml><?xml version="1.0" encoding="utf-8"?>
 <p:sld xmlns:a="http://schemas.openxmlformats.org/drawingml/2006/main" xmlns:r="http://schemas.openxmlformats.org/officeDocument/2006/relationships" xmlns:p="http://schemas.openxmlformats.org/presentationml/2006/main">
   <p:cSld>
     <p:spTree>
@@ -9429,7 +7879,7 @@
 </p:sld>
 </file>
 
-<file path=ppt/slides/slide28.xml><?xml version="1.0" encoding="utf-8"?>
+<file path=ppt/slides/slide22.xml><?xml version="1.0" encoding="utf-8"?>
 <p:sld xmlns:a="http://schemas.openxmlformats.org/drawingml/2006/main" xmlns:r="http://schemas.openxmlformats.org/officeDocument/2006/relationships" xmlns:p="http://schemas.openxmlformats.org/presentationml/2006/main">
   <p:cSld>
     <p:spTree>
@@ -9622,7 +8072,7 @@
 </p:sld>
 </file>
 
-<file path=ppt/slides/slide29.xml><?xml version="1.0" encoding="utf-8"?>
+<file path=ppt/slides/slide23.xml><?xml version="1.0" encoding="utf-8"?>
 <p:sld xmlns:a="http://schemas.openxmlformats.org/drawingml/2006/main" xmlns:r="http://schemas.openxmlformats.org/officeDocument/2006/relationships" xmlns:p="http://schemas.openxmlformats.org/presentationml/2006/main">
   <p:cSld>
     <p:spTree>
@@ -9785,7 +8235,7 @@
 </p:sld>
 </file>
 
-<file path=ppt/slides/slide3.xml><?xml version="1.0" encoding="utf-8"?>
+<file path=ppt/slides/slide24.xml><?xml version="1.0" encoding="utf-8"?>
 <p:sld xmlns:a="http://schemas.openxmlformats.org/drawingml/2006/main" xmlns:r="http://schemas.openxmlformats.org/officeDocument/2006/relationships" xmlns:p="http://schemas.openxmlformats.org/presentationml/2006/main">
   <p:cSld>
     <p:spTree>
@@ -9812,112 +8262,6 @@
             <p:ph type="title"/>
           </p:nvPr>
         </p:nvSpPr>
-        <p:spPr/>
-        <p:txBody>
-          <a:bodyPr/>
-          <a:lstStyle/>
-          <a:p>
-            <a:pPr lvl="0" indent="0" marL="0" rtl="1" algn="r">
-              <a:buNone/>
-            </a:pPr>
-            <a:r>
-              <a:rPr lang="fa-IR" dirty="0">
-                <a:latin typeface="Tahoma"/>
-                <a:cs typeface="Tahoma"/>
-              </a:rPr>
-              <a:t>استوانه‌های جدارضخیم: سازه‌ای پرکاربرد در معرض بارهای حرارتی سریع</a:t>
-            </a:r>
-          </a:p>
-        </p:txBody>
-      </p:sp>
-      <p:sp>
-        <p:nvSpPr>
-          <p:cNvPr id="3" name="Content Placeholder 2"/>
-          <p:cNvSpPr>
-            <a:spLocks noGrp="1"/>
-          </p:cNvSpPr>
-          <p:nvPr>
-            <p:ph idx="1"/>
-          </p:nvPr>
-        </p:nvSpPr>
-        <p:spPr/>
-        <p:txBody>
-          <a:bodyPr/>
-          <a:lstStyle/>
-          <a:p>
-            <a:pPr lvl="0" rtl="1" algn="r"/>
-            <a:r>
-              <a:rPr lang="fa-IR" dirty="0">
-                <a:latin typeface="Tahoma"/>
-                <a:cs typeface="Tahoma"/>
-              </a:rPr>
-              <a:t>سیلندرها استوانه‌هایی توخالی و معمولاً جدارضخیم‌اند و بارهای محوری، برشی، پیچشی، خمشی، هیدرواستاتیک و هیدرودینامیک را تحمل می‌کنند.</a:t>
-            </a:r>
-          </a:p>
-          <a:p>
-            <a:pPr lvl="0" rtl="1" algn="r"/>
-            <a:r>
-              <a:rPr lang="fa-IR" dirty="0">
-                <a:latin typeface="Tahoma"/>
-                <a:cs typeface="Tahoma"/>
-              </a:rPr>
-              <a:t>کاربرد: مخازن نگهداری و انتقال سیال، فضاپیماها، رآکتورهای هسته‌ای، مبدل‌های حرارتی.</a:t>
-            </a:r>
-          </a:p>
-          <a:p>
-            <a:pPr lvl="0" rtl="1" algn="r"/>
-            <a:r>
-              <a:rPr lang="fa-IR" dirty="0">
-                <a:latin typeface="Tahoma"/>
-                <a:cs typeface="Tahoma"/>
-              </a:rPr>
-              <a:t>این اجزا اغلب در معرض بارهای حرارتیِ سریع و شدید قرار می‌گیرند.</a:t>
-            </a:r>
-          </a:p>
-          <a:p>
-            <a:pPr lvl="0" rtl="1" algn="r"/>
-            <a:r>
-              <a:rPr lang="fa-IR" dirty="0">
-                <a:latin typeface="Tahoma"/>
-                <a:cs typeface="Tahoma"/>
-              </a:rPr>
-              <a:t>پیش‌بینی دقیق دما و تنش‌های حرارتیِ گذرا برای ایمنی و طول عمر سازه حیاتی است.</a:t>
-            </a:r>
-          </a:p>
-        </p:txBody>
-      </p:sp>
-    </p:spTree>
-  </p:cSld>
-</p:sld>
-</file>
-
-<file path=ppt/slides/slide30.xml><?xml version="1.0" encoding="utf-8"?>
-<p:sld xmlns:a="http://schemas.openxmlformats.org/drawingml/2006/main" xmlns:r="http://schemas.openxmlformats.org/officeDocument/2006/relationships" xmlns:p="http://schemas.openxmlformats.org/presentationml/2006/main">
-  <p:cSld>
-    <p:spTree>
-      <p:nvGrpSpPr>
-        <p:cNvPr id="1" name=""/>
-        <p:cNvGrpSpPr/>
-        <p:nvPr/>
-      </p:nvGrpSpPr>
-      <p:grpSpPr>
-        <a:xfrm>
-          <a:off x="0" y="0"/>
-          <a:ext cx="0" cy="0"/>
-          <a:chOff x="0" y="0"/>
-          <a:chExt cx="0" cy="0"/>
-        </a:xfrm>
-      </p:grpSpPr>
-      <p:sp>
-        <p:nvSpPr>
-          <p:cNvPr id="2" name="Title 1"/>
-          <p:cNvSpPr>
-            <a:spLocks noGrp="1"/>
-          </p:cNvSpPr>
-          <p:nvPr>
-            <p:ph type="title"/>
-          </p:nvPr>
-        </p:nvSpPr>
         <p:spPr>
           <a:xfrm>
             <a:off x="457200" y="150000"/>
@@ -9936,7 +8280,7 @@
                 <a:latin typeface="Tahoma"/>
                 <a:cs typeface="Tahoma"/>
               </a:rPr>
-              <a:t>نتیجه ۶: در شوک گاوسی، بیشینهٔ دمای فوریه حدود ۲٫۵ برابر کمتر است</a:t>
+              <a:t>نتیجه ۶: در شوک گاوسی، فوریه دما را ۲٫۵ برابر کم‌برآورد می‌کند</a:t>
             </a:r>
           </a:p>
         </p:txBody>
@@ -9962,7 +8306,21 @@
                 <a:latin typeface="Tahoma"/>
                 <a:cs typeface="Tahoma"/>
               </a:rPr>
-              <a:t>در شوک کوتاه‌مدت، انتخاب مدل هدایت بر پیش‌بینی بیشینهٔ دما اثر زیادی دارد.</a:t>
+              <a:t>مدل کلاسیک در شوک کوتاه‌مدت </a:t>
+            </a:r>
+            <a:r>
+              <a:rPr b="1" lang="fa-IR" dirty="0">
+                <a:latin typeface="Tahoma"/>
+                <a:cs typeface="Tahoma"/>
+              </a:rPr>
+              <a:t>غیرمحافظه‌کارانه</a:t>
+            </a:r>
+            <a:r>
+              <a:rPr lang="fa-IR" dirty="0">
+                <a:latin typeface="Tahoma"/>
+                <a:cs typeface="Tahoma"/>
+              </a:rPr>
+              <a:t> است.</a:t>
             </a:r>
           </a:p>
           <a:p>
@@ -10026,7 +8384,7 @@
 </p:sld>
 </file>
 
-<file path=ppt/slides/slide31.xml><?xml version="1.0" encoding="utf-8"?>
+<file path=ppt/slides/slide25.xml><?xml version="1.0" encoding="utf-8"?>
 <p:sld xmlns:a="http://schemas.openxmlformats.org/drawingml/2006/main" xmlns:r="http://schemas.openxmlformats.org/officeDocument/2006/relationships" xmlns:p="http://schemas.openxmlformats.org/presentationml/2006/main">
   <p:cSld>
     <p:spTree>
@@ -10182,7 +8540,7 @@
 </p:sld>
 </file>
 
-<file path=ppt/slides/slide32.xml><?xml version="1.0" encoding="utf-8"?>
+<file path=ppt/slides/slide26.xml><?xml version="1.0" encoding="utf-8"?>
 <p:sld xmlns:a="http://schemas.openxmlformats.org/drawingml/2006/main" xmlns:r="http://schemas.openxmlformats.org/officeDocument/2006/relationships" xmlns:p="http://schemas.openxmlformats.org/presentationml/2006/main">
   <p:cSld>
     <p:spTree>
@@ -10371,7 +8729,7 @@
 </p:sld>
 </file>
 
-<file path=ppt/slides/slide33.xml><?xml version="1.0" encoding="utf-8"?>
+<file path=ppt/slides/slide27.xml><?xml version="1.0" encoding="utf-8"?>
 <p:sld xmlns:a="http://schemas.openxmlformats.org/drawingml/2006/main" xmlns:r="http://schemas.openxmlformats.org/officeDocument/2006/relationships" xmlns:p="http://schemas.openxmlformats.org/presentationml/2006/main">
   <p:cSld>
     <p:spTree>
@@ -10437,7 +8795,7 @@
                 <a:latin typeface="Tahoma"/>
                 <a:cs typeface="Tahoma"/>
               </a:rPr>
-              <a:t>در </a:t>
+              <a:t>برای </a:t>
             </a:r>
             <a:r>
               <a:rPr b="1" lang="fa-IR" dirty="0">
@@ -10451,7 +8809,21 @@
                 <a:latin typeface="Tahoma"/>
                 <a:cs typeface="Tahoma"/>
               </a:rPr>
-              <a:t>، پیش‌بینی دما و تنش به انتخاب مدل هدایت حساس است؛ در پالس گاوسی فوریه بیشینهٔ دما را حدود ۲٫۵ برابر کمتر می‌دهد.</a:t>
+              <a:t>، لرد-شولمن </a:t>
+            </a:r>
+            <a:r>
+              <a:rPr b="1" lang="fa-IR" dirty="0">
+                <a:latin typeface="Tahoma"/>
+                <a:cs typeface="Tahoma"/>
+              </a:rPr>
+              <a:t>ضروری</a:t>
+            </a:r>
+            <a:r>
+              <a:rPr lang="fa-IR" dirty="0">
+                <a:latin typeface="Tahoma"/>
+                <a:cs typeface="Tahoma"/>
+              </a:rPr>
+              <a:t> است؛ فوریه دما و تنش گذرا را به‌شدت کم‌برآورد می‌کند.</a:t>
             </a:r>
           </a:p>
           <a:p>
@@ -10526,7 +8898,7 @@
 </p:sld>
 </file>
 
-<file path=ppt/slides/slide34.xml><?xml version="1.0" encoding="utf-8"?>
+<file path=ppt/slides/slide28.xml><?xml version="1.0" encoding="utf-8"?>
 <p:sld xmlns:a="http://schemas.openxmlformats.org/drawingml/2006/main" xmlns:r="http://schemas.openxmlformats.org/officeDocument/2006/relationships" xmlns:p="http://schemas.openxmlformats.org/presentationml/2006/main">
   <p:cSld>
     <p:spTree>
@@ -10743,7 +9115,7 @@
 </p:sld>
 </file>
 
-<file path=ppt/slides/slide35.xml><?xml version="1.0" encoding="utf-8"?>
+<file path=ppt/slides/slide29.xml><?xml version="1.0" encoding="utf-8"?>
 <p:sld xmlns:a="http://schemas.openxmlformats.org/drawingml/2006/main" xmlns:r="http://schemas.openxmlformats.org/officeDocument/2006/relationships" xmlns:p="http://schemas.openxmlformats.org/presentationml/2006/main">
   <p:cSld>
     <p:spTree>
@@ -10821,7 +9193,7 @@
 </p:sld>
 </file>
 
-<file path=ppt/slides/slide36.xml><?xml version="1.0" encoding="utf-8"?>
+<file path=ppt/slides/slide3.xml><?xml version="1.0" encoding="utf-8"?>
 <p:sld xmlns:a="http://schemas.openxmlformats.org/drawingml/2006/main" xmlns:r="http://schemas.openxmlformats.org/officeDocument/2006/relationships" xmlns:p="http://schemas.openxmlformats.org/presentationml/2006/main">
   <p:cSld>
     <p:spTree>
@@ -10861,17 +9233,206 @@
                 <a:latin typeface="Tahoma"/>
                 <a:cs typeface="Tahoma"/>
               </a:rPr>
-              <a:t>اسلایدهای پشتیبان</a:t>
-            </a:r>
-          </a:p>
-        </p:txBody>
-      </p:sp>
+              <a:t>چرا تئوری کلاسیک فوریه کافی نیست؟</a:t>
+            </a:r>
+          </a:p>
+        </p:txBody>
+      </p:sp>
+      <mc:AlternateContent xmlns:mc="http://schemas.openxmlformats.org/markup-compatibility/2006">
+        <mc:Choice xmlns:a14="http://schemas.microsoft.com/office/drawing/2010/main" Requires="a14">
+          <p:sp>
+            <p:nvSpPr>
+              <p:cNvPr id="3" name="Content Placeholder 2"/>
+              <p:cNvSpPr>
+                <a:spLocks noGrp="1"/>
+              </p:cNvSpPr>
+              <p:nvPr>
+                <p:ph idx="1"/>
+              </p:nvPr>
+            </p:nvSpPr>
+            <p:spPr/>
+            <p:txBody>
+              <a:bodyPr/>
+              <a:lstStyle/>
+              <a:p>
+                <a:pPr lvl="0" rtl="1" algn="r"/>
+                <a:r>
+                  <a:rPr lang="fa-IR" dirty="0">
+                    <a:latin typeface="Tahoma"/>
+                    <a:cs typeface="Tahoma"/>
+                  </a:rPr>
+                  <a:t>تئوری فوریه سرعت انتشار حرارت را </a:t>
+                </a:r>
+                <a:r>
+                  <a:rPr b="1" lang="fa-IR" dirty="0">
+                    <a:latin typeface="Tahoma"/>
+                    <a:cs typeface="Tahoma"/>
+                  </a:rPr>
+                  <a:t>بی‌نهایت</a:t>
+                </a:r>
+                <a:r>
+                  <a:rPr lang="fa-IR" dirty="0">
+                    <a:latin typeface="Tahoma"/>
+                    <a:cs typeface="Tahoma"/>
+                  </a:rPr>
+                  <a:t> فرض می‌کند.</a:t>
+                </a:r>
+              </a:p>
+              <a:p>
+                <a:pPr lvl="0" rtl="1" algn="r"/>
+                <a:r>
+                  <a:rPr lang="fa-IR" dirty="0">
+                    <a:latin typeface="Tahoma"/>
+                    <a:cs typeface="Tahoma"/>
+                  </a:rPr>
+                  <a:t>این فرض در </a:t>
+                </a:r>
+                <a:r>
+                  <a:rPr b="1" lang="fa-IR" dirty="0">
+                    <a:latin typeface="Tahoma"/>
+                    <a:cs typeface="Tahoma"/>
+                  </a:rPr>
+                  <a:t>شوک حرارتی و زمان‌های کوتاه</a:t>
+                </a:r>
+                <a:r>
+                  <a:rPr lang="fa-IR" dirty="0">
+                    <a:latin typeface="Tahoma"/>
+                    <a:cs typeface="Tahoma"/>
+                  </a:rPr>
+                  <a:t> غیرفیزیکی است.</a:t>
+                </a:r>
+              </a:p>
+              <a:p>
+                <a:pPr lvl="0" rtl="1" algn="r"/>
+                <a:r>
+                  <a:rPr lang="fa-IR" dirty="0">
+                    <a:latin typeface="Tahoma"/>
+                    <a:cs typeface="Tahoma"/>
+                  </a:rPr>
+                  <a:t>تئوری لرد-شولمن با زمان تخفیف </a:t>
+                </a:r>
+                <a14:m>
+                  <m:oMath xmlns:m="http://schemas.openxmlformats.org/officeDocument/2006/math">
+                    <m:sSub>
+                      <m:e>
+                        <m:r>
+                          <m:t>τ</m:t>
+                        </m:r>
+                      </m:e>
+                      <m:sub>
+                        <m:r>
+                          <m:t>0</m:t>
+                        </m:r>
+                      </m:sub>
+                    </m:sSub>
+                  </m:oMath>
+                </a14:m>
+                <a:r>
+                  <a:rPr lang="fa-IR" dirty="0">
+                    <a:latin typeface="Tahoma"/>
+                    <a:cs typeface="Tahoma"/>
+                  </a:rPr>
+                  <a:t> معادلهٔ انرژی را </a:t>
+                </a:r>
+                <a:r>
+                  <a:rPr b="1" lang="fa-IR" dirty="0">
+                    <a:latin typeface="Tahoma"/>
+                    <a:cs typeface="Tahoma"/>
+                  </a:rPr>
+                  <a:t>هذلولوی</a:t>
+                </a:r>
+                <a:r>
+                  <a:rPr lang="fa-IR" dirty="0">
+                    <a:latin typeface="Tahoma"/>
+                    <a:cs typeface="Tahoma"/>
+                  </a:rPr>
+                  <a:t> می‌کند: حرارت به‌صورت </a:t>
+                </a:r>
+                <a:r>
+                  <a:rPr b="1" lang="fa-IR" dirty="0">
+                    <a:latin typeface="Tahoma"/>
+                    <a:cs typeface="Tahoma"/>
+                  </a:rPr>
+                  <a:t>موج با سرعت محدود</a:t>
+                </a:r>
+                <a:r>
+                  <a:rPr lang="fa-IR" dirty="0">
+                    <a:latin typeface="Tahoma"/>
+                    <a:cs typeface="Tahoma"/>
+                  </a:rPr>
+                  <a:t> منتشر می‌شود.</a:t>
+                </a:r>
+              </a:p>
+              <a:p>
+                <a:pPr lvl="0" rtl="1" algn="r"/>
+                <a:r>
+                  <a:rPr lang="fa-IR" dirty="0">
+                    <a:latin typeface="Tahoma"/>
+                    <a:cs typeface="Tahoma"/>
+                  </a:rPr>
+                  <a:t>کاربرد: مخازن تحت فشار، محفظه‌های احتراق و سامانه‌های حفاظت حرارتی.</a:t>
+                </a:r>
+              </a:p>
+            </p:txBody>
+          </p:sp>
+        </mc:Choice>
+      </mc:AlternateContent>
     </p:spTree>
   </p:cSld>
 </p:sld>
 </file>
 
-<file path=ppt/slides/slide37.xml><?xml version="1.0" encoding="utf-8"?>
+<file path=ppt/slides/slide30.xml><?xml version="1.0" encoding="utf-8"?>
+<p:sld xmlns:a="http://schemas.openxmlformats.org/drawingml/2006/main" xmlns:r="http://schemas.openxmlformats.org/officeDocument/2006/relationships" xmlns:p="http://schemas.openxmlformats.org/presentationml/2006/main">
+  <p:cSld>
+    <p:spTree>
+      <p:nvGrpSpPr>
+        <p:cNvPr id="1" name=""/>
+        <p:cNvGrpSpPr/>
+        <p:nvPr/>
+      </p:nvGrpSpPr>
+      <p:grpSpPr>
+        <a:xfrm>
+          <a:off x="0" y="0"/>
+          <a:ext cx="0" cy="0"/>
+          <a:chOff x="0" y="0"/>
+          <a:chExt cx="0" cy="0"/>
+        </a:xfrm>
+      </p:grpSpPr>
+      <p:sp>
+        <p:nvSpPr>
+          <p:cNvPr id="2" name="Title 1"/>
+          <p:cNvSpPr>
+            <a:spLocks noGrp="1"/>
+          </p:cNvSpPr>
+          <p:nvPr>
+            <p:ph type="title"/>
+          </p:nvPr>
+        </p:nvSpPr>
+        <p:spPr/>
+        <p:txBody>
+          <a:bodyPr/>
+          <a:lstStyle/>
+          <a:p>
+            <a:pPr lvl="0" indent="0" marL="0" rtl="1" algn="r">
+              <a:buNone/>
+            </a:pPr>
+            <a:r>
+              <a:rPr lang="fa-IR" dirty="0">
+                <a:latin typeface="Tahoma"/>
+                <a:cs typeface="Tahoma"/>
+              </a:rPr>
+              <a:t>اسلایدهای پشتیبان</a:t>
+            </a:r>
+          </a:p>
+        </p:txBody>
+      </p:sp>
+    </p:spTree>
+  </p:cSld>
+</p:sld>
+</file>
+
+<file path=ppt/slides/slide31.xml><?xml version="1.0" encoding="utf-8"?>
 <p:sld xmlns:a="http://schemas.openxmlformats.org/drawingml/2006/main" xmlns:r="http://schemas.openxmlformats.org/officeDocument/2006/relationships" xmlns:p="http://schemas.openxmlformats.org/presentationml/2006/main">
   <p:cSld>
     <p:spTree>
@@ -11062,7 +9623,7 @@
 </p:sld>
 </file>
 
-<file path=ppt/slides/slide38.xml><?xml version="1.0" encoding="utf-8"?>
+<file path=ppt/slides/slide32.xml><?xml version="1.0" encoding="utf-8"?>
 <p:sld xmlns:a="http://schemas.openxmlformats.org/drawingml/2006/main" xmlns:r="http://schemas.openxmlformats.org/officeDocument/2006/relationships" xmlns:p="http://schemas.openxmlformats.org/presentationml/2006/main">
   <p:cSld>
     <p:spTree>
@@ -11255,77 +9816,200 @@
                 <a:latin typeface="Tahoma"/>
                 <a:cs typeface="Tahoma"/>
               </a:rPr>
-              <a:t>مواد نوین: گرافن برای استحکام، تخلخل برای سبکی و عایق‌بودن</a:t>
-            </a:r>
-          </a:p>
-        </p:txBody>
-      </p:sp>
-      <p:sp>
-        <p:nvSpPr>
-          <p:cNvPr id="3" name="Content Placeholder 2"/>
-          <p:cNvSpPr>
-            <a:spLocks noGrp="1"/>
-          </p:cNvSpPr>
-          <p:nvPr>
-            <p:ph idx="1"/>
-          </p:nvPr>
-        </p:nvSpPr>
-        <p:spPr/>
-        <p:txBody>
-          <a:bodyPr/>
-          <a:lstStyle/>
-          <a:p>
-            <a:pPr lvl="0" rtl="1" algn="r"/>
-            <a:r>
-              <a:rPr lang="fa-IR" dirty="0">
-                <a:latin typeface="Tahoma"/>
-                <a:cs typeface="Tahoma"/>
-              </a:rPr>
-              <a:t>نانولوله‌های کربنی (۱۹۹۱) و گرافن (۲۰۰۴): استحکام و مدول بسیار زیاد، رسانش الکتریکی و حرارتی عالی [۱].</a:t>
-            </a:r>
-          </a:p>
-          <a:p>
-            <a:pPr lvl="0" rtl="1" algn="r"/>
-            <a:r>
-              <a:rPr lang="fa-IR" dirty="0">
-                <a:latin typeface="Tahoma"/>
-                <a:cs typeface="Tahoma"/>
-              </a:rPr>
-              <a:t>نانوکامپوزیت‌های گرافنی از کامپوزیت‌های نانولوله و نانوگرافیت خواص مکانیکی بهتری نشان داده‌اند؛ سطح تماس زیاد، انتقال بار را بهبود می‌دهد.</a:t>
-            </a:r>
-          </a:p>
-          <a:p>
-            <a:pPr lvl="0" rtl="1" algn="r"/>
-            <a:r>
-              <a:rPr lang="fa-IR" dirty="0">
-                <a:latin typeface="Tahoma"/>
-                <a:cs typeface="Tahoma"/>
-              </a:rPr>
-              <a:t>مواد متخلخل: سبک، جاذب انرژی، با سطح ویژهٔ زیاد و مقاوم در برابر حرارت؛ اما تخلخل استحکام را کم می‌کند.</a:t>
-            </a:r>
-          </a:p>
-          <a:p>
-            <a:pPr lvl="0" rtl="1" algn="r"/>
-            <a:r>
-              <a:rPr lang="fa-IR" dirty="0">
-                <a:latin typeface="Tahoma"/>
-                <a:cs typeface="Tahoma"/>
-              </a:rPr>
-              <a:t>افزودن ورقه‌های گرافنی به مادهٔ متخلخل یکی از راه‌های جبران این افت است [۲].</a:t>
-            </a:r>
-          </a:p>
-          <a:p>
-            <a:pPr lvl="0" rtl="1" algn="r"/>
-            <a:r>
-              <a:rPr lang="fa-IR" dirty="0">
-                <a:latin typeface="Tahoma"/>
-                <a:cs typeface="Tahoma"/>
-              </a:rPr>
-              <a:t>ترکیب این دو در ماده‌ای مدرجِ لایه‌ای، توزیع هدفمند ماده در ضخامت را ممکن می‌کند.</a:t>
-            </a:r>
-          </a:p>
-        </p:txBody>
-      </p:sp>
+              <a:t>هدف پژوهش</a:t>
+            </a:r>
+          </a:p>
+        </p:txBody>
+      </p:sp>
+      <mc:AlternateContent xmlns:mc="http://schemas.openxmlformats.org/markup-compatibility/2006">
+        <mc:Choice xmlns:a14="http://schemas.microsoft.com/office/drawing/2010/main" Requires="a14">
+          <p:sp>
+            <p:nvSpPr>
+              <p:cNvPr id="3" name="Content Placeholder 2"/>
+              <p:cNvSpPr>
+                <a:spLocks noGrp="1"/>
+              </p:cNvSpPr>
+              <p:nvPr>
+                <p:ph idx="1"/>
+              </p:nvPr>
+            </p:nvSpPr>
+            <p:spPr/>
+            <p:txBody>
+              <a:bodyPr/>
+              <a:lstStyle/>
+              <a:p>
+                <a:pPr lvl="0" rtl="1" algn="r"/>
+                <a:r>
+                  <a:rPr lang="fa-IR" dirty="0">
+                    <a:latin typeface="Tahoma"/>
+                    <a:cs typeface="Tahoma"/>
+                  </a:rPr>
+                  <a:t>حلِ </a:t>
+                </a:r>
+                <a:r>
+                  <a:rPr b="1" lang="fa-IR" dirty="0">
+                    <a:latin typeface="Tahoma"/>
+                    <a:cs typeface="Tahoma"/>
+                  </a:rPr>
+                  <a:t>کاملاً ممزوجِ</a:t>
+                </a:r>
+                <a:r>
+                  <a:rPr lang="fa-IR" dirty="0">
+                    <a:latin typeface="Tahoma"/>
+                    <a:cs typeface="Tahoma"/>
+                  </a:rPr>
+                  <a:t> معادلات لرد-شولمن برای استوانهٔ </a:t>
+                </a:r>
+                <a:r>
+                  <a:rPr b="1" lang="fa-IR" dirty="0">
+                    <a:latin typeface="Tahoma"/>
+                    <a:cs typeface="Tahoma"/>
+                  </a:rPr>
+                  <a:t>چندلایهٔ متخلخلِ تقویت‌شده با گرافن</a:t>
+                </a:r>
+                <a:r>
+                  <a:rPr lang="fa-IR" dirty="0">
+                    <a:latin typeface="Tahoma"/>
+                    <a:cs typeface="Tahoma"/>
+                  </a:rPr>
+                  <a:t>.</a:t>
+                </a:r>
+              </a:p>
+              <a:p>
+                <a:pPr lvl="0" rtl="1" algn="r"/>
+                <a:r>
+                  <a:rPr lang="fa-IR" dirty="0">
+                    <a:latin typeface="Tahoma"/>
+                    <a:cs typeface="Tahoma"/>
+                  </a:rPr>
+                  <a:t>بررسی </a:t>
+                </a:r>
+                <a:r>
+                  <a:rPr b="1" lang="fa-IR" dirty="0">
+                    <a:latin typeface="Tahoma"/>
+                    <a:cs typeface="Tahoma"/>
+                  </a:rPr>
+                  <a:t>دما، تنش، کرنش و جابجایی</a:t>
+                </a:r>
+                <a:r>
+                  <a:rPr lang="fa-IR" dirty="0">
+                    <a:latin typeface="Tahoma"/>
+                    <a:cs typeface="Tahoma"/>
+                  </a:rPr>
+                  <a:t> در فضای دوبعدی </a:t>
+                </a:r>
+                <a14:m>
+                  <m:oMath xmlns:m="http://schemas.openxmlformats.org/officeDocument/2006/math">
+                    <m:r>
+                      <m:rPr>
+                        <m:sty m:val="p"/>
+                      </m:rPr>
+                      <m:t>(</m:t>
+                    </m:r>
+                    <m:r>
+                      <m:t>r</m:t>
+                    </m:r>
+                    <m:r>
+                      <m:rPr>
+                        <m:sty m:val="p"/>
+                      </m:rPr>
+                      <m:t>,</m:t>
+                    </m:r>
+                    <m:r>
+                      <m:t>z</m:t>
+                    </m:r>
+                    <m:r>
+                      <m:rPr>
+                        <m:sty m:val="p"/>
+                      </m:rPr>
+                      <m:t>)</m:t>
+                    </m:r>
+                  </m:oMath>
+                </a14:m>
+                <a:r>
+                  <a:rPr lang="fa-IR" dirty="0">
+                    <a:latin typeface="Tahoma"/>
+                    <a:cs typeface="Tahoma"/>
+                  </a:rPr>
+                  <a:t>.</a:t>
+                </a:r>
+              </a:p>
+              <a:p>
+                <a:pPr lvl="0" rtl="1" algn="r"/>
+                <a:r>
+                  <a:rPr lang="fa-IR" dirty="0">
+                    <a:latin typeface="Tahoma"/>
+                    <a:cs typeface="Tahoma"/>
+                  </a:rPr>
+                  <a:t>کمّی‌سازی اثر </a:t>
+                </a:r>
+                <a:r>
+                  <a:rPr b="1" lang="fa-IR" dirty="0">
+                    <a:latin typeface="Tahoma"/>
+                    <a:cs typeface="Tahoma"/>
+                  </a:rPr>
+                  <a:t>الگوهای پنج‌گانهٔ</a:t>
+                </a:r>
+                <a:r>
+                  <a:rPr lang="fa-IR" dirty="0">
+                    <a:latin typeface="Tahoma"/>
+                    <a:cs typeface="Tahoma"/>
+                  </a:rPr>
+                  <a:t> گرافن و تخلخل (UD, O, X, V, A).</a:t>
+                </a:r>
+              </a:p>
+              <a:p>
+                <a:pPr lvl="0" rtl="1" algn="r"/>
+                <a:r>
+                  <a:rPr lang="fa-IR" dirty="0">
+                    <a:latin typeface="Tahoma"/>
+                    <a:cs typeface="Tahoma"/>
+                  </a:rPr>
+                  <a:t>مقایسهٔ </a:t>
+                </a:r>
+                <a:r>
+                  <a:rPr b="1" lang="fa-IR" dirty="0">
+                    <a:latin typeface="Tahoma"/>
+                    <a:cs typeface="Tahoma"/>
+                  </a:rPr>
+                  <a:t>چهار تئوری</a:t>
+                </a:r>
+                <a:r>
+                  <a:rPr lang="fa-IR" dirty="0">
+                    <a:latin typeface="Tahoma"/>
+                    <a:cs typeface="Tahoma"/>
+                  </a:rPr>
+                  <a:t> ترموالاستیسیته.</a:t>
+                </a:r>
+              </a:p>
+              <a:p>
+                <a:pPr lvl="0" rtl="1" algn="r"/>
+                <a:r>
+                  <a:rPr lang="fa-IR" dirty="0">
+                    <a:latin typeface="Tahoma"/>
+                    <a:cs typeface="Tahoma"/>
+                  </a:rPr>
+                  <a:t>ارائهٔ یک </a:t>
+                </a:r>
+                <a:r>
+                  <a:rPr b="1" lang="fa-IR" dirty="0">
+                    <a:latin typeface="Tahoma"/>
+                    <a:cs typeface="Tahoma"/>
+                  </a:rPr>
+                  <a:t>توصیهٔ طراحی</a:t>
+                </a:r>
+                <a:r>
+                  <a:rPr lang="fa-IR" dirty="0">
+                    <a:latin typeface="Tahoma"/>
+                    <a:cs typeface="Tahoma"/>
+                  </a:rPr>
+                  <a:t> برای حفاظت حرارتی.</a:t>
+                </a:r>
+              </a:p>
+            </p:txBody>
+          </p:sp>
+        </mc:Choice>
+      </mc:AlternateContent>
     </p:spTree>
   </p:cSld>
 </p:sld>
@@ -11371,101 +10055,134 @@
                 <a:latin typeface="Tahoma"/>
                 <a:cs typeface="Tahoma"/>
               </a:rPr>
-              <a:t>مسئله: پاسخ ترموالاستیک گذرا؛ انتخاب مدل هدایت و الگوی ماده</a:t>
-            </a:r>
-          </a:p>
-        </p:txBody>
-      </p:sp>
-      <mc:AlternateContent xmlns:mc="http://schemas.openxmlformats.org/markup-compatibility/2006">
-        <mc:Choice xmlns:a14="http://schemas.microsoft.com/office/drawing/2010/main" Requires="a14">
-          <p:sp>
-            <p:nvSpPr>
-              <p:cNvPr id="3" name="Content Placeholder 2"/>
-              <p:cNvSpPr>
-                <a:spLocks noGrp="1"/>
-              </p:cNvSpPr>
-              <p:nvPr>
-                <p:ph idx="1"/>
-              </p:nvPr>
-            </p:nvSpPr>
-            <p:spPr/>
-            <p:txBody>
-              <a:bodyPr/>
-              <a:lstStyle/>
-              <a:p>
-                <a:pPr lvl="0" rtl="1" algn="r"/>
-                <a:r>
-                  <a:rPr lang="fa-IR" dirty="0">
-                    <a:latin typeface="Tahoma"/>
-                    <a:cs typeface="Tahoma"/>
-                  </a:rPr>
-                  <a:t>قانون فوریه سرعت انتشار حرارت را نامحدود می‌گیرد؛ در بارهای حرارتی پیچیده مانند شوک حرارتی و بار انفجاری دقت کافی ندارد [۳].</a:t>
-                </a:r>
-              </a:p>
-              <a:p>
-                <a:pPr lvl="0" rtl="1" algn="r"/>
-                <a:r>
-                  <a:rPr lang="fa-IR" dirty="0">
-                    <a:latin typeface="Tahoma"/>
-                    <a:cs typeface="Tahoma"/>
-                  </a:rPr>
-                  <a:t>تئوری‌های غیرممزوج، دما و جابجایی را مستقل حساب می‌کنند.</a:t>
-                </a:r>
-              </a:p>
-              <a:p>
-                <a:pPr lvl="0" rtl="1" algn="r"/>
-                <a:r>
-                  <a:rPr lang="fa-IR" dirty="0">
-                    <a:latin typeface="Tahoma"/>
-                    <a:cs typeface="Tahoma"/>
-                  </a:rPr>
-                  <a:t>برای دقت بیشتر، تئوری‌های تعمیم‌یافته و ممزوج معرفی شده‌اند؛ یکی از آن‌ها تئوری لرد–شولمن (۱۹۶۷) با زمان تخفیف </a:t>
-                </a:r>
-                <a14:m>
-                  <m:oMath xmlns:m="http://schemas.openxmlformats.org/officeDocument/2006/math">
-                    <m:sSub>
-                      <m:e>
-                        <m:r>
-                          <m:t>τ</m:t>
-                        </m:r>
-                      </m:e>
-                      <m:sub>
-                        <m:r>
-                          <m:t>0</m:t>
-                        </m:r>
-                      </m:sub>
-                    </m:sSub>
-                  </m:oMath>
-                </a14:m>
-                <a:r>
-                  <a:rPr lang="fa-IR" dirty="0">
-                    <a:latin typeface="Tahoma"/>
-                    <a:cs typeface="Tahoma"/>
-                  </a:rPr>
-                  <a:t> است [۴].</a:t>
-                </a:r>
-              </a:p>
-              <a:p>
-                <a:pPr lvl="0" rtl="1" algn="r"/>
-                <a:r>
-                  <a:rPr b="1" lang="fa-IR" dirty="0">
-                    <a:latin typeface="Tahoma"/>
-                    <a:cs typeface="Tahoma"/>
-                  </a:rPr>
-                  <a:t>مسئلهٔ این پژوهش:</a:t>
-                </a:r>
-                <a:r>
-                  <a:rPr lang="fa-IR" dirty="0">
-                    <a:latin typeface="Tahoma"/>
-                    <a:cs typeface="Tahoma"/>
-                  </a:rPr>
-                  <a:t> توزیع دما، تنش، کرنش و جابجایی در استوانهٔ متخلخلِ تقویت‌شده با پلاکت‌های گرافنی تحت بار ترمو-مکانیکی.</a:t>
-                </a:r>
-              </a:p>
-            </p:txBody>
-          </p:sp>
-        </mc:Choice>
-      </mc:AlternateContent>
+              <a:t>شکاف تحقیقاتی: حل ممزوج دوبعدی با ماتریس کامل الگوها</a:t>
+            </a:r>
+          </a:p>
+        </p:txBody>
+      </p:sp>
+      <p:sp>
+        <p:nvSpPr>
+          <p:cNvPr id="3" name="Content Placeholder 2"/>
+          <p:cNvSpPr>
+            <a:spLocks noGrp="1"/>
+          </p:cNvSpPr>
+          <p:nvPr>
+            <p:ph idx="1"/>
+          </p:nvPr>
+        </p:nvSpPr>
+        <p:spPr/>
+        <p:txBody>
+          <a:bodyPr/>
+          <a:lstStyle/>
+          <a:p>
+            <a:pPr lvl="0" rtl="1" algn="r"/>
+            <a:r>
+              <a:rPr lang="fa-IR" dirty="0">
+                <a:latin typeface="Tahoma"/>
+                <a:cs typeface="Tahoma"/>
+              </a:rPr>
+              <a:t>مطالعات پیشین: هدایت </a:t>
+            </a:r>
+            <a:r>
+              <a:rPr b="1" lang="fa-IR" dirty="0">
+                <a:latin typeface="Tahoma"/>
+                <a:cs typeface="Tahoma"/>
+              </a:rPr>
+              <a:t>کلاسیک فوریه</a:t>
+            </a:r>
+            <a:r>
+              <a:rPr lang="fa-IR" dirty="0">
+                <a:latin typeface="Tahoma"/>
+                <a:cs typeface="Tahoma"/>
+              </a:rPr>
+              <a:t>، یا حل </a:t>
+            </a:r>
+            <a:r>
+              <a:rPr b="1" lang="fa-IR" dirty="0">
+                <a:latin typeface="Tahoma"/>
+                <a:cs typeface="Tahoma"/>
+              </a:rPr>
+              <a:t>غیرممزوج</a:t>
+            </a:r>
+            <a:r>
+              <a:rPr lang="fa-IR" dirty="0">
+                <a:latin typeface="Tahoma"/>
+                <a:cs typeface="Tahoma"/>
+              </a:rPr>
+              <a:t>، یا هندسهٔ </a:t>
+            </a:r>
+            <a:r>
+              <a:rPr b="1" lang="fa-IR" dirty="0">
+                <a:latin typeface="Tahoma"/>
+                <a:cs typeface="Tahoma"/>
+              </a:rPr>
+              <a:t>یک‌بعدی</a:t>
+            </a:r>
+            <a:r>
+              <a:rPr lang="fa-IR" dirty="0">
+                <a:latin typeface="Tahoma"/>
+                <a:cs typeface="Tahoma"/>
+              </a:rPr>
+              <a:t>.</a:t>
+            </a:r>
+          </a:p>
+          <a:p>
+            <a:pPr lvl="0" rtl="1" algn="r"/>
+            <a:r>
+              <a:rPr lang="fa-IR" dirty="0">
+                <a:latin typeface="Tahoma"/>
+                <a:cs typeface="Tahoma"/>
+              </a:rPr>
+              <a:t>اثر گرافن و تخلخل غالباً </a:t>
+            </a:r>
+            <a:r>
+              <a:rPr b="1" lang="fa-IR" dirty="0">
+                <a:latin typeface="Tahoma"/>
+                <a:cs typeface="Tahoma"/>
+              </a:rPr>
+              <a:t>جداگانه</a:t>
+            </a:r>
+            <a:r>
+              <a:rPr lang="fa-IR" dirty="0">
+                <a:latin typeface="Tahoma"/>
+                <a:cs typeface="Tahoma"/>
+              </a:rPr>
+              <a:t> بررسی شده است.</a:t>
+            </a:r>
+          </a:p>
+          <a:p>
+            <a:pPr lvl="0" rtl="1" algn="r"/>
+            <a:r>
+              <a:rPr b="1" lang="fa-IR" dirty="0">
+                <a:latin typeface="Tahoma"/>
+                <a:cs typeface="Tahoma"/>
+              </a:rPr>
+              <a:t>شکاف:</a:t>
+            </a:r>
+            <a:r>
+              <a:rPr lang="fa-IR" dirty="0">
+                <a:latin typeface="Tahoma"/>
+                <a:cs typeface="Tahoma"/>
+              </a:rPr>
+              <a:t> حل ممزوج لرد-شولمن برای استوانهٔ چندلایهٔ متخلخلِ گرافنی در دو بُعد، با </a:t>
+            </a:r>
+            <a:r>
+              <a:rPr b="1" lang="fa-IR" dirty="0">
+                <a:latin typeface="Tahoma"/>
+                <a:cs typeface="Tahoma"/>
+              </a:rPr>
+              <a:t>ماتریس کاملِ برهم‌کنش الگوها</a:t>
+            </a:r>
+            <a:r>
+              <a:rPr lang="fa-IR" dirty="0">
+                <a:latin typeface="Tahoma"/>
+                <a:cs typeface="Tahoma"/>
+              </a:rPr>
+              <a:t>.</a:t>
+            </a:r>
+          </a:p>
+        </p:txBody>
+      </p:sp>
     </p:spTree>
   </p:cSld>
 </p:sld>
@@ -11511,84 +10228,41 @@
                 <a:latin typeface="Tahoma"/>
                 <a:cs typeface="Tahoma"/>
               </a:rPr>
-              <a:t>هدف و پرسش‌های پژوهش</a:t>
-            </a:r>
-          </a:p>
-        </p:txBody>
-      </p:sp>
-      <p:sp>
-        <p:nvSpPr>
-          <p:cNvPr id="3" name="Content Placeholder 2"/>
-          <p:cNvSpPr>
-            <a:spLocks noGrp="1"/>
-          </p:cNvSpPr>
-          <p:nvPr>
-            <p:ph idx="1"/>
-          </p:nvPr>
-        </p:nvSpPr>
-        <p:spPr/>
-        <p:txBody>
-          <a:bodyPr/>
-          <a:lstStyle/>
-          <a:p>
-            <a:pPr lvl="0" rtl="1" algn="r"/>
-            <a:r>
-              <a:rPr b="1" lang="fa-IR" dirty="0">
-                <a:latin typeface="Tahoma"/>
-                <a:cs typeface="Tahoma"/>
-              </a:rPr>
-              <a:t>هدف:</a:t>
-            </a:r>
-            <a:r>
-              <a:rPr lang="fa-IR" dirty="0">
-                <a:latin typeface="Tahoma"/>
-                <a:cs typeface="Tahoma"/>
-              </a:rPr>
-              <a:t> تحلیل ترموالاستیک استوانهٔ توخالیِ متخلخل تقویت‌شده با پلاکت‌های گرافنی تحت بار ترمو-مکانیکی، برای الگوهای مختلف گرافن و تخلخل در ضخامت.</a:t>
-            </a:r>
-          </a:p>
-          <a:p>
-            <a:pPr lvl="0" rtl="1" algn="r"/>
-            <a:r>
-              <a:rPr lang="fa-IR" dirty="0">
-                <a:latin typeface="Tahoma"/>
-                <a:cs typeface="Tahoma"/>
-              </a:rPr>
-              <a:t>پاسخ دما، تنش و جابجایی با سرعت متناهی موج حرارتی چه تفاوتی با هدایت فوریه دارد؟</a:t>
-            </a:r>
-          </a:p>
-          <a:p>
-            <a:pPr lvl="0" rtl="1" algn="r"/>
-            <a:r>
-              <a:rPr lang="fa-IR" dirty="0">
-                <a:latin typeface="Tahoma"/>
-                <a:cs typeface="Tahoma"/>
-              </a:rPr>
-              <a:t>الگوی گرافن و الگو و شدت تخلخل چگونه بر بیشینهٔ دما، تنش و جابجایی اثر می‌گذارند؟</a:t>
-            </a:r>
-          </a:p>
-          <a:p>
-            <a:pPr lvl="0" rtl="1" algn="r"/>
-            <a:r>
-              <a:rPr lang="fa-IR" dirty="0">
-                <a:latin typeface="Tahoma"/>
-                <a:cs typeface="Tahoma"/>
-              </a:rPr>
-              <a:t>برهم‌کنش هم‌زمان دو الگو هم‌افزاست یا خنثی‌کننده؟</a:t>
-            </a:r>
-          </a:p>
-          <a:p>
-            <a:pPr lvl="0" rtl="1" algn="r"/>
-            <a:r>
-              <a:rPr lang="fa-IR" dirty="0">
-                <a:latin typeface="Tahoma"/>
-                <a:cs typeface="Tahoma"/>
-              </a:rPr>
-              <a:t>اثر کسر وزنی، نسبت ابعادی، زمان تخفیف، تکیه‌گاه، فشار و ضخامت بر پاسخ گذرا چیست؟</a:t>
-            </a:r>
-          </a:p>
-        </p:txBody>
-      </p:sp>
+              <a:t>استوانهٔ توخالیِ هفت‌لایه با خواص متغیر در ضخامت</a:t>
+            </a:r>
+          </a:p>
+        </p:txBody>
+      </p:sp>
+      <p:pic>
+        <p:nvPicPr>
+          <p:cNvPr descr="../figures_ch123/geometry_schematic.png" id="0" name="Picture 1"/>
+          <p:cNvPicPr>
+            <a:picLocks noGrp="1" noChangeAspect="1"/>
+          </p:cNvPicPr>
+          <p:nvPr/>
+        </p:nvPicPr>
+        <p:blipFill>
+          <a:blip r:embed="rId2"/>
+          <a:stretch>
+            <a:fillRect/>
+          </a:stretch>
+        </p:blipFill>
+        <p:spPr bwMode="auto">
+          <a:xfrm>
+            <a:off x="1358900" y="1193800"/>
+            <a:ext cx="6438900" cy="3390900"/>
+          </a:xfrm>
+          <a:prstGeom prst="rect">
+            <a:avLst/>
+          </a:prstGeom>
+          <a:noFill/>
+          <a:ln w="9525">
+            <a:noFill/>
+            <a:headEnd/>
+            <a:tailEnd/>
+          </a:ln>
+        </p:spPr>
+      </p:pic>
     </p:spTree>
   </p:cSld>
 </p:sld>
@@ -11634,98 +10308,343 @@
                 <a:latin typeface="Tahoma"/>
                 <a:cs typeface="Tahoma"/>
               </a:rPr>
-              <a:t>پیشینه ۱: تئوری‌های تحلیل استوانه — از پوسته تا الاستیسیتهٔ سه‌بعدی</a:t>
-            </a:r>
-          </a:p>
-        </p:txBody>
-      </p:sp>
-      <p:sp>
-        <p:nvSpPr>
-          <p:cNvPr id="3" name="Content Placeholder 2"/>
-          <p:cNvSpPr>
-            <a:spLocks noGrp="1"/>
-          </p:cNvSpPr>
-          <p:nvPr>
-            <p:ph idx="1"/>
-          </p:nvPr>
-        </p:nvSpPr>
-        <p:spPr/>
-        <p:txBody>
-          <a:bodyPr/>
-          <a:lstStyle/>
-          <a:p>
-            <a:pPr lvl="0" rtl="1" algn="r"/>
-            <a:r>
-              <a:rPr lang="fa-IR" dirty="0">
-                <a:latin typeface="Tahoma"/>
-                <a:cs typeface="Tahoma"/>
-              </a:rPr>
-              <a:t>تئوری‌های پوسته و ورق: کلاسیک، برشی مرتبهٔ اول و مراتب بالا [۵].</a:t>
-            </a:r>
-          </a:p>
-          <a:p>
-            <a:pPr lvl="0" rtl="1" algn="r"/>
-            <a:r>
-              <a:rPr b="1" lang="fa-IR" dirty="0">
-                <a:latin typeface="Tahoma"/>
-                <a:cs typeface="Tahoma"/>
-              </a:rPr>
-              <a:t>کلاسیک:</a:t>
-            </a:r>
-            <a:r>
-              <a:rPr lang="fa-IR" dirty="0">
-                <a:latin typeface="Tahoma"/>
-                <a:cs typeface="Tahoma"/>
-              </a:rPr>
-              <a:t> از کرنش عمودی و برش عرضی صرف‌نظر می‌کند؛ با افزایش ضخامت دقتش کم می‌شود.</a:t>
-            </a:r>
-          </a:p>
-          <a:p>
-            <a:pPr lvl="0" rtl="1" algn="r"/>
-            <a:r>
-              <a:rPr b="1" lang="fa-IR" dirty="0">
-                <a:latin typeface="Tahoma"/>
-                <a:cs typeface="Tahoma"/>
-              </a:rPr>
-              <a:t>برشی مرتبهٔ اول:</a:t>
-            </a:r>
-            <a:r>
-              <a:rPr lang="fa-IR" dirty="0">
-                <a:latin typeface="Tahoma"/>
-                <a:cs typeface="Tahoma"/>
-              </a:rPr>
-              <a:t> برش عرضی و اینرسی چرخشی را وارد می‌کند اما کرنش برشی را ثابت می‌گیرد (ضریب تصحیح برشی)؛ مراتب بالاتر جملات بیشتری نگه می‌دارند.</a:t>
-            </a:r>
-          </a:p>
-          <a:p>
-            <a:pPr lvl="0" rtl="1" algn="r"/>
-            <a:r>
-              <a:rPr lang="fa-IR" dirty="0">
-                <a:latin typeface="Tahoma"/>
-                <a:cs typeface="Tahoma"/>
-              </a:rPr>
-              <a:t>مزیت پوسته‌ها: حجم محاسباتی کم؛ ضعف: افت دقت در ضخامت زیاد و در رفتار محلی.</a:t>
-            </a:r>
-          </a:p>
-          <a:p>
-            <a:pPr lvl="0" rtl="1" algn="r"/>
-            <a:r>
-              <a:rPr b="1" lang="fa-IR" dirty="0">
-                <a:latin typeface="Tahoma"/>
-                <a:cs typeface="Tahoma"/>
-              </a:rPr>
-              <a:t>راه‌حل:</a:t>
-            </a:r>
-            <a:r>
-              <a:rPr lang="fa-IR" dirty="0">
-                <a:latin typeface="Tahoma"/>
-                <a:cs typeface="Tahoma"/>
-              </a:rPr>
-              <a:t> الاستیسیتهٔ سه‌بعدی و ترموالاستیسیتهٔ سه‌بعدی — جابجایی، تنش و کرنش در هر نقطه.</a:t>
-            </a:r>
-          </a:p>
-        </p:txBody>
-      </p:sp>
+              <a:t>حالت مرجع و شرایط مرزی</a:t>
+            </a:r>
+          </a:p>
+        </p:txBody>
+      </p:sp>
+      <mc:AlternateContent xmlns:mc="http://schemas.openxmlformats.org/markup-compatibility/2006">
+        <mc:Choice xmlns:a14="http://schemas.microsoft.com/office/drawing/2010/main" Requires="a14">
+          <p:sp>
+            <p:nvSpPr>
+              <p:cNvPr id="3" name="Content Placeholder 2"/>
+              <p:cNvSpPr>
+                <a:spLocks noGrp="1"/>
+              </p:cNvSpPr>
+              <p:nvPr>
+                <p:ph idx="1"/>
+              </p:nvPr>
+            </p:nvSpPr>
+            <p:spPr/>
+            <p:txBody>
+              <a:bodyPr/>
+              <a:lstStyle/>
+              <a:p>
+                <a:pPr lvl="0" rtl="1" algn="r"/>
+                <a:r>
+                  <a:rPr lang="fa-IR" dirty="0">
+                    <a:latin typeface="Tahoma"/>
+                    <a:cs typeface="Tahoma"/>
+                  </a:rPr>
+                  <a:t>ابعاد: </a:t>
+                </a:r>
+                <a14:m>
+                  <m:oMath xmlns:m="http://schemas.openxmlformats.org/officeDocument/2006/math">
+                    <m:sSub>
+                      <m:e>
+                        <m:r>
+                          <m:t>R</m:t>
+                        </m:r>
+                      </m:e>
+                      <m:sub>
+                        <m:r>
+                          <m:t>i</m:t>
+                        </m:r>
+                      </m:sub>
+                    </m:sSub>
+                    <m:r>
+                      <m:rPr>
+                        <m:sty m:val="p"/>
+                      </m:rPr>
+                      <m:t>=</m:t>
+                    </m:r>
+                    <m:r>
+                      <m:t>1</m:t>
+                    </m:r>
+                  </m:oMath>
+                </a14:m>
+                <a:r>
+                  <a:rPr lang="fa-IR" dirty="0">
+                    <a:latin typeface="Tahoma"/>
+                    <a:cs typeface="Tahoma"/>
+                  </a:rPr>
+                  <a:t> m، </a:t>
+                </a:r>
+                <a14:m>
+                  <m:oMath xmlns:m="http://schemas.openxmlformats.org/officeDocument/2006/math">
+                    <m:sSub>
+                      <m:e>
+                        <m:r>
+                          <m:t>R</m:t>
+                        </m:r>
+                      </m:e>
+                      <m:sub>
+                        <m:r>
+                          <m:t>o</m:t>
+                        </m:r>
+                      </m:sub>
+                    </m:sSub>
+                    <m:r>
+                      <m:rPr>
+                        <m:sty m:val="p"/>
+                      </m:rPr>
+                      <m:t>=</m:t>
+                    </m:r>
+                    <m:r>
+                      <m:t>1.5</m:t>
+                    </m:r>
+                  </m:oMath>
+                </a14:m>
+                <a:r>
+                  <a:rPr lang="fa-IR" dirty="0">
+                    <a:latin typeface="Tahoma"/>
+                    <a:cs typeface="Tahoma"/>
+                  </a:rPr>
+                  <a:t> m، طول </a:t>
+                </a:r>
+                <a14:m>
+                  <m:oMath xmlns:m="http://schemas.openxmlformats.org/officeDocument/2006/math">
+                    <m:r>
+                      <m:t>L</m:t>
+                    </m:r>
+                    <m:r>
+                      <m:rPr>
+                        <m:sty m:val="p"/>
+                      </m:rPr>
+                      <m:t>=</m:t>
+                    </m:r>
+                    <m:r>
+                      <m:t>2.1</m:t>
+                    </m:r>
+                  </m:oMath>
+                </a14:m>
+                <a:r>
+                  <a:rPr lang="fa-IR" dirty="0">
+                    <a:latin typeface="Tahoma"/>
+                    <a:cs typeface="Tahoma"/>
+                  </a:rPr>
+                  <a:t> m.</a:t>
+                </a:r>
+              </a:p>
+              <a:p>
+                <a:pPr lvl="0" rtl="1" algn="r"/>
+                <a:r>
+                  <a:rPr lang="fa-IR" dirty="0">
+                    <a:latin typeface="Tahoma"/>
+                    <a:cs typeface="Tahoma"/>
+                  </a:rPr>
+                  <a:t>حرارت: سطح داخلی </a:t>
+                </a:r>
+                <a14:m>
+                  <m:oMath xmlns:m="http://schemas.openxmlformats.org/officeDocument/2006/math">
+                    <m:r>
+                      <m:t>300</m:t>
+                    </m:r>
+                    <m:r>
+                      <m:rPr>
+                        <m:sty m:val="p"/>
+                      </m:rPr>
+                      <m:t>→</m:t>
+                    </m:r>
+                    <m:r>
+                      <m:t>600</m:t>
+                    </m:r>
+                  </m:oMath>
+                </a14:m>
+                <a:r>
+                  <a:rPr lang="fa-IR" dirty="0">
+                    <a:latin typeface="Tahoma"/>
+                    <a:cs typeface="Tahoma"/>
+                  </a:rPr>
+                  <a:t> K؛ سطح خارجی همرفت با </a:t>
+                </a:r>
+                <a14:m>
+                  <m:oMath xmlns:m="http://schemas.openxmlformats.org/officeDocument/2006/math">
+                    <m:sSub>
+                      <m:e>
+                        <m:r>
+                          <m:t>h</m:t>
+                        </m:r>
+                      </m:e>
+                      <m:sub>
+                        <m:r>
+                          <m:t>c</m:t>
+                        </m:r>
+                      </m:sub>
+                    </m:sSub>
+                    <m:r>
+                      <m:rPr>
+                        <m:sty m:val="p"/>
+                      </m:rPr>
+                      <m:t>=</m:t>
+                    </m:r>
+                    <m:r>
+                      <m:t>10</m:t>
+                    </m:r>
+                  </m:oMath>
+                </a14:m>
+                <a:r>
+                  <a:rPr lang="fa-IR" dirty="0">
+                    <a:latin typeface="Tahoma"/>
+                    <a:cs typeface="Tahoma"/>
+                  </a:rPr>
+                  <a:t> W/m²K.</a:t>
+                </a:r>
+              </a:p>
+              <a:p>
+                <a:pPr lvl="0" rtl="1" algn="r"/>
+                <a:r>
+                  <a:rPr lang="fa-IR" dirty="0">
+                    <a:latin typeface="Tahoma"/>
+                    <a:cs typeface="Tahoma"/>
+                  </a:rPr>
+                  <a:t>مکانیک: فشار داخلی </a:t>
+                </a:r>
+                <a14:m>
+                  <m:oMath xmlns:m="http://schemas.openxmlformats.org/officeDocument/2006/math">
+                    <m:sSub>
+                      <m:e>
+                        <m:r>
+                          <m:t>P</m:t>
+                        </m:r>
+                      </m:e>
+                      <m:sub>
+                        <m:r>
+                          <m:t>i</m:t>
+                        </m:r>
+                      </m:sub>
+                    </m:sSub>
+                    <m:r>
+                      <m:rPr>
+                        <m:sty m:val="p"/>
+                      </m:rPr>
+                      <m:t>=</m:t>
+                    </m:r>
+                    <m:r>
+                      <m:t>50</m:t>
+                    </m:r>
+                  </m:oMath>
+                </a14:m>
+                <a:r>
+                  <a:rPr lang="fa-IR" dirty="0">
+                    <a:latin typeface="Tahoma"/>
+                    <a:cs typeface="Tahoma"/>
+                  </a:rPr>
+                  <a:t> MPa؛ انتهاها تکیه‌گاه ساده و عایق.</a:t>
+                </a:r>
+              </a:p>
+              <a:p>
+                <a:pPr lvl="0" rtl="1" algn="r"/>
+                <a14:m>
+                  <m:oMath xmlns:m="http://schemas.openxmlformats.org/officeDocument/2006/math">
+                    <m:sSup>
+                      <m:e>
+                        <m:r>
+                          <m:t>τ</m:t>
+                        </m:r>
+                      </m:e>
+                      <m:sup>
+                        <m:r>
+                          <m:rPr>
+                            <m:sty m:val="p"/>
+                          </m:rPr>
+                          <m:t>*</m:t>
+                        </m:r>
+                      </m:sup>
+                    </m:sSup>
+                    <m:r>
+                      <m:rPr>
+                        <m:sty m:val="p"/>
+                      </m:rPr>
+                      <m:t>≈</m:t>
+                    </m:r>
+                    <m:r>
+                      <m:t>0.15</m:t>
+                    </m:r>
+                  </m:oMath>
+                </a14:m>
+                <a:r>
+                  <a:rPr lang="fa-IR" dirty="0">
+                    <a:latin typeface="Tahoma"/>
+                    <a:cs typeface="Tahoma"/>
+                  </a:rPr>
+                  <a:t> (معادل </a:t>
+                </a:r>
+                <a14:m>
+                  <m:oMath xmlns:m="http://schemas.openxmlformats.org/officeDocument/2006/math">
+                    <m:sSub>
+                      <m:e>
+                        <m:r>
+                          <m:t>τ</m:t>
+                        </m:r>
+                      </m:e>
+                      <m:sub>
+                        <m:r>
+                          <m:t>0</m:t>
+                        </m:r>
+                      </m:sub>
+                    </m:sSub>
+                    <m:r>
+                      <m:rPr>
+                        <m:sty m:val="p"/>
+                      </m:rPr>
+                      <m:t>=</m:t>
+                    </m:r>
+                    <m:r>
+                      <m:t>418</m:t>
+                    </m:r>
+                  </m:oMath>
+                </a14:m>
+                <a:r>
+                  <a:rPr lang="fa-IR" dirty="0">
+                    <a:latin typeface="Tahoma"/>
+                    <a:cs typeface="Tahoma"/>
+                  </a:rPr>
+                  <a:t> s)؛ زمان کل ۳۰۰۰ ثانیه.</a:t>
+                </a:r>
+              </a:p>
+              <a:p>
+                <a:pPr lvl="0" rtl="1" algn="r"/>
+                <a:r>
+                  <a:rPr lang="fa-IR" dirty="0">
+                    <a:latin typeface="Tahoma"/>
+                    <a:cs typeface="Tahoma"/>
+                  </a:rPr>
+                  <a:t>خواص: </a:t>
+                </a:r>
+                <a:r>
+                  <a:rPr b="1" lang="fa-IR" dirty="0">
+                    <a:latin typeface="Tahoma"/>
+                    <a:cs typeface="Tahoma"/>
+                  </a:rPr>
+                  <a:t>هالپین-تسای</a:t>
+                </a:r>
+                <a:r>
+                  <a:rPr lang="fa-IR" dirty="0">
+                    <a:latin typeface="Tahoma"/>
+                    <a:cs typeface="Tahoma"/>
+                  </a:rPr>
+                  <a:t> + قانون مخلوط‌ها؛ تخلخل: </a:t>
+                </a:r>
+                <a:r>
+                  <a:rPr b="1" lang="fa-IR" dirty="0">
+                    <a:latin typeface="Tahoma"/>
+                    <a:cs typeface="Tahoma"/>
+                  </a:rPr>
+                  <a:t>سلول باز</a:t>
+                </a:r>
+                <a:r>
+                  <a:rPr lang="fa-IR" dirty="0">
+                    <a:latin typeface="Tahoma"/>
+                    <a:cs typeface="Tahoma"/>
+                  </a:rPr>
+                  <a:t>.</a:t>
+                </a:r>
+              </a:p>
+            </p:txBody>
+          </p:sp>
+        </mc:Choice>
+      </mc:AlternateContent>
     </p:spTree>
   </p:cSld>
 </p:sld>
@@ -11758,12 +10677,7 @@
             <p:ph type="title"/>
           </p:nvPr>
         </p:nvSpPr>
-        <p:spPr>
-          <a:xfrm>
-            <a:off x="457200" y="150000"/>
-            <a:ext cx="8229600" cy="700000"/>
-          </a:xfrm>
-        </p:spPr>
+        <p:spPr/>
         <p:txBody>
           <a:bodyPr/>
           <a:lstStyle/>
@@ -11776,86 +10690,29 @@
                 <a:latin typeface="Tahoma"/>
                 <a:cs typeface="Tahoma"/>
               </a:rPr>
-              <a:t>پیشینه ۲: خانوادهٔ تئوری‌های ترموالاستیسیته</a:t>
-            </a:r>
-          </a:p>
-        </p:txBody>
-      </p:sp>
-      <p:sp>
-        <p:nvSpPr>
-          <p:cNvPr id="4" name="Text Placeholder 3"/>
-          <p:cNvSpPr>
-            <a:spLocks noGrp="1"/>
-          </p:cNvSpPr>
-          <p:nvPr>
-            <p:ph idx="2" sz="half" type="body"/>
-          </p:nvPr>
-        </p:nvSpPr>
-        <p:spPr/>
-        <p:txBody>
-          <a:bodyPr/>
-          <a:lstStyle/>
-          <a:p>
-            <a:pPr lvl="0" rtl="1" algn="r"/>
-            <a:r>
-              <a:rPr b="1" lang="fa-IR" dirty="0">
-                <a:latin typeface="Tahoma"/>
-                <a:cs typeface="Tahoma"/>
-              </a:rPr>
-              <a:t>کلاسیک</a:t>
-            </a:r>
-            <a:r>
-              <a:rPr lang="fa-IR" dirty="0">
-                <a:latin typeface="Tahoma"/>
-                <a:cs typeface="Tahoma"/>
-              </a:rPr>
-              <a:t> (فوریه، سرعت موج نامحدود): غیرممزوج و ممزوج. </a:t>
-            </a:r>
-            <a:r>
-              <a:rPr b="1" lang="fa-IR" dirty="0">
-                <a:latin typeface="Tahoma"/>
-                <a:cs typeface="Tahoma"/>
-              </a:rPr>
-              <a:t>تعمیم‌یافته</a:t>
-            </a:r>
-            <a:r>
-              <a:rPr lang="fa-IR" dirty="0">
-                <a:latin typeface="Tahoma"/>
-                <a:cs typeface="Tahoma"/>
-              </a:rPr>
-              <a:t> (هذلولوی، سرعت موج متناهی، «صوت دوم»): لرد–شولمن، گرین–لیندزی، گرین–نقدی، تأخیر دوفازی.</a:t>
-            </a:r>
-          </a:p>
-          <a:p>
-            <a:pPr lvl="0" rtl="1" algn="r"/>
-            <a:r>
-              <a:rPr lang="fa-IR" dirty="0">
-                <a:latin typeface="Tahoma"/>
-                <a:cs typeface="Tahoma"/>
-              </a:rPr>
-              <a:t>مرور جامع: شاکری‌اسکی و همکاران (۲۰۲۱) [۷۸].</a:t>
+              <a:t>پنج الگوی توزیع گرافن در ضخامت</a:t>
             </a:r>
           </a:p>
         </p:txBody>
       </p:sp>
       <p:pic>
         <p:nvPicPr>
-          <p:cNvPr descr="../figures_ch123/theory_taxonomy.png" id="0" name="Picture 1"/>
+          <p:cNvPr descr="../figures_ch123/GPL_patterns_schematic.png" id="0" name="Picture 1"/>
           <p:cNvPicPr>
             <a:picLocks noGrp="1" noChangeAspect="1"/>
           </p:cNvPicPr>
           <p:nvPr/>
         </p:nvPicPr>
         <p:blipFill>
-          <a:blip r:embed="rId3"/>
+          <a:blip r:embed="rId2"/>
           <a:stretch>
             <a:fillRect/>
           </a:stretch>
         </p:blipFill>
         <p:spPr bwMode="auto">
           <a:xfrm>
-            <a:off x="647700" y="876300"/>
-            <a:ext cx="7848600" cy="2921000"/>
+            <a:off x="2374900" y="1193800"/>
+            <a:ext cx="4381500" cy="3390900"/>
           </a:xfrm>
           <a:prstGeom prst="rect">
             <a:avLst/>
@@ -11913,97 +10770,41 @@
                 <a:latin typeface="Tahoma"/>
                 <a:cs typeface="Tahoma"/>
               </a:rPr>
-              <a:t>پیشینه ۳: مهم‌ترین پژوهش‌های پیشین</a:t>
-            </a:r>
-          </a:p>
-        </p:txBody>
-      </p:sp>
-      <p:sp>
-        <p:nvSpPr>
-          <p:cNvPr id="3" name="Content Placeholder 2"/>
-          <p:cNvSpPr>
-            <a:spLocks noGrp="1"/>
-          </p:cNvSpPr>
-          <p:nvPr>
-            <p:ph idx="1"/>
-          </p:nvPr>
-        </p:nvSpPr>
-        <p:spPr/>
-        <p:txBody>
-          <a:bodyPr/>
-          <a:lstStyle/>
-          <a:p>
-            <a:pPr lvl="0" rtl="1" algn="r"/>
-            <a:r>
-              <a:rPr lang="fa-IR" dirty="0">
-                <a:latin typeface="Tahoma"/>
-                <a:cs typeface="Tahoma"/>
-              </a:rPr>
-              <a:t>ملک‌زاده و همکاران (۲۰۱۲): پاسخ گذرای پوستهٔ چندلایه، DQM + نیومارک [۳۱].</a:t>
-            </a:r>
-          </a:p>
-          <a:p>
-            <a:pPr lvl="0" rtl="1" algn="r"/>
-            <a:r>
-              <a:rPr lang="fa-IR" dirty="0">
-                <a:latin typeface="Tahoma"/>
-                <a:cs typeface="Tahoma"/>
-              </a:rPr>
-              <a:t>ملک‌زاده و حیدرپور (۲۰۱۲): بار ترمو-مکانیکی متحرک، هدایت هذلولوی [۳۲].</a:t>
-            </a:r>
-          </a:p>
-          <a:p>
-            <a:pPr lvl="0" rtl="1" algn="r"/>
-            <a:r>
-              <a:rPr lang="fa-IR" dirty="0">
-                <a:latin typeface="Tahoma"/>
-                <a:cs typeface="Tahoma"/>
-              </a:rPr>
-              <a:t>حیدرپور و همکاران (۲۰۲۰): پوستهٔ استوانه‌ایِ گرافنی، بار ترمو-مکانیکی دینامیکی [۴۶].</a:t>
-            </a:r>
-          </a:p>
-          <a:p>
-            <a:pPr lvl="0" rtl="1" algn="r"/>
-            <a:r>
-              <a:rPr lang="fa-IR" dirty="0">
-                <a:latin typeface="Tahoma"/>
-                <a:cs typeface="Tahoma"/>
-              </a:rPr>
-              <a:t>رحیمی و همکاران (۲۰۲۰): تحلیل سه‌بعدی استوانهٔ متخلخلِ گرافنی با هالپین–تسای؛ یاس و رحیمی (۲۰۲۰): مدل سلول‌باز [۴۷، ۵۱].</a:t>
-            </a:r>
-          </a:p>
-          <a:p>
-            <a:pPr lvl="0" rtl="1" algn="r"/>
-            <a:r>
-              <a:rPr lang="fa-IR" dirty="0">
-                <a:latin typeface="Tahoma"/>
-                <a:cs typeface="Tahoma"/>
-              </a:rPr>
-              <a:t>مرادی‌دستجردی و بهدینان (۲۰۲۱): تنش در استوانهٔ جدارضخیمِ مدرجِ متخلخلِ گرافنی، حالت پایا [۵۲].</a:t>
-            </a:r>
-          </a:p>
-          <a:p>
-            <a:pPr lvl="0" rtl="1" algn="r"/>
-            <a:r>
-              <a:rPr lang="fa-IR" dirty="0">
-                <a:latin typeface="Tahoma"/>
-                <a:cs typeface="Tahoma"/>
-              </a:rPr>
-              <a:t>باهتویی و اسلامی (۲۰۰۷)، بگری و اسلامی (۲۰۰۸): ترموالاستیسیتهٔ تعمیم‌یافته (لرد–شولمن) در پوستهٔ استوانه‌ای و دیسکِ مدرج [۶۴–۶۶].</a:t>
-            </a:r>
-          </a:p>
-          <a:p>
-            <a:pPr lvl="0" rtl="1" algn="r"/>
-            <a:r>
-              <a:rPr lang="fa-IR" dirty="0">
-                <a:latin typeface="Tahoma"/>
-                <a:cs typeface="Tahoma"/>
-              </a:rPr>
-              <a:t>حیدرپور و همکاران (۲۰۱۹، ۲۰۲۰): پوستهٔ کروی و مخروط ناقصِ گرافنی با لرد–شولمن، DQM لایه‌ای + نیومارک — نزدیک‌ترین کارها و مبنای فصل‌های ۳ و ۴ [۳، ۶۸–۷۰].</a:t>
-            </a:r>
-          </a:p>
-        </p:txBody>
-      </p:sp>
+              <a:t>پنج الگوی توزیع تخلخل در ضخامت</a:t>
+            </a:r>
+          </a:p>
+        </p:txBody>
+      </p:sp>
+      <p:pic>
+        <p:nvPicPr>
+          <p:cNvPr descr="../figures_ch123/porosity_patterns_schematic.png" id="0" name="Picture 1"/>
+          <p:cNvPicPr>
+            <a:picLocks noGrp="1" noChangeAspect="1"/>
+          </p:cNvPicPr>
+          <p:nvPr/>
+        </p:nvPicPr>
+        <p:blipFill>
+          <a:blip r:embed="rId3"/>
+          <a:stretch>
+            <a:fillRect/>
+          </a:stretch>
+        </p:blipFill>
+        <p:spPr bwMode="auto">
+          <a:xfrm>
+            <a:off x="2070100" y="1193800"/>
+            <a:ext cx="5016500" cy="3390900"/>
+          </a:xfrm>
+          <a:prstGeom prst="rect">
+            <a:avLst/>
+          </a:prstGeom>
+          <a:noFill/>
+          <a:ln w="9525">
+            <a:noFill/>
+            <a:headEnd/>
+            <a:tailEnd/>
+          </a:ln>
+        </p:spPr>
+      </p:pic>
     </p:spTree>
   </p:cSld>
 </p:sld>

</xml_diff>